<commit_message>
Let students choose epoch counts and remove repeated slide footer
</commit_message>
<xml_diff>
--- a/docs/ByteFormer_MNIST_零基础实验课.pptx
+++ b/docs/ByteFormer_MNIST_零基础实验课.pptx
@@ -656,7 +656,7 @@
           <a:lstStyle/>
           <a:p>
             <a:r>
-              <a:t>这是学生实际操作，不提供虚构10轮教师参考成绩。使用验证结果作比较，测试成绩只作最终记录。epochs10会从官方预训练权重重新初始化，不是在baseline/best.pt上续训。Notebook首次保留EPOCHS=8并提示学生修改。若显存不足改batch，两组保持一致并在报告记录。</a:t>
+              <a:t>学生自行设置两次实验轮数，不指定固定数值。根据训练与验证曲线比较；测试成绩只作最终记录。对比从同一官方预训练权重开始，不是在baseline上续训。保持其他参数相同并保留独立输出。更多轮数未必更好；需记录自己的实际设置与依据。</a:t>
             </a:r>
           </a:p>
         </p:txBody>
@@ -1426,7 +1426,7 @@
           <a:lstStyle/>
           <a:p>
             <a:r>
-              <a:t>正式默认epochs8/train50000/val1000/test10000/batch32/lr1e-4/milestones4,6/gamma0.2/seed42。原正式实测训练末先测试1000，之后独立全10000；发布默认把最终测试整合成10000，共用同一score代码。输出目录已有best.pt时会报错保护结果；重跑换output且对应修改后续checkpoint。模型从官方权重全参数微调，AdamW weight_decay0.01，分类头10倍学习率。</a:t>
+              <a:t>epochs由学生输入；其余示例配置为train50000/val1000/test10000/batch32/lr1e-4/milestones4,6/gamma0.2/seed42。原正式实测训练末先测试1000，之后独立全10000；发布默认把最终测试整合成10000，共用同一score代码。输出目录已有best.pt时会报错保护结果；重跑换output且对应修改后续checkpoint。模型从官方权重全参数微调，AdamW weight_decay0.01，分类头10倍学习率。</a:t>
             </a:r>
           </a:p>
         </p:txBody>
@@ -1496,7 +1496,7 @@
           <a:lstStyle/>
           <a:p>
             <a:r>
-              <a:t>结果来自examples/course_baseline与course_full_test。完整10000测试97.07%(9707/10000)，由验证97.30%选择第5轮模型，8轮计划预先确定。曲线蓝色训练、橙色验证。loss通常希望下降，accuracy通常希望上升；训练与验证差距反映泛化。完整测试不用于选最佳轮次。</a:t>
+              <a:t>结果来自examples/course_baseline与course_full_test。完整10000测试97.07%(9707/10000)，由验证97.30%选择第5轮模型；轮数是该次实测记录，不是课程要求。曲线蓝色训练、橙色验证。loss通常希望下降，accuracy通常希望上升；训练与验证差距反映泛化。完整测试不用于选最佳轮次。</a:t>
             </a:r>
           </a:p>
         </p:txBody>
@@ -5009,8 +5009,8 @@
         </p:nvSpPr>
         <p:spPr>
           <a:xfrm>
-            <a:off x="1069848" y="6419088"/>
-            <a:ext cx="9144000" cy="228600"/>
+            <a:off x="11064240" y="6400800"/>
+            <a:ext cx="502920" cy="274320"/>
           </a:xfrm>
           <a:prstGeom prst="rect">
             <a:avLst/>
@@ -5023,11 +5023,11 @@
           </a:bodyPr>
           <a:lstStyle/>
           <a:p>
-            <a:pPr>
-              <a:spcAft>
-                <a:spcPts val="600"/>
-              </a:spcAft>
-              <a:defRPr sz="1000" b="0">
+            <a:pPr algn="r">
+              <a:spcAft>
+                <a:spcPts val="600"/>
+              </a:spcAft>
+              <a:defRPr sz="1100" b="0">
                 <a:solidFill>
                   <a:srgbClr val="647483"/>
                 </a:solidFill>
@@ -5035,45 +5035,6 @@
               </a:defRPr>
             </a:pPr>
             <a:r>
-              <a:t>Kaggle 免费 GPU 优先 · AutoDL 备用 · 记录自己的实验结果</a:t>
-            </a:r>
-          </a:p>
-        </p:txBody>
-      </p:sp>
-      <p:sp>
-        <p:nvSpPr>
-          <p:cNvPr id="9" name="TextBox 8"/>
-          <p:cNvSpPr txBox="1"/>
-          <p:nvPr/>
-        </p:nvSpPr>
-        <p:spPr>
-          <a:xfrm>
-            <a:off x="11064240" y="6400800"/>
-            <a:ext cx="502920" cy="274320"/>
-          </a:xfrm>
-          <a:prstGeom prst="rect">
-            <a:avLst/>
-          </a:prstGeom>
-          <a:noFill/>
-        </p:spPr>
-        <p:txBody>
-          <a:bodyPr wrap="square" lIns="27432" rIns="27432" tIns="18288" bIns="18288">
-            <a:spAutoFit/>
-          </a:bodyPr>
-          <a:lstStyle/>
-          <a:p>
-            <a:pPr algn="r">
-              <a:spcAft>
-                <a:spcPts val="600"/>
-              </a:spcAft>
-              <a:defRPr sz="1100" b="0">
-                <a:solidFill>
-                  <a:srgbClr val="647483"/>
-                </a:solidFill>
-                <a:latin typeface="Noto Sans CJK SC"/>
-              </a:defRPr>
-            </a:pPr>
-            <a:r>
               <a:t>10</a:t>
             </a:r>
           </a:p>
@@ -5081,7 +5042,7 @@
       </p:sp>
       <p:sp>
         <p:nvSpPr>
-          <p:cNvPr id="10" name="Rounded Rectangle 9"/>
+          <p:cNvPr id="9" name="Rounded Rectangle 8"/>
           <p:cNvSpPr/>
           <p:nvPr/>
         </p:nvSpPr>
@@ -5124,7 +5085,7 @@
       </p:sp>
       <p:sp>
         <p:nvSpPr>
-          <p:cNvPr id="11" name="TextBox 10"/>
+          <p:cNvPr id="10" name="TextBox 9"/>
           <p:cNvSpPr txBox="1"/>
           <p:nvPr/>
         </p:nvSpPr>
@@ -5179,7 +5140,7 @@
       </p:sp>
       <p:sp>
         <p:nvSpPr>
-          <p:cNvPr id="12" name="TextBox 11"/>
+          <p:cNvPr id="11" name="TextBox 10"/>
           <p:cNvSpPr txBox="1"/>
           <p:nvPr/>
         </p:nvSpPr>
@@ -5266,7 +5227,7 @@
       </p:sp>
       <p:pic>
         <p:nvPicPr>
-          <p:cNvPr id="13" name="Picture 12" descr="example_digit.png"/>
+          <p:cNvPr id="12" name="Picture 11" descr="example_digit.png"/>
           <p:cNvPicPr>
             <a:picLocks noChangeAspect="1"/>
           </p:cNvPicPr>
@@ -5290,7 +5251,7 @@
       </p:pic>
       <p:sp>
         <p:nvSpPr>
-          <p:cNvPr id="14" name="TextBox 13"/>
+          <p:cNvPr id="13" name="TextBox 12"/>
           <p:cNvSpPr txBox="1"/>
           <p:nvPr/>
         </p:nvSpPr>
@@ -5329,7 +5290,7 @@
       </p:sp>
       <p:sp>
         <p:nvSpPr>
-          <p:cNvPr id="15" name="TextBox 14"/>
+          <p:cNvPr id="14" name="TextBox 13"/>
           <p:cNvSpPr txBox="1"/>
           <p:nvPr/>
         </p:nvSpPr>
@@ -5481,7 +5442,7 @@
               </a:defRPr>
             </a:pPr>
             <a:r>
-              <a:t>10 学生实操：只把训练轮数 8 改为 10</a:t>
+              <a:t>10 学生实操：自行设置，观察验证结果</a:t>
             </a:r>
           </a:p>
         </p:txBody>
@@ -5623,8 +5584,8 @@
         </p:nvSpPr>
         <p:spPr>
           <a:xfrm>
-            <a:off x="1069848" y="6419088"/>
-            <a:ext cx="9144000" cy="228600"/>
+            <a:off x="11064240" y="6400800"/>
+            <a:ext cx="502920" cy="274320"/>
           </a:xfrm>
           <a:prstGeom prst="rect">
             <a:avLst/>
@@ -5637,11 +5598,11 @@
           </a:bodyPr>
           <a:lstStyle/>
           <a:p>
-            <a:pPr>
-              <a:spcAft>
-                <a:spcPts val="600"/>
-              </a:spcAft>
-              <a:defRPr sz="1000" b="0">
+            <a:pPr algn="r">
+              <a:spcAft>
+                <a:spcPts val="600"/>
+              </a:spcAft>
+              <a:defRPr sz="1100" b="0">
                 <a:solidFill>
                   <a:srgbClr val="647483"/>
                 </a:solidFill>
@@ -5649,45 +5610,6 @@
               </a:defRPr>
             </a:pPr>
             <a:r>
-              <a:t>Kaggle 免费 GPU 优先 · AutoDL 备用 · 记录自己的实验结果</a:t>
-            </a:r>
-          </a:p>
-        </p:txBody>
-      </p:sp>
-      <p:sp>
-        <p:nvSpPr>
-          <p:cNvPr id="9" name="TextBox 8"/>
-          <p:cNvSpPr txBox="1"/>
-          <p:nvPr/>
-        </p:nvSpPr>
-        <p:spPr>
-          <a:xfrm>
-            <a:off x="11064240" y="6400800"/>
-            <a:ext cx="502920" cy="274320"/>
-          </a:xfrm>
-          <a:prstGeom prst="rect">
-            <a:avLst/>
-          </a:prstGeom>
-          <a:noFill/>
-        </p:spPr>
-        <p:txBody>
-          <a:bodyPr wrap="square" lIns="27432" rIns="27432" tIns="18288" bIns="18288">
-            <a:spAutoFit/>
-          </a:bodyPr>
-          <a:lstStyle/>
-          <a:p>
-            <a:pPr algn="r">
-              <a:spcAft>
-                <a:spcPts val="600"/>
-              </a:spcAft>
-              <a:defRPr sz="1100" b="0">
-                <a:solidFill>
-                  <a:srgbClr val="647483"/>
-                </a:solidFill>
-                <a:latin typeface="Noto Sans CJK SC"/>
-              </a:defRPr>
-            </a:pPr>
-            <a:r>
               <a:t>11</a:t>
             </a:r>
           </a:p>
@@ -5695,7 +5617,7 @@
       </p:sp>
       <p:sp>
         <p:nvSpPr>
-          <p:cNvPr id="10" name="Rounded Rectangle 9"/>
+          <p:cNvPr id="9" name="Rounded Rectangle 8"/>
           <p:cNvSpPr/>
           <p:nvPr/>
         </p:nvSpPr>
@@ -5738,7 +5660,7 @@
       </p:sp>
       <p:sp>
         <p:nvSpPr>
-          <p:cNvPr id="11" name="TextBox 10"/>
+          <p:cNvPr id="10" name="TextBox 9"/>
           <p:cNvSpPr txBox="1"/>
           <p:nvPr/>
         </p:nvSpPr>
@@ -5762,7 +5684,7 @@
               <a:spcAft>
                 <a:spcPts val="300"/>
               </a:spcAft>
-              <a:defRPr sz="1800" b="0">
+              <a:defRPr sz="1700" b="0">
                 <a:solidFill>
                   <a:srgbClr val="FFFFFF"/>
                 </a:solidFill>
@@ -5770,7 +5692,7 @@
               </a:defRPr>
             </a:pPr>
             <a:r>
-              <a:t>EPOCHS = 10  # 亲手把原来的 8 改为 10</a:t>
+              <a:t>COMPARISON_EPOCHS = int(input("对比轮数："))</a:t>
             </a:r>
           </a:p>
           <a:p>
@@ -5778,7 +5700,7 @@
               <a:spcAft>
                 <a:spcPts val="300"/>
               </a:spcAft>
-              <a:defRPr sz="1800" b="0">
+              <a:defRPr sz="1700" b="0">
                 <a:solidFill>
                   <a:srgbClr val="FFFFFF"/>
                 </a:solidFill>
@@ -5786,14 +5708,14 @@
               </a:defRPr>
             </a:pPr>
             <a:r>
-              <a:t>!python train.py --epochs {EPOCHS} --output outputs/epochs10</a:t>
-            </a:r>
-          </a:p>
-        </p:txBody>
-      </p:sp>
-      <p:sp>
-        <p:nvSpPr>
-          <p:cNvPr id="12" name="TextBox 11"/>
+              <a:t>!python train.py --epochs {COMPARISON_EPOCHS} --output outputs/comparison</a:t>
+            </a:r>
+          </a:p>
+        </p:txBody>
+      </p:sp>
+      <p:sp>
+        <p:nvSpPr>
+          <p:cNvPr id="11" name="TextBox 10"/>
           <p:cNvSpPr txBox="1"/>
           <p:nvPr/>
         </p:nvSpPr>
@@ -5857,14 +5779,14 @@
               </a:defRPr>
             </a:pPr>
             <a:r>
-              <a:t>保留baseline，另存epochs10。</a:t>
-            </a:r>
-          </a:p>
-        </p:txBody>
-      </p:sp>
-      <p:sp>
-        <p:nvSpPr>
-          <p:cNvPr id="13" name="Rounded Rectangle 12"/>
+              <a:t>保留baseline，另存comparison。</a:t>
+            </a:r>
+          </a:p>
+        </p:txBody>
+      </p:sp>
+      <p:sp>
+        <p:nvSpPr>
+          <p:cNvPr id="12" name="Rounded Rectangle 11"/>
           <p:cNvSpPr/>
           <p:nvPr/>
         </p:nvSpPr>
@@ -5907,7 +5829,7 @@
       </p:sp>
       <p:sp>
         <p:nvSpPr>
-          <p:cNvPr id="14" name="TextBox 13"/>
+          <p:cNvPr id="13" name="TextBox 12"/>
           <p:cNvSpPr txBox="1"/>
           <p:nvPr/>
         </p:nvSpPr>
@@ -5987,7 +5909,7 @@
               </a:defRPr>
             </a:pPr>
             <a:r>
-              <a:t>· 增加轮数的收益与代价？</a:t>
+              <a:t>· 改变设置的收益与代价？</a:t>
             </a:r>
           </a:p>
           <a:p>
@@ -6010,7 +5932,7 @@
       </p:sp>
       <p:sp>
         <p:nvSpPr>
-          <p:cNvPr id="15" name="TextBox 14"/>
+          <p:cNvPr id="14" name="TextBox 13"/>
           <p:cNvSpPr txBox="1"/>
           <p:nvPr/>
         </p:nvSpPr>
@@ -6042,7 +5964,7 @@
               </a:defRPr>
             </a:pPr>
             <a:r>
-              <a:t>不预设10轮一定更好。教师已验证8轮正式基线；10轮是学生亲手运行并填写的练习。</a:t>
+              <a:t>不固定训练轮数，也不预设训练越久越好。记录自己的设置，并用验证结果解释选择。</a:t>
             </a:r>
           </a:p>
         </p:txBody>
@@ -6304,8 +6226,8 @@
         </p:nvSpPr>
         <p:spPr>
           <a:xfrm>
-            <a:off x="1069848" y="6419088"/>
-            <a:ext cx="9144000" cy="228600"/>
+            <a:off x="11064240" y="6400800"/>
+            <a:ext cx="502920" cy="274320"/>
           </a:xfrm>
           <a:prstGeom prst="rect">
             <a:avLst/>
@@ -6318,11 +6240,11 @@
           </a:bodyPr>
           <a:lstStyle/>
           <a:p>
-            <a:pPr>
-              <a:spcAft>
-                <a:spcPts val="600"/>
-              </a:spcAft>
-              <a:defRPr sz="1000" b="0">
+            <a:pPr algn="r">
+              <a:spcAft>
+                <a:spcPts val="600"/>
+              </a:spcAft>
+              <a:defRPr sz="1100" b="0">
                 <a:solidFill>
                   <a:srgbClr val="647483"/>
                 </a:solidFill>
@@ -6330,7 +6252,7 @@
               </a:defRPr>
             </a:pPr>
             <a:r>
-              <a:t>Kaggle 免费 GPU 优先 · AutoDL 备用 · 记录自己的实验结果</a:t>
+              <a:t>12</a:t>
             </a:r>
           </a:p>
         </p:txBody>
@@ -6343,8 +6265,8 @@
         </p:nvSpPr>
         <p:spPr>
           <a:xfrm>
-            <a:off x="11064240" y="6400800"/>
-            <a:ext cx="502920" cy="274320"/>
+            <a:off x="786384" y="1792224"/>
+            <a:ext cx="10652760" cy="621792"/>
           </a:xfrm>
           <a:prstGeom prst="rect">
             <a:avLst/>
@@ -6357,45 +6279,6 @@
           </a:bodyPr>
           <a:lstStyle/>
           <a:p>
-            <a:pPr algn="r">
-              <a:spcAft>
-                <a:spcPts val="600"/>
-              </a:spcAft>
-              <a:defRPr sz="1100" b="0">
-                <a:solidFill>
-                  <a:srgbClr val="647483"/>
-                </a:solidFill>
-                <a:latin typeface="Noto Sans CJK SC"/>
-              </a:defRPr>
-            </a:pPr>
-            <a:r>
-              <a:t>12</a:t>
-            </a:r>
-          </a:p>
-        </p:txBody>
-      </p:sp>
-      <p:sp>
-        <p:nvSpPr>
-          <p:cNvPr id="10" name="TextBox 9"/>
-          <p:cNvSpPr txBox="1"/>
-          <p:nvPr/>
-        </p:nvSpPr>
-        <p:spPr>
-          <a:xfrm>
-            <a:off x="786384" y="1792224"/>
-            <a:ext cx="10652760" cy="621792"/>
-          </a:xfrm>
-          <a:prstGeom prst="rect">
-            <a:avLst/>
-          </a:prstGeom>
-          <a:noFill/>
-        </p:spPr>
-        <p:txBody>
-          <a:bodyPr wrap="square" lIns="27432" rIns="27432" tIns="18288" bIns="18288">
-            <a:spAutoFit/>
-          </a:bodyPr>
-          <a:lstStyle/>
-          <a:p>
             <a:pPr>
               <a:spcAft>
                 <a:spcPts val="600"/>
@@ -6415,14 +6298,14 @@
       </p:sp>
       <p:sp>
         <p:nvSpPr>
-          <p:cNvPr id="11" name="Rounded Rectangle 10"/>
+          <p:cNvPr id="10" name="Rounded Rectangle 9"/>
           <p:cNvSpPr/>
           <p:nvPr/>
         </p:nvSpPr>
         <p:spPr>
           <a:xfrm>
-            <a:off x="749808" y="2660904"/>
-            <a:ext cx="10707624" cy="2139696"/>
+            <a:off x="749808" y="2551176"/>
+            <a:ext cx="10707624" cy="2267712"/>
           </a:xfrm>
           <a:prstGeom prst="roundRect">
             <a:avLst/>
@@ -6458,14 +6341,14 @@
       </p:sp>
       <p:sp>
         <p:nvSpPr>
-          <p:cNvPr id="12" name="TextBox 11"/>
+          <p:cNvPr id="11" name="TextBox 10"/>
           <p:cNvSpPr txBox="1"/>
           <p:nvPr/>
         </p:nvSpPr>
         <p:spPr>
           <a:xfrm>
-            <a:off x="914400" y="2788920"/>
-            <a:ext cx="10378440" cy="1883663"/>
+            <a:off x="914400" y="2679192"/>
+            <a:ext cx="10378440" cy="2011680"/>
           </a:xfrm>
           <a:prstGeom prst="rect">
             <a:avLst/>
@@ -6482,7 +6365,7 @@
               <a:spcAft>
                 <a:spcPts val="300"/>
               </a:spcAft>
-              <a:defRPr sz="1700" b="0">
+              <a:defRPr sz="1600" b="0">
                 <a:solidFill>
                   <a:srgbClr val="FFFFFF"/>
                 </a:solidFill>
@@ -6498,7 +6381,7 @@
               <a:spcAft>
                 <a:spcPts val="300"/>
               </a:spcAft>
-              <a:defRPr sz="1700" b="0">
+              <a:defRPr sz="1600" b="0">
                 <a:solidFill>
                   <a:srgbClr val="FFFFFF"/>
                 </a:solidFill>
@@ -6514,7 +6397,7 @@
               <a:spcAft>
                 <a:spcPts val="300"/>
               </a:spcAft>
-              <a:defRPr sz="1700" b="0">
+              <a:defRPr sz="1600" b="0">
                 <a:solidFill>
                   <a:srgbClr val="FFFFFF"/>
                 </a:solidFill>
@@ -6530,7 +6413,7 @@
               <a:spcAft>
                 <a:spcPts val="300"/>
               </a:spcAft>
-              <a:defRPr sz="1700" b="0">
+              <a:defRPr sz="1600" b="0">
                 <a:solidFill>
                   <a:srgbClr val="FFFFFF"/>
                 </a:solidFill>
@@ -6546,7 +6429,7 @@
               <a:spcAft>
                 <a:spcPts val="300"/>
               </a:spcAft>
-              <a:defRPr sz="1700" b="0">
+              <a:defRPr sz="1600" b="0">
                 <a:solidFill>
                   <a:srgbClr val="FFFFFF"/>
                 </a:solidFill>
@@ -6562,7 +6445,7 @@
               <a:spcAft>
                 <a:spcPts val="300"/>
               </a:spcAft>
-              <a:defRPr sz="1700" b="0">
+              <a:defRPr sz="1600" b="0">
                 <a:solidFill>
                   <a:srgbClr val="FFFFFF"/>
                 </a:solidFill>
@@ -6570,14 +6453,30 @@
               </a:defRPr>
             </a:pPr>
             <a:r>
-              <a:t>python train.py</a:t>
-            </a:r>
-          </a:p>
-        </p:txBody>
-      </p:sp>
-      <p:sp>
-        <p:nvSpPr>
-          <p:cNvPr id="13" name="TextBox 12"/>
+              <a:t>read -p "epochs: " EPOCHS</a:t>
+            </a:r>
+          </a:p>
+          <a:p>
+            <a:pPr>
+              <a:spcAft>
+                <a:spcPts val="300"/>
+              </a:spcAft>
+              <a:defRPr sz="1600" b="0">
+                <a:solidFill>
+                  <a:srgbClr val="FFFFFF"/>
+                </a:solidFill>
+                <a:latin typeface="DejaVu Sans Mono"/>
+              </a:defRPr>
+            </a:pPr>
+            <a:r>
+              <a:t>python train.py --epochs "$EPOCHS"</a:t>
+            </a:r>
+          </a:p>
+        </p:txBody>
+      </p:sp>
+      <p:sp>
+        <p:nvSpPr>
+          <p:cNvPr id="12" name="TextBox 11"/>
           <p:cNvSpPr txBox="1"/>
           <p:nvPr/>
         </p:nvSpPr>
@@ -6632,7 +6531,7 @@
       </p:sp>
       <p:sp>
         <p:nvSpPr>
-          <p:cNvPr id="14" name="TextBox 13"/>
+          <p:cNvPr id="13" name="TextBox 12"/>
           <p:cNvSpPr txBox="1"/>
           <p:nvPr/>
         </p:nvSpPr>
@@ -6929,8 +6828,8 @@
         </p:nvSpPr>
         <p:spPr>
           <a:xfrm>
-            <a:off x="1069848" y="6419088"/>
-            <a:ext cx="9144000" cy="228600"/>
+            <a:off x="11064240" y="6400800"/>
+            <a:ext cx="502920" cy="274320"/>
           </a:xfrm>
           <a:prstGeom prst="rect">
             <a:avLst/>
@@ -6943,45 +6842,6 @@
           </a:bodyPr>
           <a:lstStyle/>
           <a:p>
-            <a:pPr>
-              <a:spcAft>
-                <a:spcPts val="600"/>
-              </a:spcAft>
-              <a:defRPr sz="1000" b="0">
-                <a:solidFill>
-                  <a:srgbClr val="647483"/>
-                </a:solidFill>
-                <a:latin typeface="Noto Sans CJK SC"/>
-              </a:defRPr>
-            </a:pPr>
-            <a:r>
-              <a:t>Kaggle 免费 GPU 优先 · AutoDL 备用 · 记录自己的实验结果</a:t>
-            </a:r>
-          </a:p>
-        </p:txBody>
-      </p:sp>
-      <p:sp>
-        <p:nvSpPr>
-          <p:cNvPr id="9" name="TextBox 8"/>
-          <p:cNvSpPr txBox="1"/>
-          <p:nvPr/>
-        </p:nvSpPr>
-        <p:spPr>
-          <a:xfrm>
-            <a:off x="11064240" y="6400800"/>
-            <a:ext cx="502920" cy="274320"/>
-          </a:xfrm>
-          <a:prstGeom prst="rect">
-            <a:avLst/>
-          </a:prstGeom>
-          <a:noFill/>
-        </p:spPr>
-        <p:txBody>
-          <a:bodyPr wrap="square" lIns="27432" rIns="27432" tIns="18288" bIns="18288">
-            <a:spAutoFit/>
-          </a:bodyPr>
-          <a:lstStyle/>
-          <a:p>
             <a:pPr algn="r">
               <a:spcAft>
                 <a:spcPts val="600"/>
@@ -7001,7 +6861,7 @@
       </p:sp>
       <p:graphicFrame>
         <p:nvGraphicFramePr>
-          <p:cNvPr id="10" name="Table 9"/>
+          <p:cNvPr id="9" name="Table 8"/>
           <p:cNvGraphicFramePr>
             <a:graphicFrameLocks noGrp="1"/>
           </p:cNvGraphicFramePr>
@@ -7377,7 +7237,7 @@
       </p:graphicFrame>
       <p:sp>
         <p:nvSpPr>
-          <p:cNvPr id="11" name="TextBox 10"/>
+          <p:cNvPr id="10" name="TextBox 9"/>
           <p:cNvSpPr txBox="1"/>
           <p:nvPr/>
         </p:nvSpPr>
@@ -7671,8 +7531,8 @@
         </p:nvSpPr>
         <p:spPr>
           <a:xfrm>
-            <a:off x="1069848" y="6419088"/>
-            <a:ext cx="9144000" cy="228600"/>
+            <a:off x="11064240" y="6400800"/>
+            <a:ext cx="502920" cy="274320"/>
           </a:xfrm>
           <a:prstGeom prst="rect">
             <a:avLst/>
@@ -7685,11 +7545,11 @@
           </a:bodyPr>
           <a:lstStyle/>
           <a:p>
-            <a:pPr>
-              <a:spcAft>
-                <a:spcPts val="600"/>
-              </a:spcAft>
-              <a:defRPr sz="1000" b="0">
+            <a:pPr algn="r">
+              <a:spcAft>
+                <a:spcPts val="600"/>
+              </a:spcAft>
+              <a:defRPr sz="1100" b="0">
                 <a:solidFill>
                   <a:srgbClr val="647483"/>
                 </a:solidFill>
@@ -7697,7 +7557,7 @@
               </a:defRPr>
             </a:pPr>
             <a:r>
-              <a:t>Kaggle 免费 GPU 优先 · AutoDL 备用 · 记录自己的实验结果</a:t>
+              <a:t>14</a:t>
             </a:r>
           </a:p>
         </p:txBody>
@@ -7710,8 +7570,8 @@
         </p:nvSpPr>
         <p:spPr>
           <a:xfrm>
-            <a:off x="11064240" y="6400800"/>
-            <a:ext cx="502920" cy="274320"/>
+            <a:off x="786384" y="1810512"/>
+            <a:ext cx="5513832" cy="3328416"/>
           </a:xfrm>
           <a:prstGeom prst="rect">
             <a:avLst/>
@@ -7724,19 +7584,96 @@
           </a:bodyPr>
           <a:lstStyle/>
           <a:p>
-            <a:pPr algn="r">
-              <a:spcAft>
-                <a:spcPts val="600"/>
-              </a:spcAft>
-              <a:defRPr sz="1100" b="0">
-                <a:solidFill>
-                  <a:srgbClr val="647483"/>
-                </a:solidFill>
-                <a:latin typeface="Noto Sans CJK SC"/>
-              </a:defRPr>
-            </a:pPr>
-            <a:r>
-              <a:t>14</a:t>
+            <a:pPr>
+              <a:spcAft>
+                <a:spcPts val="600"/>
+              </a:spcAft>
+              <a:defRPr sz="2100" b="0">
+                <a:solidFill>
+                  <a:srgbClr val="243547"/>
+                </a:solidFill>
+                <a:latin typeface="Noto Sans CJK SC"/>
+              </a:defRPr>
+            </a:pPr>
+            <a:r>
+              <a:t>① 运行Notebook最后的打包单元格。</a:t>
+            </a:r>
+          </a:p>
+          <a:p>
+            <a:pPr>
+              <a:spcAft>
+                <a:spcPts val="600"/>
+              </a:spcAft>
+              <a:defRPr sz="2100" b="0">
+                <a:solidFill>
+                  <a:srgbClr val="243547"/>
+                </a:solidFill>
+                <a:latin typeface="Noto Sans CJK SC"/>
+              </a:defRPr>
+            </a:pPr>
+            <a:r>
+              <a:t>② 在文件面板下载byteformer_mnist_results.zip。</a:t>
+            </a:r>
+          </a:p>
+          <a:p>
+            <a:pPr>
+              <a:spcAft>
+                <a:spcPts val="600"/>
+              </a:spcAft>
+              <a:defRPr sz="2100" b="0">
+                <a:solidFill>
+                  <a:srgbClr val="243547"/>
+                </a:solidFill>
+                <a:latin typeface="Noto Sans CJK SC"/>
+              </a:defRPr>
+            </a:pPr>
+            <a:r>
+              <a:t>③ 用Word模板填写自己的环境、命令、指标和解释。</a:t>
+            </a:r>
+          </a:p>
+          <a:p>
+            <a:pPr>
+              <a:spcAft>
+                <a:spcPts val="600"/>
+              </a:spcAft>
+              <a:defRPr sz="2100" b="0">
+                <a:solidFill>
+                  <a:srgbClr val="243547"/>
+                </a:solidFill>
+                <a:latin typeface="Noto Sans CJK SC"/>
+              </a:defRPr>
+            </a:pPr>
+            <a:r>
+              <a:t>④ 附两组曲线、预测图、错例证据。</a:t>
+            </a:r>
+          </a:p>
+          <a:p>
+            <a:pPr>
+              <a:spcAft>
+                <a:spcPts val="600"/>
+              </a:spcAft>
+              <a:defRPr sz="2100" b="0">
+                <a:solidFill>
+                  <a:srgbClr val="243547"/>
+                </a:solidFill>
+                <a:latin typeface="Noto Sans CJK SC"/>
+              </a:defRPr>
+            </a:pPr>
+          </a:p>
+          <a:p>
+            <a:pPr>
+              <a:spcAft>
+                <a:spcPts val="600"/>
+              </a:spcAft>
+              <a:defRPr sz="2100" b="0">
+                <a:solidFill>
+                  <a:srgbClr val="243547"/>
+                </a:solidFill>
+                <a:latin typeface="Noto Sans CJK SC"/>
+              </a:defRPr>
+            </a:pPr>
+            <a:r>
+              <a:t>默认不用提交数据集、Python环境或大模型。</a:t>
             </a:r>
           </a:p>
         </p:txBody>
@@ -7749,8 +7686,8 @@
         </p:nvSpPr>
         <p:spPr>
           <a:xfrm>
-            <a:off x="786384" y="1810512"/>
-            <a:ext cx="5513832" cy="3328416"/>
+            <a:off x="6556248" y="1856231"/>
+            <a:ext cx="4572000" cy="429768"/>
           </a:xfrm>
           <a:prstGeom prst="rect">
             <a:avLst/>
@@ -7767,122 +7704,6 @@
               <a:spcAft>
                 <a:spcPts val="600"/>
               </a:spcAft>
-              <a:defRPr sz="2100" b="0">
-                <a:solidFill>
-                  <a:srgbClr val="243547"/>
-                </a:solidFill>
-                <a:latin typeface="Noto Sans CJK SC"/>
-              </a:defRPr>
-            </a:pPr>
-            <a:r>
-              <a:t>① 运行Notebook最后的打包单元格。</a:t>
-            </a:r>
-          </a:p>
-          <a:p>
-            <a:pPr>
-              <a:spcAft>
-                <a:spcPts val="600"/>
-              </a:spcAft>
-              <a:defRPr sz="2100" b="0">
-                <a:solidFill>
-                  <a:srgbClr val="243547"/>
-                </a:solidFill>
-                <a:latin typeface="Noto Sans CJK SC"/>
-              </a:defRPr>
-            </a:pPr>
-            <a:r>
-              <a:t>② 在文件面板下载byteformer_mnist_results.zip。</a:t>
-            </a:r>
-          </a:p>
-          <a:p>
-            <a:pPr>
-              <a:spcAft>
-                <a:spcPts val="600"/>
-              </a:spcAft>
-              <a:defRPr sz="2100" b="0">
-                <a:solidFill>
-                  <a:srgbClr val="243547"/>
-                </a:solidFill>
-                <a:latin typeface="Noto Sans CJK SC"/>
-              </a:defRPr>
-            </a:pPr>
-            <a:r>
-              <a:t>③ 用Word模板填写自己的环境、命令、指标和解释。</a:t>
-            </a:r>
-          </a:p>
-          <a:p>
-            <a:pPr>
-              <a:spcAft>
-                <a:spcPts val="600"/>
-              </a:spcAft>
-              <a:defRPr sz="2100" b="0">
-                <a:solidFill>
-                  <a:srgbClr val="243547"/>
-                </a:solidFill>
-                <a:latin typeface="Noto Sans CJK SC"/>
-              </a:defRPr>
-            </a:pPr>
-            <a:r>
-              <a:t>④ 附两组曲线、预测图、错例证据。</a:t>
-            </a:r>
-          </a:p>
-          <a:p>
-            <a:pPr>
-              <a:spcAft>
-                <a:spcPts val="600"/>
-              </a:spcAft>
-              <a:defRPr sz="2100" b="0">
-                <a:solidFill>
-                  <a:srgbClr val="243547"/>
-                </a:solidFill>
-                <a:latin typeface="Noto Sans CJK SC"/>
-              </a:defRPr>
-            </a:pPr>
-          </a:p>
-          <a:p>
-            <a:pPr>
-              <a:spcAft>
-                <a:spcPts val="600"/>
-              </a:spcAft>
-              <a:defRPr sz="2100" b="0">
-                <a:solidFill>
-                  <a:srgbClr val="243547"/>
-                </a:solidFill>
-                <a:latin typeface="Noto Sans CJK SC"/>
-              </a:defRPr>
-            </a:pPr>
-            <a:r>
-              <a:t>默认不用提交数据集、Python环境或大模型。</a:t>
-            </a:r>
-          </a:p>
-        </p:txBody>
-      </p:sp>
-      <p:sp>
-        <p:nvSpPr>
-          <p:cNvPr id="11" name="TextBox 10"/>
-          <p:cNvSpPr txBox="1"/>
-          <p:nvPr/>
-        </p:nvSpPr>
-        <p:spPr>
-          <a:xfrm>
-            <a:off x="6556248" y="1856231"/>
-            <a:ext cx="4572000" cy="429768"/>
-          </a:xfrm>
-          <a:prstGeom prst="rect">
-            <a:avLst/>
-          </a:prstGeom>
-          <a:noFill/>
-        </p:spPr>
-        <p:txBody>
-          <a:bodyPr wrap="square" lIns="27432" rIns="27432" tIns="18288" bIns="18288">
-            <a:spAutoFit/>
-          </a:bodyPr>
-          <a:lstStyle/>
-          <a:p>
-            <a:pPr>
-              <a:spcAft>
-                <a:spcPts val="600"/>
-              </a:spcAft>
               <a:defRPr sz="2300" b="1">
                 <a:solidFill>
                   <a:srgbClr val="176BA0"/>
@@ -7898,7 +7719,7 @@
       </p:sp>
       <p:sp>
         <p:nvSpPr>
-          <p:cNvPr id="12" name="Rectangle 11"/>
+          <p:cNvPr id="11" name="Rectangle 10"/>
           <p:cNvSpPr/>
           <p:nvPr/>
         </p:nvSpPr>
@@ -7941,7 +7762,7 @@
       </p:sp>
       <p:sp>
         <p:nvSpPr>
-          <p:cNvPr id="13" name="TextBox 12"/>
+          <p:cNvPr id="12" name="TextBox 11"/>
           <p:cNvSpPr txBox="1"/>
           <p:nvPr/>
         </p:nvSpPr>
@@ -7980,7 +7801,7 @@
       </p:sp>
       <p:sp>
         <p:nvSpPr>
-          <p:cNvPr id="14" name="TextBox 13"/>
+          <p:cNvPr id="13" name="TextBox 12"/>
           <p:cNvSpPr txBox="1"/>
           <p:nvPr/>
         </p:nvSpPr>
@@ -8019,7 +7840,7 @@
       </p:sp>
       <p:sp>
         <p:nvSpPr>
-          <p:cNvPr id="15" name="Rectangle 14"/>
+          <p:cNvPr id="14" name="Rectangle 13"/>
           <p:cNvSpPr/>
           <p:nvPr/>
         </p:nvSpPr>
@@ -8062,7 +7883,7 @@
       </p:sp>
       <p:sp>
         <p:nvSpPr>
-          <p:cNvPr id="16" name="TextBox 15"/>
+          <p:cNvPr id="15" name="TextBox 14"/>
           <p:cNvSpPr txBox="1"/>
           <p:nvPr/>
         </p:nvSpPr>
@@ -8101,7 +7922,7 @@
       </p:sp>
       <p:sp>
         <p:nvSpPr>
-          <p:cNvPr id="17" name="TextBox 16"/>
+          <p:cNvPr id="16" name="TextBox 15"/>
           <p:cNvSpPr txBox="1"/>
           <p:nvPr/>
         </p:nvSpPr>
@@ -8140,7 +7961,7 @@
       </p:sp>
       <p:sp>
         <p:nvSpPr>
-          <p:cNvPr id="18" name="Rectangle 17"/>
+          <p:cNvPr id="17" name="Rectangle 16"/>
           <p:cNvSpPr/>
           <p:nvPr/>
         </p:nvSpPr>
@@ -8183,7 +8004,7 @@
       </p:sp>
       <p:sp>
         <p:nvSpPr>
-          <p:cNvPr id="19" name="TextBox 18"/>
+          <p:cNvPr id="18" name="TextBox 17"/>
           <p:cNvSpPr txBox="1"/>
           <p:nvPr/>
         </p:nvSpPr>
@@ -8222,7 +8043,7 @@
       </p:sp>
       <p:sp>
         <p:nvSpPr>
-          <p:cNvPr id="20" name="TextBox 19"/>
+          <p:cNvPr id="19" name="TextBox 18"/>
           <p:cNvSpPr txBox="1"/>
           <p:nvPr/>
         </p:nvSpPr>
@@ -8261,7 +8082,7 @@
       </p:sp>
       <p:sp>
         <p:nvSpPr>
-          <p:cNvPr id="21" name="Rectangle 20"/>
+          <p:cNvPr id="20" name="Rectangle 19"/>
           <p:cNvSpPr/>
           <p:nvPr/>
         </p:nvSpPr>
@@ -8304,7 +8125,7 @@
       </p:sp>
       <p:sp>
         <p:nvSpPr>
-          <p:cNvPr id="22" name="TextBox 21"/>
+          <p:cNvPr id="21" name="TextBox 20"/>
           <p:cNvSpPr txBox="1"/>
           <p:nvPr/>
         </p:nvSpPr>
@@ -8343,7 +8164,7 @@
       </p:sp>
       <p:sp>
         <p:nvSpPr>
-          <p:cNvPr id="23" name="TextBox 22"/>
+          <p:cNvPr id="22" name="TextBox 21"/>
           <p:cNvSpPr txBox="1"/>
           <p:nvPr/>
         </p:nvSpPr>
@@ -8382,7 +8203,7 @@
       </p:sp>
       <p:sp>
         <p:nvSpPr>
-          <p:cNvPr id="24" name="Rectangle 23"/>
+          <p:cNvPr id="23" name="Rectangle 22"/>
           <p:cNvSpPr/>
           <p:nvPr/>
         </p:nvSpPr>
@@ -8425,7 +8246,7 @@
       </p:sp>
       <p:sp>
         <p:nvSpPr>
-          <p:cNvPr id="25" name="TextBox 24"/>
+          <p:cNvPr id="24" name="TextBox 23"/>
           <p:cNvSpPr txBox="1"/>
           <p:nvPr/>
         </p:nvSpPr>
@@ -8464,7 +8285,7 @@
       </p:sp>
       <p:sp>
         <p:nvSpPr>
-          <p:cNvPr id="26" name="TextBox 25"/>
+          <p:cNvPr id="25" name="TextBox 24"/>
           <p:cNvSpPr txBox="1"/>
           <p:nvPr/>
         </p:nvSpPr>
@@ -8503,7 +8324,7 @@
       </p:sp>
       <p:sp>
         <p:nvSpPr>
-          <p:cNvPr id="27" name="Rectangle 26"/>
+          <p:cNvPr id="26" name="Rectangle 25"/>
           <p:cNvSpPr/>
           <p:nvPr/>
         </p:nvSpPr>
@@ -8546,7 +8367,7 @@
       </p:sp>
       <p:sp>
         <p:nvSpPr>
-          <p:cNvPr id="28" name="TextBox 27"/>
+          <p:cNvPr id="27" name="TextBox 26"/>
           <p:cNvSpPr txBox="1"/>
           <p:nvPr/>
         </p:nvSpPr>
@@ -8585,7 +8406,7 @@
       </p:sp>
       <p:sp>
         <p:nvSpPr>
-          <p:cNvPr id="29" name="TextBox 28"/>
+          <p:cNvPr id="28" name="TextBox 27"/>
           <p:cNvSpPr txBox="1"/>
           <p:nvPr/>
         </p:nvSpPr>
@@ -8624,7 +8445,7 @@
       </p:sp>
       <p:sp>
         <p:nvSpPr>
-          <p:cNvPr id="30" name="TextBox 29"/>
+          <p:cNvPr id="29" name="TextBox 28"/>
           <p:cNvSpPr txBox="1"/>
           <p:nvPr/>
         </p:nvSpPr>
@@ -8957,8 +8778,8 @@
         </p:nvSpPr>
         <p:spPr>
           <a:xfrm>
-            <a:off x="1069848" y="6419088"/>
-            <a:ext cx="9144000" cy="228600"/>
+            <a:off x="11064240" y="6400800"/>
+            <a:ext cx="502920" cy="274320"/>
           </a:xfrm>
           <a:prstGeom prst="rect">
             <a:avLst/>
@@ -8971,11 +8792,11 @@
           </a:bodyPr>
           <a:lstStyle/>
           <a:p>
-            <a:pPr>
-              <a:spcAft>
-                <a:spcPts val="600"/>
-              </a:spcAft>
-              <a:defRPr sz="1000" b="0">
+            <a:pPr algn="r">
+              <a:spcAft>
+                <a:spcPts val="600"/>
+              </a:spcAft>
+              <a:defRPr sz="1100" b="0">
                 <a:solidFill>
                   <a:srgbClr val="647483"/>
                 </a:solidFill>
@@ -8983,7 +8804,7 @@
               </a:defRPr>
             </a:pPr>
             <a:r>
-              <a:t>Kaggle 免费 GPU 优先 · AutoDL 备用 · 记录自己的实验结果</a:t>
+              <a:t>15</a:t>
             </a:r>
           </a:p>
         </p:txBody>
@@ -8991,45 +8812,6 @@
       <p:sp>
         <p:nvSpPr>
           <p:cNvPr id="10" name="TextBox 9"/>
-          <p:cNvSpPr txBox="1"/>
-          <p:nvPr/>
-        </p:nvSpPr>
-        <p:spPr>
-          <a:xfrm>
-            <a:off x="11064240" y="6400800"/>
-            <a:ext cx="502920" cy="274320"/>
-          </a:xfrm>
-          <a:prstGeom prst="rect">
-            <a:avLst/>
-          </a:prstGeom>
-          <a:noFill/>
-        </p:spPr>
-        <p:txBody>
-          <a:bodyPr wrap="square" lIns="27432" rIns="27432" tIns="18288" bIns="18288">
-            <a:spAutoFit/>
-          </a:bodyPr>
-          <a:lstStyle/>
-          <a:p>
-            <a:pPr algn="r">
-              <a:spcAft>
-                <a:spcPts val="600"/>
-              </a:spcAft>
-              <a:defRPr sz="1100" b="0">
-                <a:solidFill>
-                  <a:srgbClr val="647483"/>
-                </a:solidFill>
-                <a:latin typeface="Noto Sans CJK SC"/>
-              </a:defRPr>
-            </a:pPr>
-            <a:r>
-              <a:t>15</a:t>
-            </a:r>
-          </a:p>
-        </p:txBody>
-      </p:sp>
-      <p:sp>
-        <p:nvSpPr>
-          <p:cNvPr id="11" name="TextBox 10"/>
           <p:cNvSpPr txBox="1"/>
           <p:nvPr/>
         </p:nvSpPr>
@@ -9071,7 +8853,7 @@
       </p:sp>
       <p:sp>
         <p:nvSpPr>
-          <p:cNvPr id="12" name="TextBox 11"/>
+          <p:cNvPr id="11" name="TextBox 10"/>
           <p:cNvSpPr txBox="1"/>
           <p:nvPr/>
         </p:nvSpPr>
@@ -9113,7 +8895,7 @@
       </p:sp>
       <p:sp>
         <p:nvSpPr>
-          <p:cNvPr id="13" name="TextBox 12"/>
+          <p:cNvPr id="12" name="TextBox 11"/>
           <p:cNvSpPr txBox="1"/>
           <p:nvPr/>
         </p:nvSpPr>
@@ -9155,7 +8937,7 @@
       </p:sp>
       <p:sp>
         <p:nvSpPr>
-          <p:cNvPr id="14" name="TextBox 13"/>
+          <p:cNvPr id="13" name="TextBox 12"/>
           <p:cNvSpPr txBox="1"/>
           <p:nvPr/>
         </p:nvSpPr>
@@ -9197,7 +8979,7 @@
       </p:sp>
       <p:sp>
         <p:nvSpPr>
-          <p:cNvPr id="15" name="TextBox 14"/>
+          <p:cNvPr id="14" name="TextBox 13"/>
           <p:cNvSpPr txBox="1"/>
           <p:nvPr/>
         </p:nvSpPr>
@@ -9239,7 +9021,7 @@
       </p:sp>
       <p:sp>
         <p:nvSpPr>
-          <p:cNvPr id="16" name="TextBox 15"/>
+          <p:cNvPr id="15" name="TextBox 14"/>
           <p:cNvSpPr txBox="1"/>
           <p:nvPr/>
         </p:nvSpPr>
@@ -9281,7 +9063,7 @@
       </p:sp>
       <p:sp>
         <p:nvSpPr>
-          <p:cNvPr id="17" name="TextBox 16"/>
+          <p:cNvPr id="16" name="TextBox 15"/>
           <p:cNvSpPr txBox="1"/>
           <p:nvPr/>
         </p:nvSpPr>
@@ -9575,8 +9357,8 @@
         </p:nvSpPr>
         <p:spPr>
           <a:xfrm>
-            <a:off x="1069848" y="6419088"/>
-            <a:ext cx="9144000" cy="228600"/>
+            <a:off x="11064240" y="6400800"/>
+            <a:ext cx="502920" cy="274320"/>
           </a:xfrm>
           <a:prstGeom prst="rect">
             <a:avLst/>
@@ -9589,11 +9371,11 @@
           </a:bodyPr>
           <a:lstStyle/>
           <a:p>
-            <a:pPr>
-              <a:spcAft>
-                <a:spcPts val="600"/>
-              </a:spcAft>
-              <a:defRPr sz="1000" b="0">
+            <a:pPr algn="r">
+              <a:spcAft>
+                <a:spcPts val="600"/>
+              </a:spcAft>
+              <a:defRPr sz="1100" b="0">
                 <a:solidFill>
                   <a:srgbClr val="647483"/>
                 </a:solidFill>
@@ -9601,45 +9383,6 @@
               </a:defRPr>
             </a:pPr>
             <a:r>
-              <a:t>Kaggle 免费 GPU 优先 · AutoDL 备用 · 记录自己的实验结果</a:t>
-            </a:r>
-          </a:p>
-        </p:txBody>
-      </p:sp>
-      <p:sp>
-        <p:nvSpPr>
-          <p:cNvPr id="9" name="TextBox 8"/>
-          <p:cNvSpPr txBox="1"/>
-          <p:nvPr/>
-        </p:nvSpPr>
-        <p:spPr>
-          <a:xfrm>
-            <a:off x="11064240" y="6400800"/>
-            <a:ext cx="502920" cy="274320"/>
-          </a:xfrm>
-          <a:prstGeom prst="rect">
-            <a:avLst/>
-          </a:prstGeom>
-          <a:noFill/>
-        </p:spPr>
-        <p:txBody>
-          <a:bodyPr wrap="square" lIns="27432" rIns="27432" tIns="18288" bIns="18288">
-            <a:spAutoFit/>
-          </a:bodyPr>
-          <a:lstStyle/>
-          <a:p>
-            <a:pPr algn="r">
-              <a:spcAft>
-                <a:spcPts val="600"/>
-              </a:spcAft>
-              <a:defRPr sz="1100" b="0">
-                <a:solidFill>
-                  <a:srgbClr val="647483"/>
-                </a:solidFill>
-                <a:latin typeface="Noto Sans CJK SC"/>
-              </a:defRPr>
-            </a:pPr>
-            <a:r>
               <a:t>2</a:t>
             </a:r>
           </a:p>
@@ -9647,7 +9390,7 @@
       </p:sp>
       <p:sp>
         <p:nvSpPr>
-          <p:cNvPr id="10" name="Rectangle 9"/>
+          <p:cNvPr id="9" name="Rectangle 8"/>
           <p:cNvSpPr/>
           <p:nvPr/>
         </p:nvSpPr>
@@ -9690,7 +9433,7 @@
       </p:sp>
       <p:sp>
         <p:nvSpPr>
-          <p:cNvPr id="11" name="TextBox 10"/>
+          <p:cNvPr id="10" name="TextBox 9"/>
           <p:cNvSpPr txBox="1"/>
           <p:nvPr/>
         </p:nvSpPr>
@@ -9729,7 +9472,7 @@
       </p:sp>
       <p:sp>
         <p:nvSpPr>
-          <p:cNvPr id="12" name="TextBox 11"/>
+          <p:cNvPr id="11" name="TextBox 10"/>
           <p:cNvSpPr txBox="1"/>
           <p:nvPr/>
         </p:nvSpPr>
@@ -9768,7 +9511,7 @@
       </p:sp>
       <p:sp>
         <p:nvSpPr>
-          <p:cNvPr id="13" name="Rectangle 12"/>
+          <p:cNvPr id="12" name="Rectangle 11"/>
           <p:cNvSpPr/>
           <p:nvPr/>
         </p:nvSpPr>
@@ -9811,7 +9554,7 @@
       </p:sp>
       <p:sp>
         <p:nvSpPr>
-          <p:cNvPr id="14" name="TextBox 13"/>
+          <p:cNvPr id="13" name="TextBox 12"/>
           <p:cNvSpPr txBox="1"/>
           <p:nvPr/>
         </p:nvSpPr>
@@ -9850,7 +9593,7 @@
       </p:sp>
       <p:sp>
         <p:nvSpPr>
-          <p:cNvPr id="15" name="TextBox 14"/>
+          <p:cNvPr id="14" name="TextBox 13"/>
           <p:cNvSpPr txBox="1"/>
           <p:nvPr/>
         </p:nvSpPr>
@@ -9882,14 +9625,14 @@
               </a:defRPr>
             </a:pPr>
             <a:r>
-              <a:t>运行基线 → 把训练轮数8改为10 → 查看并解释一个错例。</a:t>
-            </a:r>
-          </a:p>
-        </p:txBody>
-      </p:sp>
-      <p:sp>
-        <p:nvSpPr>
-          <p:cNvPr id="16" name="Rectangle 15"/>
+              <a:t>自行设置轮数并微调 → 观察验证曲线 → 查看并解释一个错例。</a:t>
+            </a:r>
+          </a:p>
+        </p:txBody>
+      </p:sp>
+      <p:sp>
+        <p:nvSpPr>
+          <p:cNvPr id="15" name="Rectangle 14"/>
           <p:cNvSpPr/>
           <p:nvPr/>
         </p:nvSpPr>
@@ -9932,7 +9675,7 @@
       </p:sp>
       <p:sp>
         <p:nvSpPr>
-          <p:cNvPr id="17" name="TextBox 16"/>
+          <p:cNvPr id="16" name="TextBox 15"/>
           <p:cNvSpPr txBox="1"/>
           <p:nvPr/>
         </p:nvSpPr>
@@ -9971,7 +9714,7 @@
       </p:sp>
       <p:sp>
         <p:nvSpPr>
-          <p:cNvPr id="18" name="TextBox 17"/>
+          <p:cNvPr id="17" name="TextBox 16"/>
           <p:cNvSpPr txBox="1"/>
           <p:nvPr/>
         </p:nvSpPr>
@@ -10265,8 +10008,8 @@
         </p:nvSpPr>
         <p:spPr>
           <a:xfrm>
-            <a:off x="1069848" y="6419088"/>
-            <a:ext cx="9144000" cy="228600"/>
+            <a:off x="11064240" y="6400800"/>
+            <a:ext cx="502920" cy="274320"/>
           </a:xfrm>
           <a:prstGeom prst="rect">
             <a:avLst/>
@@ -10279,11 +10022,11 @@
           </a:bodyPr>
           <a:lstStyle/>
           <a:p>
-            <a:pPr>
-              <a:spcAft>
-                <a:spcPts val="600"/>
-              </a:spcAft>
-              <a:defRPr sz="1000" b="0">
+            <a:pPr algn="r">
+              <a:spcAft>
+                <a:spcPts val="600"/>
+              </a:spcAft>
+              <a:defRPr sz="1100" b="0">
                 <a:solidFill>
                   <a:srgbClr val="647483"/>
                 </a:solidFill>
@@ -10291,45 +10034,6 @@
               </a:defRPr>
             </a:pPr>
             <a:r>
-              <a:t>Kaggle 免费 GPU 优先 · AutoDL 备用 · 记录自己的实验结果</a:t>
-            </a:r>
-          </a:p>
-        </p:txBody>
-      </p:sp>
-      <p:sp>
-        <p:nvSpPr>
-          <p:cNvPr id="9" name="TextBox 8"/>
-          <p:cNvSpPr txBox="1"/>
-          <p:nvPr/>
-        </p:nvSpPr>
-        <p:spPr>
-          <a:xfrm>
-            <a:off x="11064240" y="6400800"/>
-            <a:ext cx="502920" cy="274320"/>
-          </a:xfrm>
-          <a:prstGeom prst="rect">
-            <a:avLst/>
-          </a:prstGeom>
-          <a:noFill/>
-        </p:spPr>
-        <p:txBody>
-          <a:bodyPr wrap="square" lIns="27432" rIns="27432" tIns="18288" bIns="18288">
-            <a:spAutoFit/>
-          </a:bodyPr>
-          <a:lstStyle/>
-          <a:p>
-            <a:pPr algn="r">
-              <a:spcAft>
-                <a:spcPts val="600"/>
-              </a:spcAft>
-              <a:defRPr sz="1100" b="0">
-                <a:solidFill>
-                  <a:srgbClr val="647483"/>
-                </a:solidFill>
-                <a:latin typeface="Noto Sans CJK SC"/>
-              </a:defRPr>
-            </a:pPr>
-            <a:r>
               <a:t>3</a:t>
             </a:r>
           </a:p>
@@ -10337,7 +10041,7 @@
       </p:sp>
       <p:sp>
         <p:nvSpPr>
-          <p:cNvPr id="10" name="Rounded Rectangle 9"/>
+          <p:cNvPr id="9" name="Rounded Rectangle 8"/>
           <p:cNvSpPr/>
           <p:nvPr/>
         </p:nvSpPr>
@@ -10380,7 +10084,7 @@
       </p:sp>
       <p:sp>
         <p:nvSpPr>
-          <p:cNvPr id="11" name="TextBox 10"/>
+          <p:cNvPr id="10" name="TextBox 9"/>
           <p:cNvSpPr txBox="1"/>
           <p:nvPr/>
         </p:nvSpPr>
@@ -10419,7 +10123,7 @@
       </p:sp>
       <p:sp>
         <p:nvSpPr>
-          <p:cNvPr id="12" name="TextBox 11"/>
+          <p:cNvPr id="11" name="TextBox 10"/>
           <p:cNvSpPr txBox="1"/>
           <p:nvPr/>
         </p:nvSpPr>
@@ -10458,7 +10162,7 @@
       </p:sp>
       <p:sp>
         <p:nvSpPr>
-          <p:cNvPr id="13" name="Rounded Rectangle 12"/>
+          <p:cNvPr id="12" name="Rounded Rectangle 11"/>
           <p:cNvSpPr/>
           <p:nvPr/>
         </p:nvSpPr>
@@ -10501,7 +10205,7 @@
       </p:sp>
       <p:sp>
         <p:nvSpPr>
-          <p:cNvPr id="14" name="TextBox 13"/>
+          <p:cNvPr id="13" name="TextBox 12"/>
           <p:cNvSpPr txBox="1"/>
           <p:nvPr/>
         </p:nvSpPr>
@@ -10540,7 +10244,7 @@
       </p:sp>
       <p:sp>
         <p:nvSpPr>
-          <p:cNvPr id="15" name="TextBox 14"/>
+          <p:cNvPr id="14" name="TextBox 13"/>
           <p:cNvSpPr txBox="1"/>
           <p:nvPr/>
         </p:nvSpPr>
@@ -10579,7 +10283,7 @@
       </p:sp>
       <p:sp>
         <p:nvSpPr>
-          <p:cNvPr id="16" name="Rounded Rectangle 15"/>
+          <p:cNvPr id="15" name="Rounded Rectangle 14"/>
           <p:cNvSpPr/>
           <p:nvPr/>
         </p:nvSpPr>
@@ -10622,7 +10326,7 @@
       </p:sp>
       <p:sp>
         <p:nvSpPr>
-          <p:cNvPr id="17" name="TextBox 16"/>
+          <p:cNvPr id="16" name="TextBox 15"/>
           <p:cNvSpPr txBox="1"/>
           <p:nvPr/>
         </p:nvSpPr>
@@ -10661,7 +10365,7 @@
       </p:sp>
       <p:sp>
         <p:nvSpPr>
-          <p:cNvPr id="18" name="TextBox 17"/>
+          <p:cNvPr id="17" name="TextBox 16"/>
           <p:cNvSpPr txBox="1"/>
           <p:nvPr/>
         </p:nvSpPr>
@@ -10700,7 +10404,7 @@
       </p:sp>
       <p:sp>
         <p:nvSpPr>
-          <p:cNvPr id="19" name="Rounded Rectangle 18"/>
+          <p:cNvPr id="18" name="Rounded Rectangle 17"/>
           <p:cNvSpPr/>
           <p:nvPr/>
         </p:nvSpPr>
@@ -10743,7 +10447,7 @@
       </p:sp>
       <p:sp>
         <p:nvSpPr>
-          <p:cNvPr id="20" name="TextBox 19"/>
+          <p:cNvPr id="19" name="TextBox 18"/>
           <p:cNvSpPr txBox="1"/>
           <p:nvPr/>
         </p:nvSpPr>
@@ -10782,7 +10486,7 @@
       </p:sp>
       <p:sp>
         <p:nvSpPr>
-          <p:cNvPr id="21" name="TextBox 20"/>
+          <p:cNvPr id="20" name="TextBox 19"/>
           <p:cNvSpPr txBox="1"/>
           <p:nvPr/>
         </p:nvSpPr>
@@ -10821,7 +10525,7 @@
       </p:sp>
       <p:sp>
         <p:nvSpPr>
-          <p:cNvPr id="22" name="Rounded Rectangle 21"/>
+          <p:cNvPr id="21" name="Rounded Rectangle 20"/>
           <p:cNvSpPr/>
           <p:nvPr/>
         </p:nvSpPr>
@@ -10864,7 +10568,7 @@
       </p:sp>
       <p:sp>
         <p:nvSpPr>
-          <p:cNvPr id="23" name="TextBox 22"/>
+          <p:cNvPr id="22" name="TextBox 21"/>
           <p:cNvSpPr txBox="1"/>
           <p:nvPr/>
         </p:nvSpPr>
@@ -10903,7 +10607,7 @@
       </p:sp>
       <p:sp>
         <p:nvSpPr>
-          <p:cNvPr id="24" name="TextBox 23"/>
+          <p:cNvPr id="23" name="TextBox 22"/>
           <p:cNvSpPr txBox="1"/>
           <p:nvPr/>
         </p:nvSpPr>
@@ -10974,7 +10678,7 @@
       </p:sp>
       <p:sp>
         <p:nvSpPr>
-          <p:cNvPr id="25" name="TextBox 24"/>
+          <p:cNvPr id="24" name="TextBox 23"/>
           <p:cNvSpPr txBox="1"/>
           <p:nvPr/>
         </p:nvSpPr>
@@ -11268,8 +10972,8 @@
         </p:nvSpPr>
         <p:spPr>
           <a:xfrm>
-            <a:off x="1069848" y="6419088"/>
-            <a:ext cx="9144000" cy="228600"/>
+            <a:off x="11064240" y="6400800"/>
+            <a:ext cx="502920" cy="274320"/>
           </a:xfrm>
           <a:prstGeom prst="rect">
             <a:avLst/>
@@ -11282,45 +10986,6 @@
           </a:bodyPr>
           <a:lstStyle/>
           <a:p>
-            <a:pPr>
-              <a:spcAft>
-                <a:spcPts val="600"/>
-              </a:spcAft>
-              <a:defRPr sz="1000" b="0">
-                <a:solidFill>
-                  <a:srgbClr val="647483"/>
-                </a:solidFill>
-                <a:latin typeface="Noto Sans CJK SC"/>
-              </a:defRPr>
-            </a:pPr>
-            <a:r>
-              <a:t>Kaggle 免费 GPU 优先 · AutoDL 备用 · 记录自己的实验结果</a:t>
-            </a:r>
-          </a:p>
-        </p:txBody>
-      </p:sp>
-      <p:sp>
-        <p:nvSpPr>
-          <p:cNvPr id="9" name="TextBox 8"/>
-          <p:cNvSpPr txBox="1"/>
-          <p:nvPr/>
-        </p:nvSpPr>
-        <p:spPr>
-          <a:xfrm>
-            <a:off x="11064240" y="6400800"/>
-            <a:ext cx="502920" cy="274320"/>
-          </a:xfrm>
-          <a:prstGeom prst="rect">
-            <a:avLst/>
-          </a:prstGeom>
-          <a:noFill/>
-        </p:spPr>
-        <p:txBody>
-          <a:bodyPr wrap="square" lIns="27432" rIns="27432" tIns="18288" bIns="18288">
-            <a:spAutoFit/>
-          </a:bodyPr>
-          <a:lstStyle/>
-          <a:p>
             <a:pPr algn="r">
               <a:spcAft>
                 <a:spcPts val="600"/>
@@ -11340,7 +11005,7 @@
       </p:sp>
       <p:pic>
         <p:nvPicPr>
-          <p:cNvPr id="10" name="Picture 9" descr="mnist_digits.png"/>
+          <p:cNvPr id="9" name="Picture 8" descr="mnist_digits.png"/>
           <p:cNvPicPr>
             <a:picLocks noChangeAspect="1"/>
           </p:cNvPicPr>
@@ -11364,7 +11029,7 @@
       </p:pic>
       <p:sp>
         <p:nvSpPr>
-          <p:cNvPr id="11" name="TextBox 10"/>
+          <p:cNvPr id="10" name="TextBox 9"/>
           <p:cNvSpPr txBox="1"/>
           <p:nvPr/>
         </p:nvSpPr>
@@ -11419,7 +11084,7 @@
       </p:sp>
       <p:sp>
         <p:nvSpPr>
-          <p:cNvPr id="12" name="Rounded Rectangle 11"/>
+          <p:cNvPr id="11" name="Rounded Rectangle 10"/>
           <p:cNvSpPr/>
           <p:nvPr/>
         </p:nvSpPr>
@@ -11462,7 +11127,7 @@
       </p:sp>
       <p:sp>
         <p:nvSpPr>
-          <p:cNvPr id="13" name="TextBox 12"/>
+          <p:cNvPr id="12" name="TextBox 11"/>
           <p:cNvSpPr txBox="1"/>
           <p:nvPr/>
         </p:nvSpPr>
@@ -11517,7 +11182,7 @@
       </p:sp>
       <p:sp>
         <p:nvSpPr>
-          <p:cNvPr id="14" name="TextBox 13"/>
+          <p:cNvPr id="13" name="TextBox 12"/>
           <p:cNvSpPr txBox="1"/>
           <p:nvPr/>
         </p:nvSpPr>
@@ -11556,7 +11221,7 @@
       </p:sp>
       <p:sp>
         <p:nvSpPr>
-          <p:cNvPr id="15" name="Rounded Rectangle 14"/>
+          <p:cNvPr id="14" name="Rounded Rectangle 13"/>
           <p:cNvSpPr/>
           <p:nvPr/>
         </p:nvSpPr>
@@ -11599,7 +11264,7 @@
       </p:sp>
       <p:sp>
         <p:nvSpPr>
-          <p:cNvPr id="16" name="TextBox 15"/>
+          <p:cNvPr id="15" name="TextBox 14"/>
           <p:cNvSpPr txBox="1"/>
           <p:nvPr/>
         </p:nvSpPr>
@@ -11654,7 +11319,7 @@
       </p:sp>
       <p:sp>
         <p:nvSpPr>
-          <p:cNvPr id="17" name="TextBox 16"/>
+          <p:cNvPr id="16" name="TextBox 15"/>
           <p:cNvSpPr txBox="1"/>
           <p:nvPr/>
         </p:nvSpPr>
@@ -11693,7 +11358,7 @@
       </p:sp>
       <p:sp>
         <p:nvSpPr>
-          <p:cNvPr id="18" name="Rounded Rectangle 17"/>
+          <p:cNvPr id="17" name="Rounded Rectangle 16"/>
           <p:cNvSpPr/>
           <p:nvPr/>
         </p:nvSpPr>
@@ -11736,7 +11401,7 @@
       </p:sp>
       <p:sp>
         <p:nvSpPr>
-          <p:cNvPr id="19" name="TextBox 18"/>
+          <p:cNvPr id="18" name="TextBox 17"/>
           <p:cNvSpPr txBox="1"/>
           <p:nvPr/>
         </p:nvSpPr>
@@ -11791,7 +11456,7 @@
       </p:sp>
       <p:sp>
         <p:nvSpPr>
-          <p:cNvPr id="20" name="TextBox 19"/>
+          <p:cNvPr id="19" name="TextBox 18"/>
           <p:cNvSpPr txBox="1"/>
           <p:nvPr/>
         </p:nvSpPr>
@@ -11830,7 +11495,7 @@
       </p:sp>
       <p:sp>
         <p:nvSpPr>
-          <p:cNvPr id="21" name="TextBox 20"/>
+          <p:cNvPr id="20" name="TextBox 19"/>
           <p:cNvSpPr txBox="1"/>
           <p:nvPr/>
         </p:nvSpPr>
@@ -12163,8 +11828,8 @@
         </p:nvSpPr>
         <p:spPr>
           <a:xfrm>
-            <a:off x="1069848" y="6419088"/>
-            <a:ext cx="9144000" cy="228600"/>
+            <a:off x="11064240" y="6400800"/>
+            <a:ext cx="502920" cy="274320"/>
           </a:xfrm>
           <a:prstGeom prst="rect">
             <a:avLst/>
@@ -12177,45 +11842,6 @@
           </a:bodyPr>
           <a:lstStyle/>
           <a:p>
-            <a:pPr>
-              <a:spcAft>
-                <a:spcPts val="600"/>
-              </a:spcAft>
-              <a:defRPr sz="1000" b="0">
-                <a:solidFill>
-                  <a:srgbClr val="647483"/>
-                </a:solidFill>
-                <a:latin typeface="Noto Sans CJK SC"/>
-              </a:defRPr>
-            </a:pPr>
-            <a:r>
-              <a:t>Kaggle 免费 GPU 优先 · AutoDL 备用 · 记录自己的实验结果</a:t>
-            </a:r>
-          </a:p>
-        </p:txBody>
-      </p:sp>
-      <p:sp>
-        <p:nvSpPr>
-          <p:cNvPr id="10" name="TextBox 9"/>
-          <p:cNvSpPr txBox="1"/>
-          <p:nvPr/>
-        </p:nvSpPr>
-        <p:spPr>
-          <a:xfrm>
-            <a:off x="11064240" y="6400800"/>
-            <a:ext cx="502920" cy="274320"/>
-          </a:xfrm>
-          <a:prstGeom prst="rect">
-            <a:avLst/>
-          </a:prstGeom>
-          <a:noFill/>
-        </p:spPr>
-        <p:txBody>
-          <a:bodyPr wrap="square" lIns="27432" rIns="27432" tIns="18288" bIns="18288">
-            <a:spAutoFit/>
-          </a:bodyPr>
-          <a:lstStyle/>
-          <a:p>
             <a:pPr algn="r">
               <a:spcAft>
                 <a:spcPts val="600"/>
@@ -12235,7 +11861,7 @@
       </p:sp>
       <p:graphicFrame>
         <p:nvGraphicFramePr>
-          <p:cNvPr id="11" name="Table 10"/>
+          <p:cNvPr id="10" name="Table 9"/>
           <p:cNvGraphicFramePr>
             <a:graphicFrameLocks noGrp="1"/>
           </p:cNvGraphicFramePr>
@@ -12558,7 +12184,7 @@
       </p:graphicFrame>
       <p:sp>
         <p:nvSpPr>
-          <p:cNvPr id="12" name="TextBox 11"/>
+          <p:cNvPr id="11" name="TextBox 10"/>
           <p:cNvSpPr txBox="1"/>
           <p:nvPr/>
         </p:nvSpPr>
@@ -12600,7 +12226,7 @@
       </p:sp>
       <p:sp>
         <p:nvSpPr>
-          <p:cNvPr id="13" name="TextBox 12"/>
+          <p:cNvPr id="12" name="TextBox 11"/>
           <p:cNvSpPr txBox="1"/>
           <p:nvPr/>
         </p:nvSpPr>
@@ -12642,7 +12268,7 @@
       </p:sp>
       <p:sp>
         <p:nvSpPr>
-          <p:cNvPr id="14" name="TextBox 13"/>
+          <p:cNvPr id="13" name="TextBox 12"/>
           <p:cNvSpPr txBox="1"/>
           <p:nvPr/>
         </p:nvSpPr>
@@ -12936,8 +12562,8 @@
         </p:nvSpPr>
         <p:spPr>
           <a:xfrm>
-            <a:off x="1069848" y="6419088"/>
-            <a:ext cx="9144000" cy="228600"/>
+            <a:off x="11064240" y="6400800"/>
+            <a:ext cx="502920" cy="274320"/>
           </a:xfrm>
           <a:prstGeom prst="rect">
             <a:avLst/>
@@ -12950,11 +12576,11 @@
           </a:bodyPr>
           <a:lstStyle/>
           <a:p>
-            <a:pPr>
-              <a:spcAft>
-                <a:spcPts val="600"/>
-              </a:spcAft>
-              <a:defRPr sz="1000" b="0">
+            <a:pPr algn="r">
+              <a:spcAft>
+                <a:spcPts val="600"/>
+              </a:spcAft>
+              <a:defRPr sz="1100" b="0">
                 <a:solidFill>
                   <a:srgbClr val="647483"/>
                 </a:solidFill>
@@ -12962,7 +12588,7 @@
               </a:defRPr>
             </a:pPr>
             <a:r>
-              <a:t>Kaggle 免费 GPU 优先 · AutoDL 备用 · 记录自己的实验结果</a:t>
+              <a:t>6</a:t>
             </a:r>
           </a:p>
         </p:txBody>
@@ -12975,8 +12601,8 @@
         </p:nvSpPr>
         <p:spPr>
           <a:xfrm>
-            <a:off x="11064240" y="6400800"/>
-            <a:ext cx="502920" cy="274320"/>
+            <a:off x="777240" y="1810512"/>
+            <a:ext cx="5486400" cy="3611880"/>
           </a:xfrm>
           <a:prstGeom prst="rect">
             <a:avLst/>
@@ -12989,45 +12615,6 @@
           </a:bodyPr>
           <a:lstStyle/>
           <a:p>
-            <a:pPr algn="r">
-              <a:spcAft>
-                <a:spcPts val="600"/>
-              </a:spcAft>
-              <a:defRPr sz="1100" b="0">
-                <a:solidFill>
-                  <a:srgbClr val="647483"/>
-                </a:solidFill>
-                <a:latin typeface="Noto Sans CJK SC"/>
-              </a:defRPr>
-            </a:pPr>
-            <a:r>
-              <a:t>6</a:t>
-            </a:r>
-          </a:p>
-        </p:txBody>
-      </p:sp>
-      <p:sp>
-        <p:nvSpPr>
-          <p:cNvPr id="10" name="TextBox 9"/>
-          <p:cNvSpPr txBox="1"/>
-          <p:nvPr/>
-        </p:nvSpPr>
-        <p:spPr>
-          <a:xfrm>
-            <a:off x="777240" y="1810512"/>
-            <a:ext cx="5486400" cy="3611880"/>
-          </a:xfrm>
-          <a:prstGeom prst="rect">
-            <a:avLst/>
-          </a:prstGeom>
-          <a:noFill/>
-        </p:spPr>
-        <p:txBody>
-          <a:bodyPr wrap="square" lIns="27432" rIns="27432" tIns="18288" bIns="18288">
-            <a:spAutoFit/>
-          </a:bodyPr>
-          <a:lstStyle/>
-          <a:p>
             <a:pPr>
               <a:spcAft>
                 <a:spcPts val="600"/>
@@ -13111,7 +12698,7 @@
       </p:sp>
       <p:sp>
         <p:nvSpPr>
-          <p:cNvPr id="11" name="Rounded Rectangle 10"/>
+          <p:cNvPr id="10" name="Rounded Rectangle 9"/>
           <p:cNvSpPr/>
           <p:nvPr/>
         </p:nvSpPr>
@@ -13154,7 +12741,7 @@
       </p:sp>
       <p:sp>
         <p:nvSpPr>
-          <p:cNvPr id="12" name="TextBox 11"/>
+          <p:cNvPr id="11" name="TextBox 10"/>
           <p:cNvSpPr txBox="1"/>
           <p:nvPr/>
         </p:nvSpPr>
@@ -13225,7 +12812,7 @@
       </p:sp>
       <p:sp>
         <p:nvSpPr>
-          <p:cNvPr id="13" name="TextBox 12"/>
+          <p:cNvPr id="12" name="TextBox 11"/>
           <p:cNvSpPr txBox="1"/>
           <p:nvPr/>
         </p:nvSpPr>
@@ -13312,7 +12899,7 @@
       </p:sp>
       <p:sp>
         <p:nvSpPr>
-          <p:cNvPr id="14" name="TextBox 13"/>
+          <p:cNvPr id="13" name="TextBox 12"/>
           <p:cNvSpPr txBox="1"/>
           <p:nvPr/>
         </p:nvSpPr>
@@ -13344,7 +12931,7 @@
               </a:defRPr>
             </a:pPr>
             <a:r>
-              <a:t>首次不要直接Run All：练习单元格需要亲手把EPOCHS从8改为10。</a:t>
+              <a:t>按顺序逐格运行：训练单元格会提示输入自己选择的轮数。</a:t>
             </a:r>
           </a:p>
         </p:txBody>
@@ -13645,8 +13232,8 @@
         </p:nvSpPr>
         <p:spPr>
           <a:xfrm>
-            <a:off x="1069848" y="6419088"/>
-            <a:ext cx="9144000" cy="228600"/>
+            <a:off x="11064240" y="6400800"/>
+            <a:ext cx="502920" cy="274320"/>
           </a:xfrm>
           <a:prstGeom prst="rect">
             <a:avLst/>
@@ -13659,11 +13246,11 @@
           </a:bodyPr>
           <a:lstStyle/>
           <a:p>
-            <a:pPr>
-              <a:spcAft>
-                <a:spcPts val="600"/>
-              </a:spcAft>
-              <a:defRPr sz="1000" b="0">
+            <a:pPr algn="r">
+              <a:spcAft>
+                <a:spcPts val="600"/>
+              </a:spcAft>
+              <a:defRPr sz="1100" b="0">
                 <a:solidFill>
                   <a:srgbClr val="647483"/>
                 </a:solidFill>
@@ -13671,45 +13258,6 @@
               </a:defRPr>
             </a:pPr>
             <a:r>
-              <a:t>Kaggle 免费 GPU 优先 · AutoDL 备用 · 记录自己的实验结果</a:t>
-            </a:r>
-          </a:p>
-        </p:txBody>
-      </p:sp>
-      <p:sp>
-        <p:nvSpPr>
-          <p:cNvPr id="10" name="TextBox 9"/>
-          <p:cNvSpPr txBox="1"/>
-          <p:nvPr/>
-        </p:nvSpPr>
-        <p:spPr>
-          <a:xfrm>
-            <a:off x="11064240" y="6400800"/>
-            <a:ext cx="502920" cy="274320"/>
-          </a:xfrm>
-          <a:prstGeom prst="rect">
-            <a:avLst/>
-          </a:prstGeom>
-          <a:noFill/>
-        </p:spPr>
-        <p:txBody>
-          <a:bodyPr wrap="square" lIns="27432" rIns="27432" tIns="18288" bIns="18288">
-            <a:spAutoFit/>
-          </a:bodyPr>
-          <a:lstStyle/>
-          <a:p>
-            <a:pPr algn="r">
-              <a:spcAft>
-                <a:spcPts val="600"/>
-              </a:spcAft>
-              <a:defRPr sz="1100" b="0">
-                <a:solidFill>
-                  <a:srgbClr val="647483"/>
-                </a:solidFill>
-                <a:latin typeface="Noto Sans CJK SC"/>
-              </a:defRPr>
-            </a:pPr>
-            <a:r>
               <a:t>7</a:t>
             </a:r>
           </a:p>
@@ -13717,7 +13265,7 @@
       </p:sp>
       <p:sp>
         <p:nvSpPr>
-          <p:cNvPr id="11" name="Rounded Rectangle 10"/>
+          <p:cNvPr id="10" name="Rounded Rectangle 9"/>
           <p:cNvSpPr/>
           <p:nvPr/>
         </p:nvSpPr>
@@ -13760,7 +13308,7 @@
       </p:sp>
       <p:sp>
         <p:nvSpPr>
-          <p:cNvPr id="12" name="TextBox 11"/>
+          <p:cNvPr id="11" name="TextBox 10"/>
           <p:cNvSpPr txBox="1"/>
           <p:nvPr/>
         </p:nvSpPr>
@@ -13847,7 +13395,7 @@
       </p:sp>
       <p:sp>
         <p:nvSpPr>
-          <p:cNvPr id="13" name="TextBox 12"/>
+          <p:cNvPr id="12" name="TextBox 11"/>
           <p:cNvSpPr txBox="1"/>
           <p:nvPr/>
         </p:nvSpPr>
@@ -13886,7 +13434,7 @@
       </p:sp>
       <p:sp>
         <p:nvSpPr>
-          <p:cNvPr id="14" name="TextBox 13"/>
+          <p:cNvPr id="13" name="TextBox 12"/>
           <p:cNvSpPr txBox="1"/>
           <p:nvPr/>
         </p:nvSpPr>
@@ -14196,8 +13744,8 @@
         </p:nvSpPr>
         <p:spPr>
           <a:xfrm>
-            <a:off x="1069848" y="6419088"/>
-            <a:ext cx="9144000" cy="228600"/>
+            <a:off x="11064240" y="6400800"/>
+            <a:ext cx="502920" cy="274320"/>
           </a:xfrm>
           <a:prstGeom prst="rect">
             <a:avLst/>
@@ -14210,11 +13758,11 @@
           </a:bodyPr>
           <a:lstStyle/>
           <a:p>
-            <a:pPr>
-              <a:spcAft>
-                <a:spcPts val="600"/>
-              </a:spcAft>
-              <a:defRPr sz="1000" b="0">
+            <a:pPr algn="r">
+              <a:spcAft>
+                <a:spcPts val="600"/>
+              </a:spcAft>
+              <a:defRPr sz="1100" b="0">
                 <a:solidFill>
                   <a:srgbClr val="647483"/>
                 </a:solidFill>
@@ -14222,45 +13770,6 @@
               </a:defRPr>
             </a:pPr>
             <a:r>
-              <a:t>Kaggle 免费 GPU 优先 · AutoDL 备用 · 记录自己的实验结果</a:t>
-            </a:r>
-          </a:p>
-        </p:txBody>
-      </p:sp>
-      <p:sp>
-        <p:nvSpPr>
-          <p:cNvPr id="9" name="TextBox 8"/>
-          <p:cNvSpPr txBox="1"/>
-          <p:nvPr/>
-        </p:nvSpPr>
-        <p:spPr>
-          <a:xfrm>
-            <a:off x="11064240" y="6400800"/>
-            <a:ext cx="502920" cy="274320"/>
-          </a:xfrm>
-          <a:prstGeom prst="rect">
-            <a:avLst/>
-          </a:prstGeom>
-          <a:noFill/>
-        </p:spPr>
-        <p:txBody>
-          <a:bodyPr wrap="square" lIns="27432" rIns="27432" tIns="18288" bIns="18288">
-            <a:spAutoFit/>
-          </a:bodyPr>
-          <a:lstStyle/>
-          <a:p>
-            <a:pPr algn="r">
-              <a:spcAft>
-                <a:spcPts val="600"/>
-              </a:spcAft>
-              <a:defRPr sz="1100" b="0">
-                <a:solidFill>
-                  <a:srgbClr val="647483"/>
-                </a:solidFill>
-                <a:latin typeface="Noto Sans CJK SC"/>
-              </a:defRPr>
-            </a:pPr>
-            <a:r>
               <a:t>8</a:t>
             </a:r>
           </a:p>
@@ -14268,7 +13777,7 @@
       </p:sp>
       <p:sp>
         <p:nvSpPr>
-          <p:cNvPr id="10" name="Rectangle 9"/>
+          <p:cNvPr id="9" name="Rectangle 8"/>
           <p:cNvSpPr/>
           <p:nvPr/>
         </p:nvSpPr>
@@ -14311,7 +13820,7 @@
       </p:sp>
       <p:sp>
         <p:nvSpPr>
-          <p:cNvPr id="11" name="TextBox 10"/>
+          <p:cNvPr id="10" name="TextBox 9"/>
           <p:cNvSpPr txBox="1"/>
           <p:nvPr/>
         </p:nvSpPr>
@@ -14350,7 +13859,7 @@
       </p:sp>
       <p:sp>
         <p:nvSpPr>
-          <p:cNvPr id="12" name="TextBox 11"/>
+          <p:cNvPr id="11" name="TextBox 10"/>
           <p:cNvSpPr txBox="1"/>
           <p:nvPr/>
         </p:nvSpPr>
@@ -14389,7 +13898,7 @@
       </p:sp>
       <p:sp>
         <p:nvSpPr>
-          <p:cNvPr id="13" name="Rectangle 12"/>
+          <p:cNvPr id="12" name="Rectangle 11"/>
           <p:cNvSpPr/>
           <p:nvPr/>
         </p:nvSpPr>
@@ -14432,7 +13941,7 @@
       </p:sp>
       <p:sp>
         <p:nvSpPr>
-          <p:cNvPr id="14" name="TextBox 13"/>
+          <p:cNvPr id="13" name="TextBox 12"/>
           <p:cNvSpPr txBox="1"/>
           <p:nvPr/>
         </p:nvSpPr>
@@ -14471,7 +13980,7 @@
       </p:sp>
       <p:sp>
         <p:nvSpPr>
-          <p:cNvPr id="15" name="TextBox 14"/>
+          <p:cNvPr id="14" name="TextBox 13"/>
           <p:cNvSpPr txBox="1"/>
           <p:nvPr/>
         </p:nvSpPr>
@@ -14510,7 +14019,7 @@
       </p:sp>
       <p:sp>
         <p:nvSpPr>
-          <p:cNvPr id="16" name="Rectangle 15"/>
+          <p:cNvPr id="15" name="Rectangle 14"/>
           <p:cNvSpPr/>
           <p:nvPr/>
         </p:nvSpPr>
@@ -14553,7 +14062,7 @@
       </p:sp>
       <p:sp>
         <p:nvSpPr>
-          <p:cNvPr id="17" name="TextBox 16"/>
+          <p:cNvPr id="16" name="TextBox 15"/>
           <p:cNvSpPr txBox="1"/>
           <p:nvPr/>
         </p:nvSpPr>
@@ -14592,7 +14101,7 @@
       </p:sp>
       <p:sp>
         <p:nvSpPr>
-          <p:cNvPr id="18" name="TextBox 17"/>
+          <p:cNvPr id="17" name="TextBox 16"/>
           <p:cNvSpPr txBox="1"/>
           <p:nvPr/>
         </p:nvSpPr>
@@ -14624,14 +14133,14 @@
               </a:defRPr>
             </a:pPr>
             <a:r>
-              <a:t>8</a:t>
-            </a:r>
-          </a:p>
-        </p:txBody>
-      </p:sp>
-      <p:sp>
-        <p:nvSpPr>
-          <p:cNvPr id="19" name="Rectangle 18"/>
+              <a:t>自行设置</a:t>
+            </a:r>
+          </a:p>
+        </p:txBody>
+      </p:sp>
+      <p:sp>
+        <p:nvSpPr>
+          <p:cNvPr id="18" name="Rectangle 17"/>
           <p:cNvSpPr/>
           <p:nvPr/>
         </p:nvSpPr>
@@ -14674,7 +14183,7 @@
       </p:sp>
       <p:sp>
         <p:nvSpPr>
-          <p:cNvPr id="20" name="TextBox 19"/>
+          <p:cNvPr id="19" name="TextBox 18"/>
           <p:cNvSpPr txBox="1"/>
           <p:nvPr/>
         </p:nvSpPr>
@@ -14713,7 +14222,7 @@
       </p:sp>
       <p:sp>
         <p:nvSpPr>
-          <p:cNvPr id="21" name="TextBox 20"/>
+          <p:cNvPr id="20" name="TextBox 19"/>
           <p:cNvSpPr txBox="1"/>
           <p:nvPr/>
         </p:nvSpPr>
@@ -14752,7 +14261,7 @@
       </p:sp>
       <p:sp>
         <p:nvSpPr>
-          <p:cNvPr id="22" name="Rectangle 21"/>
+          <p:cNvPr id="21" name="Rectangle 20"/>
           <p:cNvSpPr/>
           <p:nvPr/>
         </p:nvSpPr>
@@ -14795,7 +14304,7 @@
       </p:sp>
       <p:sp>
         <p:nvSpPr>
-          <p:cNvPr id="23" name="TextBox 22"/>
+          <p:cNvPr id="22" name="TextBox 21"/>
           <p:cNvSpPr txBox="1"/>
           <p:nvPr/>
         </p:nvSpPr>
@@ -14834,7 +14343,7 @@
       </p:sp>
       <p:sp>
         <p:nvSpPr>
-          <p:cNvPr id="24" name="TextBox 23"/>
+          <p:cNvPr id="23" name="TextBox 22"/>
           <p:cNvSpPr txBox="1"/>
           <p:nvPr/>
         </p:nvSpPr>
@@ -14873,14 +14382,14 @@
       </p:sp>
       <p:sp>
         <p:nvSpPr>
-          <p:cNvPr id="25" name="Rounded Rectangle 24"/>
+          <p:cNvPr id="24" name="Rounded Rectangle 23"/>
           <p:cNvSpPr/>
           <p:nvPr/>
         </p:nvSpPr>
         <p:spPr>
           <a:xfrm>
             <a:off x="6190488" y="1911095"/>
-            <a:ext cx="5230368" cy="960120"/>
+            <a:ext cx="5230368" cy="1234440"/>
           </a:xfrm>
           <a:prstGeom prst="roundRect">
             <a:avLst/>
@@ -14916,14 +14425,14 @@
       </p:sp>
       <p:sp>
         <p:nvSpPr>
-          <p:cNvPr id="26" name="TextBox 25"/>
+          <p:cNvPr id="25" name="TextBox 24"/>
           <p:cNvSpPr txBox="1"/>
           <p:nvPr/>
         </p:nvSpPr>
         <p:spPr>
           <a:xfrm>
             <a:off x="6355079" y="2039112"/>
-            <a:ext cx="4901183" cy="704088"/>
+            <a:ext cx="4901183" cy="978408"/>
           </a:xfrm>
           <a:prstGeom prst="rect">
             <a:avLst/>
@@ -14940,7 +14449,7 @@
               <a:spcAft>
                 <a:spcPts val="300"/>
               </a:spcAft>
-              <a:defRPr sz="2200" b="0">
+              <a:defRPr sz="1700" b="0">
                 <a:solidFill>
                   <a:srgbClr val="FFFFFF"/>
                 </a:solidFill>
@@ -14948,14 +14457,30 @@
               </a:defRPr>
             </a:pPr>
             <a:r>
-              <a:t>!python train.py</a:t>
-            </a:r>
-          </a:p>
-        </p:txBody>
-      </p:sp>
-      <p:sp>
-        <p:nvSpPr>
-          <p:cNvPr id="27" name="TextBox 26"/>
+              <a:t>EPOCHS = int(input("epochs: "))</a:t>
+            </a:r>
+          </a:p>
+          <a:p>
+            <a:pPr>
+              <a:spcAft>
+                <a:spcPts val="300"/>
+              </a:spcAft>
+              <a:defRPr sz="1700" b="0">
+                <a:solidFill>
+                  <a:srgbClr val="FFFFFF"/>
+                </a:solidFill>
+                <a:latin typeface="DejaVu Sans Mono"/>
+              </a:defRPr>
+            </a:pPr>
+            <a:r>
+              <a:t>!python train.py --epochs {EPOCHS}</a:t>
+            </a:r>
+          </a:p>
+        </p:txBody>
+      </p:sp>
+      <p:sp>
+        <p:nvSpPr>
+          <p:cNvPr id="26" name="TextBox 25"/>
           <p:cNvSpPr txBox="1"/>
           <p:nvPr/>
         </p:nvSpPr>
@@ -15055,7 +14580,7 @@
       </p:sp>
       <p:sp>
         <p:nvSpPr>
-          <p:cNvPr id="28" name="TextBox 27"/>
+          <p:cNvPr id="27" name="TextBox 26"/>
           <p:cNvSpPr txBox="1"/>
           <p:nvPr/>
         </p:nvSpPr>
@@ -15087,7 +14612,7 @@
               </a:defRPr>
             </a:pPr>
             <a:r>
-              <a:t>后期学习率自动衰减：第4、6轮结束后乘0.2。学生无需修改底层训练代码。</a:t>
+              <a:t>轮数根据训练与验证表现自行调整；学习率策略可配置，测试集只作最终评估。</a:t>
             </a:r>
           </a:p>
         </p:txBody>
@@ -15349,8 +14874,8 @@
         </p:nvSpPr>
         <p:spPr>
           <a:xfrm>
-            <a:off x="1069848" y="6419088"/>
-            <a:ext cx="9144000" cy="228600"/>
+            <a:off x="11064240" y="6400800"/>
+            <a:ext cx="502920" cy="274320"/>
           </a:xfrm>
           <a:prstGeom prst="rect">
             <a:avLst/>
@@ -15363,11 +14888,11 @@
           </a:bodyPr>
           <a:lstStyle/>
           <a:p>
-            <a:pPr>
-              <a:spcAft>
-                <a:spcPts val="600"/>
-              </a:spcAft>
-              <a:defRPr sz="1000" b="0">
+            <a:pPr algn="r">
+              <a:spcAft>
+                <a:spcPts val="600"/>
+              </a:spcAft>
+              <a:defRPr sz="1100" b="0">
                 <a:solidFill>
                   <a:srgbClr val="647483"/>
                 </a:solidFill>
@@ -15375,45 +14900,6 @@
               </a:defRPr>
             </a:pPr>
             <a:r>
-              <a:t>Kaggle 免费 GPU 优先 · AutoDL 备用 · 记录自己的实验结果</a:t>
-            </a:r>
-          </a:p>
-        </p:txBody>
-      </p:sp>
-      <p:sp>
-        <p:nvSpPr>
-          <p:cNvPr id="9" name="TextBox 8"/>
-          <p:cNvSpPr txBox="1"/>
-          <p:nvPr/>
-        </p:nvSpPr>
-        <p:spPr>
-          <a:xfrm>
-            <a:off x="11064240" y="6400800"/>
-            <a:ext cx="502920" cy="274320"/>
-          </a:xfrm>
-          <a:prstGeom prst="rect">
-            <a:avLst/>
-          </a:prstGeom>
-          <a:noFill/>
-        </p:spPr>
-        <p:txBody>
-          <a:bodyPr wrap="square" lIns="27432" rIns="27432" tIns="18288" bIns="18288">
-            <a:spAutoFit/>
-          </a:bodyPr>
-          <a:lstStyle/>
-          <a:p>
-            <a:pPr algn="r">
-              <a:spcAft>
-                <a:spcPts val="600"/>
-              </a:spcAft>
-              <a:defRPr sz="1100" b="0">
-                <a:solidFill>
-                  <a:srgbClr val="647483"/>
-                </a:solidFill>
-                <a:latin typeface="Noto Sans CJK SC"/>
-              </a:defRPr>
-            </a:pPr>
-            <a:r>
               <a:t>9</a:t>
             </a:r>
           </a:p>
@@ -15421,7 +14907,7 @@
       </p:sp>
       <p:sp>
         <p:nvSpPr>
-          <p:cNvPr id="10" name="Rounded Rectangle 9"/>
+          <p:cNvPr id="9" name="Rounded Rectangle 8"/>
           <p:cNvSpPr/>
           <p:nvPr/>
         </p:nvSpPr>
@@ -15464,7 +14950,7 @@
       </p:sp>
       <p:sp>
         <p:nvSpPr>
-          <p:cNvPr id="11" name="TextBox 10"/>
+          <p:cNvPr id="10" name="TextBox 9"/>
           <p:cNvSpPr txBox="1"/>
           <p:nvPr/>
         </p:nvSpPr>
@@ -15503,7 +14989,7 @@
       </p:sp>
       <p:sp>
         <p:nvSpPr>
-          <p:cNvPr id="12" name="TextBox 11"/>
+          <p:cNvPr id="11" name="TextBox 10"/>
           <p:cNvSpPr txBox="1"/>
           <p:nvPr/>
         </p:nvSpPr>
@@ -15542,7 +15028,7 @@
       </p:sp>
       <p:sp>
         <p:nvSpPr>
-          <p:cNvPr id="13" name="Rounded Rectangle 12"/>
+          <p:cNvPr id="12" name="Rounded Rectangle 11"/>
           <p:cNvSpPr/>
           <p:nvPr/>
         </p:nvSpPr>
@@ -15585,7 +15071,7 @@
       </p:sp>
       <p:sp>
         <p:nvSpPr>
-          <p:cNvPr id="14" name="TextBox 13"/>
+          <p:cNvPr id="13" name="TextBox 12"/>
           <p:cNvSpPr txBox="1"/>
           <p:nvPr/>
         </p:nvSpPr>
@@ -15624,7 +15110,7 @@
       </p:sp>
       <p:sp>
         <p:nvSpPr>
-          <p:cNvPr id="15" name="TextBox 14"/>
+          <p:cNvPr id="14" name="TextBox 13"/>
           <p:cNvSpPr txBox="1"/>
           <p:nvPr/>
         </p:nvSpPr>
@@ -15663,7 +15149,7 @@
       </p:sp>
       <p:sp>
         <p:nvSpPr>
-          <p:cNvPr id="16" name="Rounded Rectangle 15"/>
+          <p:cNvPr id="15" name="Rounded Rectangle 14"/>
           <p:cNvSpPr/>
           <p:nvPr/>
         </p:nvSpPr>
@@ -15706,7 +15192,7 @@
       </p:sp>
       <p:sp>
         <p:nvSpPr>
-          <p:cNvPr id="17" name="TextBox 16"/>
+          <p:cNvPr id="16" name="TextBox 15"/>
           <p:cNvSpPr txBox="1"/>
           <p:nvPr/>
         </p:nvSpPr>
@@ -15738,14 +15224,14 @@
               </a:defRPr>
             </a:pPr>
             <a:r>
-              <a:t>最佳模型 / 计划轮数</a:t>
-            </a:r>
-          </a:p>
-        </p:txBody>
-      </p:sp>
-      <p:sp>
-        <p:nvSpPr>
-          <p:cNvPr id="18" name="TextBox 17"/>
+              <a:t>模型选择依据</a:t>
+            </a:r>
+          </a:p>
+        </p:txBody>
+      </p:sp>
+      <p:sp>
+        <p:nvSpPr>
+          <p:cNvPr id="17" name="TextBox 16"/>
           <p:cNvSpPr txBox="1"/>
           <p:nvPr/>
         </p:nvSpPr>
@@ -15777,14 +15263,14 @@
               </a:defRPr>
             </a:pPr>
             <a:r>
-              <a:t>第5轮 / 8轮</a:t>
+              <a:t>验证集表现</a:t>
             </a:r>
           </a:p>
         </p:txBody>
       </p:sp>
       <p:pic>
         <p:nvPicPr>
-          <p:cNvPr id="19" name="Picture 18" descr="curves.png"/>
+          <p:cNvPr id="18" name="Picture 17" descr="curves.png"/>
           <p:cNvPicPr>
             <a:picLocks noChangeAspect="1"/>
           </p:cNvPicPr>
@@ -15808,7 +15294,7 @@
       </p:pic>
       <p:sp>
         <p:nvSpPr>
-          <p:cNvPr id="20" name="TextBox 19"/>
+          <p:cNvPr id="19" name="TextBox 18"/>
           <p:cNvSpPr txBox="1"/>
           <p:nvPr/>
         </p:nvSpPr>
@@ -15840,7 +15326,7 @@
               </a:defRPr>
             </a:pPr>
             <a:r>
-              <a:t>本机RTX4090：8轮约11.88分钟，不含安装下载及末尾出图。云平台耗时以实际运行为准。</a:t>
+              <a:t>本次教师实测约11.88分钟，不含安装下载及末尾出图。云平台耗时以实际运行为准。</a:t>
             </a:r>
           </a:p>
         </p:txBody>

</xml_diff>

<commit_message>
Let students choose batch size alongside training epochs
</commit_message>
<xml_diff>
--- a/docs/ByteFormer_MNIST_零基础实验课.pptx
+++ b/docs/ByteFormer_MNIST_零基础实验课.pptx
@@ -656,7 +656,7 @@
           <a:lstStyle/>
           <a:p>
             <a:r>
-              <a:t>学生自行设置两次实验轮数，不指定固定数值。根据训练与验证曲线比较；测试成绩只作最终记录。对比从同一官方预训练权重开始，不是在baseline上续训。保持其他参数相同并保留独立输出。更多轮数未必更好；需记录自己的实际设置与依据。</a:t>
+              <a:t>学生自行设置轮数与batch size；参考值不构成固定要求，建议一次只改变其中一项。根据训练与验证曲线比较；测试成绩只作最终记录。对比从同一官方预训练权重开始，不是在baseline上续训。保持其他参数相同并保留独立输出。更多轮数未必更好；需记录自己的实际设置与依据。</a:t>
             </a:r>
           </a:p>
         </p:txBody>
@@ -1426,7 +1426,7 @@
           <a:lstStyle/>
           <a:p>
             <a:r>
-              <a:t>epochs由学生输入；其余示例配置为train50000/val1000/test10000/batch32/lr1e-4/milestones4,6/gamma0.2/seed42。原正式实测训练末先测试1000，之后独立全10000；发布默认把最终测试整合成10000，共用同一score代码。输出目录已有best.pt时会报错保护结果；重跑换output且对应修改后续checkpoint。模型从官方权重全参数微调，AdamW weight_decay0.01，分类头10倍学习率。</a:t>
+              <a:t>epochs和batch size由学生输入；参考配置为train50000/val1000/test10000/batch32/lr1e-4/milestones4,6/gamma0.2/seed42。原正式实测训练末先测试1000，之后独立全10000；发布默认把最终测试整合成10000，共用同一score代码。输出目录已有best.pt时会报错保护结果；重跑换output且对应修改后续checkpoint。模型从官方权重全参数微调，AdamW weight_decay0.01，分类头10倍学习率。</a:t>
             </a:r>
           </a:p>
         </p:txBody>
@@ -5624,7 +5624,7 @@
         <p:spPr>
           <a:xfrm>
             <a:off x="740664" y="1856231"/>
-            <a:ext cx="10707624" cy="1161288"/>
+            <a:ext cx="10707624" cy="1755648"/>
           </a:xfrm>
           <a:prstGeom prst="roundRect">
             <a:avLst/>
@@ -5667,7 +5667,7 @@
         <p:spPr>
           <a:xfrm>
             <a:off x="905256" y="1984248"/>
-            <a:ext cx="10378440" cy="905256"/>
+            <a:ext cx="10378440" cy="1499616"/>
           </a:xfrm>
           <a:prstGeom prst="rect">
             <a:avLst/>
@@ -5692,7 +5692,7 @@
               </a:defRPr>
             </a:pPr>
             <a:r>
-              <a:t>COMPARISON_EPOCHS = int(input("对比轮数："))</a:t>
+              <a:t>COMPARISON_EPOCHS = int(input("epochs: "))</a:t>
             </a:r>
           </a:p>
           <a:p>
@@ -5708,7 +5708,39 @@
               </a:defRPr>
             </a:pPr>
             <a:r>
-              <a:t>!python train.py --epochs {COMPARISON_EPOCHS} --output outputs/comparison</a:t>
+              <a:t>COMPARISON_BATCH_SIZE = int(input("batch: "))</a:t>
+            </a:r>
+          </a:p>
+          <a:p>
+            <a:pPr>
+              <a:spcAft>
+                <a:spcPts val="300"/>
+              </a:spcAft>
+              <a:defRPr sz="1700" b="0">
+                <a:solidFill>
+                  <a:srgbClr val="FFFFFF"/>
+                </a:solidFill>
+                <a:latin typeface="DejaVu Sans Mono"/>
+              </a:defRPr>
+            </a:pPr>
+            <a:r>
+              <a:t>!python train.py --epochs {COMPARISON_EPOCHS} \</a:t>
+            </a:r>
+          </a:p>
+          <a:p>
+            <a:pPr>
+              <a:spcAft>
+                <a:spcPts val="300"/>
+              </a:spcAft>
+              <a:defRPr sz="1700" b="0">
+                <a:solidFill>
+                  <a:srgbClr val="FFFFFF"/>
+                </a:solidFill>
+                <a:latin typeface="DejaVu Sans Mono"/>
+              </a:defRPr>
+            </a:pPr>
+            <a:r>
+              <a:t>  --batch-size {COMPARISON_BATCH_SIZE} --output outputs/comparison</a:t>
             </a:r>
           </a:p>
         </p:txBody>
@@ -5721,8 +5753,8 @@
         </p:nvSpPr>
         <p:spPr>
           <a:xfrm>
-            <a:off x="804672" y="3355848"/>
-            <a:ext cx="5257800" cy="2322576"/>
+            <a:off x="804672" y="3822191"/>
+            <a:ext cx="5257800" cy="1792224"/>
           </a:xfrm>
           <a:prstGeom prst="rect">
             <a:avLst/>
@@ -5739,7 +5771,7 @@
               <a:spcAft>
                 <a:spcPts val="600"/>
               </a:spcAft>
-              <a:defRPr sz="2100" b="0">
+              <a:defRPr sz="1900" b="0">
                 <a:solidFill>
                   <a:srgbClr val="243547"/>
                 </a:solidFill>
@@ -5747,7 +5779,7 @@
               </a:defRPr>
             </a:pPr>
             <a:r>
-              <a:t>保持样本数、随机种子、batch和学习率策略不变。</a:t>
+              <a:t>轮数和batch size均自行设置，</a:t>
             </a:r>
           </a:p>
           <a:p>
@@ -5755,7 +5787,7 @@
               <a:spcAft>
                 <a:spcPts val="600"/>
               </a:spcAft>
-              <a:defRPr sz="2100" b="0">
+              <a:defRPr sz="1900" b="0">
                 <a:solidFill>
                   <a:srgbClr val="243547"/>
                 </a:solidFill>
@@ -5763,7 +5795,7 @@
               </a:defRPr>
             </a:pPr>
             <a:r>
-              <a:t>两次都从同一官方预训练权重开始。</a:t>
+              <a:t>建议一次只改变其中一项。</a:t>
             </a:r>
           </a:p>
           <a:p>
@@ -5771,7 +5803,23 @@
               <a:spcAft>
                 <a:spcPts val="600"/>
               </a:spcAft>
-              <a:defRPr sz="2100" b="0">
+              <a:defRPr sz="1900" b="0">
+                <a:solidFill>
+                  <a:srgbClr val="243547"/>
+                </a:solidFill>
+                <a:latin typeface="Noto Sans CJK SC"/>
+              </a:defRPr>
+            </a:pPr>
+            <a:r>
+              <a:t>数据、随机种子和预训练来源相同。</a:t>
+            </a:r>
+          </a:p>
+          <a:p>
+            <a:pPr>
+              <a:spcAft>
+                <a:spcPts val="600"/>
+              </a:spcAft>
+              <a:defRPr sz="1900" b="0">
                 <a:solidFill>
                   <a:srgbClr val="243547"/>
                 </a:solidFill>
@@ -5792,8 +5840,8 @@
         </p:nvSpPr>
         <p:spPr>
           <a:xfrm>
-            <a:off x="6437376" y="3401568"/>
-            <a:ext cx="4718304" cy="2267712"/>
+            <a:off x="6437376" y="3767328"/>
+            <a:ext cx="4718304" cy="1901952"/>
           </a:xfrm>
           <a:prstGeom prst="roundRect">
             <a:avLst/>
@@ -5835,8 +5883,8 @@
         </p:nvSpPr>
         <p:spPr>
           <a:xfrm>
-            <a:off x="6629400" y="3602736"/>
-            <a:ext cx="4315968" cy="1865376"/>
+            <a:off x="6629400" y="3886200"/>
+            <a:ext cx="4315968" cy="1655064"/>
           </a:xfrm>
           <a:prstGeom prst="rect">
             <a:avLst/>
@@ -5853,7 +5901,7 @@
               <a:spcAft>
                 <a:spcPts val="600"/>
               </a:spcAft>
-              <a:defRPr sz="1800" b="0">
+              <a:defRPr sz="1700" b="0">
                 <a:solidFill>
                   <a:srgbClr val="243547"/>
                 </a:solidFill>
@@ -5869,7 +5917,7 @@
               <a:spcAft>
                 <a:spcPts val="600"/>
               </a:spcAft>
-              <a:defRPr sz="1800" b="0">
+              <a:defRPr sz="1700" b="0">
                 <a:solidFill>
                   <a:srgbClr val="243547"/>
                 </a:solidFill>
@@ -5885,7 +5933,7 @@
               <a:spcAft>
                 <a:spcPts val="600"/>
               </a:spcAft>
-              <a:defRPr sz="1800" b="0">
+              <a:defRPr sz="1700" b="0">
                 <a:solidFill>
                   <a:srgbClr val="243547"/>
                 </a:solidFill>
@@ -5901,7 +5949,7 @@
               <a:spcAft>
                 <a:spcPts val="600"/>
               </a:spcAft>
-              <a:defRPr sz="1800" b="0">
+              <a:defRPr sz="1700" b="0">
                 <a:solidFill>
                   <a:srgbClr val="243547"/>
                 </a:solidFill>
@@ -5917,7 +5965,7 @@
               <a:spcAft>
                 <a:spcPts val="600"/>
               </a:spcAft>
-              <a:defRPr sz="1800" b="0">
+              <a:defRPr sz="1700" b="0">
                 <a:solidFill>
                   <a:srgbClr val="243547"/>
                 </a:solidFill>
@@ -5964,7 +6012,7 @@
               </a:defRPr>
             </a:pPr>
             <a:r>
-              <a:t>不固定训练轮数，也不预设训练越久越好。记录自己的设置，并用验证结果解释选择。</a:t>
+              <a:t>记录两次实验的参数、验证准确率与耗时，解释设置变化带来的影响。</a:t>
             </a:r>
           </a:p>
         </p:txBody>
@@ -6304,8 +6352,8 @@
         </p:nvSpPr>
         <p:spPr>
           <a:xfrm>
-            <a:off x="749808" y="2551176"/>
-            <a:ext cx="10707624" cy="2267712"/>
+            <a:off x="749808" y="2423160"/>
+            <a:ext cx="10707624" cy="2496312"/>
           </a:xfrm>
           <a:prstGeom prst="roundRect">
             <a:avLst/>
@@ -6347,8 +6395,8 @@
         </p:nvSpPr>
         <p:spPr>
           <a:xfrm>
-            <a:off x="914400" y="2679192"/>
-            <a:ext cx="10378440" cy="2011680"/>
+            <a:off x="914400" y="2551176"/>
+            <a:ext cx="10378440" cy="2240280"/>
           </a:xfrm>
           <a:prstGeom prst="rect">
             <a:avLst/>
@@ -6469,7 +6517,23 @@
               </a:defRPr>
             </a:pPr>
             <a:r>
-              <a:t>python train.py --epochs "$EPOCHS"</a:t>
+              <a:t>read -p "batch size (ref 32): " BATCH_SIZE</a:t>
+            </a:r>
+          </a:p>
+          <a:p>
+            <a:pPr>
+              <a:spcAft>
+                <a:spcPts val="300"/>
+              </a:spcAft>
+              <a:defRPr sz="1600" b="0">
+                <a:solidFill>
+                  <a:srgbClr val="FFFFFF"/>
+                </a:solidFill>
+                <a:latin typeface="DejaVu Sans Mono"/>
+              </a:defRPr>
+            </a:pPr>
+            <a:r>
+              <a:t>python train.py --epochs "$EPOCHS" --batch-size "$BATCH_SIZE"</a:t>
             </a:r>
           </a:p>
         </p:txBody>
@@ -7120,7 +7184,7 @@
                         </a:defRPr>
                       </a:pPr>
                       <a:r>
-                        <a:t>batch-size改16或8，两组对比保持一致</a:t>
+                        <a:t>减小batch size，如32降到16或8，并记录实际值</a:t>
                       </a:r>
                     </a:p>
                   </a:txBody>
@@ -9625,7 +9689,7 @@
               </a:defRPr>
             </a:pPr>
             <a:r>
-              <a:t>自行设置轮数并微调 → 观察验证曲线 → 查看并解释一个错例。</a:t>
+              <a:t>自行设置参数并微调 → 观察验证曲线 → 查看并解释一个错例。</a:t>
             </a:r>
           </a:p>
         </p:txBody>
@@ -12931,7 +12995,7 @@
               </a:defRPr>
             </a:pPr>
             <a:r>
-              <a:t>按顺序逐格运行：训练单元格会提示输入自己选择的轮数。</a:t>
+              <a:t>按顺序逐格运行：训练单元格会提示输入轮数和batch size。</a:t>
             </a:r>
           </a:p>
         </p:txBody>
@@ -14254,7 +14318,7 @@
               </a:defRPr>
             </a:pPr>
             <a:r>
-              <a:t>32</a:t>
+              <a:t>自行设置，参考32</a:t>
             </a:r>
           </a:p>
         </p:txBody>
@@ -14389,7 +14453,7 @@
         <p:spPr>
           <a:xfrm>
             <a:off x="6190488" y="1911095"/>
-            <a:ext cx="5230368" cy="1234440"/>
+            <a:ext cx="5230368" cy="1719072"/>
           </a:xfrm>
           <a:prstGeom prst="roundRect">
             <a:avLst/>
@@ -14432,7 +14496,7 @@
         <p:spPr>
           <a:xfrm>
             <a:off x="6355079" y="2039112"/>
-            <a:ext cx="4901183" cy="978408"/>
+            <a:ext cx="4901183" cy="1463039"/>
           </a:xfrm>
           <a:prstGeom prst="rect">
             <a:avLst/>
@@ -14449,7 +14513,7 @@
               <a:spcAft>
                 <a:spcPts val="300"/>
               </a:spcAft>
-              <a:defRPr sz="1700" b="0">
+              <a:defRPr sz="1600" b="0">
                 <a:solidFill>
                   <a:srgbClr val="FFFFFF"/>
                 </a:solidFill>
@@ -14465,7 +14529,7 @@
               <a:spcAft>
                 <a:spcPts val="300"/>
               </a:spcAft>
-              <a:defRPr sz="1700" b="0">
+              <a:defRPr sz="1600" b="0">
                 <a:solidFill>
                   <a:srgbClr val="FFFFFF"/>
                 </a:solidFill>
@@ -14473,7 +14537,39 @@
               </a:defRPr>
             </a:pPr>
             <a:r>
-              <a:t>!python train.py --epochs {EPOCHS}</a:t>
+              <a:t>BATCH_SIZE = int(input("batch: "))</a:t>
+            </a:r>
+          </a:p>
+          <a:p>
+            <a:pPr>
+              <a:spcAft>
+                <a:spcPts val="300"/>
+              </a:spcAft>
+              <a:defRPr sz="1600" b="0">
+                <a:solidFill>
+                  <a:srgbClr val="FFFFFF"/>
+                </a:solidFill>
+                <a:latin typeface="DejaVu Sans Mono"/>
+              </a:defRPr>
+            </a:pPr>
+            <a:r>
+              <a:t>!python train.py --epochs {EPOCHS} \</a:t>
+            </a:r>
+          </a:p>
+          <a:p>
+            <a:pPr>
+              <a:spcAft>
+                <a:spcPts val="300"/>
+              </a:spcAft>
+              <a:defRPr sz="1600" b="0">
+                <a:solidFill>
+                  <a:srgbClr val="FFFFFF"/>
+                </a:solidFill>
+                <a:latin typeface="DejaVu Sans Mono"/>
+              </a:defRPr>
+            </a:pPr>
+            <a:r>
+              <a:t>  --batch-size {BATCH_SIZE}</a:t>
             </a:r>
           </a:p>
         </p:txBody>
@@ -14486,8 +14582,8 @@
         </p:nvSpPr>
         <p:spPr>
           <a:xfrm>
-            <a:off x="6318504" y="3255264"/>
-            <a:ext cx="4919472" cy="2029968"/>
+            <a:off x="6318504" y="3886200"/>
+            <a:ext cx="4919472" cy="1463040"/>
           </a:xfrm>
           <a:prstGeom prst="rect">
             <a:avLst/>
@@ -14504,7 +14600,7 @@
               <a:spcAft>
                 <a:spcPts val="600"/>
               </a:spcAft>
-              <a:defRPr sz="2100" b="0">
+              <a:defRPr sz="2000" b="0">
                 <a:solidFill>
                   <a:srgbClr val="243547"/>
                 </a:solidFill>
@@ -14512,7 +14608,7 @@
               </a:defRPr>
             </a:pPr>
             <a:r>
-              <a:t>出现[TRAIN]和每轮[EPOCH]，</a:t>
+              <a:t>看到[DONE]即训练完成。</a:t>
             </a:r>
           </a:p>
           <a:p>
@@ -14520,7 +14616,7 @@
               <a:spcAft>
                 <a:spcPts val="600"/>
               </a:spcAft>
-              <a:defRPr sz="2100" b="0">
+              <a:defRPr sz="2000" b="0">
                 <a:solidFill>
                   <a:srgbClr val="243547"/>
                 </a:solidFill>
@@ -14528,7 +14624,7 @@
               </a:defRPr>
             </a:pPr>
             <a:r>
-              <a:t>最后看到[DONE]。</a:t>
+              <a:t>结果保存到outputs/baseline/。</a:t>
             </a:r>
           </a:p>
           <a:p>
@@ -14536,44 +14632,15 @@
               <a:spcAft>
                 <a:spcPts val="600"/>
               </a:spcAft>
-              <a:defRPr sz="2100" b="0">
+              <a:defRPr sz="2000" b="0">
                 <a:solidFill>
                   <a:srgbClr val="243547"/>
                 </a:solidFill>
                 <a:latin typeface="Noto Sans CJK SC"/>
               </a:defRPr>
             </a:pPr>
-          </a:p>
-          <a:p>
-            <a:pPr>
-              <a:spcAft>
-                <a:spcPts val="600"/>
-              </a:spcAft>
-              <a:defRPr sz="2100" b="0">
-                <a:solidFill>
-                  <a:srgbClr val="243547"/>
-                </a:solidFill>
-                <a:latin typeface="Noto Sans CJK SC"/>
-              </a:defRPr>
-            </a:pPr>
-            <a:r>
-              <a:t>输出保存到outputs/baseline/。</a:t>
-            </a:r>
-          </a:p>
-          <a:p>
-            <a:pPr>
-              <a:spcAft>
-                <a:spcPts val="600"/>
-              </a:spcAft>
-              <a:defRPr sz="2100" b="0">
-                <a:solidFill>
-                  <a:srgbClr val="243547"/>
-                </a:solidFill>
-                <a:latin typeface="Noto Sans CJK SC"/>
-              </a:defRPr>
-            </a:pPr>
-            <a:r>
-              <a:t>训练中不要关闭运行会话。</a:t>
+            <a:r>
+              <a:t>请记录实际使用的参数。</a:t>
             </a:r>
           </a:p>
         </p:txBody>
@@ -14612,7 +14679,7 @@
               </a:defRPr>
             </a:pPr>
             <a:r>
-              <a:t>轮数根据训练与验证表现自行调整；学习率策略可配置，测试集只作最终评估。</a:t>
+              <a:t>训练轮数和batch size均可调整；参考值仅供起步，测试集只作最终评估。</a:t>
             </a:r>
           </a:p>
         </p:txBody>

</xml_diff>

<commit_message>
Replace Kaggle setup walkthrough with tutorial links
</commit_message>
<xml_diff>
--- a/docs/ByteFormer_MNIST_零基础实验课.pptx
+++ b/docs/ByteFormer_MNIST_零基础实验课.pptx
@@ -1286,7 +1286,7 @@
           <a:lstStyle/>
           <a:p>
             <a:r>
-              <a:t>下载原始ipynb文件，不要将GitHub网页另存为ipynb。GPU检查在独立子进程中运行，避免安装NumPy依赖前污染内核。运行一格后等它完成，再继续下一格。工作目录必须可写：/kaggle/working/byteformer-mnist-course，而不是只读/kaggle/input。界面名称变化时参考官方Notebook文档。</a:t>
+              <a:t>教程仅作平台准备入口，不要求运行文章中的示例项目。中文教程来自搜索检索；CSDN和知乎限制自动读取，本次未逐图核验，授课前请用学生浏览器确认可访问性。界面、验证和GPU额度以Kaggle实际页面及官方文档为准。下载原始ipynb文件后在Kaggle导入；课程尚未登录Kaggle账号实机执行。</a:t>
             </a:r>
           </a:p>
         </p:txBody>
@@ -12484,7 +12484,7 @@
               </a:defRPr>
             </a:pPr>
             <a:r>
-              <a:t>05 Kaggle 准备：导入、GPU、网络，一次设好</a:t>
+              <a:t>05 Kaggle GPU：课前教程与课程入口</a:t>
             </a:r>
           </a:p>
         </p:txBody>
@@ -12659,117 +12659,14 @@
       </p:sp>
       <p:sp>
         <p:nvSpPr>
-          <p:cNvPr id="9" name="TextBox 8"/>
-          <p:cNvSpPr txBox="1"/>
-          <p:nvPr/>
-        </p:nvSpPr>
-        <p:spPr>
-          <a:xfrm>
-            <a:off x="777240" y="1810512"/>
-            <a:ext cx="5486400" cy="3611880"/>
-          </a:xfrm>
-          <a:prstGeom prst="rect">
-            <a:avLst/>
-          </a:prstGeom>
-          <a:noFill/>
-        </p:spPr>
-        <p:txBody>
-          <a:bodyPr wrap="square" lIns="27432" rIns="27432" tIns="18288" bIns="18288">
-            <a:spAutoFit/>
-          </a:bodyPr>
-          <a:lstStyle/>
-          <a:p>
-            <a:pPr>
-              <a:spcAft>
-                <a:spcPts val="600"/>
-              </a:spcAft>
-              <a:defRPr sz="2100" b="0">
-                <a:solidFill>
-                  <a:srgbClr val="243547"/>
-                </a:solidFill>
-                <a:latin typeface="Noto Sans CJK SC"/>
-              </a:defRPr>
-            </a:pPr>
-            <a:r>
-              <a:t>1. 从GitHub下载course_kaggle.ipynb。</a:t>
-            </a:r>
-          </a:p>
-          <a:p>
-            <a:pPr>
-              <a:spcAft>
-                <a:spcPts val="600"/>
-              </a:spcAft>
-              <a:defRPr sz="2100" b="0">
-                <a:solidFill>
-                  <a:srgbClr val="243547"/>
-                </a:solidFill>
-                <a:latin typeface="Noto Sans CJK SC"/>
-              </a:defRPr>
-            </a:pPr>
-            <a:r>
-              <a:t>2. 新建Notebook，File → Import Notebook。</a:t>
-            </a:r>
-          </a:p>
-          <a:p>
-            <a:pPr>
-              <a:spcAft>
-                <a:spcPts val="600"/>
-              </a:spcAft>
-              <a:defRPr sz="2100" b="0">
-                <a:solidFill>
-                  <a:srgbClr val="243547"/>
-                </a:solidFill>
-                <a:latin typeface="Noto Sans CJK SC"/>
-              </a:defRPr>
-            </a:pPr>
-            <a:r>
-              <a:t>3. 在设置中选择GPU Accelerator。</a:t>
-            </a:r>
-          </a:p>
-          <a:p>
-            <a:pPr>
-              <a:spcAft>
-                <a:spcPts val="600"/>
-              </a:spcAft>
-              <a:defRPr sz="2100" b="0">
-                <a:solidFill>
-                  <a:srgbClr val="243547"/>
-                </a:solidFill>
-                <a:latin typeface="Noto Sans CJK SC"/>
-              </a:defRPr>
-            </a:pPr>
-            <a:r>
-              <a:t>4. 打开Internet，按提示完成账号验证。</a:t>
-            </a:r>
-          </a:p>
-          <a:p>
-            <a:pPr>
-              <a:spcAft>
-                <a:spcPts val="600"/>
-              </a:spcAft>
-              <a:defRPr sz="2100" b="0">
-                <a:solidFill>
-                  <a:srgbClr val="243547"/>
-                </a:solidFill>
-                <a:latin typeface="Noto Sans CJK SC"/>
-              </a:defRPr>
-            </a:pPr>
-            <a:r>
-              <a:t>5. 从上到下逐格运行，先完成环境检查。</a:t>
-            </a:r>
-          </a:p>
-        </p:txBody>
-      </p:sp>
-      <p:sp>
-        <p:nvSpPr>
-          <p:cNvPr id="10" name="Rounded Rectangle 9"/>
+          <p:cNvPr id="9" name="Rounded Rectangle 8"/>
           <p:cNvSpPr/>
           <p:nvPr/>
         </p:nvSpPr>
         <p:spPr>
           <a:xfrm>
-            <a:off x="6675120" y="1938528"/>
-            <a:ext cx="4572000" cy="1892807"/>
+            <a:off x="749808" y="1828800"/>
+            <a:ext cx="10671048" cy="621792"/>
           </a:xfrm>
           <a:prstGeom prst="roundRect">
             <a:avLst/>
@@ -12805,14 +12702,14 @@
       </p:sp>
       <p:sp>
         <p:nvSpPr>
-          <p:cNvPr id="11" name="TextBox 10"/>
+          <p:cNvPr id="10" name="TextBox 9"/>
           <p:cNvSpPr txBox="1"/>
           <p:nvPr/>
         </p:nvSpPr>
         <p:spPr>
           <a:xfrm>
-            <a:off x="6903720" y="2167128"/>
-            <a:ext cx="4114800" cy="1325880"/>
+            <a:off x="941832" y="1938528"/>
+            <a:ext cx="10232136" cy="384048"/>
           </a:xfrm>
           <a:prstGeom prst="rect">
             <a:avLst/>
@@ -12829,7 +12726,7 @@
               <a:spcAft>
                 <a:spcPts val="600"/>
               </a:spcAft>
-              <a:defRPr sz="2100" b="1">
+              <a:defRPr sz="2100" b="0">
                 <a:solidFill>
                   <a:srgbClr val="176BA0"/>
                 </a:solidFill>
@@ -12837,40 +12734,54 @@
               </a:defRPr>
             </a:pPr>
             <a:r>
-              <a:t>成功标志</a:t>
-            </a:r>
-          </a:p>
-          <a:p>
-            <a:pPr>
-              <a:spcAft>
-                <a:spcPts val="600"/>
-              </a:spcAft>
-              <a:defRPr sz="2100" b="1">
-                <a:solidFill>
-                  <a:srgbClr val="176BA0"/>
-                </a:solidFill>
-                <a:latin typeface="Noto Sans CJK SC"/>
-              </a:defRPr>
-            </a:pPr>
-            <a:r>
-              <a:t>GPU available: True</a:t>
-            </a:r>
-          </a:p>
-          <a:p>
-            <a:pPr>
-              <a:spcAft>
-                <a:spcPts val="600"/>
-              </a:spcAft>
-              <a:defRPr sz="2100" b="1">
-                <a:solidFill>
-                  <a:srgbClr val="176BA0"/>
-                </a:solidFill>
-                <a:latin typeface="Noto Sans CJK SC"/>
-              </a:defRPr>
-            </a:pPr>
-            <a:r>
-              <a:t>随后运行“获取课程”单元格。</a:t>
-            </a:r>
+              <a:rPr u="sng">
+                <a:hlinkClick r:id="rId4"/>
+              </a:rPr>
+              <a:t>知乎｜Kaggle GPU资源使用教程——针对超级小白</a:t>
+            </a:r>
+          </a:p>
+        </p:txBody>
+      </p:sp>
+      <p:sp>
+        <p:nvSpPr>
+          <p:cNvPr id="11" name="Rounded Rectangle 10"/>
+          <p:cNvSpPr/>
+          <p:nvPr/>
+        </p:nvSpPr>
+        <p:spPr>
+          <a:xfrm>
+            <a:off x="749808" y="2615184"/>
+            <a:ext cx="10671048" cy="621792"/>
+          </a:xfrm>
+          <a:prstGeom prst="roundRect">
+            <a:avLst/>
+          </a:prstGeom>
+          <a:solidFill>
+            <a:srgbClr val="EDF4F8"/>
+          </a:solidFill>
+          <a:ln>
+            <a:noFill/>
+          </a:ln>
+        </p:spPr>
+        <p:style>
+          <a:lnRef idx="1">
+            <a:schemeClr val="accent1"/>
+          </a:lnRef>
+          <a:fillRef idx="3">
+            <a:schemeClr val="accent1"/>
+          </a:fillRef>
+          <a:effectRef idx="2">
+            <a:schemeClr val="accent1"/>
+          </a:effectRef>
+          <a:fontRef idx="minor">
+            <a:schemeClr val="lt1"/>
+          </a:fontRef>
+        </p:style>
+        <p:txBody>
+          <a:bodyPr rtlCol="0" anchor="ctr"/>
+          <a:lstStyle/>
+          <a:p>
+            <a:pPr algn="ctr"/>
           </a:p>
         </p:txBody>
       </p:sp>
@@ -12882,8 +12793,8 @@
         </p:nvSpPr>
         <p:spPr>
           <a:xfrm>
-            <a:off x="6876288" y="4023360"/>
-            <a:ext cx="4251960" cy="1673352"/>
+            <a:off x="941832" y="2724912"/>
+            <a:ext cx="10232136" cy="384048"/>
           </a:xfrm>
           <a:prstGeom prst="rect">
             <a:avLst/>
@@ -12900,77 +12811,75 @@
               <a:spcAft>
                 <a:spcPts val="600"/>
               </a:spcAft>
-              <a:defRPr sz="2000" b="0">
-                <a:solidFill>
-                  <a:srgbClr val="243547"/>
+              <a:defRPr sz="2100" b="0">
+                <a:solidFill>
+                  <a:srgbClr val="176BA0"/>
                 </a:solidFill>
                 <a:latin typeface="Noto Sans CJK SC"/>
               </a:defRPr>
             </a:pPr>
             <a:r>
-              <a:t>命令规则</a:t>
-            </a:r>
-          </a:p>
-          <a:p>
-            <a:pPr>
-              <a:spcAft>
-                <a:spcPts val="600"/>
-              </a:spcAft>
-              <a:defRPr sz="2000" b="0">
-                <a:solidFill>
-                  <a:srgbClr val="243547"/>
-                </a:solidFill>
-                <a:latin typeface="Noto Sans CJK SC"/>
-              </a:defRPr>
-            </a:pPr>
-            <a:r>
-              <a:t>Kaggle单元格：!python …</a:t>
-            </a:r>
-          </a:p>
-          <a:p>
-            <a:pPr>
-              <a:spcAft>
-                <a:spcPts val="600"/>
-              </a:spcAft>
-              <a:defRPr sz="2000" b="0">
-                <a:solidFill>
-                  <a:srgbClr val="243547"/>
-                </a:solidFill>
-                <a:latin typeface="Noto Sans CJK SC"/>
-              </a:defRPr>
-            </a:pPr>
-            <a:r>
-              <a:t>切换目录：%cd …</a:t>
-            </a:r>
-          </a:p>
-          <a:p>
-            <a:pPr>
-              <a:spcAft>
-                <a:spcPts val="600"/>
-              </a:spcAft>
-              <a:defRPr sz="2000" b="0">
-                <a:solidFill>
-                  <a:srgbClr val="243547"/>
-                </a:solidFill>
-                <a:latin typeface="Noto Sans CJK SC"/>
-              </a:defRPr>
-            </a:pPr>
-            <a:r>
-              <a:t>AutoDL终端：python …</a:t>
-            </a:r>
-          </a:p>
-        </p:txBody>
-      </p:sp>
-      <p:sp>
-        <p:nvSpPr>
-          <p:cNvPr id="13" name="TextBox 12"/>
+              <a:rPr u="sng">
+                <a:hlinkClick r:id="rId5"/>
+              </a:rPr>
+              <a:t>CSDN｜科研小白扫盲：Kaggle平台使用指导指南</a:t>
+            </a:r>
+          </a:p>
+        </p:txBody>
+      </p:sp>
+      <p:sp>
+        <p:nvSpPr>
+          <p:cNvPr id="13" name="Rounded Rectangle 12"/>
+          <p:cNvSpPr/>
+          <p:nvPr/>
+        </p:nvSpPr>
+        <p:spPr>
+          <a:xfrm>
+            <a:off x="749808" y="3401568"/>
+            <a:ext cx="10671048" cy="621792"/>
+          </a:xfrm>
+          <a:prstGeom prst="roundRect">
+            <a:avLst/>
+          </a:prstGeom>
+          <a:solidFill>
+            <a:srgbClr val="EDF4F8"/>
+          </a:solidFill>
+          <a:ln>
+            <a:noFill/>
+          </a:ln>
+        </p:spPr>
+        <p:style>
+          <a:lnRef idx="1">
+            <a:schemeClr val="accent1"/>
+          </a:lnRef>
+          <a:fillRef idx="3">
+            <a:schemeClr val="accent1"/>
+          </a:fillRef>
+          <a:effectRef idx="2">
+            <a:schemeClr val="accent1"/>
+          </a:effectRef>
+          <a:fontRef idx="minor">
+            <a:schemeClr val="lt1"/>
+          </a:fontRef>
+        </p:style>
+        <p:txBody>
+          <a:bodyPr rtlCol="0" anchor="ctr"/>
+          <a:lstStyle/>
+          <a:p>
+            <a:pPr algn="ctr"/>
+          </a:p>
+        </p:txBody>
+      </p:sp>
+      <p:sp>
+        <p:nvSpPr>
+          <p:cNvPr id="14" name="TextBox 13"/>
           <p:cNvSpPr txBox="1"/>
           <p:nvPr/>
         </p:nvSpPr>
         <p:spPr>
           <a:xfrm>
-            <a:off x="777240" y="5870448"/>
-            <a:ext cx="10515600" cy="365760"/>
+            <a:off x="941832" y="3511296"/>
+            <a:ext cx="10232136" cy="384048"/>
           </a:xfrm>
           <a:prstGeom prst="rect">
             <a:avLst/>
@@ -12987,15 +12896,115 @@
               <a:spcAft>
                 <a:spcPts val="600"/>
               </a:spcAft>
-              <a:defRPr sz="1700" b="0">
-                <a:solidFill>
-                  <a:srgbClr val="BA3F3F"/>
+              <a:defRPr sz="2100" b="0">
+                <a:solidFill>
+                  <a:srgbClr val="176BA0"/>
                 </a:solidFill>
                 <a:latin typeface="Noto Sans CJK SC"/>
               </a:defRPr>
             </a:pPr>
             <a:r>
-              <a:t>按顺序逐格运行：训练单元格会提示输入轮数和batch size。</a:t>
+              <a:rPr u="sng">
+                <a:hlinkClick r:id="rId6"/>
+              </a:rPr>
+              <a:t>Kaggle官方｜Notebook使用文档</a:t>
+            </a:r>
+          </a:p>
+        </p:txBody>
+      </p:sp>
+      <p:sp>
+        <p:nvSpPr>
+          <p:cNvPr id="15" name="TextBox 14"/>
+          <p:cNvSpPr txBox="1"/>
+          <p:nvPr/>
+        </p:nvSpPr>
+        <p:spPr>
+          <a:xfrm>
+            <a:off x="877824" y="4462272"/>
+            <a:ext cx="10424160" cy="384048"/>
+          </a:xfrm>
+          <a:prstGeom prst="rect">
+            <a:avLst/>
+          </a:prstGeom>
+          <a:noFill/>
+        </p:spPr>
+        <p:txBody>
+          <a:bodyPr wrap="square" lIns="27432" rIns="27432" tIns="18288" bIns="18288">
+            <a:spAutoFit/>
+          </a:bodyPr>
+          <a:lstStyle/>
+          <a:p>
+            <a:pPr>
+              <a:spcAft>
+                <a:spcPts val="600"/>
+              </a:spcAft>
+              <a:defRPr sz="2100" b="0">
+                <a:solidFill>
+                  <a:srgbClr val="176BA0"/>
+                </a:solidFill>
+                <a:latin typeface="Noto Sans CJK SC"/>
+              </a:defRPr>
+            </a:pPr>
+            <a:r>
+              <a:rPr u="sng">
+                <a:hlinkClick r:id="rId7"/>
+              </a:rPr>
+              <a:t>课程Notebook：下载course_kaggle.ipynb</a:t>
+            </a:r>
+          </a:p>
+        </p:txBody>
+      </p:sp>
+      <p:sp>
+        <p:nvSpPr>
+          <p:cNvPr id="16" name="TextBox 15"/>
+          <p:cNvSpPr txBox="1"/>
+          <p:nvPr/>
+        </p:nvSpPr>
+        <p:spPr>
+          <a:xfrm>
+            <a:off x="905256" y="5102352"/>
+            <a:ext cx="10378440" cy="713232"/>
+          </a:xfrm>
+          <a:prstGeom prst="rect">
+            <a:avLst/>
+          </a:prstGeom>
+          <a:noFill/>
+        </p:spPr>
+        <p:txBody>
+          <a:bodyPr wrap="square" lIns="27432" rIns="27432" tIns="18288" bIns="18288">
+            <a:spAutoFit/>
+          </a:bodyPr>
+          <a:lstStyle/>
+          <a:p>
+            <a:pPr>
+              <a:spcAft>
+                <a:spcPts val="600"/>
+              </a:spcAft>
+              <a:defRPr sz="2100" b="0">
+                <a:solidFill>
+                  <a:srgbClr val="243547"/>
+                </a:solidFill>
+                <a:latin typeface="Noto Sans CJK SC"/>
+              </a:defRPr>
+            </a:pPr>
+            <a:r>
+              <a:t>按教程准备好GPU后，导入课程Notebook，逐格运行。</a:t>
+            </a:r>
+          </a:p>
+          <a:p>
+            <a:pPr>
+              <a:spcAft>
+                <a:spcPts val="600"/>
+              </a:spcAft>
+              <a:defRPr sz="2100" b="0">
+                <a:solidFill>
+                  <a:srgbClr val="243547"/>
+                </a:solidFill>
+                <a:latin typeface="Noto Sans CJK SC"/>
+              </a:defRPr>
+            </a:pPr>
+            <a:r>
+              <a:t>环境检查显示 GPU available: True，即可继续实验。</a:t>
             </a:r>
           </a:p>
         </p:txBody>

</xml_diff>

<commit_message>
Remove unnecessary attribution sentence from course slide
</commit_message>
<xml_diff>
--- a/docs/ByteFormer_MNIST_零基础实验课.pptx
+++ b/docs/ByteFormer_MNIST_零基础实验课.pptx
@@ -9121,45 +9121,6 @@
                 <a:hlinkClick r:id="rId9"/>
               </a:rPr>
               <a:t>MNIST：CVDF镜像与原作者说明</a:t>
-            </a:r>
-          </a:p>
-        </p:txBody>
-      </p:sp>
-      <p:sp>
-        <p:nvSpPr>
-          <p:cNvPr id="16" name="TextBox 15"/>
-          <p:cNvSpPr txBox="1"/>
-          <p:nvPr/>
-        </p:nvSpPr>
-        <p:spPr>
-          <a:xfrm>
-            <a:off x="832104" y="5733288"/>
-            <a:ext cx="10479024" cy="512064"/>
-          </a:xfrm>
-          <a:prstGeom prst="rect">
-            <a:avLst/>
-          </a:prstGeom>
-          <a:noFill/>
-        </p:spPr>
-        <p:txBody>
-          <a:bodyPr wrap="square" lIns="27432" rIns="27432" tIns="18288" bIns="18288">
-            <a:spAutoFit/>
-          </a:bodyPr>
-          <a:lstStyle/>
-          <a:p>
-            <a:pPr>
-              <a:spcAft>
-                <a:spcPts val="600"/>
-              </a:spcAft>
-              <a:defRPr sz="1500" b="0">
-                <a:solidFill>
-                  <a:srgbClr val="647483"/>
-                </a:solidFill>
-                <a:latin typeface="Noto Sans CJK SC"/>
-              </a:defRPr>
-            </a:pPr>
-            <a:r>
-              <a:t>校园、校徽来自教师样例并保留原权利；代码、数据与模型归属见仓库说明。</a:t>
             </a:r>
           </a:p>
         </p:txBody>

</xml_diff>

<commit_message>
Focus slides on student results and add optional fine-tuning tasks
</commit_message>
<xml_diff>
--- a/docs/ByteFormer_MNIST_零基础实验课.pptx
+++ b/docs/ByteFormer_MNIST_零基础实验课.pptx
@@ -20,6 +20,7 @@
     <p:sldId id="268" r:id="rId20"/>
     <p:sldId id="269" r:id="rId21"/>
     <p:sldId id="270" r:id="rId22"/>
+    <p:sldId id="271" r:id="rId23"/>
   </p:sldIdLst>
   <p:sldSz cx="12191695" cy="6858000" type="screen4x3"/>
   <p:notesSz cx="6858000" cy="9144000"/>
@@ -516,7 +517,7 @@
           <a:lstStyle/>
           <a:p>
             <a:r>
-              <a:t>沿用教师样例的校园、校徽与白蓝风格，不沿用旧老师邮箱、截止日期或其他旧课程信息。本课PPT压缩为15页；逐格操作细节见course_kaggle.ipynb和README。</a:t>
+              <a:t>沿用教师样例的校园、校徽与白蓝风格，不沿用旧老师邮箱、截止日期或其他旧课程信息。本课PPT共16页；逐格操作细节见course_kaggle.ipynb和README。</a:t>
             </a:r>
           </a:p>
         </p:txBody>
@@ -936,7 +937,77 @@
           <a:lstStyle/>
           <a:p>
             <a:r>
-              <a:t>所有链接为可点击链接。PPT共15页，对齐教师样例的信息密度；课堂主讲只需本PPT，学生逐步实操使用Notebook。未进行真实Kaggle或AutoDL登录执行，所有性能结果注明本地实测。</a:t>
+              <a:t>MNIST规定任务完成即可达标及格。两项拓展均为可选加分路径，不设固定加分数值或准确率门槛；本轮仅补充任务说明，未执行CIFAR-10或Stanford40实验，也不宣称课程现有脚本已直接支持这两个数据集。</a:t>
+            </a:r>
+          </a:p>
+        </p:txBody>
+      </p:sp>
+      <p:sp>
+        <p:nvSpPr>
+          <p:cNvPr id="4" name="Slide Number Placeholder 3"/>
+          <p:cNvSpPr>
+            <a:spLocks noGrp="1"/>
+          </p:cNvSpPr>
+          <p:nvPr>
+            <p:ph type="sldNum" idx="5" sz="quarter"/>
+          </p:nvPr>
+        </p:nvSpPr>
+        <p:spPr/>
+      </p:sp>
+    </p:spTree>
+  </p:cSld>
+  <p:clrMapOvr>
+    <a:masterClrMapping/>
+  </p:clrMapOvr>
+</p:notes>
+</file>
+
+<file path=ppt/notesSlides/notesSlide16.xml><?xml version="1.0" encoding="utf-8"?>
+<p:notes xmlns:a="http://schemas.openxmlformats.org/drawingml/2006/main" xmlns:p="http://schemas.openxmlformats.org/presentationml/2006/main" xmlns:r="http://schemas.openxmlformats.org/officeDocument/2006/relationships">
+  <p:cSld>
+    <p:spTree>
+      <p:nvGrpSpPr>
+        <p:cNvPr id="1" name=""/>
+        <p:cNvGrpSpPr/>
+        <p:nvPr/>
+      </p:nvGrpSpPr>
+      <p:grpSpPr>
+        <a:xfrm>
+          <a:off x="0" y="0"/>
+          <a:ext cx="0" cy="0"/>
+          <a:chOff x="0" y="0"/>
+          <a:chExt cx="0" cy="0"/>
+        </a:xfrm>
+      </p:grpSpPr>
+      <p:sp>
+        <p:nvSpPr>
+          <p:cNvPr id="2" name="Slide Image Placeholder 1"/>
+          <p:cNvSpPr>
+            <a:spLocks noGrp="1"/>
+          </p:cNvSpPr>
+          <p:nvPr>
+            <p:ph type="sldImg" idx="2"/>
+          </p:nvPr>
+        </p:nvSpPr>
+        <p:spPr/>
+      </p:sp>
+      <p:sp>
+        <p:nvSpPr>
+          <p:cNvPr id="3" name="Notes Placeholder 2"/>
+          <p:cNvSpPr>
+            <a:spLocks noGrp="1"/>
+          </p:cNvSpPr>
+          <p:nvPr>
+            <p:ph type="body" idx="3" sz="quarter"/>
+          </p:nvPr>
+        </p:nvSpPr>
+        <p:spPr/>
+        <p:txBody>
+          <a:bodyPr/>
+          <a:lstStyle/>
+          <a:p>
+            <a:r>
+              <a:t>所有链接为可点击链接。PPT共16页，对齐教师样例的信息密度；课堂主讲只需本PPT，学生逐步实操使用Notebook。未进行真实Kaggle或AutoDL登录执行，所有性能结果注明本地实测。</a:t>
             </a:r>
           </a:p>
         </p:txBody>
@@ -1496,7 +1567,7 @@
           <a:lstStyle/>
           <a:p>
             <a:r>
-              <a:t>结果来自examples/course_baseline与course_full_test。完整10000测试97.07%(9707/10000)，由验证97.30%选择第5轮模型；轮数是该次实测记录，不是课程要求。曲线蓝色训练、橙色验证。loss通常希望下降，accuracy通常希望上升；训练与验证差距反映泛化。完整测试不用于选最佳轮次。</a:t>
+              <a:t>在课程Notebook中显示学生本次运行的曲线。训练损失用于观察拟合过程，验证集用于模型与参数选择；锁定模型后查看测试结果，不根据测试分数反复调参。本页只引导结果解读，不展示教师准确率或设置成绩门槛。</a:t>
             </a:r>
           </a:p>
         </p:txBody>
@@ -7260,7 +7331,7 @@
                         </a:defRPr>
                       </a:pPr>
                       <a:r>
-                        <a:t>准确率低于参考</a:t>
+                        <a:t>验证表现不再改善</a:t>
                       </a:r>
                     </a:p>
                   </a:txBody>
@@ -7284,7 +7355,7 @@
                         </a:defRPr>
                       </a:pPr>
                       <a:r>
-                        <a:t>核对样本量、轮数、预训练来源与学习率策略，记录真实结果</a:t>
+                        <a:t>查看训练与验证曲线，检查样本量、预训练权重与学习率</a:t>
                       </a:r>
                     </a:p>
                   </a:txBody>
@@ -7333,7 +7404,7 @@
               </a:defRPr>
             </a:pPr>
             <a:r>
-              <a:t>CPU备用：README提供1,000张训练图、1轮的流程检查命令；它不代表正式95%以上的课程效果。</a:t>
+              <a:t>CPU备用：README提供小样本流程检查命令，便于先熟悉代码运行。</a:t>
             </a:r>
           </a:p>
         </p:txBody>
@@ -7776,7 +7847,7 @@
               </a:defRPr>
             </a:pPr>
             <a:r>
-              <a:t>建议评分 / 100分</a:t>
+              <a:t>基础任务达标检查</a:t>
             </a:r>
           </a:p>
         </p:txBody>
@@ -7833,7 +7904,7 @@
         <p:spPr>
           <a:xfrm>
             <a:off x="6665976" y="2496312"/>
-            <a:ext cx="3584448" cy="320040"/>
+            <a:ext cx="4343400" cy="320040"/>
           </a:xfrm>
           <a:prstGeom prst="rect">
             <a:avLst/>
@@ -7858,53 +7929,14 @@
               </a:defRPr>
             </a:pPr>
             <a:r>
-              <a:t>环境与数据</a:t>
-            </a:r>
-          </a:p>
-        </p:txBody>
-      </p:sp>
-      <p:sp>
-        <p:nvSpPr>
-          <p:cNvPr id="13" name="TextBox 12"/>
-          <p:cNvSpPr txBox="1"/>
-          <p:nvPr/>
-        </p:nvSpPr>
-        <p:spPr>
-          <a:xfrm>
-            <a:off x="10296144" y="2496312"/>
-            <a:ext cx="658368" cy="320040"/>
-          </a:xfrm>
-          <a:prstGeom prst="rect">
-            <a:avLst/>
-          </a:prstGeom>
-          <a:noFill/>
-        </p:spPr>
-        <p:txBody>
-          <a:bodyPr wrap="square" lIns="27432" rIns="27432" tIns="18288" bIns="18288">
-            <a:spAutoFit/>
-          </a:bodyPr>
-          <a:lstStyle/>
-          <a:p>
-            <a:pPr>
-              <a:spcAft>
-                <a:spcPts val="600"/>
-              </a:spcAft>
-              <a:defRPr sz="1700" b="1">
-                <a:solidFill>
-                  <a:srgbClr val="176BA0"/>
-                </a:solidFill>
-                <a:latin typeface="Noto Sans CJK SC"/>
-              </a:defRPr>
-            </a:pPr>
-            <a:r>
-              <a:t>15</a:t>
-            </a:r>
-          </a:p>
-        </p:txBody>
-      </p:sp>
-      <p:sp>
-        <p:nvSpPr>
-          <p:cNvPr id="14" name="Rectangle 13"/>
+              <a:t>训练、验证和测试流程完整</a:t>
+            </a:r>
+          </a:p>
+        </p:txBody>
+      </p:sp>
+      <p:sp>
+        <p:nvSpPr>
+          <p:cNvPr id="13" name="Rectangle 12"/>
           <p:cNvSpPr/>
           <p:nvPr/>
         </p:nvSpPr>
@@ -7947,14 +7979,14 @@
       </p:sp>
       <p:sp>
         <p:nvSpPr>
-          <p:cNvPr id="15" name="TextBox 14"/>
+          <p:cNvPr id="14" name="TextBox 13"/>
           <p:cNvSpPr txBox="1"/>
           <p:nvPr/>
         </p:nvSpPr>
         <p:spPr>
           <a:xfrm>
             <a:off x="6665976" y="2962656"/>
-            <a:ext cx="3584448" cy="320040"/>
+            <a:ext cx="4343400" cy="320040"/>
           </a:xfrm>
           <a:prstGeom prst="rect">
             <a:avLst/>
@@ -7979,53 +8011,14 @@
               </a:defRPr>
             </a:pPr>
             <a:r>
-              <a:t>基线完成</a:t>
-            </a:r>
-          </a:p>
-        </p:txBody>
-      </p:sp>
-      <p:sp>
-        <p:nvSpPr>
-          <p:cNvPr id="16" name="TextBox 15"/>
-          <p:cNvSpPr txBox="1"/>
-          <p:nvPr/>
-        </p:nvSpPr>
-        <p:spPr>
-          <a:xfrm>
-            <a:off x="10296144" y="2962656"/>
-            <a:ext cx="658368" cy="320040"/>
-          </a:xfrm>
-          <a:prstGeom prst="rect">
-            <a:avLst/>
-          </a:prstGeom>
-          <a:noFill/>
-        </p:spPr>
-        <p:txBody>
-          <a:bodyPr wrap="square" lIns="27432" rIns="27432" tIns="18288" bIns="18288">
-            <a:spAutoFit/>
-          </a:bodyPr>
-          <a:lstStyle/>
-          <a:p>
-            <a:pPr>
-              <a:spcAft>
-                <a:spcPts val="600"/>
-              </a:spcAft>
-              <a:defRPr sz="1700" b="1">
-                <a:solidFill>
-                  <a:srgbClr val="176BA0"/>
-                </a:solidFill>
-                <a:latin typeface="Noto Sans CJK SC"/>
-              </a:defRPr>
-            </a:pPr>
-            <a:r>
-              <a:t>25</a:t>
-            </a:r>
-          </a:p>
-        </p:txBody>
-      </p:sp>
-      <p:sp>
-        <p:nvSpPr>
-          <p:cNvPr id="17" name="Rectangle 16"/>
+              <a:t>记录实际参数与运行环境</a:t>
+            </a:r>
+          </a:p>
+        </p:txBody>
+      </p:sp>
+      <p:sp>
+        <p:nvSpPr>
+          <p:cNvPr id="15" name="Rectangle 14"/>
           <p:cNvSpPr/>
           <p:nvPr/>
         </p:nvSpPr>
@@ -8068,14 +8061,14 @@
       </p:sp>
       <p:sp>
         <p:nvSpPr>
-          <p:cNvPr id="18" name="TextBox 17"/>
+          <p:cNvPr id="16" name="TextBox 15"/>
           <p:cNvSpPr txBox="1"/>
           <p:nvPr/>
         </p:nvSpPr>
         <p:spPr>
           <a:xfrm>
             <a:off x="6665976" y="3429000"/>
-            <a:ext cx="3584448" cy="320040"/>
+            <a:ext cx="4343400" cy="320040"/>
           </a:xfrm>
           <a:prstGeom prst="rect">
             <a:avLst/>
@@ -8100,53 +8093,14 @@
               </a:defRPr>
             </a:pPr>
             <a:r>
-              <a:t>曲线与指标解读</a:t>
-            </a:r>
-          </a:p>
-        </p:txBody>
-      </p:sp>
-      <p:sp>
-        <p:nvSpPr>
-          <p:cNvPr id="19" name="TextBox 18"/>
-          <p:cNvSpPr txBox="1"/>
-          <p:nvPr/>
-        </p:nvSpPr>
-        <p:spPr>
-          <a:xfrm>
-            <a:off x="10296144" y="3429000"/>
-            <a:ext cx="658368" cy="320040"/>
-          </a:xfrm>
-          <a:prstGeom prst="rect">
-            <a:avLst/>
-          </a:prstGeom>
-          <a:noFill/>
-        </p:spPr>
-        <p:txBody>
-          <a:bodyPr wrap="square" lIns="27432" rIns="27432" tIns="18288" bIns="18288">
-            <a:spAutoFit/>
-          </a:bodyPr>
-          <a:lstStyle/>
-          <a:p>
-            <a:pPr>
-              <a:spcAft>
-                <a:spcPts val="600"/>
-              </a:spcAft>
-              <a:defRPr sz="1700" b="1">
-                <a:solidFill>
-                  <a:srgbClr val="176BA0"/>
-                </a:solidFill>
-                <a:latin typeface="Noto Sans CJK SC"/>
-              </a:defRPr>
-            </a:pPr>
-            <a:r>
-              <a:t>20</a:t>
-            </a:r>
-          </a:p>
-        </p:txBody>
-      </p:sp>
-      <p:sp>
-        <p:nvSpPr>
-          <p:cNvPr id="20" name="Rectangle 19"/>
+              <a:t>说明训练与验证曲线变化</a:t>
+            </a:r>
+          </a:p>
+        </p:txBody>
+      </p:sp>
+      <p:sp>
+        <p:nvSpPr>
+          <p:cNvPr id="17" name="Rectangle 16"/>
           <p:cNvSpPr/>
           <p:nvPr/>
         </p:nvSpPr>
@@ -8189,14 +8143,14 @@
       </p:sp>
       <p:sp>
         <p:nvSpPr>
-          <p:cNvPr id="21" name="TextBox 20"/>
+          <p:cNvPr id="18" name="TextBox 17"/>
           <p:cNvSpPr txBox="1"/>
           <p:nvPr/>
         </p:nvSpPr>
         <p:spPr>
           <a:xfrm>
             <a:off x="6665976" y="3895344"/>
-            <a:ext cx="3584448" cy="320040"/>
+            <a:ext cx="4343400" cy="320040"/>
           </a:xfrm>
           <a:prstGeom prst="rect">
             <a:avLst/>
@@ -8221,53 +8175,14 @@
               </a:defRPr>
             </a:pPr>
             <a:r>
-              <a:t>单参数对比</a:t>
-            </a:r>
-          </a:p>
-        </p:txBody>
-      </p:sp>
-      <p:sp>
-        <p:nvSpPr>
-          <p:cNvPr id="22" name="TextBox 21"/>
-          <p:cNvSpPr txBox="1"/>
-          <p:nvPr/>
-        </p:nvSpPr>
-        <p:spPr>
-          <a:xfrm>
-            <a:off x="10296144" y="3895344"/>
-            <a:ext cx="658368" cy="320040"/>
-          </a:xfrm>
-          <a:prstGeom prst="rect">
-            <a:avLst/>
-          </a:prstGeom>
-          <a:noFill/>
-        </p:spPr>
-        <p:txBody>
-          <a:bodyPr wrap="square" lIns="27432" rIns="27432" tIns="18288" bIns="18288">
-            <a:spAutoFit/>
-          </a:bodyPr>
-          <a:lstStyle/>
-          <a:p>
-            <a:pPr>
-              <a:spcAft>
-                <a:spcPts val="600"/>
-              </a:spcAft>
-              <a:defRPr sz="1700" b="1">
-                <a:solidFill>
-                  <a:srgbClr val="176BA0"/>
-                </a:solidFill>
-                <a:latin typeface="Noto Sans CJK SC"/>
-              </a:defRPr>
-            </a:pPr>
-            <a:r>
-              <a:t>20</a:t>
-            </a:r>
-          </a:p>
-        </p:txBody>
-      </p:sp>
-      <p:sp>
-        <p:nvSpPr>
-          <p:cNvPr id="23" name="Rectangle 22"/>
+              <a:t>完成一次自选参数对比</a:t>
+            </a:r>
+          </a:p>
+        </p:txBody>
+      </p:sp>
+      <p:sp>
+        <p:nvSpPr>
+          <p:cNvPr id="19" name="Rectangle 18"/>
           <p:cNvSpPr/>
           <p:nvPr/>
         </p:nvSpPr>
@@ -8310,14 +8225,14 @@
       </p:sp>
       <p:sp>
         <p:nvSpPr>
-          <p:cNvPr id="24" name="TextBox 23"/>
+          <p:cNvPr id="20" name="TextBox 19"/>
           <p:cNvSpPr txBox="1"/>
           <p:nvPr/>
         </p:nvSpPr>
         <p:spPr>
           <a:xfrm>
             <a:off x="6665976" y="4361688"/>
-            <a:ext cx="3584448" cy="320040"/>
+            <a:ext cx="4343400" cy="320040"/>
           </a:xfrm>
           <a:prstGeom prst="rect">
             <a:avLst/>
@@ -8342,53 +8257,14 @@
               </a:defRPr>
             </a:pPr>
             <a:r>
-              <a:t>错例分析</a:t>
-            </a:r>
-          </a:p>
-        </p:txBody>
-      </p:sp>
-      <p:sp>
-        <p:nvSpPr>
-          <p:cNvPr id="25" name="TextBox 24"/>
-          <p:cNvSpPr txBox="1"/>
-          <p:nvPr/>
-        </p:nvSpPr>
-        <p:spPr>
-          <a:xfrm>
-            <a:off x="10296144" y="4361688"/>
-            <a:ext cx="658368" cy="320040"/>
-          </a:xfrm>
-          <a:prstGeom prst="rect">
-            <a:avLst/>
-          </a:prstGeom>
-          <a:noFill/>
-        </p:spPr>
-        <p:txBody>
-          <a:bodyPr wrap="square" lIns="27432" rIns="27432" tIns="18288" bIns="18288">
-            <a:spAutoFit/>
-          </a:bodyPr>
-          <a:lstStyle/>
-          <a:p>
-            <a:pPr>
-              <a:spcAft>
-                <a:spcPts val="600"/>
-              </a:spcAft>
-              <a:defRPr sz="1700" b="1">
-                <a:solidFill>
-                  <a:srgbClr val="176BA0"/>
-                </a:solidFill>
-                <a:latin typeface="Noto Sans CJK SC"/>
-              </a:defRPr>
-            </a:pPr>
-            <a:r>
-              <a:t>10</a:t>
-            </a:r>
-          </a:p>
-        </p:txBody>
-      </p:sp>
-      <p:sp>
-        <p:nvSpPr>
-          <p:cNvPr id="26" name="Rectangle 25"/>
+              <a:t>查看预测并分析错例</a:t>
+            </a:r>
+          </a:p>
+        </p:txBody>
+      </p:sp>
+      <p:sp>
+        <p:nvSpPr>
+          <p:cNvPr id="21" name="Rectangle 20"/>
           <p:cNvSpPr/>
           <p:nvPr/>
         </p:nvSpPr>
@@ -8431,14 +8307,14 @@
       </p:sp>
       <p:sp>
         <p:nvSpPr>
-          <p:cNvPr id="27" name="TextBox 26"/>
+          <p:cNvPr id="22" name="TextBox 21"/>
           <p:cNvSpPr txBox="1"/>
           <p:nvPr/>
         </p:nvSpPr>
         <p:spPr>
           <a:xfrm>
             <a:off x="6665976" y="4828032"/>
-            <a:ext cx="3584448" cy="320040"/>
+            <a:ext cx="4343400" cy="320040"/>
           </a:xfrm>
           <a:prstGeom prst="rect">
             <a:avLst/>
@@ -8463,53 +8339,14 @@
               </a:defRPr>
             </a:pPr>
             <a:r>
-              <a:t>报告完整性</a:t>
-            </a:r>
-          </a:p>
-        </p:txBody>
-      </p:sp>
-      <p:sp>
-        <p:nvSpPr>
-          <p:cNvPr id="28" name="TextBox 27"/>
-          <p:cNvSpPr txBox="1"/>
-          <p:nvPr/>
-        </p:nvSpPr>
-        <p:spPr>
-          <a:xfrm>
-            <a:off x="10296144" y="4828032"/>
-            <a:ext cx="658368" cy="320040"/>
-          </a:xfrm>
-          <a:prstGeom prst="rect">
-            <a:avLst/>
-          </a:prstGeom>
-          <a:noFill/>
-        </p:spPr>
-        <p:txBody>
-          <a:bodyPr wrap="square" lIns="27432" rIns="27432" tIns="18288" bIns="18288">
-            <a:spAutoFit/>
-          </a:bodyPr>
-          <a:lstStyle/>
-          <a:p>
-            <a:pPr>
-              <a:spcAft>
-                <a:spcPts val="600"/>
-              </a:spcAft>
-              <a:defRPr sz="1700" b="1">
-                <a:solidFill>
-                  <a:srgbClr val="176BA0"/>
-                </a:solidFill>
-                <a:latin typeface="Noto Sans CJK SC"/>
-              </a:defRPr>
-            </a:pPr>
-            <a:r>
-              <a:t>10</a:t>
-            </a:r>
-          </a:p>
-        </p:txBody>
-      </p:sp>
-      <p:sp>
-        <p:nvSpPr>
-          <p:cNvPr id="29" name="TextBox 28"/>
+              <a:t>提交自己的实验报告</a:t>
+            </a:r>
+          </a:p>
+        </p:txBody>
+      </p:sp>
+      <p:sp>
+        <p:nvSpPr>
+          <p:cNvPr id="23" name="TextBox 22"/>
           <p:cNvSpPr txBox="1"/>
           <p:nvPr/>
         </p:nvSpPr>
@@ -8661,7 +8498,7 @@
               </a:defRPr>
             </a:pPr>
             <a:r>
-              <a:t>14 课程入口与参考资料</a:t>
+              <a:t>14 拓展加分任务</a:t>
             </a:r>
           </a:p>
         </p:txBody>
@@ -8711,46 +8548,7 @@
       </p:sp>
       <p:sp>
         <p:nvSpPr>
-          <p:cNvPr id="6" name="TextBox 5"/>
-          <p:cNvSpPr txBox="1"/>
-          <p:nvPr/>
-        </p:nvSpPr>
-        <p:spPr>
-          <a:xfrm>
-            <a:off x="603504" y="1517904"/>
-            <a:ext cx="10972800" cy="502920"/>
-          </a:xfrm>
-          <a:prstGeom prst="rect">
-            <a:avLst/>
-          </a:prstGeom>
-          <a:noFill/>
-        </p:spPr>
-        <p:txBody>
-          <a:bodyPr wrap="square" lIns="27432" rIns="27432" tIns="18288" bIns="18288">
-            <a:spAutoFit/>
-          </a:bodyPr>
-          <a:lstStyle/>
-          <a:p>
-            <a:pPr>
-              <a:spcAft>
-                <a:spcPts val="600"/>
-              </a:spcAft>
-              <a:defRPr sz="1700" b="0">
-                <a:solidFill>
-                  <a:srgbClr val="647483"/>
-                </a:solidFill>
-                <a:latin typeface="Noto Sans CJK SC"/>
-              </a:defRPr>
-            </a:pPr>
-            <a:r>
-              <a:t>详细点击步骤、完整命令和排错说明，统一放在配套指南与Notebook。</a:t>
-            </a:r>
-          </a:p>
-        </p:txBody>
-      </p:sp>
-      <p:sp>
-        <p:nvSpPr>
-          <p:cNvPr id="7" name="Rectangle 6"/>
+          <p:cNvPr id="6" name="Rectangle 5"/>
           <p:cNvSpPr/>
           <p:nvPr/>
         </p:nvSpPr>
@@ -8793,7 +8591,7 @@
       </p:sp>
       <p:sp>
         <p:nvSpPr>
-          <p:cNvPr id="8" name="Rectangle 7"/>
+          <p:cNvPr id="7" name="Rectangle 6"/>
           <p:cNvSpPr/>
           <p:nvPr/>
         </p:nvSpPr>
@@ -8836,7 +8634,7 @@
       </p:sp>
       <p:sp>
         <p:nvSpPr>
-          <p:cNvPr id="9" name="TextBox 8"/>
+          <p:cNvPr id="8" name="TextBox 7"/>
           <p:cNvSpPr txBox="1"/>
           <p:nvPr/>
         </p:nvSpPr>
@@ -8869,6 +8667,776 @@
             </a:pPr>
             <a:r>
               <a:t>15</a:t>
+            </a:r>
+          </a:p>
+        </p:txBody>
+      </p:sp>
+      <p:sp>
+        <p:nvSpPr>
+          <p:cNvPr id="9" name="Rounded Rectangle 8"/>
+          <p:cNvSpPr/>
+          <p:nvPr/>
+        </p:nvSpPr>
+        <p:spPr>
+          <a:xfrm>
+            <a:off x="758952" y="1792224"/>
+            <a:ext cx="10680192" cy="786384"/>
+          </a:xfrm>
+          <a:prstGeom prst="roundRect">
+            <a:avLst/>
+          </a:prstGeom>
+          <a:solidFill>
+            <a:srgbClr val="EDF4F8"/>
+          </a:solidFill>
+          <a:ln>
+            <a:noFill/>
+          </a:ln>
+        </p:spPr>
+        <p:style>
+          <a:lnRef idx="1">
+            <a:schemeClr val="accent1"/>
+          </a:lnRef>
+          <a:fillRef idx="3">
+            <a:schemeClr val="accent1"/>
+          </a:fillRef>
+          <a:effectRef idx="2">
+            <a:schemeClr val="accent1"/>
+          </a:effectRef>
+          <a:fontRef idx="minor">
+            <a:schemeClr val="lt1"/>
+          </a:fontRef>
+        </p:style>
+        <p:txBody>
+          <a:bodyPr rtlCol="0" anchor="ctr"/>
+          <a:lstStyle/>
+          <a:p>
+            <a:pPr algn="ctr"/>
+          </a:p>
+        </p:txBody>
+      </p:sp>
+      <p:sp>
+        <p:nvSpPr>
+          <p:cNvPr id="10" name="TextBox 9"/>
+          <p:cNvSpPr txBox="1"/>
+          <p:nvPr/>
+        </p:nvSpPr>
+        <p:spPr>
+          <a:xfrm>
+            <a:off x="941832" y="1984248"/>
+            <a:ext cx="10287000" cy="420624"/>
+          </a:xfrm>
+          <a:prstGeom prst="rect">
+            <a:avLst/>
+          </a:prstGeom>
+          <a:noFill/>
+        </p:spPr>
+        <p:txBody>
+          <a:bodyPr wrap="square" lIns="27432" rIns="27432" tIns="18288" bIns="18288">
+            <a:spAutoFit/>
+          </a:bodyPr>
+          <a:lstStyle/>
+          <a:p>
+            <a:pPr>
+              <a:spcAft>
+                <a:spcPts val="600"/>
+              </a:spcAft>
+              <a:defRPr sz="2300" b="1">
+                <a:solidFill>
+                  <a:srgbClr val="176BA0"/>
+                </a:solidFill>
+                <a:latin typeface="Noto Sans CJK SC"/>
+              </a:defRPr>
+            </a:pPr>
+            <a:r>
+              <a:t>完成MNIST规定任务并提交实验报告，即达标及格。</a:t>
+            </a:r>
+          </a:p>
+        </p:txBody>
+      </p:sp>
+      <p:sp>
+        <p:nvSpPr>
+          <p:cNvPr id="11" name="Rounded Rectangle 10"/>
+          <p:cNvSpPr/>
+          <p:nvPr/>
+        </p:nvSpPr>
+        <p:spPr>
+          <a:xfrm>
+            <a:off x="758952" y="2944368"/>
+            <a:ext cx="5212080" cy="2212848"/>
+          </a:xfrm>
+          <a:prstGeom prst="roundRect">
+            <a:avLst/>
+          </a:prstGeom>
+          <a:solidFill>
+            <a:srgbClr val="EDF4F8"/>
+          </a:solidFill>
+          <a:ln>
+            <a:noFill/>
+          </a:ln>
+        </p:spPr>
+        <p:style>
+          <a:lnRef idx="1">
+            <a:schemeClr val="accent1"/>
+          </a:lnRef>
+          <a:fillRef idx="3">
+            <a:schemeClr val="accent1"/>
+          </a:fillRef>
+          <a:effectRef idx="2">
+            <a:schemeClr val="accent1"/>
+          </a:effectRef>
+          <a:fontRef idx="minor">
+            <a:schemeClr val="lt1"/>
+          </a:fontRef>
+        </p:style>
+        <p:txBody>
+          <a:bodyPr rtlCol="0" anchor="ctr"/>
+          <a:lstStyle/>
+          <a:p>
+            <a:pPr algn="ctr"/>
+          </a:p>
+        </p:txBody>
+      </p:sp>
+      <p:sp>
+        <p:nvSpPr>
+          <p:cNvPr id="12" name="TextBox 11"/>
+          <p:cNvSpPr txBox="1"/>
+          <p:nvPr/>
+        </p:nvSpPr>
+        <p:spPr>
+          <a:xfrm>
+            <a:off x="914400" y="3145536"/>
+            <a:ext cx="4882896" cy="420624"/>
+          </a:xfrm>
+          <a:prstGeom prst="rect">
+            <a:avLst/>
+          </a:prstGeom>
+          <a:noFill/>
+        </p:spPr>
+        <p:txBody>
+          <a:bodyPr wrap="square" lIns="27432" rIns="27432" tIns="18288" bIns="18288">
+            <a:spAutoFit/>
+          </a:bodyPr>
+          <a:lstStyle/>
+          <a:p>
+            <a:pPr>
+              <a:spcAft>
+                <a:spcPts val="600"/>
+              </a:spcAft>
+              <a:defRPr sz="2200" b="1">
+                <a:solidFill>
+                  <a:srgbClr val="176BA0"/>
+                </a:solidFill>
+                <a:latin typeface="Noto Sans CJK SC"/>
+              </a:defRPr>
+            </a:pPr>
+            <a:r>
+              <a:t>加分任务一｜CIFAR-10微调</a:t>
+            </a:r>
+          </a:p>
+        </p:txBody>
+      </p:sp>
+      <p:sp>
+        <p:nvSpPr>
+          <p:cNvPr id="13" name="TextBox 12"/>
+          <p:cNvSpPr txBox="1"/>
+          <p:nvPr/>
+        </p:nvSpPr>
+        <p:spPr>
+          <a:xfrm>
+            <a:off x="914400" y="3822191"/>
+            <a:ext cx="4882896" cy="1170432"/>
+          </a:xfrm>
+          <a:prstGeom prst="rect">
+            <a:avLst/>
+          </a:prstGeom>
+          <a:noFill/>
+        </p:spPr>
+        <p:txBody>
+          <a:bodyPr wrap="square" lIns="27432" rIns="27432" tIns="18288" bIns="18288">
+            <a:spAutoFit/>
+          </a:bodyPr>
+          <a:lstStyle/>
+          <a:p>
+            <a:pPr>
+              <a:spcAft>
+                <a:spcPts val="600"/>
+              </a:spcAft>
+              <a:defRPr sz="1800" b="0">
+                <a:solidFill>
+                  <a:srgbClr val="243547"/>
+                </a:solidFill>
+                <a:latin typeface="Noto Sans CJK SC"/>
+              </a:defRPr>
+            </a:pPr>
+            <a:r>
+              <a:t>把ByteFormer微调流程迁移到CIFAR-10。</a:t>
+            </a:r>
+          </a:p>
+          <a:p>
+            <a:pPr>
+              <a:spcAft>
+                <a:spcPts val="600"/>
+              </a:spcAft>
+              <a:defRPr sz="1800" b="0">
+                <a:solidFill>
+                  <a:srgbClr val="243547"/>
+                </a:solidFill>
+                <a:latin typeface="Noto Sans CJK SC"/>
+              </a:defRPr>
+            </a:pPr>
+            <a:r>
+              <a:t>自行适配数据读取与分类任务，</a:t>
+            </a:r>
+          </a:p>
+          <a:p>
+            <a:pPr>
+              <a:spcAft>
+                <a:spcPts val="600"/>
+              </a:spcAft>
+              <a:defRPr sz="1800" b="0">
+                <a:solidFill>
+                  <a:srgbClr val="243547"/>
+                </a:solidFill>
+                <a:latin typeface="Noto Sans CJK SC"/>
+              </a:defRPr>
+            </a:pPr>
+            <a:r>
+              <a:t>完成训练、验证和测试。</a:t>
+            </a:r>
+          </a:p>
+        </p:txBody>
+      </p:sp>
+      <p:sp>
+        <p:nvSpPr>
+          <p:cNvPr id="14" name="Rounded Rectangle 13"/>
+          <p:cNvSpPr/>
+          <p:nvPr/>
+        </p:nvSpPr>
+        <p:spPr>
+          <a:xfrm>
+            <a:off x="6227064" y="2944368"/>
+            <a:ext cx="5212080" cy="2212848"/>
+          </a:xfrm>
+          <a:prstGeom prst="roundRect">
+            <a:avLst/>
+          </a:prstGeom>
+          <a:solidFill>
+            <a:srgbClr val="EDF4F8"/>
+          </a:solidFill>
+          <a:ln>
+            <a:noFill/>
+          </a:ln>
+        </p:spPr>
+        <p:style>
+          <a:lnRef idx="1">
+            <a:schemeClr val="accent1"/>
+          </a:lnRef>
+          <a:fillRef idx="3">
+            <a:schemeClr val="accent1"/>
+          </a:fillRef>
+          <a:effectRef idx="2">
+            <a:schemeClr val="accent1"/>
+          </a:effectRef>
+          <a:fontRef idx="minor">
+            <a:schemeClr val="lt1"/>
+          </a:fontRef>
+        </p:style>
+        <p:txBody>
+          <a:bodyPr rtlCol="0" anchor="ctr"/>
+          <a:lstStyle/>
+          <a:p>
+            <a:pPr algn="ctr"/>
+          </a:p>
+        </p:txBody>
+      </p:sp>
+      <p:sp>
+        <p:nvSpPr>
+          <p:cNvPr id="15" name="TextBox 14"/>
+          <p:cNvSpPr txBox="1"/>
+          <p:nvPr/>
+        </p:nvSpPr>
+        <p:spPr>
+          <a:xfrm>
+            <a:off x="6382512" y="3145536"/>
+            <a:ext cx="4882896" cy="420624"/>
+          </a:xfrm>
+          <a:prstGeom prst="rect">
+            <a:avLst/>
+          </a:prstGeom>
+          <a:noFill/>
+        </p:spPr>
+        <p:txBody>
+          <a:bodyPr wrap="square" lIns="27432" rIns="27432" tIns="18288" bIns="18288">
+            <a:spAutoFit/>
+          </a:bodyPr>
+          <a:lstStyle/>
+          <a:p>
+            <a:pPr>
+              <a:spcAft>
+                <a:spcPts val="600"/>
+              </a:spcAft>
+              <a:defRPr sz="2200" b="1">
+                <a:solidFill>
+                  <a:srgbClr val="176BA0"/>
+                </a:solidFill>
+                <a:latin typeface="Noto Sans CJK SC"/>
+              </a:defRPr>
+            </a:pPr>
+            <a:r>
+              <a:t>进阶加分任务二｜Stanford40</a:t>
+            </a:r>
+          </a:p>
+        </p:txBody>
+      </p:sp>
+      <p:sp>
+        <p:nvSpPr>
+          <p:cNvPr id="16" name="TextBox 15"/>
+          <p:cNvSpPr txBox="1"/>
+          <p:nvPr/>
+        </p:nvSpPr>
+        <p:spPr>
+          <a:xfrm>
+            <a:off x="6382512" y="3822191"/>
+            <a:ext cx="4882896" cy="1170432"/>
+          </a:xfrm>
+          <a:prstGeom prst="rect">
+            <a:avLst/>
+          </a:prstGeom>
+          <a:noFill/>
+        </p:spPr>
+        <p:txBody>
+          <a:bodyPr wrap="square" lIns="27432" rIns="27432" tIns="18288" bIns="18288">
+            <a:spAutoFit/>
+          </a:bodyPr>
+          <a:lstStyle/>
+          <a:p>
+            <a:pPr>
+              <a:spcAft>
+                <a:spcPts val="600"/>
+              </a:spcAft>
+              <a:defRPr sz="1800" b="0">
+                <a:solidFill>
+                  <a:srgbClr val="243547"/>
+                </a:solidFill>
+                <a:latin typeface="Noto Sans CJK SC"/>
+              </a:defRPr>
+            </a:pPr>
+            <a:r>
+              <a:t>完成斯坦福40动作识别数据集的微调分类。</a:t>
+            </a:r>
+          </a:p>
+          <a:p>
+            <a:pPr>
+              <a:spcAft>
+                <a:spcPts val="600"/>
+              </a:spcAft>
+              <a:defRPr sz="1800" b="0">
+                <a:solidFill>
+                  <a:srgbClr val="243547"/>
+                </a:solidFill>
+                <a:latin typeface="Noto Sans CJK SC"/>
+              </a:defRPr>
+            </a:pPr>
+            <a:r>
+              <a:t>自行准备数据、调整分类头并设置参数，</a:t>
+            </a:r>
+          </a:p>
+          <a:p>
+            <a:pPr>
+              <a:spcAft>
+                <a:spcPts val="600"/>
+              </a:spcAft>
+              <a:defRPr sz="1800" b="0">
+                <a:solidFill>
+                  <a:srgbClr val="243547"/>
+                </a:solidFill>
+                <a:latin typeface="Noto Sans CJK SC"/>
+              </a:defRPr>
+            </a:pPr>
+            <a:r>
+              <a:t>分析预测结果与典型错例。</a:t>
+            </a:r>
+          </a:p>
+        </p:txBody>
+      </p:sp>
+      <p:sp>
+        <p:nvSpPr>
+          <p:cNvPr id="17" name="TextBox 16"/>
+          <p:cNvSpPr txBox="1"/>
+          <p:nvPr/>
+        </p:nvSpPr>
+        <p:spPr>
+          <a:xfrm>
+            <a:off x="896112" y="5477256"/>
+            <a:ext cx="10378440" cy="768096"/>
+          </a:xfrm>
+          <a:prstGeom prst="rect">
+            <a:avLst/>
+          </a:prstGeom>
+          <a:noFill/>
+        </p:spPr>
+        <p:txBody>
+          <a:bodyPr wrap="square" lIns="27432" rIns="27432" tIns="18288" bIns="18288">
+            <a:spAutoFit/>
+          </a:bodyPr>
+          <a:lstStyle/>
+          <a:p>
+            <a:pPr>
+              <a:spcAft>
+                <a:spcPts val="600"/>
+              </a:spcAft>
+              <a:defRPr sz="2000" b="0">
+                <a:solidFill>
+                  <a:srgbClr val="243547"/>
+                </a:solidFill>
+                <a:latin typeface="Noto Sans CJK SC"/>
+              </a:defRPr>
+            </a:pPr>
+            <a:r>
+              <a:t>完成额外任务可获得加分，挑战进阶任务可争取更高分。</a:t>
+            </a:r>
+          </a:p>
+          <a:p>
+            <a:pPr>
+              <a:spcAft>
+                <a:spcPts val="600"/>
+              </a:spcAft>
+              <a:defRPr sz="2000" b="0">
+                <a:solidFill>
+                  <a:srgbClr val="243547"/>
+                </a:solidFill>
+                <a:latin typeface="Noto Sans CJK SC"/>
+              </a:defRPr>
+            </a:pPr>
+            <a:r>
+              <a:t>附上代码、数据划分、实际结果与简要分析，说明你做了哪些调整。</a:t>
+            </a:r>
+          </a:p>
+        </p:txBody>
+      </p:sp>
+    </p:spTree>
+  </p:cSld>
+  <p:clrMapOvr>
+    <a:masterClrMapping/>
+  </p:clrMapOvr>
+</p:sld>
+</file>
+
+<file path=ppt/slides/slide16.xml><?xml version="1.0" encoding="utf-8"?>
+<p:sld xmlns:a="http://schemas.openxmlformats.org/drawingml/2006/main" xmlns:p="http://schemas.openxmlformats.org/presentationml/2006/main" xmlns:r="http://schemas.openxmlformats.org/officeDocument/2006/relationships">
+  <p:cSld>
+    <p:spTree>
+      <p:nvGrpSpPr>
+        <p:cNvPr id="1" name=""/>
+        <p:cNvGrpSpPr/>
+        <p:nvPr/>
+      </p:nvGrpSpPr>
+      <p:grpSpPr/>
+      <p:pic>
+        <p:nvPicPr>
+          <p:cNvPr id="2" name="Picture 1" descr="hust_wordmark.png"/>
+          <p:cNvPicPr>
+            <a:picLocks noChangeAspect="1"/>
+          </p:cNvPicPr>
+          <p:nvPr/>
+        </p:nvPicPr>
+        <p:blipFill>
+          <a:blip r:embed="rId2"/>
+          <a:stretch>
+            <a:fillRect/>
+          </a:stretch>
+        </p:blipFill>
+        <p:spPr>
+          <a:xfrm>
+            <a:off x="1011360" y="182880"/>
+            <a:ext cx="1406278" cy="475488"/>
+          </a:xfrm>
+          <a:prstGeom prst="rect">
+            <a:avLst/>
+          </a:prstGeom>
+        </p:spPr>
+      </p:pic>
+      <p:sp>
+        <p:nvSpPr>
+          <p:cNvPr id="3" name="TextBox 2"/>
+          <p:cNvSpPr txBox="1"/>
+          <p:nvPr/>
+        </p:nvSpPr>
+        <p:spPr>
+          <a:xfrm>
+            <a:off x="7772400" y="219456"/>
+            <a:ext cx="3840480" cy="320040"/>
+          </a:xfrm>
+          <a:prstGeom prst="rect">
+            <a:avLst/>
+          </a:prstGeom>
+          <a:noFill/>
+        </p:spPr>
+        <p:txBody>
+          <a:bodyPr wrap="square" lIns="27432" rIns="27432" tIns="18288" bIns="18288">
+            <a:spAutoFit/>
+          </a:bodyPr>
+          <a:lstStyle/>
+          <a:p>
+            <a:pPr algn="r">
+              <a:spcAft>
+                <a:spcPts val="600"/>
+              </a:spcAft>
+              <a:defRPr sz="1300" b="0">
+                <a:solidFill>
+                  <a:srgbClr val="647483"/>
+                </a:solidFill>
+                <a:latin typeface="Noto Sans CJK SC"/>
+              </a:defRPr>
+            </a:pPr>
+            <a:r>
+              <a:t>ByteFormer · MNIST 实验课</a:t>
+            </a:r>
+          </a:p>
+        </p:txBody>
+      </p:sp>
+      <p:sp>
+        <p:nvSpPr>
+          <p:cNvPr id="4" name="TextBox 3"/>
+          <p:cNvSpPr txBox="1"/>
+          <p:nvPr/>
+        </p:nvSpPr>
+        <p:spPr>
+          <a:xfrm>
+            <a:off x="548640" y="786384"/>
+            <a:ext cx="11064240" cy="512064"/>
+          </a:xfrm>
+          <a:prstGeom prst="rect">
+            <a:avLst/>
+          </a:prstGeom>
+          <a:noFill/>
+        </p:spPr>
+        <p:txBody>
+          <a:bodyPr wrap="square" lIns="27432" rIns="27432" tIns="18288" bIns="18288">
+            <a:spAutoFit/>
+          </a:bodyPr>
+          <a:lstStyle/>
+          <a:p>
+            <a:pPr>
+              <a:spcAft>
+                <a:spcPts val="600"/>
+              </a:spcAft>
+              <a:defRPr sz="3000" b="1">
+                <a:solidFill>
+                  <a:srgbClr val="243547"/>
+                </a:solidFill>
+                <a:latin typeface="Noto Sans CJK SC"/>
+              </a:defRPr>
+            </a:pPr>
+            <a:r>
+              <a:t>15 课程入口与参考资料</a:t>
+            </a:r>
+          </a:p>
+        </p:txBody>
+      </p:sp>
+      <p:sp>
+        <p:nvSpPr>
+          <p:cNvPr id="5" name="Rectangle 4"/>
+          <p:cNvSpPr/>
+          <p:nvPr/>
+        </p:nvSpPr>
+        <p:spPr>
+          <a:xfrm>
+            <a:off x="594360" y="1371600"/>
+            <a:ext cx="10991088" cy="21031"/>
+          </a:xfrm>
+          <a:prstGeom prst="rect">
+            <a:avLst/>
+          </a:prstGeom>
+          <a:solidFill>
+            <a:srgbClr val="BACBD7"/>
+          </a:solidFill>
+          <a:ln>
+            <a:noFill/>
+          </a:ln>
+        </p:spPr>
+        <p:style>
+          <a:lnRef idx="1">
+            <a:schemeClr val="accent1"/>
+          </a:lnRef>
+          <a:fillRef idx="3">
+            <a:schemeClr val="accent1"/>
+          </a:fillRef>
+          <a:effectRef idx="2">
+            <a:schemeClr val="accent1"/>
+          </a:effectRef>
+          <a:fontRef idx="minor">
+            <a:schemeClr val="lt1"/>
+          </a:fontRef>
+        </p:style>
+        <p:txBody>
+          <a:bodyPr rtlCol="0" anchor="ctr"/>
+          <a:lstStyle/>
+          <a:p>
+            <a:pPr algn="ctr"/>
+          </a:p>
+        </p:txBody>
+      </p:sp>
+      <p:sp>
+        <p:nvSpPr>
+          <p:cNvPr id="6" name="TextBox 5"/>
+          <p:cNvSpPr txBox="1"/>
+          <p:nvPr/>
+        </p:nvSpPr>
+        <p:spPr>
+          <a:xfrm>
+            <a:off x="603504" y="1517904"/>
+            <a:ext cx="10972800" cy="502920"/>
+          </a:xfrm>
+          <a:prstGeom prst="rect">
+            <a:avLst/>
+          </a:prstGeom>
+          <a:noFill/>
+        </p:spPr>
+        <p:txBody>
+          <a:bodyPr wrap="square" lIns="27432" rIns="27432" tIns="18288" bIns="18288">
+            <a:spAutoFit/>
+          </a:bodyPr>
+          <a:lstStyle/>
+          <a:p>
+            <a:pPr>
+              <a:spcAft>
+                <a:spcPts val="600"/>
+              </a:spcAft>
+              <a:defRPr sz="1700" b="0">
+                <a:solidFill>
+                  <a:srgbClr val="647483"/>
+                </a:solidFill>
+                <a:latin typeface="Noto Sans CJK SC"/>
+              </a:defRPr>
+            </a:pPr>
+            <a:r>
+              <a:t>详细点击步骤、完整命令和排错说明，统一放在配套指南与Notebook。</a:t>
+            </a:r>
+          </a:p>
+        </p:txBody>
+      </p:sp>
+      <p:sp>
+        <p:nvSpPr>
+          <p:cNvPr id="7" name="Rectangle 6"/>
+          <p:cNvSpPr/>
+          <p:nvPr/>
+        </p:nvSpPr>
+        <p:spPr>
+          <a:xfrm>
+            <a:off x="256032" y="6373368"/>
+            <a:ext cx="292608" cy="292608"/>
+          </a:xfrm>
+          <a:prstGeom prst="rect">
+            <a:avLst/>
+          </a:prstGeom>
+          <a:solidFill>
+            <a:srgbClr val="B8D7EA"/>
+          </a:solidFill>
+          <a:ln>
+            <a:noFill/>
+          </a:ln>
+        </p:spPr>
+        <p:style>
+          <a:lnRef idx="1">
+            <a:schemeClr val="accent1"/>
+          </a:lnRef>
+          <a:fillRef idx="3">
+            <a:schemeClr val="accent1"/>
+          </a:fillRef>
+          <a:effectRef idx="2">
+            <a:schemeClr val="accent1"/>
+          </a:effectRef>
+          <a:fontRef idx="minor">
+            <a:schemeClr val="lt1"/>
+          </a:fontRef>
+        </p:style>
+        <p:txBody>
+          <a:bodyPr rtlCol="0" anchor="ctr"/>
+          <a:lstStyle/>
+          <a:p>
+            <a:pPr algn="ctr"/>
+          </a:p>
+        </p:txBody>
+      </p:sp>
+      <p:sp>
+        <p:nvSpPr>
+          <p:cNvPr id="8" name="Rectangle 7"/>
+          <p:cNvSpPr/>
+          <p:nvPr/>
+        </p:nvSpPr>
+        <p:spPr>
+          <a:xfrm>
+            <a:off x="621792" y="6373368"/>
+            <a:ext cx="292608" cy="292608"/>
+          </a:xfrm>
+          <a:prstGeom prst="rect">
+            <a:avLst/>
+          </a:prstGeom>
+          <a:solidFill>
+            <a:srgbClr val="C5C3D3"/>
+          </a:solidFill>
+          <a:ln>
+            <a:noFill/>
+          </a:ln>
+        </p:spPr>
+        <p:style>
+          <a:lnRef idx="1">
+            <a:schemeClr val="accent1"/>
+          </a:lnRef>
+          <a:fillRef idx="3">
+            <a:schemeClr val="accent1"/>
+          </a:fillRef>
+          <a:effectRef idx="2">
+            <a:schemeClr val="accent1"/>
+          </a:effectRef>
+          <a:fontRef idx="minor">
+            <a:schemeClr val="lt1"/>
+          </a:fontRef>
+        </p:style>
+        <p:txBody>
+          <a:bodyPr rtlCol="0" anchor="ctr"/>
+          <a:lstStyle/>
+          <a:p>
+            <a:pPr algn="ctr"/>
+          </a:p>
+        </p:txBody>
+      </p:sp>
+      <p:sp>
+        <p:nvSpPr>
+          <p:cNvPr id="9" name="TextBox 8"/>
+          <p:cNvSpPr txBox="1"/>
+          <p:nvPr/>
+        </p:nvSpPr>
+        <p:spPr>
+          <a:xfrm>
+            <a:off x="11064240" y="6400800"/>
+            <a:ext cx="502920" cy="274320"/>
+          </a:xfrm>
+          <a:prstGeom prst="rect">
+            <a:avLst/>
+          </a:prstGeom>
+          <a:noFill/>
+        </p:spPr>
+        <p:txBody>
+          <a:bodyPr wrap="square" lIns="27432" rIns="27432" tIns="18288" bIns="18288">
+            <a:spAutoFit/>
+          </a:bodyPr>
+          <a:lstStyle/>
+          <a:p>
+            <a:pPr algn="r">
+              <a:spcAft>
+                <a:spcPts val="600"/>
+              </a:spcAft>
+              <a:defRPr sz="1100" b="0">
+                <a:solidFill>
+                  <a:srgbClr val="647483"/>
+                </a:solidFill>
+                <a:latin typeface="Noto Sans CJK SC"/>
+              </a:defRPr>
+            </a:pPr>
+            <a:r>
+              <a:t>16</a:t>
             </a:r>
           </a:p>
         </p:txBody>
@@ -9529,7 +10097,7 @@
               </a:defRPr>
             </a:pPr>
             <a:r>
-              <a:t>加载官方预训练ByteFormer，识别MNIST手写数字0—9；教师正式测试97.07%。</a:t>
+              <a:t>加载官方预训练ByteFormer，完成MNIST手写数字0—9分类。</a:t>
             </a:r>
           </a:p>
         </p:txBody>
@@ -9771,7 +10339,7 @@
               </a:defRPr>
             </a:pPr>
             <a:r>
-              <a:t>保留指标、曲线、错例和Word报告，不能用教师结果代替自己的运行。</a:t>
+              <a:t>保留自己的指标、曲线、错例和Word报告，说明参数选择与结果。</a:t>
             </a:r>
           </a:p>
         </p:txBody>
@@ -13636,7 +14204,7 @@
               </a:defRPr>
             </a:pPr>
             <a:r>
-              <a:t>07 正式训练：看懂参数，运行一条命令</a:t>
+              <a:t>07 开始训练：看懂参数，运行一条命令</a:t>
             </a:r>
           </a:p>
         </p:txBody>
@@ -14769,7 +15337,7 @@
               </a:defRPr>
             </a:pPr>
             <a:r>
-              <a:t>08 正式实测结果：先用验证选模型，再做测试</a:t>
+              <a:t>08 查看自己的训练结果</a:t>
             </a:r>
           </a:p>
         </p:txBody>
@@ -14950,8 +15518,106 @@
         </p:nvSpPr>
         <p:spPr>
           <a:xfrm>
-            <a:off x="768096" y="1801368"/>
-            <a:ext cx="3566160" cy="914400"/>
+            <a:off x="749808" y="1828800"/>
+            <a:ext cx="10698480" cy="1170432"/>
+          </a:xfrm>
+          <a:prstGeom prst="roundRect">
+            <a:avLst/>
+          </a:prstGeom>
+          <a:solidFill>
+            <a:srgbClr val="20384B"/>
+          </a:solidFill>
+          <a:ln>
+            <a:noFill/>
+          </a:ln>
+        </p:spPr>
+        <p:style>
+          <a:lnRef idx="1">
+            <a:schemeClr val="accent1"/>
+          </a:lnRef>
+          <a:fillRef idx="3">
+            <a:schemeClr val="accent1"/>
+          </a:fillRef>
+          <a:effectRef idx="2">
+            <a:schemeClr val="accent1"/>
+          </a:effectRef>
+          <a:fontRef idx="minor">
+            <a:schemeClr val="lt1"/>
+          </a:fontRef>
+        </p:style>
+        <p:txBody>
+          <a:bodyPr rtlCol="0" anchor="ctr"/>
+          <a:lstStyle/>
+          <a:p>
+            <a:pPr algn="ctr"/>
+          </a:p>
+        </p:txBody>
+      </p:sp>
+      <p:sp>
+        <p:nvSpPr>
+          <p:cNvPr id="10" name="TextBox 9"/>
+          <p:cNvSpPr txBox="1"/>
+          <p:nvPr/>
+        </p:nvSpPr>
+        <p:spPr>
+          <a:xfrm>
+            <a:off x="914400" y="1956816"/>
+            <a:ext cx="10369296" cy="914400"/>
+          </a:xfrm>
+          <a:prstGeom prst="rect">
+            <a:avLst/>
+          </a:prstGeom>
+          <a:noFill/>
+        </p:spPr>
+        <p:txBody>
+          <a:bodyPr wrap="square" lIns="27432" rIns="27432" tIns="18288" bIns="18288">
+            <a:spAutoFit/>
+          </a:bodyPr>
+          <a:lstStyle/>
+          <a:p>
+            <a:pPr>
+              <a:spcAft>
+                <a:spcPts val="300"/>
+              </a:spcAft>
+              <a:defRPr sz="2000" b="0">
+                <a:solidFill>
+                  <a:srgbClr val="FFFFFF"/>
+                </a:solidFill>
+                <a:latin typeface="DejaVu Sans Mono"/>
+              </a:defRPr>
+            </a:pPr>
+            <a:r>
+              <a:t>from IPython.display import display, Image</a:t>
+            </a:r>
+          </a:p>
+          <a:p>
+            <a:pPr>
+              <a:spcAft>
+                <a:spcPts val="300"/>
+              </a:spcAft>
+              <a:defRPr sz="2000" b="0">
+                <a:solidFill>
+                  <a:srgbClr val="FFFFFF"/>
+                </a:solidFill>
+                <a:latin typeface="DejaVu Sans Mono"/>
+              </a:defRPr>
+            </a:pPr>
+            <a:r>
+              <a:t>display(Image("outputs/baseline/curves.png"))</a:t>
+            </a:r>
+          </a:p>
+        </p:txBody>
+      </p:sp>
+      <p:sp>
+        <p:nvSpPr>
+          <p:cNvPr id="11" name="Rounded Rectangle 10"/>
+          <p:cNvSpPr/>
+          <p:nvPr/>
+        </p:nvSpPr>
+        <p:spPr>
+          <a:xfrm>
+            <a:off x="758952" y="3456432"/>
+            <a:ext cx="3547872" cy="1746504"/>
           </a:xfrm>
           <a:prstGeom prst="roundRect">
             <a:avLst/>
@@ -14987,14 +15653,14 @@
       </p:sp>
       <p:sp>
         <p:nvSpPr>
-          <p:cNvPr id="10" name="TextBox 9"/>
+          <p:cNvPr id="12" name="TextBox 11"/>
           <p:cNvSpPr txBox="1"/>
           <p:nvPr/>
         </p:nvSpPr>
         <p:spPr>
           <a:xfrm>
-            <a:off x="886968" y="1901952"/>
-            <a:ext cx="3328416" cy="292608"/>
+            <a:off x="914400" y="3621024"/>
+            <a:ext cx="3218688" cy="393192"/>
           </a:xfrm>
           <a:prstGeom prst="rect">
             <a:avLst/>
@@ -15007,33 +15673,33 @@
           </a:bodyPr>
           <a:lstStyle/>
           <a:p>
-            <a:pPr algn="ctr">
-              <a:spcAft>
-                <a:spcPts val="600"/>
-              </a:spcAft>
-              <a:defRPr sz="1600" b="0">
-                <a:solidFill>
-                  <a:srgbClr val="647483"/>
-                </a:solidFill>
-                <a:latin typeface="Noto Sans CJK SC"/>
-              </a:defRPr>
-            </a:pPr>
-            <a:r>
-              <a:t>最佳验证准确率</a:t>
-            </a:r>
-          </a:p>
-        </p:txBody>
-      </p:sp>
-      <p:sp>
-        <p:nvSpPr>
-          <p:cNvPr id="11" name="TextBox 10"/>
+            <a:pPr>
+              <a:spcAft>
+                <a:spcPts val="600"/>
+              </a:spcAft>
+              <a:defRPr sz="2300" b="1">
+                <a:solidFill>
+                  <a:srgbClr val="176BA0"/>
+                </a:solidFill>
+                <a:latin typeface="Noto Sans CJK SC"/>
+              </a:defRPr>
+            </a:pPr>
+            <a:r>
+              <a:t>训练损失</a:t>
+            </a:r>
+          </a:p>
+        </p:txBody>
+      </p:sp>
+      <p:sp>
+        <p:nvSpPr>
+          <p:cNvPr id="13" name="TextBox 12"/>
           <p:cNvSpPr txBox="1"/>
           <p:nvPr/>
         </p:nvSpPr>
         <p:spPr>
           <a:xfrm>
-            <a:off x="886968" y="2221992"/>
-            <a:ext cx="3328416" cy="420624"/>
+            <a:off x="914400" y="4251960"/>
+            <a:ext cx="3218688" cy="841248"/>
           </a:xfrm>
           <a:prstGeom prst="rect">
             <a:avLst/>
@@ -15046,33 +15712,49 @@
           </a:bodyPr>
           <a:lstStyle/>
           <a:p>
-            <a:pPr algn="ctr">
-              <a:spcAft>
-                <a:spcPts val="600"/>
-              </a:spcAft>
-              <a:defRPr sz="2500" b="1">
-                <a:solidFill>
-                  <a:srgbClr val="176BA0"/>
-                </a:solidFill>
-                <a:latin typeface="Noto Sans CJK SC"/>
-              </a:defRPr>
-            </a:pPr>
-            <a:r>
-              <a:t>97.30%</a:t>
-            </a:r>
-          </a:p>
-        </p:txBody>
-      </p:sp>
-      <p:sp>
-        <p:nvSpPr>
-          <p:cNvPr id="12" name="Rounded Rectangle 11"/>
+            <a:pPr>
+              <a:spcAft>
+                <a:spcPts val="600"/>
+              </a:spcAft>
+              <a:defRPr sz="1900" b="0">
+                <a:solidFill>
+                  <a:srgbClr val="243547"/>
+                </a:solidFill>
+                <a:latin typeface="Noto Sans CJK SC"/>
+              </a:defRPr>
+            </a:pPr>
+            <a:r>
+              <a:t>损失是否逐渐下降？</a:t>
+            </a:r>
+          </a:p>
+          <a:p>
+            <a:pPr>
+              <a:spcAft>
+                <a:spcPts val="600"/>
+              </a:spcAft>
+              <a:defRPr sz="1900" b="0">
+                <a:solidFill>
+                  <a:srgbClr val="243547"/>
+                </a:solidFill>
+                <a:latin typeface="Noto Sans CJK SC"/>
+              </a:defRPr>
+            </a:pPr>
+            <a:r>
+              <a:t>后期是否还在改善？</a:t>
+            </a:r>
+          </a:p>
+        </p:txBody>
+      </p:sp>
+      <p:sp>
+        <p:nvSpPr>
+          <p:cNvPr id="14" name="Rounded Rectangle 13"/>
           <p:cNvSpPr/>
           <p:nvPr/>
         </p:nvSpPr>
         <p:spPr>
           <a:xfrm>
-            <a:off x="4590288" y="1801368"/>
-            <a:ext cx="3566160" cy="914400"/>
+            <a:off x="4572000" y="3456432"/>
+            <a:ext cx="3547872" cy="1746504"/>
           </a:xfrm>
           <a:prstGeom prst="roundRect">
             <a:avLst/>
@@ -15108,14 +15790,14 @@
       </p:sp>
       <p:sp>
         <p:nvSpPr>
-          <p:cNvPr id="13" name="TextBox 12"/>
+          <p:cNvPr id="15" name="TextBox 14"/>
           <p:cNvSpPr txBox="1"/>
           <p:nvPr/>
         </p:nvSpPr>
         <p:spPr>
           <a:xfrm>
-            <a:off x="4709159" y="1901952"/>
-            <a:ext cx="3328416" cy="292608"/>
+            <a:off x="4727448" y="3621024"/>
+            <a:ext cx="3218688" cy="393192"/>
           </a:xfrm>
           <a:prstGeom prst="rect">
             <a:avLst/>
@@ -15128,33 +15810,33 @@
           </a:bodyPr>
           <a:lstStyle/>
           <a:p>
-            <a:pPr algn="ctr">
-              <a:spcAft>
-                <a:spcPts val="600"/>
-              </a:spcAft>
-              <a:defRPr sz="1600" b="0">
-                <a:solidFill>
-                  <a:srgbClr val="647483"/>
-                </a:solidFill>
-                <a:latin typeface="Noto Sans CJK SC"/>
-              </a:defRPr>
-            </a:pPr>
-            <a:r>
-              <a:t>完整测试准确率</a:t>
-            </a:r>
-          </a:p>
-        </p:txBody>
-      </p:sp>
-      <p:sp>
-        <p:nvSpPr>
-          <p:cNvPr id="14" name="TextBox 13"/>
+            <a:pPr>
+              <a:spcAft>
+                <a:spcPts val="600"/>
+              </a:spcAft>
+              <a:defRPr sz="2300" b="1">
+                <a:solidFill>
+                  <a:srgbClr val="176BA0"/>
+                </a:solidFill>
+                <a:latin typeface="Noto Sans CJK SC"/>
+              </a:defRPr>
+            </a:pPr>
+            <a:r>
+              <a:t>验证表现</a:t>
+            </a:r>
+          </a:p>
+        </p:txBody>
+      </p:sp>
+      <p:sp>
+        <p:nvSpPr>
+          <p:cNvPr id="16" name="TextBox 15"/>
           <p:cNvSpPr txBox="1"/>
           <p:nvPr/>
         </p:nvSpPr>
         <p:spPr>
           <a:xfrm>
-            <a:off x="4709159" y="2221992"/>
-            <a:ext cx="3328416" cy="420624"/>
+            <a:off x="4727448" y="4251960"/>
+            <a:ext cx="3218688" cy="841248"/>
           </a:xfrm>
           <a:prstGeom prst="rect">
             <a:avLst/>
@@ -15167,33 +15849,49 @@
           </a:bodyPr>
           <a:lstStyle/>
           <a:p>
-            <a:pPr algn="ctr">
-              <a:spcAft>
-                <a:spcPts val="600"/>
-              </a:spcAft>
-              <a:defRPr sz="2500" b="1">
-                <a:solidFill>
-                  <a:srgbClr val="176BA0"/>
-                </a:solidFill>
-                <a:latin typeface="Noto Sans CJK SC"/>
-              </a:defRPr>
-            </a:pPr>
-            <a:r>
-              <a:t>97.07%</a:t>
-            </a:r>
-          </a:p>
-        </p:txBody>
-      </p:sp>
-      <p:sp>
-        <p:nvSpPr>
-          <p:cNvPr id="15" name="Rounded Rectangle 14"/>
+            <a:pPr>
+              <a:spcAft>
+                <a:spcPts val="600"/>
+              </a:spcAft>
+              <a:defRPr sz="1900" b="0">
+                <a:solidFill>
+                  <a:srgbClr val="243547"/>
+                </a:solidFill>
+                <a:latin typeface="Noto Sans CJK SC"/>
+              </a:defRPr>
+            </a:pPr>
+            <a:r>
+              <a:t>验证准确率怎样变化？</a:t>
+            </a:r>
+          </a:p>
+          <a:p>
+            <a:pPr>
+              <a:spcAft>
+                <a:spcPts val="600"/>
+              </a:spcAft>
+              <a:defRPr sz="1900" b="0">
+                <a:solidFill>
+                  <a:srgbClr val="243547"/>
+                </a:solidFill>
+                <a:latin typeface="Noto Sans CJK SC"/>
+              </a:defRPr>
+            </a:pPr>
+            <a:r>
+              <a:t>与训练表现差距多大？</a:t>
+            </a:r>
+          </a:p>
+        </p:txBody>
+      </p:sp>
+      <p:sp>
+        <p:nvSpPr>
+          <p:cNvPr id="17" name="Rounded Rectangle 16"/>
           <p:cNvSpPr/>
           <p:nvPr/>
         </p:nvSpPr>
         <p:spPr>
           <a:xfrm>
-            <a:off x="8412480" y="1801368"/>
-            <a:ext cx="3566160" cy="914400"/>
+            <a:off x="8385048" y="3456432"/>
+            <a:ext cx="3547872" cy="1746504"/>
           </a:xfrm>
           <a:prstGeom prst="roundRect">
             <a:avLst/>
@@ -15229,14 +15927,14 @@
       </p:sp>
       <p:sp>
         <p:nvSpPr>
-          <p:cNvPr id="16" name="TextBox 15"/>
+          <p:cNvPr id="18" name="TextBox 17"/>
           <p:cNvSpPr txBox="1"/>
           <p:nvPr/>
         </p:nvSpPr>
         <p:spPr>
           <a:xfrm>
-            <a:off x="8531352" y="1901952"/>
-            <a:ext cx="3328416" cy="292608"/>
+            <a:off x="8540496" y="3621024"/>
+            <a:ext cx="3218688" cy="393192"/>
           </a:xfrm>
           <a:prstGeom prst="rect">
             <a:avLst/>
@@ -15249,33 +15947,33 @@
           </a:bodyPr>
           <a:lstStyle/>
           <a:p>
-            <a:pPr algn="ctr">
-              <a:spcAft>
-                <a:spcPts val="600"/>
-              </a:spcAft>
-              <a:defRPr sz="1600" b="0">
-                <a:solidFill>
-                  <a:srgbClr val="647483"/>
-                </a:solidFill>
-                <a:latin typeface="Noto Sans CJK SC"/>
-              </a:defRPr>
-            </a:pPr>
-            <a:r>
-              <a:t>模型选择依据</a:t>
-            </a:r>
-          </a:p>
-        </p:txBody>
-      </p:sp>
-      <p:sp>
-        <p:nvSpPr>
-          <p:cNvPr id="17" name="TextBox 16"/>
+            <a:pPr>
+              <a:spcAft>
+                <a:spcPts val="600"/>
+              </a:spcAft>
+              <a:defRPr sz="2300" b="1">
+                <a:solidFill>
+                  <a:srgbClr val="176BA0"/>
+                </a:solidFill>
+                <a:latin typeface="Noto Sans CJK SC"/>
+              </a:defRPr>
+            </a:pPr>
+            <a:r>
+              <a:t>测试结果</a:t>
+            </a:r>
+          </a:p>
+        </p:txBody>
+      </p:sp>
+      <p:sp>
+        <p:nvSpPr>
+          <p:cNvPr id="19" name="TextBox 18"/>
           <p:cNvSpPr txBox="1"/>
           <p:nvPr/>
         </p:nvSpPr>
         <p:spPr>
           <a:xfrm>
-            <a:off x="8531352" y="2221992"/>
-            <a:ext cx="3328416" cy="420624"/>
+            <a:off x="8540496" y="4251960"/>
+            <a:ext cx="3218688" cy="841248"/>
           </a:xfrm>
           <a:prstGeom prst="rect">
             <a:avLst/>
@@ -15288,57 +15986,49 @@
           </a:bodyPr>
           <a:lstStyle/>
           <a:p>
-            <a:pPr algn="ctr">
-              <a:spcAft>
-                <a:spcPts val="600"/>
-              </a:spcAft>
-              <a:defRPr sz="2500" b="1">
-                <a:solidFill>
-                  <a:srgbClr val="176BA0"/>
-                </a:solidFill>
-                <a:latin typeface="Noto Sans CJK SC"/>
-              </a:defRPr>
-            </a:pPr>
-            <a:r>
-              <a:t>验证集表现</a:t>
-            </a:r>
-          </a:p>
-        </p:txBody>
-      </p:sp>
-      <p:pic>
-        <p:nvPicPr>
-          <p:cNvPr id="18" name="Picture 17" descr="curves.png"/>
-          <p:cNvPicPr>
-            <a:picLocks noChangeAspect="1"/>
-          </p:cNvPicPr>
-          <p:nvPr/>
-        </p:nvPicPr>
-        <p:blipFill>
-          <a:blip r:embed="rId4"/>
-          <a:stretch>
-            <a:fillRect/>
-          </a:stretch>
-        </p:blipFill>
-        <p:spPr>
-          <a:xfrm>
-            <a:off x="2169599" y="2926080"/>
-            <a:ext cx="7858897" cy="2907792"/>
-          </a:xfrm>
-          <a:prstGeom prst="rect">
-            <a:avLst/>
-          </a:prstGeom>
-        </p:spPr>
-      </p:pic>
-      <p:sp>
-        <p:nvSpPr>
-          <p:cNvPr id="19" name="TextBox 18"/>
+            <a:pPr>
+              <a:spcAft>
+                <a:spcPts val="600"/>
+              </a:spcAft>
+              <a:defRPr sz="1900" b="0">
+                <a:solidFill>
+                  <a:srgbClr val="243547"/>
+                </a:solidFill>
+                <a:latin typeface="Noto Sans CJK SC"/>
+              </a:defRPr>
+            </a:pPr>
+            <a:r>
+              <a:t>加载验证集选出的模型，</a:t>
+            </a:r>
+          </a:p>
+          <a:p>
+            <a:pPr>
+              <a:spcAft>
+                <a:spcPts val="600"/>
+              </a:spcAft>
+              <a:defRPr sz="1900" b="0">
+                <a:solidFill>
+                  <a:srgbClr val="243547"/>
+                </a:solidFill>
+                <a:latin typeface="Noto Sans CJK SC"/>
+              </a:defRPr>
+            </a:pPr>
+            <a:r>
+              <a:t>在测试集上评估并记录。</a:t>
+            </a:r>
+          </a:p>
+        </p:txBody>
+      </p:sp>
+      <p:sp>
+        <p:nvSpPr>
+          <p:cNvPr id="20" name="TextBox 19"/>
           <p:cNvSpPr txBox="1"/>
           <p:nvPr/>
         </p:nvSpPr>
         <p:spPr>
           <a:xfrm>
-            <a:off x="832104" y="5971032"/>
-            <a:ext cx="10469880" cy="292608"/>
+            <a:off x="850392" y="5596128"/>
+            <a:ext cx="10424160" cy="502920"/>
           </a:xfrm>
           <a:prstGeom prst="rect">
             <a:avLst/>
@@ -15355,7 +16045,7 @@
               <a:spcAft>
                 <a:spcPts val="600"/>
               </a:spcAft>
-              <a:defRPr sz="1400" b="0">
+              <a:defRPr sz="1900" b="0">
                 <a:solidFill>
                   <a:srgbClr val="647483"/>
                 </a:solidFill>
@@ -15363,7 +16053,7 @@
               </a:defRPr>
             </a:pPr>
             <a:r>
-              <a:t>本次教师实测约11.88分钟，不含安装下载及末尾出图。云平台耗时以实际运行为准。</a:t>
+              <a:t>指标与参数保存在metrics.json中；结合曲线，解释本次实验的结果。</a:t>
             </a:r>
           </a:p>
         </p:txBody>

</xml_diff>

<commit_message>
Remove all production notes from submission slides
</commit_message>
<xml_diff>
--- a/docs/ByteFormer_MNIST_零基础实验课.pptx
+++ b/docs/ByteFormer_MNIST_零基础实验课.pptx
@@ -6,21 +6,21 @@
   </p:sldMasterIdLst>
   <p:sldIdLst>
     <p:sldId id="256" r:id="rId7"/>
-    <p:sldId id="257" r:id="rId9"/>
-    <p:sldId id="258" r:id="rId10"/>
-    <p:sldId id="259" r:id="rId11"/>
-    <p:sldId id="260" r:id="rId12"/>
-    <p:sldId id="261" r:id="rId13"/>
-    <p:sldId id="262" r:id="rId14"/>
-    <p:sldId id="263" r:id="rId15"/>
-    <p:sldId id="264" r:id="rId16"/>
-    <p:sldId id="265" r:id="rId17"/>
-    <p:sldId id="266" r:id="rId18"/>
-    <p:sldId id="267" r:id="rId19"/>
-    <p:sldId id="268" r:id="rId20"/>
-    <p:sldId id="269" r:id="rId21"/>
-    <p:sldId id="270" r:id="rId22"/>
-    <p:sldId id="271" r:id="rId23"/>
+    <p:sldId id="257" r:id="rId8"/>
+    <p:sldId id="258" r:id="rId9"/>
+    <p:sldId id="259" r:id="rId10"/>
+    <p:sldId id="260" r:id="rId11"/>
+    <p:sldId id="261" r:id="rId12"/>
+    <p:sldId id="262" r:id="rId13"/>
+    <p:sldId id="263" r:id="rId14"/>
+    <p:sldId id="264" r:id="rId15"/>
+    <p:sldId id="265" r:id="rId16"/>
+    <p:sldId id="266" r:id="rId17"/>
+    <p:sldId id="267" r:id="rId18"/>
+    <p:sldId id="268" r:id="rId19"/>
+    <p:sldId id="269" r:id="rId20"/>
+    <p:sldId id="270" r:id="rId21"/>
+    <p:sldId id="271" r:id="rId22"/>
   </p:sldIdLst>
   <p:sldSz cx="12191695" cy="6858000" type="screen4x3"/>
   <p:notesSz cx="6858000" cy="9144000"/>
@@ -120,1476 +120,6 @@
     </a:lvl9pPr>
   </p:defaultTextStyle>
 </p:presentation>
-</file>
-
-<file path=ppt/notesMasters/notesMaster1.xml><?xml version="1.0" encoding="utf-8"?>
-<p:notesMaster xmlns:a="http://schemas.openxmlformats.org/drawingml/2006/main" xmlns:p="http://schemas.openxmlformats.org/presentationml/2006/main" xmlns:r="http://schemas.openxmlformats.org/officeDocument/2006/relationships">
-  <p:cSld>
-    <p:bg>
-      <p:bgRef idx="1001">
-        <a:schemeClr val="bg1"/>
-      </p:bgRef>
-    </p:bg>
-    <p:spTree>
-      <p:nvGrpSpPr>
-        <p:cNvPr id="1" name=""/>
-        <p:cNvGrpSpPr/>
-        <p:nvPr/>
-      </p:nvGrpSpPr>
-      <p:grpSpPr>
-        <a:xfrm>
-          <a:off x="0" y="0"/>
-          <a:ext cx="0" cy="0"/>
-          <a:chOff x="0" y="0"/>
-          <a:chExt cx="0" cy="0"/>
-        </a:xfrm>
-      </p:grpSpPr>
-      <p:sp>
-        <p:nvSpPr>
-          <p:cNvPr id="2" name="Header Placeholder 1"/>
-          <p:cNvSpPr>
-            <a:spLocks noGrp="1"/>
-          </p:cNvSpPr>
-          <p:nvPr>
-            <p:ph type="hdr" sz="quarter"/>
-          </p:nvPr>
-        </p:nvSpPr>
-        <p:spPr>
-          <a:xfrm>
-            <a:off x="0" y="0"/>
-            <a:ext cx="2971800" cy="457200"/>
-          </a:xfrm>
-          <a:prstGeom prst="rect">
-            <a:avLst/>
-          </a:prstGeom>
-        </p:spPr>
-        <p:txBody>
-          <a:bodyPr vert="horz" lIns="91440" tIns="45720" rIns="91440" bIns="45720" rtlCol="0"/>
-          <a:lstStyle>
-            <a:lvl1pPr algn="l">
-              <a:defRPr sz="1200"/>
-            </a:lvl1pPr>
-          </a:lstStyle>
-          <a:p>
-            <a:endParaRPr lang="en-US"/>
-          </a:p>
-        </p:txBody>
-      </p:sp>
-      <p:sp>
-        <p:nvSpPr>
-          <p:cNvPr id="3" name="Date Placeholder 2"/>
-          <p:cNvSpPr>
-            <a:spLocks noGrp="1"/>
-          </p:cNvSpPr>
-          <p:nvPr>
-            <p:ph type="dt" idx="1"/>
-          </p:nvPr>
-        </p:nvSpPr>
-        <p:spPr>
-          <a:xfrm>
-            <a:off x="3884613" y="0"/>
-            <a:ext cx="2971800" cy="457200"/>
-          </a:xfrm>
-          <a:prstGeom prst="rect">
-            <a:avLst/>
-          </a:prstGeom>
-        </p:spPr>
-        <p:txBody>
-          <a:bodyPr vert="horz" lIns="91440" tIns="45720" rIns="91440" bIns="45720" rtlCol="0"/>
-          <a:lstStyle>
-            <a:lvl1pPr algn="r">
-              <a:defRPr sz="1200"/>
-            </a:lvl1pPr>
-          </a:lstStyle>
-          <a:p>
-            <a:fld id="{0F89C1C7-3DCD-1040-A9CF-14679D8B5DDD}" type="datetimeFigureOut">
-              <a:rPr lang="en-US" smtClean="0"/>
-              <a:t>10/17/16</a:t>
-            </a:fld>
-            <a:endParaRPr lang="en-US"/>
-          </a:p>
-        </p:txBody>
-      </p:sp>
-      <p:sp>
-        <p:nvSpPr>
-          <p:cNvPr id="4" name="Slide Image Placeholder 3"/>
-          <p:cNvSpPr>
-            <a:spLocks noGrp="1" noRot="1" noChangeAspect="1"/>
-          </p:cNvSpPr>
-          <p:nvPr>
-            <p:ph type="sldImg" idx="2"/>
-          </p:nvPr>
-        </p:nvSpPr>
-        <p:spPr>
-          <a:xfrm>
-            <a:off x="1143000" y="685800"/>
-            <a:ext cx="4572000" cy="3429000"/>
-          </a:xfrm>
-          <a:prstGeom prst="rect">
-            <a:avLst/>
-          </a:prstGeom>
-          <a:noFill/>
-          <a:ln w="12700">
-            <a:solidFill>
-              <a:prstClr val="black"/>
-            </a:solidFill>
-          </a:ln>
-        </p:spPr>
-        <p:txBody>
-          <a:bodyPr vert="horz" lIns="91440" tIns="45720" rIns="91440" bIns="45720" rtlCol="0" anchor="ctr"/>
-          <a:lstStyle/>
-          <a:p>
-            <a:endParaRPr lang="en-US"/>
-          </a:p>
-        </p:txBody>
-      </p:sp>
-      <p:sp>
-        <p:nvSpPr>
-          <p:cNvPr id="5" name="Notes Placeholder 4"/>
-          <p:cNvSpPr>
-            <a:spLocks noGrp="1"/>
-          </p:cNvSpPr>
-          <p:nvPr>
-            <p:ph type="body" sz="quarter" idx="3"/>
-          </p:nvPr>
-        </p:nvSpPr>
-        <p:spPr>
-          <a:xfrm>
-            <a:off x="685800" y="4343400"/>
-            <a:ext cx="5486400" cy="4114800"/>
-          </a:xfrm>
-          <a:prstGeom prst="rect">
-            <a:avLst/>
-          </a:prstGeom>
-        </p:spPr>
-        <p:txBody>
-          <a:bodyPr vert="horz" lIns="91440" tIns="45720" rIns="91440" bIns="45720" rtlCol="0"/>
-          <a:lstStyle/>
-          <a:p>
-            <a:pPr lvl="0"/>
-            <a:r>
-              <a:rPr lang="en-US" smtClean="0"/>
-              <a:t>Click to edit Master text styles</a:t>
-            </a:r>
-          </a:p>
-          <a:p>
-            <a:pPr lvl="1"/>
-            <a:r>
-              <a:rPr lang="en-US" smtClean="0"/>
-              <a:t>Second level</a:t>
-            </a:r>
-          </a:p>
-          <a:p>
-            <a:pPr lvl="2"/>
-            <a:r>
-              <a:rPr lang="en-US" smtClean="0"/>
-              <a:t>Third level</a:t>
-            </a:r>
-          </a:p>
-          <a:p>
-            <a:pPr lvl="3"/>
-            <a:r>
-              <a:rPr lang="en-US" smtClean="0"/>
-              <a:t>Fourth level</a:t>
-            </a:r>
-          </a:p>
-          <a:p>
-            <a:pPr lvl="4"/>
-            <a:r>
-              <a:rPr lang="en-US" smtClean="0"/>
-              <a:t>Fifth level</a:t>
-            </a:r>
-            <a:endParaRPr lang="en-US"/>
-          </a:p>
-        </p:txBody>
-      </p:sp>
-      <p:sp>
-        <p:nvSpPr>
-          <p:cNvPr id="6" name="Footer Placeholder 5"/>
-          <p:cNvSpPr>
-            <a:spLocks noGrp="1"/>
-          </p:cNvSpPr>
-          <p:nvPr>
-            <p:ph type="ftr" sz="quarter" idx="4"/>
-          </p:nvPr>
-        </p:nvSpPr>
-        <p:spPr>
-          <a:xfrm>
-            <a:off x="0" y="8685213"/>
-            <a:ext cx="2971800" cy="457200"/>
-          </a:xfrm>
-          <a:prstGeom prst="rect">
-            <a:avLst/>
-          </a:prstGeom>
-        </p:spPr>
-        <p:txBody>
-          <a:bodyPr vert="horz" lIns="91440" tIns="45720" rIns="91440" bIns="45720" rtlCol="0" anchor="b"/>
-          <a:lstStyle>
-            <a:lvl1pPr algn="l">
-              <a:defRPr sz="1200"/>
-            </a:lvl1pPr>
-          </a:lstStyle>
-          <a:p>
-            <a:endParaRPr lang="en-US"/>
-          </a:p>
-        </p:txBody>
-      </p:sp>
-      <p:sp>
-        <p:nvSpPr>
-          <p:cNvPr id="7" name="Slide Number Placeholder 6"/>
-          <p:cNvSpPr>
-            <a:spLocks noGrp="1"/>
-          </p:cNvSpPr>
-          <p:nvPr>
-            <p:ph type="sldNum" sz="quarter" idx="5"/>
-          </p:nvPr>
-        </p:nvSpPr>
-        <p:spPr>
-          <a:xfrm>
-            <a:off x="3884613" y="8685213"/>
-            <a:ext cx="2971800" cy="457200"/>
-          </a:xfrm>
-          <a:prstGeom prst="rect">
-            <a:avLst/>
-          </a:prstGeom>
-        </p:spPr>
-        <p:txBody>
-          <a:bodyPr vert="horz" lIns="91440" tIns="45720" rIns="91440" bIns="45720" rtlCol="0" anchor="b"/>
-          <a:lstStyle>
-            <a:lvl1pPr algn="r">
-              <a:defRPr sz="1200"/>
-            </a:lvl1pPr>
-          </a:lstStyle>
-          <a:p>
-            <a:fld id="{BB5E49A5-4136-284D-997B-48E1D791AD67}" type="slidenum">
-              <a:rPr lang="en-US" smtClean="0"/>
-              <a:t>‹#›</a:t>
-            </a:fld>
-            <a:endParaRPr lang="en-US"/>
-          </a:p>
-        </p:txBody>
-      </p:sp>
-    </p:spTree>
-    <p:extLst>
-      <p:ext uri="{BB962C8B-B14F-4D97-AF65-F5344CB8AC3E}">
-        <p14:creationId xmlns:p14="http://schemas.microsoft.com/office/powerpoint/2010/main" val="2623252185"/>
-      </p:ext>
-    </p:extLst>
-  </p:cSld>
-  <p:clrMap bg1="lt1" tx1="dk1" bg2="lt2" tx2="dk2" accent1="accent1" accent2="accent2" accent3="accent3" accent4="accent4" accent5="accent5" accent6="accent6" hlink="hlink" folHlink="folHlink"/>
-  <p:notesStyle>
-    <a:lvl1pPr marL="0" algn="l" defTabSz="457200" rtl="0" eaLnBrk="1" latinLnBrk="0" hangingPunct="1">
-      <a:defRPr sz="1200" kern="1200">
-        <a:solidFill>
-          <a:schemeClr val="tx1"/>
-        </a:solidFill>
-        <a:latin typeface="+mn-lt"/>
-        <a:ea typeface="+mn-ea"/>
-        <a:cs typeface="+mn-cs"/>
-      </a:defRPr>
-    </a:lvl1pPr>
-    <a:lvl2pPr marL="457200" algn="l" defTabSz="457200" rtl="0" eaLnBrk="1" latinLnBrk="0" hangingPunct="1">
-      <a:defRPr sz="1200" kern="1200">
-        <a:solidFill>
-          <a:schemeClr val="tx1"/>
-        </a:solidFill>
-        <a:latin typeface="+mn-lt"/>
-        <a:ea typeface="+mn-ea"/>
-        <a:cs typeface="+mn-cs"/>
-      </a:defRPr>
-    </a:lvl2pPr>
-    <a:lvl3pPr marL="914400" algn="l" defTabSz="457200" rtl="0" eaLnBrk="1" latinLnBrk="0" hangingPunct="1">
-      <a:defRPr sz="1200" kern="1200">
-        <a:solidFill>
-          <a:schemeClr val="tx1"/>
-        </a:solidFill>
-        <a:latin typeface="+mn-lt"/>
-        <a:ea typeface="+mn-ea"/>
-        <a:cs typeface="+mn-cs"/>
-      </a:defRPr>
-    </a:lvl3pPr>
-    <a:lvl4pPr marL="1371600" algn="l" defTabSz="457200" rtl="0" eaLnBrk="1" latinLnBrk="0" hangingPunct="1">
-      <a:defRPr sz="1200" kern="1200">
-        <a:solidFill>
-          <a:schemeClr val="tx1"/>
-        </a:solidFill>
-        <a:latin typeface="+mn-lt"/>
-        <a:ea typeface="+mn-ea"/>
-        <a:cs typeface="+mn-cs"/>
-      </a:defRPr>
-    </a:lvl4pPr>
-    <a:lvl5pPr marL="1828800" algn="l" defTabSz="457200" rtl="0" eaLnBrk="1" latinLnBrk="0" hangingPunct="1">
-      <a:defRPr sz="1200" kern="1200">
-        <a:solidFill>
-          <a:schemeClr val="tx1"/>
-        </a:solidFill>
-        <a:latin typeface="+mn-lt"/>
-        <a:ea typeface="+mn-ea"/>
-        <a:cs typeface="+mn-cs"/>
-      </a:defRPr>
-    </a:lvl5pPr>
-    <a:lvl6pPr marL="2286000" algn="l" defTabSz="457200" rtl="0" eaLnBrk="1" latinLnBrk="0" hangingPunct="1">
-      <a:defRPr sz="1200" kern="1200">
-        <a:solidFill>
-          <a:schemeClr val="tx1"/>
-        </a:solidFill>
-        <a:latin typeface="+mn-lt"/>
-        <a:ea typeface="+mn-ea"/>
-        <a:cs typeface="+mn-cs"/>
-      </a:defRPr>
-    </a:lvl6pPr>
-    <a:lvl7pPr marL="2743200" algn="l" defTabSz="457200" rtl="0" eaLnBrk="1" latinLnBrk="0" hangingPunct="1">
-      <a:defRPr sz="1200" kern="1200">
-        <a:solidFill>
-          <a:schemeClr val="tx1"/>
-        </a:solidFill>
-        <a:latin typeface="+mn-lt"/>
-        <a:ea typeface="+mn-ea"/>
-        <a:cs typeface="+mn-cs"/>
-      </a:defRPr>
-    </a:lvl7pPr>
-    <a:lvl8pPr marL="3200400" algn="l" defTabSz="457200" rtl="0" eaLnBrk="1" latinLnBrk="0" hangingPunct="1">
-      <a:defRPr sz="1200" kern="1200">
-        <a:solidFill>
-          <a:schemeClr val="tx1"/>
-        </a:solidFill>
-        <a:latin typeface="+mn-lt"/>
-        <a:ea typeface="+mn-ea"/>
-        <a:cs typeface="+mn-cs"/>
-      </a:defRPr>
-    </a:lvl8pPr>
-    <a:lvl9pPr marL="3657600" algn="l" defTabSz="457200" rtl="0" eaLnBrk="1" latinLnBrk="0" hangingPunct="1">
-      <a:defRPr sz="1200" kern="1200">
-        <a:solidFill>
-          <a:schemeClr val="tx1"/>
-        </a:solidFill>
-        <a:latin typeface="+mn-lt"/>
-        <a:ea typeface="+mn-ea"/>
-        <a:cs typeface="+mn-cs"/>
-      </a:defRPr>
-    </a:lvl9pPr>
-  </p:notesStyle>
-</p:notesMaster>
-</file>
-
-<file path=ppt/notesSlides/notesSlide1.xml><?xml version="1.0" encoding="utf-8"?>
-<p:notes xmlns:a="http://schemas.openxmlformats.org/drawingml/2006/main" xmlns:p="http://schemas.openxmlformats.org/presentationml/2006/main" xmlns:r="http://schemas.openxmlformats.org/officeDocument/2006/relationships">
-  <p:cSld>
-    <p:spTree>
-      <p:nvGrpSpPr>
-        <p:cNvPr id="1" name=""/>
-        <p:cNvGrpSpPr/>
-        <p:nvPr/>
-      </p:nvGrpSpPr>
-      <p:grpSpPr>
-        <a:xfrm>
-          <a:off x="0" y="0"/>
-          <a:ext cx="0" cy="0"/>
-          <a:chOff x="0" y="0"/>
-          <a:chExt cx="0" cy="0"/>
-        </a:xfrm>
-      </p:grpSpPr>
-      <p:sp>
-        <p:nvSpPr>
-          <p:cNvPr id="2" name="Slide Image Placeholder 1"/>
-          <p:cNvSpPr>
-            <a:spLocks noGrp="1"/>
-          </p:cNvSpPr>
-          <p:nvPr>
-            <p:ph type="sldImg" idx="2"/>
-          </p:nvPr>
-        </p:nvSpPr>
-        <p:spPr/>
-      </p:sp>
-      <p:sp>
-        <p:nvSpPr>
-          <p:cNvPr id="3" name="Notes Placeholder 2"/>
-          <p:cNvSpPr>
-            <a:spLocks noGrp="1"/>
-          </p:cNvSpPr>
-          <p:nvPr>
-            <p:ph type="body" idx="3" sz="quarter"/>
-          </p:nvPr>
-        </p:nvSpPr>
-        <p:spPr/>
-        <p:txBody>
-          <a:bodyPr/>
-          <a:lstStyle/>
-          <a:p>
-            <a:r>
-              <a:t>沿用教师样例的校园、校徽与白蓝风格，不沿用旧老师邮箱、截止日期或其他旧课程信息。本课PPT共16页；逐格操作细节见course_kaggle.ipynb和README。</a:t>
-            </a:r>
-          </a:p>
-        </p:txBody>
-      </p:sp>
-      <p:sp>
-        <p:nvSpPr>
-          <p:cNvPr id="4" name="Slide Number Placeholder 3"/>
-          <p:cNvSpPr>
-            <a:spLocks noGrp="1"/>
-          </p:cNvSpPr>
-          <p:nvPr>
-            <p:ph type="sldNum" idx="5" sz="quarter"/>
-          </p:nvPr>
-        </p:nvSpPr>
-        <p:spPr/>
-      </p:sp>
-    </p:spTree>
-  </p:cSld>
-  <p:clrMapOvr>
-    <a:masterClrMapping/>
-  </p:clrMapOvr>
-</p:notes>
-</file>
-
-<file path=ppt/notesSlides/notesSlide10.xml><?xml version="1.0" encoding="utf-8"?>
-<p:notes xmlns:a="http://schemas.openxmlformats.org/drawingml/2006/main" xmlns:p="http://schemas.openxmlformats.org/presentationml/2006/main" xmlns:r="http://schemas.openxmlformats.org/officeDocument/2006/relationships">
-  <p:cSld>
-    <p:spTree>
-      <p:nvGrpSpPr>
-        <p:cNvPr id="1" name=""/>
-        <p:cNvGrpSpPr/>
-        <p:nvPr/>
-      </p:nvGrpSpPr>
-      <p:grpSpPr>
-        <a:xfrm>
-          <a:off x="0" y="0"/>
-          <a:ext cx="0" cy="0"/>
-          <a:chOff x="0" y="0"/>
-          <a:chExt cx="0" cy="0"/>
-        </a:xfrm>
-      </p:grpSpPr>
-      <p:sp>
-        <p:nvSpPr>
-          <p:cNvPr id="2" name="Slide Image Placeholder 1"/>
-          <p:cNvSpPr>
-            <a:spLocks noGrp="1"/>
-          </p:cNvSpPr>
-          <p:nvPr>
-            <p:ph type="sldImg" idx="2"/>
-          </p:nvPr>
-        </p:nvSpPr>
-        <p:spPr/>
-      </p:sp>
-      <p:sp>
-        <p:nvSpPr>
-          <p:cNvPr id="3" name="Notes Placeholder 2"/>
-          <p:cNvSpPr>
-            <a:spLocks noGrp="1"/>
-          </p:cNvSpPr>
-          <p:nvPr>
-            <p:ph type="body" idx="3" sz="quarter"/>
-          </p:nvPr>
-        </p:nvSpPr>
-        <p:spPr/>
-        <p:txBody>
-          <a:bodyPr/>
-          <a:lstStyle/>
-          <a:p>
-            <a:r>
-              <a:t>预测图为测试顺序前12张加最多4个实际错例，不能用图中正确比例当整体准确率。index是原始测试索引，和随机排列后的行号不同；Notebook已自动映射。概率是模型softmax分数，不等于已校准可信度。自制图片可用--image assets/example_digit.png，黑底白字、单个居中数字。评估不改训练metrics.json。</a:t>
-            </a:r>
-          </a:p>
-        </p:txBody>
-      </p:sp>
-      <p:sp>
-        <p:nvSpPr>
-          <p:cNvPr id="4" name="Slide Number Placeholder 3"/>
-          <p:cNvSpPr>
-            <a:spLocks noGrp="1"/>
-          </p:cNvSpPr>
-          <p:nvPr>
-            <p:ph type="sldNum" idx="5" sz="quarter"/>
-          </p:nvPr>
-        </p:nvSpPr>
-        <p:spPr/>
-      </p:sp>
-    </p:spTree>
-  </p:cSld>
-  <p:clrMapOvr>
-    <a:masterClrMapping/>
-  </p:clrMapOvr>
-</p:notes>
-</file>
-
-<file path=ppt/notesSlides/notesSlide11.xml><?xml version="1.0" encoding="utf-8"?>
-<p:notes xmlns:a="http://schemas.openxmlformats.org/drawingml/2006/main" xmlns:p="http://schemas.openxmlformats.org/presentationml/2006/main" xmlns:r="http://schemas.openxmlformats.org/officeDocument/2006/relationships">
-  <p:cSld>
-    <p:spTree>
-      <p:nvGrpSpPr>
-        <p:cNvPr id="1" name=""/>
-        <p:cNvGrpSpPr/>
-        <p:nvPr/>
-      </p:nvGrpSpPr>
-      <p:grpSpPr>
-        <a:xfrm>
-          <a:off x="0" y="0"/>
-          <a:ext cx="0" cy="0"/>
-          <a:chOff x="0" y="0"/>
-          <a:chExt cx="0" cy="0"/>
-        </a:xfrm>
-      </p:grpSpPr>
-      <p:sp>
-        <p:nvSpPr>
-          <p:cNvPr id="2" name="Slide Image Placeholder 1"/>
-          <p:cNvSpPr>
-            <a:spLocks noGrp="1"/>
-          </p:cNvSpPr>
-          <p:nvPr>
-            <p:ph type="sldImg" idx="2"/>
-          </p:nvPr>
-        </p:nvSpPr>
-        <p:spPr/>
-      </p:sp>
-      <p:sp>
-        <p:nvSpPr>
-          <p:cNvPr id="3" name="Notes Placeholder 2"/>
-          <p:cNvSpPr>
-            <a:spLocks noGrp="1"/>
-          </p:cNvSpPr>
-          <p:nvPr>
-            <p:ph type="body" idx="3" sz="quarter"/>
-          </p:nvPr>
-        </p:nvSpPr>
-        <p:spPr/>
-        <p:txBody>
-          <a:bodyPr/>
-          <a:lstStyle/>
-          <a:p>
-            <a:r>
-              <a:t>学生自行设置轮数与batch size；参考值不构成固定要求，建议一次只改变其中一项。根据训练与验证曲线比较；测试成绩只作最终记录。对比从同一官方预训练权重开始，不是在baseline上续训。保持其他参数相同并保留独立输出。更多轮数未必更好；需记录自己的实际设置与依据。</a:t>
-            </a:r>
-          </a:p>
-        </p:txBody>
-      </p:sp>
-      <p:sp>
-        <p:nvSpPr>
-          <p:cNvPr id="4" name="Slide Number Placeholder 3"/>
-          <p:cNvSpPr>
-            <a:spLocks noGrp="1"/>
-          </p:cNvSpPr>
-          <p:nvPr>
-            <p:ph type="sldNum" idx="5" sz="quarter"/>
-          </p:nvPr>
-        </p:nvSpPr>
-        <p:spPr/>
-      </p:sp>
-    </p:spTree>
-  </p:cSld>
-  <p:clrMapOvr>
-    <a:masterClrMapping/>
-  </p:clrMapOvr>
-</p:notes>
-</file>
-
-<file path=ppt/notesSlides/notesSlide12.xml><?xml version="1.0" encoding="utf-8"?>
-<p:notes xmlns:a="http://schemas.openxmlformats.org/drawingml/2006/main" xmlns:p="http://schemas.openxmlformats.org/presentationml/2006/main" xmlns:r="http://schemas.openxmlformats.org/officeDocument/2006/relationships">
-  <p:cSld>
-    <p:spTree>
-      <p:nvGrpSpPr>
-        <p:cNvPr id="1" name=""/>
-        <p:cNvGrpSpPr/>
-        <p:nvPr/>
-      </p:nvGrpSpPr>
-      <p:grpSpPr>
-        <a:xfrm>
-          <a:off x="0" y="0"/>
-          <a:ext cx="0" cy="0"/>
-          <a:chOff x="0" y="0"/>
-          <a:chExt cx="0" cy="0"/>
-        </a:xfrm>
-      </p:grpSpPr>
-      <p:sp>
-        <p:nvSpPr>
-          <p:cNvPr id="2" name="Slide Image Placeholder 1"/>
-          <p:cNvSpPr>
-            <a:spLocks noGrp="1"/>
-          </p:cNvSpPr>
-          <p:nvPr>
-            <p:ph type="sldImg" idx="2"/>
-          </p:nvPr>
-        </p:nvSpPr>
-        <p:spPr/>
-      </p:sp>
-      <p:sp>
-        <p:nvSpPr>
-          <p:cNvPr id="3" name="Notes Placeholder 2"/>
-          <p:cNvSpPr>
-            <a:spLocks noGrp="1"/>
-          </p:cNvSpPr>
-          <p:nvPr>
-            <p:ph type="body" idx="3" sz="quarter"/>
-          </p:nvPr>
-        </p:nvSpPr>
-        <p:spPr/>
-        <p:txBody>
-          <a:bodyPr/>
-          <a:lstStyle/>
-          <a:p>
-            <a:r>
-              <a:t>按AutoDL控制台选择空闲GPU、计费方式和PyTorch镜像，无需多卡。GPU检查命令python -c "import torch; print(torch.cuda.is_available())"。GitHub慢可用仓库ZIP上传解压进入正确目录。下载打包详细命令见README。关机与数据保留按当前官方规则，不承诺永久保存。</a:t>
-            </a:r>
-          </a:p>
-        </p:txBody>
-      </p:sp>
-      <p:sp>
-        <p:nvSpPr>
-          <p:cNvPr id="4" name="Slide Number Placeholder 3"/>
-          <p:cNvSpPr>
-            <a:spLocks noGrp="1"/>
-          </p:cNvSpPr>
-          <p:nvPr>
-            <p:ph type="sldNum" idx="5" sz="quarter"/>
-          </p:nvPr>
-        </p:nvSpPr>
-        <p:spPr/>
-      </p:sp>
-    </p:spTree>
-  </p:cSld>
-  <p:clrMapOvr>
-    <a:masterClrMapping/>
-  </p:clrMapOvr>
-</p:notes>
-</file>
-
-<file path=ppt/notesSlides/notesSlide13.xml><?xml version="1.0" encoding="utf-8"?>
-<p:notes xmlns:a="http://schemas.openxmlformats.org/drawingml/2006/main" xmlns:p="http://schemas.openxmlformats.org/presentationml/2006/main" xmlns:r="http://schemas.openxmlformats.org/officeDocument/2006/relationships">
-  <p:cSld>
-    <p:spTree>
-      <p:nvGrpSpPr>
-        <p:cNvPr id="1" name=""/>
-        <p:cNvGrpSpPr/>
-        <p:nvPr/>
-      </p:nvGrpSpPr>
-      <p:grpSpPr>
-        <a:xfrm>
-          <a:off x="0" y="0"/>
-          <a:ext cx="0" cy="0"/>
-          <a:chOff x="0" y="0"/>
-          <a:chExt cx="0" cy="0"/>
-        </a:xfrm>
-      </p:grpSpPr>
-      <p:sp>
-        <p:nvSpPr>
-          <p:cNvPr id="2" name="Slide Image Placeholder 1"/>
-          <p:cNvSpPr>
-            <a:spLocks noGrp="1"/>
-          </p:cNvSpPr>
-          <p:nvPr>
-            <p:ph type="sldImg" idx="2"/>
-          </p:nvPr>
-        </p:nvSpPr>
-        <p:spPr/>
-      </p:sp>
-      <p:sp>
-        <p:nvSpPr>
-          <p:cNvPr id="3" name="Notes Placeholder 2"/>
-          <p:cNvSpPr>
-            <a:spLocks noGrp="1"/>
-          </p:cNvSpPr>
-          <p:nvPr>
-            <p:ph type="body" idx="3" sz="quarter"/>
-          </p:nvPr>
-        </p:nvSpPr>
-        <p:spPr/>
-        <p:txBody>
-          <a:bodyPr/>
-          <a:lstStyle/>
-          <a:p>
-            <a:r>
-              <a:t>不要为一个warning盲目重装CUDA。出现cuDNN plan fallback但程序继续且loss有限可记录；Traceback且进程停止时看最后一行。CPU小样本路线已实测通过，但不是完整作业。所有操作均不需要修改其他同学的环境或删除公共数据。</a:t>
-            </a:r>
-          </a:p>
-        </p:txBody>
-      </p:sp>
-      <p:sp>
-        <p:nvSpPr>
-          <p:cNvPr id="4" name="Slide Number Placeholder 3"/>
-          <p:cNvSpPr>
-            <a:spLocks noGrp="1"/>
-          </p:cNvSpPr>
-          <p:nvPr>
-            <p:ph type="sldNum" idx="5" sz="quarter"/>
-          </p:nvPr>
-        </p:nvSpPr>
-        <p:spPr/>
-      </p:sp>
-    </p:spTree>
-  </p:cSld>
-  <p:clrMapOvr>
-    <a:masterClrMapping/>
-  </p:clrMapOvr>
-</p:notes>
-</file>
-
-<file path=ppt/notesSlides/notesSlide14.xml><?xml version="1.0" encoding="utf-8"?>
-<p:notes xmlns:a="http://schemas.openxmlformats.org/drawingml/2006/main" xmlns:p="http://schemas.openxmlformats.org/presentationml/2006/main" xmlns:r="http://schemas.openxmlformats.org/officeDocument/2006/relationships">
-  <p:cSld>
-    <p:spTree>
-      <p:nvGrpSpPr>
-        <p:cNvPr id="1" name=""/>
-        <p:cNvGrpSpPr/>
-        <p:nvPr/>
-      </p:nvGrpSpPr>
-      <p:grpSpPr>
-        <a:xfrm>
-          <a:off x="0" y="0"/>
-          <a:ext cx="0" cy="0"/>
-          <a:chOff x="0" y="0"/>
-          <a:chExt cx="0" cy="0"/>
-        </a:xfrm>
-      </p:grpSpPr>
-      <p:sp>
-        <p:nvSpPr>
-          <p:cNvPr id="2" name="Slide Image Placeholder 1"/>
-          <p:cNvSpPr>
-            <a:spLocks noGrp="1"/>
-          </p:cNvSpPr>
-          <p:nvPr>
-            <p:ph type="sldImg" idx="2"/>
-          </p:nvPr>
-        </p:nvSpPr>
-        <p:spPr/>
-      </p:sp>
-      <p:sp>
-        <p:nvSpPr>
-          <p:cNvPr id="3" name="Notes Placeholder 2"/>
-          <p:cNvSpPr>
-            <a:spLocks noGrp="1"/>
-          </p:cNvSpPr>
-          <p:nvPr>
-            <p:ph type="body" idx="3" sz="quarter"/>
-          </p:nvPr>
-        </p:nvSpPr>
-        <p:spPr/>
-        <p:txBody>
-          <a:bodyPr/>
-          <a:lstStyle/>
-          <a:p>
-            <a:r>
-              <a:t>Word模板路径docs/学生实验报告模板.docx。ZIP只含json/csv/png/npz小文件，不含best.pt；若后续想预测请另存模型。Kaggle ZIP在/kaggle/working根目录，AutoDL打包命令见README。评分重操作和解释，不按准确率排名替代教学目标。</a:t>
-            </a:r>
-          </a:p>
-        </p:txBody>
-      </p:sp>
-      <p:sp>
-        <p:nvSpPr>
-          <p:cNvPr id="4" name="Slide Number Placeholder 3"/>
-          <p:cNvSpPr>
-            <a:spLocks noGrp="1"/>
-          </p:cNvSpPr>
-          <p:nvPr>
-            <p:ph type="sldNum" idx="5" sz="quarter"/>
-          </p:nvPr>
-        </p:nvSpPr>
-        <p:spPr/>
-      </p:sp>
-    </p:spTree>
-  </p:cSld>
-  <p:clrMapOvr>
-    <a:masterClrMapping/>
-  </p:clrMapOvr>
-</p:notes>
-</file>
-
-<file path=ppt/notesSlides/notesSlide15.xml><?xml version="1.0" encoding="utf-8"?>
-<p:notes xmlns:a="http://schemas.openxmlformats.org/drawingml/2006/main" xmlns:p="http://schemas.openxmlformats.org/presentationml/2006/main" xmlns:r="http://schemas.openxmlformats.org/officeDocument/2006/relationships">
-  <p:cSld>
-    <p:spTree>
-      <p:nvGrpSpPr>
-        <p:cNvPr id="1" name=""/>
-        <p:cNvGrpSpPr/>
-        <p:nvPr/>
-      </p:nvGrpSpPr>
-      <p:grpSpPr>
-        <a:xfrm>
-          <a:off x="0" y="0"/>
-          <a:ext cx="0" cy="0"/>
-          <a:chOff x="0" y="0"/>
-          <a:chExt cx="0" cy="0"/>
-        </a:xfrm>
-      </p:grpSpPr>
-      <p:sp>
-        <p:nvSpPr>
-          <p:cNvPr id="2" name="Slide Image Placeholder 1"/>
-          <p:cNvSpPr>
-            <a:spLocks noGrp="1"/>
-          </p:cNvSpPr>
-          <p:nvPr>
-            <p:ph type="sldImg" idx="2"/>
-          </p:nvPr>
-        </p:nvSpPr>
-        <p:spPr/>
-      </p:sp>
-      <p:sp>
-        <p:nvSpPr>
-          <p:cNvPr id="3" name="Notes Placeholder 2"/>
-          <p:cNvSpPr>
-            <a:spLocks noGrp="1"/>
-          </p:cNvSpPr>
-          <p:nvPr>
-            <p:ph type="body" idx="3" sz="quarter"/>
-          </p:nvPr>
-        </p:nvSpPr>
-        <p:spPr/>
-        <p:txBody>
-          <a:bodyPr/>
-          <a:lstStyle/>
-          <a:p>
-            <a:r>
-              <a:t>MNIST规定任务完成即可达标及格。两项拓展均为可选加分路径，不设固定加分数值或准确率门槛；本轮仅补充任务说明，未执行CIFAR-10或Stanford40实验，也不宣称课程现有脚本已直接支持这两个数据集。</a:t>
-            </a:r>
-          </a:p>
-        </p:txBody>
-      </p:sp>
-      <p:sp>
-        <p:nvSpPr>
-          <p:cNvPr id="4" name="Slide Number Placeholder 3"/>
-          <p:cNvSpPr>
-            <a:spLocks noGrp="1"/>
-          </p:cNvSpPr>
-          <p:nvPr>
-            <p:ph type="sldNum" idx="5" sz="quarter"/>
-          </p:nvPr>
-        </p:nvSpPr>
-        <p:spPr/>
-      </p:sp>
-    </p:spTree>
-  </p:cSld>
-  <p:clrMapOvr>
-    <a:masterClrMapping/>
-  </p:clrMapOvr>
-</p:notes>
-</file>
-
-<file path=ppt/notesSlides/notesSlide16.xml><?xml version="1.0" encoding="utf-8"?>
-<p:notes xmlns:a="http://schemas.openxmlformats.org/drawingml/2006/main" xmlns:p="http://schemas.openxmlformats.org/presentationml/2006/main" xmlns:r="http://schemas.openxmlformats.org/officeDocument/2006/relationships">
-  <p:cSld>
-    <p:spTree>
-      <p:nvGrpSpPr>
-        <p:cNvPr id="1" name=""/>
-        <p:cNvGrpSpPr/>
-        <p:nvPr/>
-      </p:nvGrpSpPr>
-      <p:grpSpPr>
-        <a:xfrm>
-          <a:off x="0" y="0"/>
-          <a:ext cx="0" cy="0"/>
-          <a:chOff x="0" y="0"/>
-          <a:chExt cx="0" cy="0"/>
-        </a:xfrm>
-      </p:grpSpPr>
-      <p:sp>
-        <p:nvSpPr>
-          <p:cNvPr id="2" name="Slide Image Placeholder 1"/>
-          <p:cNvSpPr>
-            <a:spLocks noGrp="1"/>
-          </p:cNvSpPr>
-          <p:nvPr>
-            <p:ph type="sldImg" idx="2"/>
-          </p:nvPr>
-        </p:nvSpPr>
-        <p:spPr/>
-      </p:sp>
-      <p:sp>
-        <p:nvSpPr>
-          <p:cNvPr id="3" name="Notes Placeholder 2"/>
-          <p:cNvSpPr>
-            <a:spLocks noGrp="1"/>
-          </p:cNvSpPr>
-          <p:nvPr>
-            <p:ph type="body" idx="3" sz="quarter"/>
-          </p:nvPr>
-        </p:nvSpPr>
-        <p:spPr/>
-        <p:txBody>
-          <a:bodyPr/>
-          <a:lstStyle/>
-          <a:p>
-            <a:r>
-              <a:t>所有链接为可点击链接。PPT共16页，对齐教师样例的信息密度；课堂主讲只需本PPT，学生逐步实操使用Notebook。未进行真实Kaggle或AutoDL登录执行，所有性能结果注明本地实测。</a:t>
-            </a:r>
-          </a:p>
-        </p:txBody>
-      </p:sp>
-      <p:sp>
-        <p:nvSpPr>
-          <p:cNvPr id="4" name="Slide Number Placeholder 3"/>
-          <p:cNvSpPr>
-            <a:spLocks noGrp="1"/>
-          </p:cNvSpPr>
-          <p:nvPr>
-            <p:ph type="sldNum" idx="5" sz="quarter"/>
-          </p:nvPr>
-        </p:nvSpPr>
-        <p:spPr/>
-      </p:sp>
-    </p:spTree>
-  </p:cSld>
-  <p:clrMapOvr>
-    <a:masterClrMapping/>
-  </p:clrMapOvr>
-</p:notes>
-</file>
-
-<file path=ppt/notesSlides/notesSlide2.xml><?xml version="1.0" encoding="utf-8"?>
-<p:notes xmlns:a="http://schemas.openxmlformats.org/drawingml/2006/main" xmlns:p="http://schemas.openxmlformats.org/presentationml/2006/main" xmlns:r="http://schemas.openxmlformats.org/officeDocument/2006/relationships">
-  <p:cSld>
-    <p:spTree>
-      <p:nvGrpSpPr>
-        <p:cNvPr id="1" name=""/>
-        <p:cNvGrpSpPr/>
-        <p:nvPr/>
-      </p:nvGrpSpPr>
-      <p:grpSpPr>
-        <a:xfrm>
-          <a:off x="0" y="0"/>
-          <a:ext cx="0" cy="0"/>
-          <a:chOff x="0" y="0"/>
-          <a:chExt cx="0" cy="0"/>
-        </a:xfrm>
-      </p:grpSpPr>
-      <p:sp>
-        <p:nvSpPr>
-          <p:cNvPr id="2" name="Slide Image Placeholder 1"/>
-          <p:cNvSpPr>
-            <a:spLocks noGrp="1"/>
-          </p:cNvSpPr>
-          <p:nvPr>
-            <p:ph type="sldImg" idx="2"/>
-          </p:nvPr>
-        </p:nvSpPr>
-        <p:spPr/>
-      </p:sp>
-      <p:sp>
-        <p:nvSpPr>
-          <p:cNvPr id="3" name="Notes Placeholder 2"/>
-          <p:cNvSpPr>
-            <a:spLocks noGrp="1"/>
-          </p:cNvSpPr>
-          <p:nvPr>
-            <p:ph type="body" idx="3" sz="quarter"/>
-          </p:nvPr>
-        </p:nvSpPr>
-        <p:spPr/>
-        <p:txBody>
-          <a:bodyPr/>
-          <a:lstStyle/>
-          <a:p>
-            <a:r>
-              <a:t>先展示最终任务，再介绍学习路线：准备环境和资源、训练、评估/预测、单参数练习、提交。评分见第14页。不会要求学生从零编写神经网络。</a:t>
-            </a:r>
-          </a:p>
-        </p:txBody>
-      </p:sp>
-      <p:sp>
-        <p:nvSpPr>
-          <p:cNvPr id="4" name="Slide Number Placeholder 3"/>
-          <p:cNvSpPr>
-            <a:spLocks noGrp="1"/>
-          </p:cNvSpPr>
-          <p:nvPr>
-            <p:ph type="sldNum" idx="5" sz="quarter"/>
-          </p:nvPr>
-        </p:nvSpPr>
-        <p:spPr/>
-      </p:sp>
-    </p:spTree>
-  </p:cSld>
-  <p:clrMapOvr>
-    <a:masterClrMapping/>
-  </p:clrMapOvr>
-</p:notes>
-</file>
-
-<file path=ppt/notesSlides/notesSlide3.xml><?xml version="1.0" encoding="utf-8"?>
-<p:notes xmlns:a="http://schemas.openxmlformats.org/drawingml/2006/main" xmlns:p="http://schemas.openxmlformats.org/presentationml/2006/main" xmlns:r="http://schemas.openxmlformats.org/officeDocument/2006/relationships">
-  <p:cSld>
-    <p:spTree>
-      <p:nvGrpSpPr>
-        <p:cNvPr id="1" name=""/>
-        <p:cNvGrpSpPr/>
-        <p:nvPr/>
-      </p:nvGrpSpPr>
-      <p:grpSpPr>
-        <a:xfrm>
-          <a:off x="0" y="0"/>
-          <a:ext cx="0" cy="0"/>
-          <a:chOff x="0" y="0"/>
-          <a:chExt cx="0" cy="0"/>
-        </a:xfrm>
-      </p:grpSpPr>
-      <p:sp>
-        <p:nvSpPr>
-          <p:cNvPr id="2" name="Slide Image Placeholder 1"/>
-          <p:cNvSpPr>
-            <a:spLocks noGrp="1"/>
-          </p:cNvSpPr>
-          <p:nvPr>
-            <p:ph type="sldImg" idx="2"/>
-          </p:nvPr>
-        </p:nvSpPr>
-        <p:spPr/>
-      </p:sp>
-      <p:sp>
-        <p:nvSpPr>
-          <p:cNvPr id="3" name="Notes Placeholder 2"/>
-          <p:cNvSpPr>
-            <a:spLocks noGrp="1"/>
-          </p:cNvSpPr>
-          <p:nvPr>
-            <p:ph type="body" idx="3" sz="quarter"/>
-          </p:nvPr>
-        </p:nvSpPr>
-        <p:spPr/>
-        <p:txBody>
-          <a:bodyPr/>
-          <a:lstStyle/>
-          <a:p>
-            <a:r>
-              <a:t>ByteFormer处理JPEG文件字节，不是ViT像素patch。MNIST灰度图转RGB后保存28x28 quality100 JPEG。模型167个主干张量严格匹配官方权重；教学移植修复padding/shift mask，见THIRD_PARTY_NOTICES.md。微调前新分类头未学习MNIST，不代表原ImageNet模型的原任务准确率。</a:t>
-            </a:r>
-          </a:p>
-        </p:txBody>
-      </p:sp>
-      <p:sp>
-        <p:nvSpPr>
-          <p:cNvPr id="4" name="Slide Number Placeholder 3"/>
-          <p:cNvSpPr>
-            <a:spLocks noGrp="1"/>
-          </p:cNvSpPr>
-          <p:nvPr>
-            <p:ph type="sldNum" idx="5" sz="quarter"/>
-          </p:nvPr>
-        </p:nvSpPr>
-        <p:spPr/>
-      </p:sp>
-    </p:spTree>
-  </p:cSld>
-  <p:clrMapOvr>
-    <a:masterClrMapping/>
-  </p:clrMapOvr>
-</p:notes>
-</file>
-
-<file path=ppt/notesSlides/notesSlide4.xml><?xml version="1.0" encoding="utf-8"?>
-<p:notes xmlns:a="http://schemas.openxmlformats.org/drawingml/2006/main" xmlns:p="http://schemas.openxmlformats.org/presentationml/2006/main" xmlns:r="http://schemas.openxmlformats.org/officeDocument/2006/relationships">
-  <p:cSld>
-    <p:spTree>
-      <p:nvGrpSpPr>
-        <p:cNvPr id="1" name=""/>
-        <p:cNvGrpSpPr/>
-        <p:nvPr/>
-      </p:nvGrpSpPr>
-      <p:grpSpPr>
-        <a:xfrm>
-          <a:off x="0" y="0"/>
-          <a:ext cx="0" cy="0"/>
-          <a:chOff x="0" y="0"/>
-          <a:chExt cx="0" cy="0"/>
-        </a:xfrm>
-      </p:grpSpPr>
-      <p:sp>
-        <p:nvSpPr>
-          <p:cNvPr id="2" name="Slide Image Placeholder 1"/>
-          <p:cNvSpPr>
-            <a:spLocks noGrp="1"/>
-          </p:cNvSpPr>
-          <p:nvPr>
-            <p:ph type="sldImg" idx="2"/>
-          </p:nvPr>
-        </p:nvSpPr>
-        <p:spPr/>
-      </p:sp>
-      <p:sp>
-        <p:nvSpPr>
-          <p:cNvPr id="3" name="Notes Placeholder 2"/>
-          <p:cNvSpPr>
-            <a:spLocks noGrp="1"/>
-          </p:cNvSpPr>
-          <p:nvPr>
-            <p:ph type="body" idx="3" sz="quarter"/>
-          </p:nvPr>
-        </p:nvSpPr>
-        <p:spPr/>
-        <p:txBody>
-          <a:bodyPr/>
-          <a:lstStyle/>
-          <a:p>
-            <a:r>
-              <a:t>验证集用于选模型，测试集只作最终评估，不能用测试分数反复调参。种子42排列官方60000训练部分，前50000训练、后10000验证候选，再取验证池前1000；种子43排列官方10000测试部分。正式默认测试全部10000。首次实测先测1000再用相同锁定模型独立全测10000，原始两份报告分别保留。</a:t>
-            </a:r>
-          </a:p>
-        </p:txBody>
-      </p:sp>
-      <p:sp>
-        <p:nvSpPr>
-          <p:cNvPr id="4" name="Slide Number Placeholder 3"/>
-          <p:cNvSpPr>
-            <a:spLocks noGrp="1"/>
-          </p:cNvSpPr>
-          <p:nvPr>
-            <p:ph type="sldNum" idx="5" sz="quarter"/>
-          </p:nvPr>
-        </p:nvSpPr>
-        <p:spPr/>
-      </p:sp>
-    </p:spTree>
-  </p:cSld>
-  <p:clrMapOvr>
-    <a:masterClrMapping/>
-  </p:clrMapOvr>
-</p:notes>
-</file>
-
-<file path=ppt/notesSlides/notesSlide5.xml><?xml version="1.0" encoding="utf-8"?>
-<p:notes xmlns:a="http://schemas.openxmlformats.org/drawingml/2006/main" xmlns:p="http://schemas.openxmlformats.org/presentationml/2006/main" xmlns:r="http://schemas.openxmlformats.org/officeDocument/2006/relationships">
-  <p:cSld>
-    <p:spTree>
-      <p:nvGrpSpPr>
-        <p:cNvPr id="1" name=""/>
-        <p:cNvGrpSpPr/>
-        <p:nvPr/>
-      </p:nvGrpSpPr>
-      <p:grpSpPr>
-        <a:xfrm>
-          <a:off x="0" y="0"/>
-          <a:ext cx="0" cy="0"/>
-          <a:chOff x="0" y="0"/>
-          <a:chExt cx="0" cy="0"/>
-        </a:xfrm>
-      </p:grpSpPr>
-      <p:sp>
-        <p:nvSpPr>
-          <p:cNvPr id="2" name="Slide Image Placeholder 1"/>
-          <p:cNvSpPr>
-            <a:spLocks noGrp="1"/>
-          </p:cNvSpPr>
-          <p:nvPr>
-            <p:ph type="sldImg" idx="2"/>
-          </p:nvPr>
-        </p:nvSpPr>
-        <p:spPr/>
-      </p:sp>
-      <p:sp>
-        <p:nvSpPr>
-          <p:cNvPr id="3" name="Notes Placeholder 2"/>
-          <p:cNvSpPr>
-            <a:spLocks noGrp="1"/>
-          </p:cNvSpPr>
-          <p:nvPr>
-            <p:ph type="body" idx="3" sz="quarter"/>
-          </p:nvPr>
-        </p:nvSpPr>
-        <p:spPr/>
-        <p:txBody>
-          <a:bodyPr/>
-          <a:lstStyle/>
-          <a:p>
-            <a:r>
-              <a:t>平台网页步骤依据官方文档整理；本课程尚未登录Kaggle或AutoDL实际账号执行。所有展示的准确率、时间来自本地记录的RTX4090实验。无需在学生个人电脑安装CUDA。</a:t>
-            </a:r>
-          </a:p>
-        </p:txBody>
-      </p:sp>
-      <p:sp>
-        <p:nvSpPr>
-          <p:cNvPr id="4" name="Slide Number Placeholder 3"/>
-          <p:cNvSpPr>
-            <a:spLocks noGrp="1"/>
-          </p:cNvSpPr>
-          <p:nvPr>
-            <p:ph type="sldNum" idx="5" sz="quarter"/>
-          </p:nvPr>
-        </p:nvSpPr>
-        <p:spPr/>
-      </p:sp>
-    </p:spTree>
-  </p:cSld>
-  <p:clrMapOvr>
-    <a:masterClrMapping/>
-  </p:clrMapOvr>
-</p:notes>
-</file>
-
-<file path=ppt/notesSlides/notesSlide6.xml><?xml version="1.0" encoding="utf-8"?>
-<p:notes xmlns:a="http://schemas.openxmlformats.org/drawingml/2006/main" xmlns:p="http://schemas.openxmlformats.org/presentationml/2006/main" xmlns:r="http://schemas.openxmlformats.org/officeDocument/2006/relationships">
-  <p:cSld>
-    <p:spTree>
-      <p:nvGrpSpPr>
-        <p:cNvPr id="1" name=""/>
-        <p:cNvGrpSpPr/>
-        <p:nvPr/>
-      </p:nvGrpSpPr>
-      <p:grpSpPr>
-        <a:xfrm>
-          <a:off x="0" y="0"/>
-          <a:ext cx="0" cy="0"/>
-          <a:chOff x="0" y="0"/>
-          <a:chExt cx="0" cy="0"/>
-        </a:xfrm>
-      </p:grpSpPr>
-      <p:sp>
-        <p:nvSpPr>
-          <p:cNvPr id="2" name="Slide Image Placeholder 1"/>
-          <p:cNvSpPr>
-            <a:spLocks noGrp="1"/>
-          </p:cNvSpPr>
-          <p:nvPr>
-            <p:ph type="sldImg" idx="2"/>
-          </p:nvPr>
-        </p:nvSpPr>
-        <p:spPr/>
-      </p:sp>
-      <p:sp>
-        <p:nvSpPr>
-          <p:cNvPr id="3" name="Notes Placeholder 2"/>
-          <p:cNvSpPr>
-            <a:spLocks noGrp="1"/>
-          </p:cNvSpPr>
-          <p:nvPr>
-            <p:ph type="body" idx="3" sz="quarter"/>
-          </p:nvPr>
-        </p:nvSpPr>
-        <p:spPr/>
-        <p:txBody>
-          <a:bodyPr/>
-          <a:lstStyle/>
-          <a:p>
-            <a:r>
-              <a:t>教程仅作平台准备入口，不要求运行文章中的示例项目。中文教程来自搜索检索；CSDN和知乎限制自动读取，本次未逐图核验，授课前请用学生浏览器确认可访问性。界面、验证和GPU额度以Kaggle实际页面及官方文档为准。下载原始ipynb文件后在Kaggle导入；课程尚未登录Kaggle账号实机执行。</a:t>
-            </a:r>
-          </a:p>
-        </p:txBody>
-      </p:sp>
-      <p:sp>
-        <p:nvSpPr>
-          <p:cNvPr id="4" name="Slide Number Placeholder 3"/>
-          <p:cNvSpPr>
-            <a:spLocks noGrp="1"/>
-          </p:cNvSpPr>
-          <p:nvPr>
-            <p:ph type="sldNum" idx="5" sz="quarter"/>
-          </p:nvPr>
-        </p:nvSpPr>
-        <p:spPr/>
-      </p:sp>
-    </p:spTree>
-  </p:cSld>
-  <p:clrMapOvr>
-    <a:masterClrMapping/>
-  </p:clrMapOvr>
-</p:notes>
-</file>
-
-<file path=ppt/notesSlides/notesSlide7.xml><?xml version="1.0" encoding="utf-8"?>
-<p:notes xmlns:a="http://schemas.openxmlformats.org/drawingml/2006/main" xmlns:p="http://schemas.openxmlformats.org/presentationml/2006/main" xmlns:r="http://schemas.openxmlformats.org/officeDocument/2006/relationships">
-  <p:cSld>
-    <p:spTree>
-      <p:nvGrpSpPr>
-        <p:cNvPr id="1" name=""/>
-        <p:cNvGrpSpPr/>
-        <p:nvPr/>
-      </p:nvGrpSpPr>
-      <p:grpSpPr>
-        <a:xfrm>
-          <a:off x="0" y="0"/>
-          <a:ext cx="0" cy="0"/>
-          <a:chOff x="0" y="0"/>
-          <a:chExt cx="0" cy="0"/>
-        </a:xfrm>
-      </p:grpSpPr>
-      <p:sp>
-        <p:nvSpPr>
-          <p:cNvPr id="2" name="Slide Image Placeholder 1"/>
-          <p:cNvSpPr>
-            <a:spLocks noGrp="1"/>
-          </p:cNvSpPr>
-          <p:nvPr>
-            <p:ph type="sldImg" idx="2"/>
-          </p:nvPr>
-        </p:nvSpPr>
-        <p:spPr/>
-      </p:sp>
-      <p:sp>
-        <p:nvSpPr>
-          <p:cNvPr id="3" name="Notes Placeholder 2"/>
-          <p:cNvSpPr>
-            <a:spLocks noGrp="1"/>
-          </p:cNvSpPr>
-          <p:nvPr>
-            <p:ph type="body" idx="3" sz="quarter"/>
-          </p:nvPr>
-        </p:nvSpPr>
-        <p:spPr/>
-        <p:txBody>
-          <a:bodyPr/>
-          <a:lstStyle/>
-          <a:p>
-            <a:r>
-              <a:t>Notebook实际使用绝对目标路径并检测已有目录，重复运行不会删除结果。默认Kaggle工作目录为/kaggle/working。requirements只安装轻量依赖、限制NumPy&lt;2，不重装平台PyTorch/CUDA。数据4个MD5、权重SHA256已实测；资源缺失可重新运行prepare。网络受限可使用教师含数据和权重的课堂资源包，仍需已有PyTorch环境。</a:t>
-            </a:r>
-          </a:p>
-        </p:txBody>
-      </p:sp>
-      <p:sp>
-        <p:nvSpPr>
-          <p:cNvPr id="4" name="Slide Number Placeholder 3"/>
-          <p:cNvSpPr>
-            <a:spLocks noGrp="1"/>
-          </p:cNvSpPr>
-          <p:nvPr>
-            <p:ph type="sldNum" idx="5" sz="quarter"/>
-          </p:nvPr>
-        </p:nvSpPr>
-        <p:spPr/>
-      </p:sp>
-    </p:spTree>
-  </p:cSld>
-  <p:clrMapOvr>
-    <a:masterClrMapping/>
-  </p:clrMapOvr>
-</p:notes>
-</file>
-
-<file path=ppt/notesSlides/notesSlide8.xml><?xml version="1.0" encoding="utf-8"?>
-<p:notes xmlns:a="http://schemas.openxmlformats.org/drawingml/2006/main" xmlns:p="http://schemas.openxmlformats.org/presentationml/2006/main" xmlns:r="http://schemas.openxmlformats.org/officeDocument/2006/relationships">
-  <p:cSld>
-    <p:spTree>
-      <p:nvGrpSpPr>
-        <p:cNvPr id="1" name=""/>
-        <p:cNvGrpSpPr/>
-        <p:nvPr/>
-      </p:nvGrpSpPr>
-      <p:grpSpPr>
-        <a:xfrm>
-          <a:off x="0" y="0"/>
-          <a:ext cx="0" cy="0"/>
-          <a:chOff x="0" y="0"/>
-          <a:chExt cx="0" cy="0"/>
-        </a:xfrm>
-      </p:grpSpPr>
-      <p:sp>
-        <p:nvSpPr>
-          <p:cNvPr id="2" name="Slide Image Placeholder 1"/>
-          <p:cNvSpPr>
-            <a:spLocks noGrp="1"/>
-          </p:cNvSpPr>
-          <p:nvPr>
-            <p:ph type="sldImg" idx="2"/>
-          </p:nvPr>
-        </p:nvSpPr>
-        <p:spPr/>
-      </p:sp>
-      <p:sp>
-        <p:nvSpPr>
-          <p:cNvPr id="3" name="Notes Placeholder 2"/>
-          <p:cNvSpPr>
-            <a:spLocks noGrp="1"/>
-          </p:cNvSpPr>
-          <p:nvPr>
-            <p:ph type="body" idx="3" sz="quarter"/>
-          </p:nvPr>
-        </p:nvSpPr>
-        <p:spPr/>
-        <p:txBody>
-          <a:bodyPr/>
-          <a:lstStyle/>
-          <a:p>
-            <a:r>
-              <a:t>epochs和batch size由学生输入；参考配置为train50000/val1000/test10000/batch32/lr1e-4/milestones4,6/gamma0.2/seed42。原正式实测训练末先测试1000，之后独立全10000；发布默认把最终测试整合成10000，共用同一score代码。输出目录已有best.pt时会报错保护结果；重跑换output且对应修改后续checkpoint。模型从官方权重全参数微调，AdamW weight_decay0.01，分类头10倍学习率。</a:t>
-            </a:r>
-          </a:p>
-        </p:txBody>
-      </p:sp>
-      <p:sp>
-        <p:nvSpPr>
-          <p:cNvPr id="4" name="Slide Number Placeholder 3"/>
-          <p:cNvSpPr>
-            <a:spLocks noGrp="1"/>
-          </p:cNvSpPr>
-          <p:nvPr>
-            <p:ph type="sldNum" idx="5" sz="quarter"/>
-          </p:nvPr>
-        </p:nvSpPr>
-        <p:spPr/>
-      </p:sp>
-    </p:spTree>
-  </p:cSld>
-  <p:clrMapOvr>
-    <a:masterClrMapping/>
-  </p:clrMapOvr>
-</p:notes>
-</file>
-
-<file path=ppt/notesSlides/notesSlide9.xml><?xml version="1.0" encoding="utf-8"?>
-<p:notes xmlns:a="http://schemas.openxmlformats.org/drawingml/2006/main" xmlns:p="http://schemas.openxmlformats.org/presentationml/2006/main" xmlns:r="http://schemas.openxmlformats.org/officeDocument/2006/relationships">
-  <p:cSld>
-    <p:spTree>
-      <p:nvGrpSpPr>
-        <p:cNvPr id="1" name=""/>
-        <p:cNvGrpSpPr/>
-        <p:nvPr/>
-      </p:nvGrpSpPr>
-      <p:grpSpPr>
-        <a:xfrm>
-          <a:off x="0" y="0"/>
-          <a:ext cx="0" cy="0"/>
-          <a:chOff x="0" y="0"/>
-          <a:chExt cx="0" cy="0"/>
-        </a:xfrm>
-      </p:grpSpPr>
-      <p:sp>
-        <p:nvSpPr>
-          <p:cNvPr id="2" name="Slide Image Placeholder 1"/>
-          <p:cNvSpPr>
-            <a:spLocks noGrp="1"/>
-          </p:cNvSpPr>
-          <p:nvPr>
-            <p:ph type="sldImg" idx="2"/>
-          </p:nvPr>
-        </p:nvSpPr>
-        <p:spPr/>
-      </p:sp>
-      <p:sp>
-        <p:nvSpPr>
-          <p:cNvPr id="3" name="Notes Placeholder 2"/>
-          <p:cNvSpPr>
-            <a:spLocks noGrp="1"/>
-          </p:cNvSpPr>
-          <p:nvPr>
-            <p:ph type="body" idx="3" sz="quarter"/>
-          </p:nvPr>
-        </p:nvSpPr>
-        <p:spPr/>
-        <p:txBody>
-          <a:bodyPr/>
-          <a:lstStyle/>
-          <a:p>
-            <a:r>
-              <a:t>在课程Notebook中显示学生本次运行的曲线。训练损失用于观察拟合过程，验证集用于模型与参数选择；锁定模型后查看测试结果，不根据测试分数反复调参。本页只引导结果解读，不展示教师准确率或设置成绩门槛。</a:t>
-            </a:r>
-          </a:p>
-        </p:txBody>
-      </p:sp>
-      <p:sp>
-        <p:nvSpPr>
-          <p:cNvPr id="4" name="Slide Number Placeholder 3"/>
-          <p:cNvSpPr>
-            <a:spLocks noGrp="1"/>
-          </p:cNvSpPr>
-          <p:nvPr>
-            <p:ph type="sldNum" idx="5" sz="quarter"/>
-          </p:nvPr>
-        </p:nvSpPr>
-        <p:spPr/>
-      </p:sp>
-    </p:spTree>
-  </p:cSld>
-  <p:clrMapOvr>
-    <a:masterClrMapping/>
-  </p:clrMapOvr>
-</p:notes>
 </file>
 
 <file path=ppt/slideLayouts/slideLayout1.xml><?xml version="1.0" encoding="utf-8"?>
@@ -5305,7 +3835,7 @@
           <p:nvPr/>
         </p:nvPicPr>
         <p:blipFill>
-          <a:blip r:embed="rId4"/>
+          <a:blip r:embed="rId3"/>
           <a:stretch>
             <a:fillRect/>
           </a:stretch>
@@ -6699,7 +5229,7 @@
             </a:pPr>
             <a:r>
               <a:rPr u="sng">
-                <a:hlinkClick r:id="rId4"/>
+                <a:hlinkClick r:id="rId3"/>
               </a:rPr>
               <a:t>AutoDL官方快速开始（实例、JupyterLab、Terminal）</a:t>
             </a:r>
@@ -9476,7 +8006,7 @@
             </a:pPr>
             <a:r>
               <a:rPr u="sng">
-                <a:hlinkClick r:id="rId4"/>
+                <a:hlinkClick r:id="rId3"/>
               </a:rPr>
               <a:t>课程仓库：代码、Notebook、数据、PPT、报告模板</a:t>
             </a:r>
@@ -9518,7 +8048,7 @@
             </a:pPr>
             <a:r>
               <a:rPr u="sng">
-                <a:hlinkClick r:id="rId5"/>
+                <a:hlinkClick r:id="rId4"/>
               </a:rPr>
               <a:t>Kaggle Notebook 官方文档</a:t>
             </a:r>
@@ -9560,7 +8090,7 @@
             </a:pPr>
             <a:r>
               <a:rPr u="sng">
-                <a:hlinkClick r:id="rId6"/>
+                <a:hlinkClick r:id="rId5"/>
               </a:rPr>
               <a:t>AutoDL 官方快速开始</a:t>
             </a:r>
@@ -9602,7 +8132,7 @@
             </a:pPr>
             <a:r>
               <a:rPr u="sng">
-                <a:hlinkClick r:id="rId7"/>
+                <a:hlinkClick r:id="rId6"/>
               </a:rPr>
               <a:t>ByteFormer 原论文：Bytes Are All You Need</a:t>
             </a:r>
@@ -9644,7 +8174,7 @@
             </a:pPr>
             <a:r>
               <a:rPr u="sng">
-                <a:hlinkClick r:id="rId8"/>
+                <a:hlinkClick r:id="rId7"/>
               </a:rPr>
               <a:t>Apple CoreNet：ByteFormer代码与预训练权重</a:t>
             </a:r>
@@ -9686,7 +8216,7 @@
             </a:pPr>
             <a:r>
               <a:rPr u="sng">
-                <a:hlinkClick r:id="rId9"/>
+                <a:hlinkClick r:id="rId8"/>
               </a:rPr>
               <a:t>MNIST：CVDF镜像与原作者说明</a:t>
             </a:r>
@@ -11605,7 +10135,7 @@
           <p:nvPr/>
         </p:nvPicPr>
         <p:blipFill>
-          <a:blip r:embed="rId4"/>
+          <a:blip r:embed="rId3"/>
           <a:stretch>
             <a:fillRect/>
           </a:stretch>
@@ -12810,7 +11340,7 @@
             </a:pPr>
             <a:r>
               <a:rPr u="sng">
-                <a:hlinkClick r:id="rId4"/>
+                <a:hlinkClick r:id="rId3"/>
               </a:rPr>
               <a:t>Kaggle：创建Notebook</a:t>
             </a:r>
@@ -12852,7 +11382,7 @@
             </a:pPr>
             <a:r>
               <a:rPr u="sng">
-                <a:hlinkClick r:id="rId5"/>
+                <a:hlinkClick r:id="rId4"/>
               </a:rPr>
               <a:t>AutoDL：实例与价格</a:t>
             </a:r>
@@ -13264,7 +11794,7 @@
             </a:pPr>
             <a:r>
               <a:rPr u="sng">
-                <a:hlinkClick r:id="rId4"/>
+                <a:hlinkClick r:id="rId3"/>
               </a:rPr>
               <a:t>知乎｜Kaggle GPU资源使用教程——针对超级小白</a:t>
             </a:r>
@@ -13349,7 +11879,7 @@
             </a:pPr>
             <a:r>
               <a:rPr u="sng">
-                <a:hlinkClick r:id="rId5"/>
+                <a:hlinkClick r:id="rId4"/>
               </a:rPr>
               <a:t>CSDN｜科研小白扫盲：Kaggle平台使用指导指南</a:t>
             </a:r>
@@ -13434,7 +11964,7 @@
             </a:pPr>
             <a:r>
               <a:rPr u="sng">
-                <a:hlinkClick r:id="rId6"/>
+                <a:hlinkClick r:id="rId5"/>
               </a:rPr>
               <a:t>Kaggle官方｜Notebook使用文档</a:t>
             </a:r>
@@ -13476,7 +12006,7 @@
             </a:pPr>
             <a:r>
               <a:rPr u="sng">
-                <a:hlinkClick r:id="rId7"/>
+                <a:hlinkClick r:id="rId6"/>
               </a:rPr>
               <a:t>课程Notebook：下载course_kaggle.ipynb</a:t>
             </a:r>
@@ -16384,324 +14914,4 @@
   </a:objectDefaults>
   <a:extraClrSchemeLst/>
 </a:theme>
-</file>
-
-<file path=ppt/theme/theme2.xml><?xml version="1.0" encoding="utf-8"?>
-<a:theme xmlns:a="http://schemas.openxmlformats.org/drawingml/2006/main" name="Office Theme">
-  <a:themeElements>
-    <a:clrScheme name="Office">
-      <a:dk1>
-        <a:sysClr val="windowText" lastClr="000000"/>
-      </a:dk1>
-      <a:lt1>
-        <a:sysClr val="window" lastClr="FFFFFF"/>
-      </a:lt1>
-      <a:dk2>
-        <a:srgbClr val="1F497D"/>
-      </a:dk2>
-      <a:lt2>
-        <a:srgbClr val="EEECE1"/>
-      </a:lt2>
-      <a:accent1>
-        <a:srgbClr val="4F81BD"/>
-      </a:accent1>
-      <a:accent2>
-        <a:srgbClr val="C0504D"/>
-      </a:accent2>
-      <a:accent3>
-        <a:srgbClr val="9BBB59"/>
-      </a:accent3>
-      <a:accent4>
-        <a:srgbClr val="8064A2"/>
-      </a:accent4>
-      <a:accent5>
-        <a:srgbClr val="4BACC6"/>
-      </a:accent5>
-      <a:accent6>
-        <a:srgbClr val="F79646"/>
-      </a:accent6>
-      <a:hlink>
-        <a:srgbClr val="0000FF"/>
-      </a:hlink>
-      <a:folHlink>
-        <a:srgbClr val="800080"/>
-      </a:folHlink>
-    </a:clrScheme>
-    <a:fontScheme name="Office">
-      <a:majorFont>
-        <a:latin typeface="Calibri"/>
-        <a:ea typeface=""/>
-        <a:cs typeface=""/>
-        <a:font script="Jpan" typeface="ＭＳ Ｐゴシック"/>
-        <a:font script="Hang" typeface="맑은 고딕"/>
-        <a:font script="Hans" typeface="宋体"/>
-        <a:font script="Hant" typeface="新細明體"/>
-        <a:font script="Arab" typeface="Times New Roman"/>
-        <a:font script="Hebr" typeface="Times New Roman"/>
-        <a:font script="Thai" typeface="Angsana New"/>
-        <a:font script="Ethi" typeface="Nyala"/>
-        <a:font script="Beng" typeface="Vrinda"/>
-        <a:font script="Gujr" typeface="Shruti"/>
-        <a:font script="Khmr" typeface="MoolBoran"/>
-        <a:font script="Knda" typeface="Tunga"/>
-        <a:font script="Guru" typeface="Raavi"/>
-        <a:font script="Cans" typeface="Euphemia"/>
-        <a:font script="Cher" typeface="Plantagenet Cherokee"/>
-        <a:font script="Yiii" typeface="Microsoft Yi Baiti"/>
-        <a:font script="Tibt" typeface="Microsoft Himalaya"/>
-        <a:font script="Thaa" typeface="MV Boli"/>
-        <a:font script="Deva" typeface="Mangal"/>
-        <a:font script="Telu" typeface="Gautami"/>
-        <a:font script="Taml" typeface="Latha"/>
-        <a:font script="Syrc" typeface="Estrangelo Edessa"/>
-        <a:font script="Orya" typeface="Kalinga"/>
-        <a:font script="Mlym" typeface="Kartika"/>
-        <a:font script="Laoo" typeface="DokChampa"/>
-        <a:font script="Sinh" typeface="Iskoola Pota"/>
-        <a:font script="Mong" typeface="Mongolian Baiti"/>
-        <a:font script="Viet" typeface="Times New Roman"/>
-        <a:font script="Uigh" typeface="Microsoft Uighur"/>
-        <a:font script="Geor" typeface="Sylfaen"/>
-      </a:majorFont>
-      <a:minorFont>
-        <a:latin typeface="Calibri"/>
-        <a:ea typeface=""/>
-        <a:cs typeface=""/>
-        <a:font script="Jpan" typeface="ＭＳ Ｐゴシック"/>
-        <a:font script="Hang" typeface="맑은 고딕"/>
-        <a:font script="Hans" typeface="宋体"/>
-        <a:font script="Hant" typeface="新細明體"/>
-        <a:font script="Arab" typeface="Arial"/>
-        <a:font script="Hebr" typeface="Arial"/>
-        <a:font script="Thai" typeface="Cordia New"/>
-        <a:font script="Ethi" typeface="Nyala"/>
-        <a:font script="Beng" typeface="Vrinda"/>
-        <a:font script="Gujr" typeface="Shruti"/>
-        <a:font script="Khmr" typeface="DaunPenh"/>
-        <a:font script="Knda" typeface="Tunga"/>
-        <a:font script="Guru" typeface="Raavi"/>
-        <a:font script="Cans" typeface="Euphemia"/>
-        <a:font script="Cher" typeface="Plantagenet Cherokee"/>
-        <a:font script="Yiii" typeface="Microsoft Yi Baiti"/>
-        <a:font script="Tibt" typeface="Microsoft Himalaya"/>
-        <a:font script="Thaa" typeface="MV Boli"/>
-        <a:font script="Deva" typeface="Mangal"/>
-        <a:font script="Telu" typeface="Gautami"/>
-        <a:font script="Taml" typeface="Latha"/>
-        <a:font script="Syrc" typeface="Estrangelo Edessa"/>
-        <a:font script="Orya" typeface="Kalinga"/>
-        <a:font script="Mlym" typeface="Kartika"/>
-        <a:font script="Laoo" typeface="DokChampa"/>
-        <a:font script="Sinh" typeface="Iskoola Pota"/>
-        <a:font script="Mong" typeface="Mongolian Baiti"/>
-        <a:font script="Viet" typeface="Arial"/>
-        <a:font script="Uigh" typeface="Microsoft Uighur"/>
-        <a:font script="Geor" typeface="Sylfaen"/>
-      </a:minorFont>
-    </a:fontScheme>
-    <a:fmtScheme name="Office">
-      <a:fillStyleLst>
-        <a:solidFill>
-          <a:schemeClr val="phClr"/>
-        </a:solidFill>
-        <a:gradFill rotWithShape="1">
-          <a:gsLst>
-            <a:gs pos="0">
-              <a:schemeClr val="phClr">
-                <a:tint val="50000"/>
-                <a:satMod val="300000"/>
-              </a:schemeClr>
-            </a:gs>
-            <a:gs pos="35000">
-              <a:schemeClr val="phClr">
-                <a:tint val="37000"/>
-                <a:satMod val="300000"/>
-              </a:schemeClr>
-            </a:gs>
-            <a:gs pos="100000">
-              <a:schemeClr val="phClr">
-                <a:tint val="15000"/>
-                <a:satMod val="350000"/>
-              </a:schemeClr>
-            </a:gs>
-          </a:gsLst>
-          <a:lin ang="16200000" scaled="1"/>
-        </a:gradFill>
-        <a:gradFill rotWithShape="1">
-          <a:gsLst>
-            <a:gs pos="0">
-              <a:schemeClr val="phClr">
-                <a:tint val="100000"/>
-                <a:shade val="100000"/>
-                <a:satMod val="130000"/>
-              </a:schemeClr>
-            </a:gs>
-            <a:gs pos="100000">
-              <a:schemeClr val="phClr">
-                <a:tint val="50000"/>
-                <a:shade val="100000"/>
-                <a:satMod val="350000"/>
-              </a:schemeClr>
-            </a:gs>
-          </a:gsLst>
-          <a:lin ang="16200000" scaled="0"/>
-        </a:gradFill>
-      </a:fillStyleLst>
-      <a:lnStyleLst>
-        <a:ln w="9525" cap="flat" cmpd="sng" algn="ctr">
-          <a:solidFill>
-            <a:schemeClr val="phClr">
-              <a:shade val="95000"/>
-              <a:satMod val="105000"/>
-            </a:schemeClr>
-          </a:solidFill>
-          <a:prstDash val="solid"/>
-        </a:ln>
-        <a:ln w="25400" cap="flat" cmpd="sng" algn="ctr">
-          <a:solidFill>
-            <a:schemeClr val="phClr"/>
-          </a:solidFill>
-          <a:prstDash val="solid"/>
-        </a:ln>
-        <a:ln w="38100" cap="flat" cmpd="sng" algn="ctr">
-          <a:solidFill>
-            <a:schemeClr val="phClr"/>
-          </a:solidFill>
-          <a:prstDash val="solid"/>
-        </a:ln>
-      </a:lnStyleLst>
-      <a:effectStyleLst>
-        <a:effectStyle>
-          <a:effectLst>
-            <a:outerShdw blurRad="40000" dist="20000" dir="5400000" rotWithShape="0">
-              <a:srgbClr val="000000">
-                <a:alpha val="38000"/>
-              </a:srgbClr>
-            </a:outerShdw>
-          </a:effectLst>
-        </a:effectStyle>
-        <a:effectStyle>
-          <a:effectLst>
-            <a:outerShdw blurRad="40000" dist="23000" dir="5400000" rotWithShape="0">
-              <a:srgbClr val="000000">
-                <a:alpha val="35000"/>
-              </a:srgbClr>
-            </a:outerShdw>
-          </a:effectLst>
-        </a:effectStyle>
-        <a:effectStyle>
-          <a:effectLst>
-            <a:outerShdw blurRad="40000" dist="23000" dir="5400000" rotWithShape="0">
-              <a:srgbClr val="000000">
-                <a:alpha val="35000"/>
-              </a:srgbClr>
-            </a:outerShdw>
-          </a:effectLst>
-          <a:scene3d>
-            <a:camera prst="orthographicFront">
-              <a:rot lat="0" lon="0" rev="0"/>
-            </a:camera>
-            <a:lightRig rig="threePt" dir="t">
-              <a:rot lat="0" lon="0" rev="1200000"/>
-            </a:lightRig>
-          </a:scene3d>
-          <a:sp3d>
-            <a:bevelT w="63500" h="25400"/>
-          </a:sp3d>
-        </a:effectStyle>
-      </a:effectStyleLst>
-      <a:bgFillStyleLst>
-        <a:solidFill>
-          <a:schemeClr val="phClr"/>
-        </a:solidFill>
-        <a:gradFill rotWithShape="1">
-          <a:gsLst>
-            <a:gs pos="0">
-              <a:schemeClr val="phClr">
-                <a:tint val="40000"/>
-                <a:satMod val="350000"/>
-              </a:schemeClr>
-            </a:gs>
-            <a:gs pos="40000">
-              <a:schemeClr val="phClr">
-                <a:tint val="45000"/>
-                <a:shade val="99000"/>
-                <a:satMod val="350000"/>
-              </a:schemeClr>
-            </a:gs>
-            <a:gs pos="100000">
-              <a:schemeClr val="phClr">
-                <a:shade val="20000"/>
-                <a:satMod val="255000"/>
-              </a:schemeClr>
-            </a:gs>
-          </a:gsLst>
-          <a:path path="circle">
-            <a:fillToRect l="50000" t="-80000" r="50000" b="180000"/>
-          </a:path>
-        </a:gradFill>
-        <a:gradFill rotWithShape="1">
-          <a:gsLst>
-            <a:gs pos="0">
-              <a:schemeClr val="phClr">
-                <a:tint val="80000"/>
-                <a:satMod val="300000"/>
-              </a:schemeClr>
-            </a:gs>
-            <a:gs pos="100000">
-              <a:schemeClr val="phClr">
-                <a:shade val="30000"/>
-                <a:satMod val="200000"/>
-              </a:schemeClr>
-            </a:gs>
-          </a:gsLst>
-          <a:path path="circle">
-            <a:fillToRect l="50000" t="50000" r="50000" b="50000"/>
-          </a:path>
-        </a:gradFill>
-      </a:bgFillStyleLst>
-    </a:fmtScheme>
-  </a:themeElements>
-  <a:objectDefaults>
-    <a:spDef>
-      <a:spPr/>
-      <a:bodyPr/>
-      <a:lstStyle/>
-      <a:style>
-        <a:lnRef idx="1">
-          <a:schemeClr val="accent1"/>
-        </a:lnRef>
-        <a:fillRef idx="3">
-          <a:schemeClr val="accent1"/>
-        </a:fillRef>
-        <a:effectRef idx="2">
-          <a:schemeClr val="accent1"/>
-        </a:effectRef>
-        <a:fontRef idx="minor">
-          <a:schemeClr val="lt1"/>
-        </a:fontRef>
-      </a:style>
-    </a:spDef>
-    <a:lnDef>
-      <a:spPr/>
-      <a:bodyPr/>
-      <a:lstStyle/>
-      <a:style>
-        <a:lnRef idx="2">
-          <a:schemeClr val="accent1"/>
-        </a:lnRef>
-        <a:fillRef idx="0">
-          <a:schemeClr val="accent1"/>
-        </a:fillRef>
-        <a:effectRef idx="1">
-          <a:schemeClr val="accent1"/>
-        </a:effectRef>
-        <a:fontRef idx="minor">
-          <a:schemeClr val="tx1"/>
-        </a:fontRef>
-      </a:style>
-    </a:lnDef>
-  </a:objectDefaults>
-  <a:extraClrSchemeLst/>
-</a:theme>
 </file>
</xml_diff>

<commit_message>
Identify Wu Kejun as the course instructor on the cover
</commit_message>
<xml_diff>
--- a/docs/ByteFormer_MNIST_零基础实验课.pptx
+++ b/docs/ByteFormer_MNIST_零基础实验课.pptx
@@ -3280,8 +3280,8 @@
         </p:nvSpPr>
         <p:spPr>
           <a:xfrm>
-            <a:off x="2587752" y="4846320"/>
-            <a:ext cx="8778240" cy="731520"/>
+            <a:off x="2587752" y="4782312"/>
+            <a:ext cx="8778240" cy="438912"/>
           </a:xfrm>
           <a:prstGeom prst="rect">
             <a:avLst/>
@@ -3298,15 +3298,15 @@
               <a:spcAft>
                 <a:spcPts val="600"/>
               </a:spcAft>
-              <a:defRPr sz="2000" b="0">
-                <a:solidFill>
-                  <a:srgbClr val="647483"/>
-                </a:solidFill>
-                <a:latin typeface="Noto Sans CJK SC"/>
-              </a:defRPr>
-            </a:pPr>
-            <a:r>
-              <a:t>按步骤运行 · 查看真实结果 · 亲手修改一个参数</a:t>
+              <a:defRPr sz="2300" b="0">
+                <a:solidFill>
+                  <a:srgbClr val="243547"/>
+                </a:solidFill>
+                <a:latin typeface="Noto Sans CJK SC"/>
+              </a:defRPr>
+            </a:pPr>
+            <a:r>
+              <a:t>授课教师：吴科君</a:t>
             </a:r>
           </a:p>
         </p:txBody>
@@ -3319,7 +3319,46 @@
         </p:nvSpPr>
         <p:spPr>
           <a:xfrm>
-            <a:off x="2606040" y="5879592"/>
+            <a:off x="2587752" y="5404104"/>
+            <a:ext cx="8778240" cy="393192"/>
+          </a:xfrm>
+          <a:prstGeom prst="rect">
+            <a:avLst/>
+          </a:prstGeom>
+          <a:noFill/>
+        </p:spPr>
+        <p:txBody>
+          <a:bodyPr wrap="square" lIns="27432" rIns="27432" tIns="18288" bIns="18288">
+            <a:spAutoFit/>
+          </a:bodyPr>
+          <a:lstStyle/>
+          <a:p>
+            <a:pPr>
+              <a:spcAft>
+                <a:spcPts val="600"/>
+              </a:spcAft>
+              <a:defRPr sz="2000" b="0">
+                <a:solidFill>
+                  <a:srgbClr val="647483"/>
+                </a:solidFill>
+                <a:latin typeface="Noto Sans CJK SC"/>
+              </a:defRPr>
+            </a:pPr>
+            <a:r>
+              <a:t>按步骤运行 · 查看真实结果 · 亲手修改一个参数</a:t>
+            </a:r>
+          </a:p>
+        </p:txBody>
+      </p:sp>
+      <p:sp>
+        <p:nvSpPr>
+          <p:cNvPr id="9" name="TextBox 8"/>
+          <p:cNvSpPr txBox="1"/>
+          <p:nvPr/>
+        </p:nvSpPr>
+        <p:spPr>
+          <a:xfrm>
+            <a:off x="2606040" y="6025896"/>
             <a:ext cx="9144000" cy="384048"/>
           </a:xfrm>
           <a:prstGeom prst="rect">

</xml_diff>

<commit_message>
Use direct course language consistent with the reference deck
</commit_message>
<xml_diff>
--- a/docs/ByteFormer_MNIST_零基础实验课.pptx
+++ b/docs/ByteFormer_MNIST_零基础实验课.pptx
@@ -3267,7 +3267,7 @@
               </a:defRPr>
             </a:pPr>
             <a:r>
-              <a:t>零基础图像分类实验课</a:t>
+              <a:t>图像分类实验任务说明</a:t>
             </a:r>
           </a:p>
         </p:txBody>
@@ -3314,45 +3314,6 @@
       <p:sp>
         <p:nvSpPr>
           <p:cNvPr id="8" name="TextBox 7"/>
-          <p:cNvSpPr txBox="1"/>
-          <p:nvPr/>
-        </p:nvSpPr>
-        <p:spPr>
-          <a:xfrm>
-            <a:off x="2587752" y="5404104"/>
-            <a:ext cx="8778240" cy="393192"/>
-          </a:xfrm>
-          <a:prstGeom prst="rect">
-            <a:avLst/>
-          </a:prstGeom>
-          <a:noFill/>
-        </p:spPr>
-        <p:txBody>
-          <a:bodyPr wrap="square" lIns="27432" rIns="27432" tIns="18288" bIns="18288">
-            <a:spAutoFit/>
-          </a:bodyPr>
-          <a:lstStyle/>
-          <a:p>
-            <a:pPr>
-              <a:spcAft>
-                <a:spcPts val="600"/>
-              </a:spcAft>
-              <a:defRPr sz="2000" b="0">
-                <a:solidFill>
-                  <a:srgbClr val="647483"/>
-                </a:solidFill>
-                <a:latin typeface="Noto Sans CJK SC"/>
-              </a:defRPr>
-            </a:pPr>
-            <a:r>
-              <a:t>按步骤运行 · 查看真实结果 · 亲手修改一个参数</a:t>
-            </a:r>
-          </a:p>
-        </p:txBody>
-      </p:sp>
-      <p:sp>
-        <p:nvSpPr>
-          <p:cNvPr id="9" name="TextBox 8"/>
           <p:cNvSpPr txBox="1"/>
           <p:nvPr/>
         </p:nvSpPr>
@@ -4082,7 +4043,7 @@
               </a:defRPr>
             </a:pPr>
             <a:r>
-              <a:t>10 学生实操：自行设置，观察验证结果</a:t>
+              <a:t>10 参数对比实验</a:t>
             </a:r>
           </a:p>
         </p:txBody>
@@ -4549,7 +4510,7 @@
               </a:defRPr>
             </a:pPr>
             <a:r>
-              <a:t>用自己的结果回答</a:t>
+              <a:t>对比分析内容</a:t>
             </a:r>
           </a:p>
           <a:p>
@@ -4772,7 +4733,7 @@
               </a:defRPr>
             </a:pPr>
             <a:r>
-              <a:t>11 AutoDL 备用路线：开机 → 运行 → 下载 → 关机</a:t>
+              <a:t>11 AutoDL环境配置与运行</a:t>
             </a:r>
           </a:p>
         </p:txBody>
@@ -5390,7 +5351,7 @@
               </a:defRPr>
             </a:pPr>
             <a:r>
-              <a:t>12 常见问题：从错误最后一行定位</a:t>
+              <a:t>12 常见问题与处理方法</a:t>
             </a:r>
           </a:p>
         </p:txBody>
@@ -6093,7 +6054,7 @@
               </a:defRPr>
             </a:pPr>
             <a:r>
-              <a:t>13 下载结果、填写报告并提交</a:t>
+              <a:t>13 实验结果与报告提交</a:t>
             </a:r>
           </a:p>
         </p:txBody>
@@ -6947,7 +6908,7 @@
               </a:defRPr>
             </a:pPr>
             <a:r>
-              <a:t>提交渠道与截止时间由任课教师说明；只填写真实运行结果，验证与测试指标不要混写。</a:t>
+              <a:t>提交时间与方式由任课教师通知；报告分别列出验证集和测试集结果。</a:t>
             </a:r>
           </a:p>
         </p:txBody>
@@ -7067,7 +7028,7 @@
               </a:defRPr>
             </a:pPr>
             <a:r>
-              <a:t>14 拓展加分任务</a:t>
+              <a:t>14 拓展任务与加分要求</a:t>
             </a:r>
           </a:p>
         </p:txBody>
@@ -7662,7 +7623,7 @@
               </a:defRPr>
             </a:pPr>
             <a:r>
-              <a:t>完成额外任务可获得加分，挑战进阶任务可争取更高分。</a:t>
+              <a:t>完成拓展任务可获得加分，进阶任务的加分高于基础拓展任务。</a:t>
             </a:r>
           </a:p>
           <a:p>
@@ -7678,7 +7639,7 @@
               </a:defRPr>
             </a:pPr>
             <a:r>
-              <a:t>附上代码、数据划分、实际结果与简要分析，说明你做了哪些调整。</a:t>
+              <a:t>提交代码、数据划分、实验结果及分析，说明数据处理和模型调整方法。</a:t>
             </a:r>
           </a:p>
         </p:txBody>
@@ -7798,7 +7759,7 @@
               </a:defRPr>
             </a:pPr>
             <a:r>
-              <a:t>15 课程入口与参考资料</a:t>
+              <a:t>15 配套材料与参考文献</a:t>
             </a:r>
           </a:p>
         </p:txBody>
@@ -7880,7 +7841,7 @@
               </a:defRPr>
             </a:pPr>
             <a:r>
-              <a:t>详细点击步骤、完整命令和排错说明，统一放在配套指南与Notebook。</a:t>
+              <a:t>实验步骤、运行命令和常见问题见README与课程Notebook。</a:t>
             </a:r>
           </a:p>
         </p:txBody>
@@ -8377,7 +8338,7 @@
               </a:defRPr>
             </a:pPr>
             <a:r>
-              <a:t>01 任务要求与完成路线</a:t>
+              <a:t>01 实验目标与任务要求</a:t>
             </a:r>
           </a:p>
         </p:txBody>
@@ -8627,7 +8588,7 @@
               </a:defRPr>
             </a:pPr>
             <a:r>
-              <a:t>完成一次真实微调</a:t>
+              <a:t>实验目标</a:t>
             </a:r>
           </a:p>
         </p:txBody>
@@ -8748,7 +8709,7 @@
               </a:defRPr>
             </a:pPr>
             <a:r>
-              <a:t>亲手完成三个操作</a:t>
+              <a:t>实验内容</a:t>
             </a:r>
           </a:p>
         </p:txBody>
@@ -8787,7 +8748,7 @@
               </a:defRPr>
             </a:pPr>
             <a:r>
-              <a:t>自行设置参数并微调 → 观察验证曲线 → 查看并解释一个错例。</a:t>
+              <a:t>设置训练参数，完成模型微调、验证结果分析及错例分析。</a:t>
             </a:r>
           </a:p>
         </p:txBody>
@@ -8869,7 +8830,7 @@
               </a:defRPr>
             </a:pPr>
             <a:r>
-              <a:t>交付自己的实验记录</a:t>
+              <a:t>提交材料</a:t>
             </a:r>
           </a:p>
         </p:txBody>
@@ -8908,7 +8869,7 @@
               </a:defRPr>
             </a:pPr>
             <a:r>
-              <a:t>保留自己的指标、曲线、错例和Word报告，说明参数选择与结果。</a:t>
+              <a:t>提交实验报告及运行记录，包括参数设置、学习曲线、评估结果和错例分析。</a:t>
             </a:r>
           </a:p>
         </p:txBody>
@@ -9028,7 +8989,7 @@
               </a:defRPr>
             </a:pPr>
             <a:r>
-              <a:t>02 实验原理：文件字节输入 + 预训练微调</a:t>
+              <a:t>02 ByteFormer原理与微调方法</a:t>
             </a:r>
           </a:p>
         </p:txBody>
@@ -10809,7 +10770,7 @@
               </a:defRPr>
             </a:pPr>
             <a:r>
-              <a:t>04 平台与配套材料：优先 Kaggle，备用 AutoDL</a:t>
+              <a:t>04 实验环境与配套材料</a:t>
             </a:r>
           </a:p>
         </p:txBody>
@@ -11059,7 +11020,7 @@
                         </a:defRPr>
                       </a:pPr>
                       <a:r>
-                        <a:t>路线</a:t>
+                        <a:t>运行平台</a:t>
                       </a:r>
                     </a:p>
                   </a:txBody>
@@ -11083,7 +11044,7 @@
                         </a:defRPr>
                       </a:pPr>
                       <a:r>
-                        <a:t>学生要准备什么</a:t>
+                        <a:t>环境要求</a:t>
                       </a:r>
                     </a:p>
                   </a:txBody>
@@ -11582,7 +11543,7 @@
               </a:defRPr>
             </a:pPr>
             <a:r>
-              <a:t>05 Kaggle GPU：课前教程与课程入口</a:t>
+              <a:t>05 Kaggle GPU使用参考</a:t>
             </a:r>
           </a:p>
         </p:txBody>
@@ -12773,7 +12734,7 @@
               </a:defRPr>
             </a:pPr>
             <a:r>
-              <a:t>07 开始训练：看懂参数，运行一条命令</a:t>
+              <a:t>07 模型训练与参数设置</a:t>
             </a:r>
           </a:p>
         </p:txBody>
@@ -13906,7 +13867,7 @@
               </a:defRPr>
             </a:pPr>
             <a:r>
-              <a:t>08 查看自己的训练结果</a:t>
+              <a:t>08 训练结果分析</a:t>
             </a:r>
           </a:p>
         </p:txBody>

</xml_diff>

<commit_message>
Set course identity and contacts and simplify teaching materials
</commit_message>
<xml_diff>
--- a/docs/ByteFormer_MNIST_零基础实验课.pptx
+++ b/docs/ByteFormer_MNIST_零基础实验课.pptx
@@ -3202,8 +3202,8 @@
         </p:nvSpPr>
         <p:spPr>
           <a:xfrm>
-            <a:off x="2560320" y="2770632"/>
-            <a:ext cx="8869680" cy="1033271"/>
+            <a:off x="2560320" y="2953512"/>
+            <a:ext cx="9144000" cy="1033271"/>
           </a:xfrm>
           <a:prstGeom prst="rect">
             <a:avLst/>
@@ -3228,7 +3228,7 @@
               </a:defRPr>
             </a:pPr>
             <a:r>
-              <a:t>ByteFormer 微调 MNIST</a:t>
+              <a:t>码流图像分类任务说明</a:t>
             </a:r>
           </a:p>
         </p:txBody>
@@ -3241,8 +3241,8 @@
         </p:nvSpPr>
         <p:spPr>
           <a:xfrm>
-            <a:off x="2578608" y="3913632"/>
-            <a:ext cx="8686800" cy="685800"/>
+            <a:off x="2587752" y="4279392"/>
+            <a:ext cx="4251960" cy="502920"/>
           </a:xfrm>
           <a:prstGeom prst="rect">
             <a:avLst/>
@@ -3259,15 +3259,15 @@
               <a:spcAft>
                 <a:spcPts val="600"/>
               </a:spcAft>
-              <a:defRPr sz="3000" b="0">
-                <a:solidFill>
-                  <a:srgbClr val="243547"/>
-                </a:solidFill>
-                <a:latin typeface="Noto Sans CJK SC"/>
-              </a:defRPr>
-            </a:pPr>
-            <a:r>
-              <a:t>图像分类实验任务说明</a:t>
+              <a:defRPr sz="2400" b="1">
+                <a:solidFill>
+                  <a:srgbClr val="000000"/>
+                </a:solidFill>
+                <a:latin typeface="Noto Sans CJK SC"/>
+              </a:defRPr>
+            </a:pPr>
+            <a:r>
+              <a:t>助教：李方成</a:t>
             </a:r>
           </a:p>
         </p:txBody>
@@ -3280,8 +3280,8 @@
         </p:nvSpPr>
         <p:spPr>
           <a:xfrm>
-            <a:off x="2587752" y="4782312"/>
-            <a:ext cx="8778240" cy="438912"/>
+            <a:off x="7315200" y="4279392"/>
+            <a:ext cx="4251960" cy="502920"/>
           </a:xfrm>
           <a:prstGeom prst="rect">
             <a:avLst/>
@@ -3298,15 +3298,15 @@
               <a:spcAft>
                 <a:spcPts val="600"/>
               </a:spcAft>
-              <a:defRPr sz="2300" b="0">
-                <a:solidFill>
-                  <a:srgbClr val="243547"/>
-                </a:solidFill>
-                <a:latin typeface="Noto Sans CJK SC"/>
-              </a:defRPr>
-            </a:pPr>
-            <a:r>
-              <a:t>授课教师：吴科君</a:t>
+              <a:defRPr sz="2400" b="1">
+                <a:solidFill>
+                  <a:srgbClr val="000000"/>
+                </a:solidFill>
+                <a:latin typeface="Noto Sans CJK SC"/>
+              </a:defRPr>
+            </a:pPr>
+            <a:r>
+              <a:t>教师：吴科君</a:t>
             </a:r>
           </a:p>
         </p:txBody>
@@ -3319,8 +3319,8 @@
         </p:nvSpPr>
         <p:spPr>
           <a:xfrm>
-            <a:off x="2606040" y="6025896"/>
-            <a:ext cx="9144000" cy="384048"/>
+            <a:off x="2587752" y="4992624"/>
+            <a:ext cx="4251960" cy="502920"/>
           </a:xfrm>
           <a:prstGeom prst="rect">
             <a:avLst/>
@@ -3337,18 +3337,54 @@
               <a:spcAft>
                 <a:spcPts val="600"/>
               </a:spcAft>
-              <a:defRPr sz="1600" b="0">
-                <a:solidFill>
-                  <a:srgbClr val="176BA0"/>
-                </a:solidFill>
-                <a:latin typeface="Noto Sans CJK SC"/>
-              </a:defRPr>
-            </a:pPr>
-            <a:r>
-              <a:rPr u="sng">
-                <a:hlinkClick r:id="rId4"/>
-              </a:rPr>
-              <a:t>https://github.com/Franklin-L/byteformer-mnist-course</a:t>
+              <a:defRPr sz="1900" b="1">
+                <a:solidFill>
+                  <a:srgbClr val="000000"/>
+                </a:solidFill>
+                <a:latin typeface="Noto Sans CJK SC"/>
+              </a:defRPr>
+            </a:pPr>
+            <a:r>
+              <a:t>lifangcheng2002@163.com</a:t>
+            </a:r>
+          </a:p>
+        </p:txBody>
+      </p:sp>
+      <p:sp>
+        <p:nvSpPr>
+          <p:cNvPr id="9" name="TextBox 8"/>
+          <p:cNvSpPr txBox="1"/>
+          <p:nvPr/>
+        </p:nvSpPr>
+        <p:spPr>
+          <a:xfrm>
+            <a:off x="7315200" y="4992624"/>
+            <a:ext cx="4251960" cy="502920"/>
+          </a:xfrm>
+          <a:prstGeom prst="rect">
+            <a:avLst/>
+          </a:prstGeom>
+          <a:noFill/>
+        </p:spPr>
+        <p:txBody>
+          <a:bodyPr wrap="square" lIns="27432" rIns="27432" tIns="18288" bIns="18288">
+            <a:spAutoFit/>
+          </a:bodyPr>
+          <a:lstStyle/>
+          <a:p>
+            <a:pPr>
+              <a:spcAft>
+                <a:spcPts val="600"/>
+              </a:spcAft>
+              <a:defRPr sz="1900" b="1">
+                <a:solidFill>
+                  <a:srgbClr val="000000"/>
+                </a:solidFill>
+                <a:latin typeface="Noto Sans CJK SC"/>
+              </a:defRPr>
+            </a:pPr>
+            <a:r>
+              <a:t>kjwu@hust.edu.cn</a:t>
             </a:r>
           </a:p>
         </p:txBody>
@@ -3429,7 +3465,7 @@
               </a:defRPr>
             </a:pPr>
             <a:r>
-              <a:t>ByteFormer · MNIST 实验课</a:t>
+              <a:t>码流图像分类</a:t>
             </a:r>
           </a:p>
         </p:txBody>
@@ -4004,7 +4040,7 @@
               </a:defRPr>
             </a:pPr>
             <a:r>
-              <a:t>ByteFormer · MNIST 实验课</a:t>
+              <a:t>码流图像分类</a:t>
             </a:r>
           </a:p>
         </p:txBody>
@@ -4694,7 +4730,7 @@
               </a:defRPr>
             </a:pPr>
             <a:r>
-              <a:t>ByteFormer · MNIST 实验课</a:t>
+              <a:t>码流图像分类</a:t>
             </a:r>
           </a:p>
         </p:txBody>
@@ -5312,7 +5348,7 @@
               </a:defRPr>
             </a:pPr>
             <a:r>
-              <a:t>ByteFormer · MNIST 实验课</a:t>
+              <a:t>码流图像分类</a:t>
             </a:r>
           </a:p>
         </p:txBody>
@@ -6015,7 +6051,7 @@
               </a:defRPr>
             </a:pPr>
             <a:r>
-              <a:t>ByteFormer · MNIST 实验课</a:t>
+              <a:t>码流图像分类</a:t>
             </a:r>
           </a:p>
         </p:txBody>
@@ -6989,7 +7025,7 @@
               </a:defRPr>
             </a:pPr>
             <a:r>
-              <a:t>ByteFormer · MNIST 实验课</a:t>
+              <a:t>码流图像分类</a:t>
             </a:r>
           </a:p>
         </p:txBody>
@@ -7720,7 +7756,7 @@
               </a:defRPr>
             </a:pPr>
             <a:r>
-              <a:t>ByteFormer · MNIST 实验课</a:t>
+              <a:t>码流图像分类</a:t>
             </a:r>
           </a:p>
         </p:txBody>
@@ -8299,7 +8335,7 @@
               </a:defRPr>
             </a:pPr>
             <a:r>
-              <a:t>ByteFormer · MNIST 实验课</a:t>
+              <a:t>码流图像分类</a:t>
             </a:r>
           </a:p>
         </p:txBody>
@@ -8950,7 +8986,7 @@
               </a:defRPr>
             </a:pPr>
             <a:r>
-              <a:t>ByteFormer · MNIST 实验课</a:t>
+              <a:t>码流图像分类</a:t>
             </a:r>
           </a:p>
         </p:txBody>
@@ -9914,7 +9950,7 @@
               </a:defRPr>
             </a:pPr>
             <a:r>
-              <a:t>ByteFormer · MNIST 实验课</a:t>
+              <a:t>码流图像分类</a:t>
             </a:r>
           </a:p>
         </p:txBody>
@@ -10731,7 +10767,7 @@
               </a:defRPr>
             </a:pPr>
             <a:r>
-              <a:t>ByteFormer · MNIST 实验课</a:t>
+              <a:t>码流图像分类</a:t>
             </a:r>
           </a:p>
         </p:txBody>
@@ -11504,7 +11540,7 @@
               </a:defRPr>
             </a:pPr>
             <a:r>
-              <a:t>ByteFormer · MNIST 实验课</a:t>
+              <a:t>码流图像分类</a:t>
             </a:r>
           </a:p>
         </p:txBody>
@@ -12144,7 +12180,7 @@
               </a:defRPr>
             </a:pPr>
             <a:r>
-              <a:t>ByteFormer · MNIST 实验课</a:t>
+              <a:t>码流图像分类</a:t>
             </a:r>
           </a:p>
         </p:txBody>
@@ -12695,7 +12731,7 @@
               </a:defRPr>
             </a:pPr>
             <a:r>
-              <a:t>ByteFormer · MNIST 实验课</a:t>
+              <a:t>码流图像分类</a:t>
             </a:r>
           </a:p>
         </p:txBody>
@@ -13828,7 +13864,7 @@
               </a:defRPr>
             </a:pPr>
             <a:r>
-              <a:t>ByteFormer · MNIST 实验课</a:t>
+              <a:t>码流图像分类</a:t>
             </a:r>
           </a:p>
         </p:txBody>

</xml_diff>

<commit_message>
Remove decorative squares from slide footers
</commit_message>
<xml_diff>
--- a/docs/ByteFormer_MNIST_零基础实验课.pptx
+++ b/docs/ByteFormer_MNIST_零基础实验课.pptx
@@ -3554,93 +3554,7 @@
       </p:sp>
       <p:sp>
         <p:nvSpPr>
-          <p:cNvPr id="6" name="Rectangle 5"/>
-          <p:cNvSpPr/>
-          <p:nvPr/>
-        </p:nvSpPr>
-        <p:spPr>
-          <a:xfrm>
-            <a:off x="256032" y="6373368"/>
-            <a:ext cx="292608" cy="292608"/>
-          </a:xfrm>
-          <a:prstGeom prst="rect">
-            <a:avLst/>
-          </a:prstGeom>
-          <a:solidFill>
-            <a:srgbClr val="B8D7EA"/>
-          </a:solidFill>
-          <a:ln>
-            <a:noFill/>
-          </a:ln>
-        </p:spPr>
-        <p:style>
-          <a:lnRef idx="1">
-            <a:schemeClr val="accent1"/>
-          </a:lnRef>
-          <a:fillRef idx="3">
-            <a:schemeClr val="accent1"/>
-          </a:fillRef>
-          <a:effectRef idx="2">
-            <a:schemeClr val="accent1"/>
-          </a:effectRef>
-          <a:fontRef idx="minor">
-            <a:schemeClr val="lt1"/>
-          </a:fontRef>
-        </p:style>
-        <p:txBody>
-          <a:bodyPr rtlCol="0" anchor="ctr"/>
-          <a:lstStyle/>
-          <a:p>
-            <a:pPr algn="ctr"/>
-          </a:p>
-        </p:txBody>
-      </p:sp>
-      <p:sp>
-        <p:nvSpPr>
-          <p:cNvPr id="7" name="Rectangle 6"/>
-          <p:cNvSpPr/>
-          <p:nvPr/>
-        </p:nvSpPr>
-        <p:spPr>
-          <a:xfrm>
-            <a:off x="621792" y="6373368"/>
-            <a:ext cx="292608" cy="292608"/>
-          </a:xfrm>
-          <a:prstGeom prst="rect">
-            <a:avLst/>
-          </a:prstGeom>
-          <a:solidFill>
-            <a:srgbClr val="C5C3D3"/>
-          </a:solidFill>
-          <a:ln>
-            <a:noFill/>
-          </a:ln>
-        </p:spPr>
-        <p:style>
-          <a:lnRef idx="1">
-            <a:schemeClr val="accent1"/>
-          </a:lnRef>
-          <a:fillRef idx="3">
-            <a:schemeClr val="accent1"/>
-          </a:fillRef>
-          <a:effectRef idx="2">
-            <a:schemeClr val="accent1"/>
-          </a:effectRef>
-          <a:fontRef idx="minor">
-            <a:schemeClr val="lt1"/>
-          </a:fontRef>
-        </p:style>
-        <p:txBody>
-          <a:bodyPr rtlCol="0" anchor="ctr"/>
-          <a:lstStyle/>
-          <a:p>
-            <a:pPr algn="ctr"/>
-          </a:p>
-        </p:txBody>
-      </p:sp>
-      <p:sp>
-        <p:nvSpPr>
-          <p:cNvPr id="8" name="TextBox 7"/>
+          <p:cNvPr id="6" name="TextBox 5"/>
           <p:cNvSpPr txBox="1"/>
           <p:nvPr/>
         </p:nvSpPr>
@@ -3679,7 +3593,7 @@
       </p:sp>
       <p:sp>
         <p:nvSpPr>
-          <p:cNvPr id="9" name="Rounded Rectangle 8"/>
+          <p:cNvPr id="7" name="Rounded Rectangle 6"/>
           <p:cNvSpPr/>
           <p:nvPr/>
         </p:nvSpPr>
@@ -3722,7 +3636,7 @@
       </p:sp>
       <p:sp>
         <p:nvSpPr>
-          <p:cNvPr id="10" name="TextBox 9"/>
+          <p:cNvPr id="8" name="TextBox 7"/>
           <p:cNvSpPr txBox="1"/>
           <p:nvPr/>
         </p:nvSpPr>
@@ -3777,7 +3691,7 @@
       </p:sp>
       <p:sp>
         <p:nvSpPr>
-          <p:cNvPr id="11" name="TextBox 10"/>
+          <p:cNvPr id="9" name="TextBox 8"/>
           <p:cNvSpPr txBox="1"/>
           <p:nvPr/>
         </p:nvSpPr>
@@ -3864,7 +3778,7 @@
       </p:sp>
       <p:pic>
         <p:nvPicPr>
-          <p:cNvPr id="12" name="Picture 11" descr="example_digit.png"/>
+          <p:cNvPr id="10" name="Picture 9" descr="example_digit.png"/>
           <p:cNvPicPr>
             <a:picLocks noChangeAspect="1"/>
           </p:cNvPicPr>
@@ -3888,7 +3802,7 @@
       </p:pic>
       <p:sp>
         <p:nvSpPr>
-          <p:cNvPr id="13" name="TextBox 12"/>
+          <p:cNvPr id="11" name="TextBox 10"/>
           <p:cNvSpPr txBox="1"/>
           <p:nvPr/>
         </p:nvSpPr>
@@ -3927,7 +3841,7 @@
       </p:sp>
       <p:sp>
         <p:nvSpPr>
-          <p:cNvPr id="14" name="TextBox 13"/>
+          <p:cNvPr id="12" name="TextBox 11"/>
           <p:cNvSpPr txBox="1"/>
           <p:nvPr/>
         </p:nvSpPr>
@@ -4129,93 +4043,7 @@
       </p:sp>
       <p:sp>
         <p:nvSpPr>
-          <p:cNvPr id="6" name="Rectangle 5"/>
-          <p:cNvSpPr/>
-          <p:nvPr/>
-        </p:nvSpPr>
-        <p:spPr>
-          <a:xfrm>
-            <a:off x="256032" y="6373368"/>
-            <a:ext cx="292608" cy="292608"/>
-          </a:xfrm>
-          <a:prstGeom prst="rect">
-            <a:avLst/>
-          </a:prstGeom>
-          <a:solidFill>
-            <a:srgbClr val="B8D7EA"/>
-          </a:solidFill>
-          <a:ln>
-            <a:noFill/>
-          </a:ln>
-        </p:spPr>
-        <p:style>
-          <a:lnRef idx="1">
-            <a:schemeClr val="accent1"/>
-          </a:lnRef>
-          <a:fillRef idx="3">
-            <a:schemeClr val="accent1"/>
-          </a:fillRef>
-          <a:effectRef idx="2">
-            <a:schemeClr val="accent1"/>
-          </a:effectRef>
-          <a:fontRef idx="minor">
-            <a:schemeClr val="lt1"/>
-          </a:fontRef>
-        </p:style>
-        <p:txBody>
-          <a:bodyPr rtlCol="0" anchor="ctr"/>
-          <a:lstStyle/>
-          <a:p>
-            <a:pPr algn="ctr"/>
-          </a:p>
-        </p:txBody>
-      </p:sp>
-      <p:sp>
-        <p:nvSpPr>
-          <p:cNvPr id="7" name="Rectangle 6"/>
-          <p:cNvSpPr/>
-          <p:nvPr/>
-        </p:nvSpPr>
-        <p:spPr>
-          <a:xfrm>
-            <a:off x="621792" y="6373368"/>
-            <a:ext cx="292608" cy="292608"/>
-          </a:xfrm>
-          <a:prstGeom prst="rect">
-            <a:avLst/>
-          </a:prstGeom>
-          <a:solidFill>
-            <a:srgbClr val="C5C3D3"/>
-          </a:solidFill>
-          <a:ln>
-            <a:noFill/>
-          </a:ln>
-        </p:spPr>
-        <p:style>
-          <a:lnRef idx="1">
-            <a:schemeClr val="accent1"/>
-          </a:lnRef>
-          <a:fillRef idx="3">
-            <a:schemeClr val="accent1"/>
-          </a:fillRef>
-          <a:effectRef idx="2">
-            <a:schemeClr val="accent1"/>
-          </a:effectRef>
-          <a:fontRef idx="minor">
-            <a:schemeClr val="lt1"/>
-          </a:fontRef>
-        </p:style>
-        <p:txBody>
-          <a:bodyPr rtlCol="0" anchor="ctr"/>
-          <a:lstStyle/>
-          <a:p>
-            <a:pPr algn="ctr"/>
-          </a:p>
-        </p:txBody>
-      </p:sp>
-      <p:sp>
-        <p:nvSpPr>
-          <p:cNvPr id="8" name="TextBox 7"/>
+          <p:cNvPr id="6" name="TextBox 5"/>
           <p:cNvSpPr txBox="1"/>
           <p:nvPr/>
         </p:nvSpPr>
@@ -4254,7 +4082,7 @@
       </p:sp>
       <p:sp>
         <p:nvSpPr>
-          <p:cNvPr id="9" name="Rounded Rectangle 8"/>
+          <p:cNvPr id="7" name="Rounded Rectangle 6"/>
           <p:cNvSpPr/>
           <p:nvPr/>
         </p:nvSpPr>
@@ -4297,7 +4125,7 @@
       </p:sp>
       <p:sp>
         <p:nvSpPr>
-          <p:cNvPr id="10" name="TextBox 9"/>
+          <p:cNvPr id="8" name="TextBox 7"/>
           <p:cNvSpPr txBox="1"/>
           <p:nvPr/>
         </p:nvSpPr>
@@ -4384,7 +4212,7 @@
       </p:sp>
       <p:sp>
         <p:nvSpPr>
-          <p:cNvPr id="11" name="TextBox 10"/>
+          <p:cNvPr id="9" name="TextBox 8"/>
           <p:cNvSpPr txBox="1"/>
           <p:nvPr/>
         </p:nvSpPr>
@@ -4471,7 +4299,7 @@
       </p:sp>
       <p:sp>
         <p:nvSpPr>
-          <p:cNvPr id="12" name="Rounded Rectangle 11"/>
+          <p:cNvPr id="10" name="Rounded Rectangle 9"/>
           <p:cNvSpPr/>
           <p:nvPr/>
         </p:nvSpPr>
@@ -4514,7 +4342,7 @@
       </p:sp>
       <p:sp>
         <p:nvSpPr>
-          <p:cNvPr id="13" name="TextBox 12"/>
+          <p:cNvPr id="11" name="TextBox 10"/>
           <p:cNvSpPr txBox="1"/>
           <p:nvPr/>
         </p:nvSpPr>
@@ -4617,7 +4445,7 @@
       </p:sp>
       <p:sp>
         <p:nvSpPr>
-          <p:cNvPr id="14" name="TextBox 13"/>
+          <p:cNvPr id="12" name="TextBox 11"/>
           <p:cNvSpPr txBox="1"/>
           <p:nvPr/>
         </p:nvSpPr>
@@ -4819,93 +4647,7 @@
       </p:sp>
       <p:sp>
         <p:nvSpPr>
-          <p:cNvPr id="6" name="Rectangle 5"/>
-          <p:cNvSpPr/>
-          <p:nvPr/>
-        </p:nvSpPr>
-        <p:spPr>
-          <a:xfrm>
-            <a:off x="256032" y="6373368"/>
-            <a:ext cx="292608" cy="292608"/>
-          </a:xfrm>
-          <a:prstGeom prst="rect">
-            <a:avLst/>
-          </a:prstGeom>
-          <a:solidFill>
-            <a:srgbClr val="B8D7EA"/>
-          </a:solidFill>
-          <a:ln>
-            <a:noFill/>
-          </a:ln>
-        </p:spPr>
-        <p:style>
-          <a:lnRef idx="1">
-            <a:schemeClr val="accent1"/>
-          </a:lnRef>
-          <a:fillRef idx="3">
-            <a:schemeClr val="accent1"/>
-          </a:fillRef>
-          <a:effectRef idx="2">
-            <a:schemeClr val="accent1"/>
-          </a:effectRef>
-          <a:fontRef idx="minor">
-            <a:schemeClr val="lt1"/>
-          </a:fontRef>
-        </p:style>
-        <p:txBody>
-          <a:bodyPr rtlCol="0" anchor="ctr"/>
-          <a:lstStyle/>
-          <a:p>
-            <a:pPr algn="ctr"/>
-          </a:p>
-        </p:txBody>
-      </p:sp>
-      <p:sp>
-        <p:nvSpPr>
-          <p:cNvPr id="7" name="Rectangle 6"/>
-          <p:cNvSpPr/>
-          <p:nvPr/>
-        </p:nvSpPr>
-        <p:spPr>
-          <a:xfrm>
-            <a:off x="621792" y="6373368"/>
-            <a:ext cx="292608" cy="292608"/>
-          </a:xfrm>
-          <a:prstGeom prst="rect">
-            <a:avLst/>
-          </a:prstGeom>
-          <a:solidFill>
-            <a:srgbClr val="C5C3D3"/>
-          </a:solidFill>
-          <a:ln>
-            <a:noFill/>
-          </a:ln>
-        </p:spPr>
-        <p:style>
-          <a:lnRef idx="1">
-            <a:schemeClr val="accent1"/>
-          </a:lnRef>
-          <a:fillRef idx="3">
-            <a:schemeClr val="accent1"/>
-          </a:fillRef>
-          <a:effectRef idx="2">
-            <a:schemeClr val="accent1"/>
-          </a:effectRef>
-          <a:fontRef idx="minor">
-            <a:schemeClr val="lt1"/>
-          </a:fontRef>
-        </p:style>
-        <p:txBody>
-          <a:bodyPr rtlCol="0" anchor="ctr"/>
-          <a:lstStyle/>
-          <a:p>
-            <a:pPr algn="ctr"/>
-          </a:p>
-        </p:txBody>
-      </p:sp>
-      <p:sp>
-        <p:nvSpPr>
-          <p:cNvPr id="8" name="TextBox 7"/>
+          <p:cNvPr id="6" name="TextBox 5"/>
           <p:cNvSpPr txBox="1"/>
           <p:nvPr/>
         </p:nvSpPr>
@@ -4944,7 +4686,7 @@
       </p:sp>
       <p:sp>
         <p:nvSpPr>
-          <p:cNvPr id="9" name="TextBox 8"/>
+          <p:cNvPr id="7" name="TextBox 6"/>
           <p:cNvSpPr txBox="1"/>
           <p:nvPr/>
         </p:nvSpPr>
@@ -4983,7 +4725,7 @@
       </p:sp>
       <p:sp>
         <p:nvSpPr>
-          <p:cNvPr id="10" name="Rounded Rectangle 9"/>
+          <p:cNvPr id="8" name="Rounded Rectangle 7"/>
           <p:cNvSpPr/>
           <p:nvPr/>
         </p:nvSpPr>
@@ -5026,7 +4768,7 @@
       </p:sp>
       <p:sp>
         <p:nvSpPr>
-          <p:cNvPr id="11" name="TextBox 10"/>
+          <p:cNvPr id="9" name="TextBox 8"/>
           <p:cNvSpPr txBox="1"/>
           <p:nvPr/>
         </p:nvSpPr>
@@ -5177,7 +4919,7 @@
       </p:sp>
       <p:sp>
         <p:nvSpPr>
-          <p:cNvPr id="12" name="TextBox 11"/>
+          <p:cNvPr id="10" name="TextBox 9"/>
           <p:cNvSpPr txBox="1"/>
           <p:nvPr/>
         </p:nvSpPr>
@@ -5232,7 +4974,7 @@
       </p:sp>
       <p:sp>
         <p:nvSpPr>
-          <p:cNvPr id="13" name="TextBox 12"/>
+          <p:cNvPr id="11" name="TextBox 10"/>
           <p:cNvSpPr txBox="1"/>
           <p:nvPr/>
         </p:nvSpPr>
@@ -5437,93 +5179,7 @@
       </p:sp>
       <p:sp>
         <p:nvSpPr>
-          <p:cNvPr id="6" name="Rectangle 5"/>
-          <p:cNvSpPr/>
-          <p:nvPr/>
-        </p:nvSpPr>
-        <p:spPr>
-          <a:xfrm>
-            <a:off x="256032" y="6373368"/>
-            <a:ext cx="292608" cy="292608"/>
-          </a:xfrm>
-          <a:prstGeom prst="rect">
-            <a:avLst/>
-          </a:prstGeom>
-          <a:solidFill>
-            <a:srgbClr val="B8D7EA"/>
-          </a:solidFill>
-          <a:ln>
-            <a:noFill/>
-          </a:ln>
-        </p:spPr>
-        <p:style>
-          <a:lnRef idx="1">
-            <a:schemeClr val="accent1"/>
-          </a:lnRef>
-          <a:fillRef idx="3">
-            <a:schemeClr val="accent1"/>
-          </a:fillRef>
-          <a:effectRef idx="2">
-            <a:schemeClr val="accent1"/>
-          </a:effectRef>
-          <a:fontRef idx="minor">
-            <a:schemeClr val="lt1"/>
-          </a:fontRef>
-        </p:style>
-        <p:txBody>
-          <a:bodyPr rtlCol="0" anchor="ctr"/>
-          <a:lstStyle/>
-          <a:p>
-            <a:pPr algn="ctr"/>
-          </a:p>
-        </p:txBody>
-      </p:sp>
-      <p:sp>
-        <p:nvSpPr>
-          <p:cNvPr id="7" name="Rectangle 6"/>
-          <p:cNvSpPr/>
-          <p:nvPr/>
-        </p:nvSpPr>
-        <p:spPr>
-          <a:xfrm>
-            <a:off x="621792" y="6373368"/>
-            <a:ext cx="292608" cy="292608"/>
-          </a:xfrm>
-          <a:prstGeom prst="rect">
-            <a:avLst/>
-          </a:prstGeom>
-          <a:solidFill>
-            <a:srgbClr val="C5C3D3"/>
-          </a:solidFill>
-          <a:ln>
-            <a:noFill/>
-          </a:ln>
-        </p:spPr>
-        <p:style>
-          <a:lnRef idx="1">
-            <a:schemeClr val="accent1"/>
-          </a:lnRef>
-          <a:fillRef idx="3">
-            <a:schemeClr val="accent1"/>
-          </a:fillRef>
-          <a:effectRef idx="2">
-            <a:schemeClr val="accent1"/>
-          </a:effectRef>
-          <a:fontRef idx="minor">
-            <a:schemeClr val="lt1"/>
-          </a:fontRef>
-        </p:style>
-        <p:txBody>
-          <a:bodyPr rtlCol="0" anchor="ctr"/>
-          <a:lstStyle/>
-          <a:p>
-            <a:pPr algn="ctr"/>
-          </a:p>
-        </p:txBody>
-      </p:sp>
-      <p:sp>
-        <p:nvSpPr>
-          <p:cNvPr id="8" name="TextBox 7"/>
+          <p:cNvPr id="6" name="TextBox 5"/>
           <p:cNvSpPr txBox="1"/>
           <p:nvPr/>
         </p:nvSpPr>
@@ -5562,7 +5218,7 @@
       </p:sp>
       <p:graphicFrame>
         <p:nvGraphicFramePr>
-          <p:cNvPr id="9" name="Table 8"/>
+          <p:cNvPr id="7" name="Table 6"/>
           <p:cNvGraphicFramePr>
             <a:graphicFrameLocks noGrp="1"/>
           </p:cNvGraphicFramePr>
@@ -5938,7 +5594,7 @@
       </p:graphicFrame>
       <p:sp>
         <p:nvSpPr>
-          <p:cNvPr id="10" name="TextBox 9"/>
+          <p:cNvPr id="8" name="TextBox 7"/>
           <p:cNvSpPr txBox="1"/>
           <p:nvPr/>
         </p:nvSpPr>
@@ -6140,93 +5796,7 @@
       </p:sp>
       <p:sp>
         <p:nvSpPr>
-          <p:cNvPr id="6" name="Rectangle 5"/>
-          <p:cNvSpPr/>
-          <p:nvPr/>
-        </p:nvSpPr>
-        <p:spPr>
-          <a:xfrm>
-            <a:off x="256032" y="6373368"/>
-            <a:ext cx="292608" cy="292608"/>
-          </a:xfrm>
-          <a:prstGeom prst="rect">
-            <a:avLst/>
-          </a:prstGeom>
-          <a:solidFill>
-            <a:srgbClr val="B8D7EA"/>
-          </a:solidFill>
-          <a:ln>
-            <a:noFill/>
-          </a:ln>
-        </p:spPr>
-        <p:style>
-          <a:lnRef idx="1">
-            <a:schemeClr val="accent1"/>
-          </a:lnRef>
-          <a:fillRef idx="3">
-            <a:schemeClr val="accent1"/>
-          </a:fillRef>
-          <a:effectRef idx="2">
-            <a:schemeClr val="accent1"/>
-          </a:effectRef>
-          <a:fontRef idx="minor">
-            <a:schemeClr val="lt1"/>
-          </a:fontRef>
-        </p:style>
-        <p:txBody>
-          <a:bodyPr rtlCol="0" anchor="ctr"/>
-          <a:lstStyle/>
-          <a:p>
-            <a:pPr algn="ctr"/>
-          </a:p>
-        </p:txBody>
-      </p:sp>
-      <p:sp>
-        <p:nvSpPr>
-          <p:cNvPr id="7" name="Rectangle 6"/>
-          <p:cNvSpPr/>
-          <p:nvPr/>
-        </p:nvSpPr>
-        <p:spPr>
-          <a:xfrm>
-            <a:off x="621792" y="6373368"/>
-            <a:ext cx="292608" cy="292608"/>
-          </a:xfrm>
-          <a:prstGeom prst="rect">
-            <a:avLst/>
-          </a:prstGeom>
-          <a:solidFill>
-            <a:srgbClr val="C5C3D3"/>
-          </a:solidFill>
-          <a:ln>
-            <a:noFill/>
-          </a:ln>
-        </p:spPr>
-        <p:style>
-          <a:lnRef idx="1">
-            <a:schemeClr val="accent1"/>
-          </a:lnRef>
-          <a:fillRef idx="3">
-            <a:schemeClr val="accent1"/>
-          </a:fillRef>
-          <a:effectRef idx="2">
-            <a:schemeClr val="accent1"/>
-          </a:effectRef>
-          <a:fontRef idx="minor">
-            <a:schemeClr val="lt1"/>
-          </a:fontRef>
-        </p:style>
-        <p:txBody>
-          <a:bodyPr rtlCol="0" anchor="ctr"/>
-          <a:lstStyle/>
-          <a:p>
-            <a:pPr algn="ctr"/>
-          </a:p>
-        </p:txBody>
-      </p:sp>
-      <p:sp>
-        <p:nvSpPr>
-          <p:cNvPr id="8" name="TextBox 7"/>
+          <p:cNvPr id="6" name="TextBox 5"/>
           <p:cNvSpPr txBox="1"/>
           <p:nvPr/>
         </p:nvSpPr>
@@ -6265,7 +5835,7 @@
       </p:sp>
       <p:sp>
         <p:nvSpPr>
-          <p:cNvPr id="9" name="TextBox 8"/>
+          <p:cNvPr id="7" name="TextBox 6"/>
           <p:cNvSpPr txBox="1"/>
           <p:nvPr/>
         </p:nvSpPr>
@@ -6381,7 +5951,7 @@
       </p:sp>
       <p:sp>
         <p:nvSpPr>
-          <p:cNvPr id="10" name="TextBox 9"/>
+          <p:cNvPr id="8" name="TextBox 7"/>
           <p:cNvSpPr txBox="1"/>
           <p:nvPr/>
         </p:nvSpPr>
@@ -6420,7 +5990,7 @@
       </p:sp>
       <p:sp>
         <p:nvSpPr>
-          <p:cNvPr id="11" name="Rectangle 10"/>
+          <p:cNvPr id="9" name="Rectangle 8"/>
           <p:cNvSpPr/>
           <p:nvPr/>
         </p:nvSpPr>
@@ -6463,7 +6033,7 @@
       </p:sp>
       <p:sp>
         <p:nvSpPr>
-          <p:cNvPr id="12" name="TextBox 11"/>
+          <p:cNvPr id="10" name="TextBox 9"/>
           <p:cNvSpPr txBox="1"/>
           <p:nvPr/>
         </p:nvSpPr>
@@ -6502,7 +6072,7 @@
       </p:sp>
       <p:sp>
         <p:nvSpPr>
-          <p:cNvPr id="13" name="Rectangle 12"/>
+          <p:cNvPr id="11" name="Rectangle 10"/>
           <p:cNvSpPr/>
           <p:nvPr/>
         </p:nvSpPr>
@@ -6545,7 +6115,7 @@
       </p:sp>
       <p:sp>
         <p:nvSpPr>
-          <p:cNvPr id="14" name="TextBox 13"/>
+          <p:cNvPr id="12" name="TextBox 11"/>
           <p:cNvSpPr txBox="1"/>
           <p:nvPr/>
         </p:nvSpPr>
@@ -6584,7 +6154,7 @@
       </p:sp>
       <p:sp>
         <p:nvSpPr>
-          <p:cNvPr id="15" name="Rectangle 14"/>
+          <p:cNvPr id="13" name="Rectangle 12"/>
           <p:cNvSpPr/>
           <p:nvPr/>
         </p:nvSpPr>
@@ -6627,7 +6197,7 @@
       </p:sp>
       <p:sp>
         <p:nvSpPr>
-          <p:cNvPr id="16" name="TextBox 15"/>
+          <p:cNvPr id="14" name="TextBox 13"/>
           <p:cNvSpPr txBox="1"/>
           <p:nvPr/>
         </p:nvSpPr>
@@ -6666,7 +6236,7 @@
       </p:sp>
       <p:sp>
         <p:nvSpPr>
-          <p:cNvPr id="17" name="Rectangle 16"/>
+          <p:cNvPr id="15" name="Rectangle 14"/>
           <p:cNvSpPr/>
           <p:nvPr/>
         </p:nvSpPr>
@@ -6709,7 +6279,7 @@
       </p:sp>
       <p:sp>
         <p:nvSpPr>
-          <p:cNvPr id="18" name="TextBox 17"/>
+          <p:cNvPr id="16" name="TextBox 15"/>
           <p:cNvSpPr txBox="1"/>
           <p:nvPr/>
         </p:nvSpPr>
@@ -6748,7 +6318,7 @@
       </p:sp>
       <p:sp>
         <p:nvSpPr>
-          <p:cNvPr id="19" name="Rectangle 18"/>
+          <p:cNvPr id="17" name="Rectangle 16"/>
           <p:cNvSpPr/>
           <p:nvPr/>
         </p:nvSpPr>
@@ -6791,7 +6361,7 @@
       </p:sp>
       <p:sp>
         <p:nvSpPr>
-          <p:cNvPr id="20" name="TextBox 19"/>
+          <p:cNvPr id="18" name="TextBox 17"/>
           <p:cNvSpPr txBox="1"/>
           <p:nvPr/>
         </p:nvSpPr>
@@ -6830,7 +6400,7 @@
       </p:sp>
       <p:sp>
         <p:nvSpPr>
-          <p:cNvPr id="21" name="Rectangle 20"/>
+          <p:cNvPr id="19" name="Rectangle 18"/>
           <p:cNvSpPr/>
           <p:nvPr/>
         </p:nvSpPr>
@@ -6873,7 +6443,7 @@
       </p:sp>
       <p:sp>
         <p:nvSpPr>
-          <p:cNvPr id="22" name="TextBox 21"/>
+          <p:cNvPr id="20" name="TextBox 19"/>
           <p:cNvSpPr txBox="1"/>
           <p:nvPr/>
         </p:nvSpPr>
@@ -6912,7 +6482,7 @@
       </p:sp>
       <p:sp>
         <p:nvSpPr>
-          <p:cNvPr id="23" name="TextBox 22"/>
+          <p:cNvPr id="21" name="TextBox 20"/>
           <p:cNvSpPr txBox="1"/>
           <p:nvPr/>
         </p:nvSpPr>
@@ -7114,93 +6684,7 @@
       </p:sp>
       <p:sp>
         <p:nvSpPr>
-          <p:cNvPr id="6" name="Rectangle 5"/>
-          <p:cNvSpPr/>
-          <p:nvPr/>
-        </p:nvSpPr>
-        <p:spPr>
-          <a:xfrm>
-            <a:off x="256032" y="6373368"/>
-            <a:ext cx="292608" cy="292608"/>
-          </a:xfrm>
-          <a:prstGeom prst="rect">
-            <a:avLst/>
-          </a:prstGeom>
-          <a:solidFill>
-            <a:srgbClr val="B8D7EA"/>
-          </a:solidFill>
-          <a:ln>
-            <a:noFill/>
-          </a:ln>
-        </p:spPr>
-        <p:style>
-          <a:lnRef idx="1">
-            <a:schemeClr val="accent1"/>
-          </a:lnRef>
-          <a:fillRef idx="3">
-            <a:schemeClr val="accent1"/>
-          </a:fillRef>
-          <a:effectRef idx="2">
-            <a:schemeClr val="accent1"/>
-          </a:effectRef>
-          <a:fontRef idx="minor">
-            <a:schemeClr val="lt1"/>
-          </a:fontRef>
-        </p:style>
-        <p:txBody>
-          <a:bodyPr rtlCol="0" anchor="ctr"/>
-          <a:lstStyle/>
-          <a:p>
-            <a:pPr algn="ctr"/>
-          </a:p>
-        </p:txBody>
-      </p:sp>
-      <p:sp>
-        <p:nvSpPr>
-          <p:cNvPr id="7" name="Rectangle 6"/>
-          <p:cNvSpPr/>
-          <p:nvPr/>
-        </p:nvSpPr>
-        <p:spPr>
-          <a:xfrm>
-            <a:off x="621792" y="6373368"/>
-            <a:ext cx="292608" cy="292608"/>
-          </a:xfrm>
-          <a:prstGeom prst="rect">
-            <a:avLst/>
-          </a:prstGeom>
-          <a:solidFill>
-            <a:srgbClr val="C5C3D3"/>
-          </a:solidFill>
-          <a:ln>
-            <a:noFill/>
-          </a:ln>
-        </p:spPr>
-        <p:style>
-          <a:lnRef idx="1">
-            <a:schemeClr val="accent1"/>
-          </a:lnRef>
-          <a:fillRef idx="3">
-            <a:schemeClr val="accent1"/>
-          </a:fillRef>
-          <a:effectRef idx="2">
-            <a:schemeClr val="accent1"/>
-          </a:effectRef>
-          <a:fontRef idx="minor">
-            <a:schemeClr val="lt1"/>
-          </a:fontRef>
-        </p:style>
-        <p:txBody>
-          <a:bodyPr rtlCol="0" anchor="ctr"/>
-          <a:lstStyle/>
-          <a:p>
-            <a:pPr algn="ctr"/>
-          </a:p>
-        </p:txBody>
-      </p:sp>
-      <p:sp>
-        <p:nvSpPr>
-          <p:cNvPr id="8" name="TextBox 7"/>
+          <p:cNvPr id="6" name="TextBox 5"/>
           <p:cNvSpPr txBox="1"/>
           <p:nvPr/>
         </p:nvSpPr>
@@ -7239,7 +6723,7 @@
       </p:sp>
       <p:sp>
         <p:nvSpPr>
-          <p:cNvPr id="9" name="Rounded Rectangle 8"/>
+          <p:cNvPr id="7" name="Rounded Rectangle 6"/>
           <p:cNvSpPr/>
           <p:nvPr/>
         </p:nvSpPr>
@@ -7282,7 +6766,7 @@
       </p:sp>
       <p:sp>
         <p:nvSpPr>
-          <p:cNvPr id="10" name="TextBox 9"/>
+          <p:cNvPr id="8" name="TextBox 7"/>
           <p:cNvSpPr txBox="1"/>
           <p:nvPr/>
         </p:nvSpPr>
@@ -7321,7 +6805,7 @@
       </p:sp>
       <p:sp>
         <p:nvSpPr>
-          <p:cNvPr id="11" name="Rounded Rectangle 10"/>
+          <p:cNvPr id="9" name="Rounded Rectangle 8"/>
           <p:cNvSpPr/>
           <p:nvPr/>
         </p:nvSpPr>
@@ -7364,7 +6848,7 @@
       </p:sp>
       <p:sp>
         <p:nvSpPr>
-          <p:cNvPr id="12" name="TextBox 11"/>
+          <p:cNvPr id="10" name="TextBox 9"/>
           <p:cNvSpPr txBox="1"/>
           <p:nvPr/>
         </p:nvSpPr>
@@ -7403,7 +6887,7 @@
       </p:sp>
       <p:sp>
         <p:nvSpPr>
-          <p:cNvPr id="13" name="TextBox 12"/>
+          <p:cNvPr id="11" name="TextBox 10"/>
           <p:cNvSpPr txBox="1"/>
           <p:nvPr/>
         </p:nvSpPr>
@@ -7474,7 +6958,7 @@
       </p:sp>
       <p:sp>
         <p:nvSpPr>
-          <p:cNvPr id="14" name="Rounded Rectangle 13"/>
+          <p:cNvPr id="12" name="Rounded Rectangle 11"/>
           <p:cNvSpPr/>
           <p:nvPr/>
         </p:nvSpPr>
@@ -7517,7 +7001,7 @@
       </p:sp>
       <p:sp>
         <p:nvSpPr>
-          <p:cNvPr id="15" name="TextBox 14"/>
+          <p:cNvPr id="13" name="TextBox 12"/>
           <p:cNvSpPr txBox="1"/>
           <p:nvPr/>
         </p:nvSpPr>
@@ -7556,7 +7040,7 @@
       </p:sp>
       <p:sp>
         <p:nvSpPr>
-          <p:cNvPr id="16" name="TextBox 15"/>
+          <p:cNvPr id="14" name="TextBox 13"/>
           <p:cNvSpPr txBox="1"/>
           <p:nvPr/>
         </p:nvSpPr>
@@ -7627,7 +7111,7 @@
       </p:sp>
       <p:sp>
         <p:nvSpPr>
-          <p:cNvPr id="17" name="TextBox 16"/>
+          <p:cNvPr id="15" name="TextBox 14"/>
           <p:cNvSpPr txBox="1"/>
           <p:nvPr/>
         </p:nvSpPr>
@@ -7884,93 +7368,7 @@
       </p:sp>
       <p:sp>
         <p:nvSpPr>
-          <p:cNvPr id="7" name="Rectangle 6"/>
-          <p:cNvSpPr/>
-          <p:nvPr/>
-        </p:nvSpPr>
-        <p:spPr>
-          <a:xfrm>
-            <a:off x="256032" y="6373368"/>
-            <a:ext cx="292608" cy="292608"/>
-          </a:xfrm>
-          <a:prstGeom prst="rect">
-            <a:avLst/>
-          </a:prstGeom>
-          <a:solidFill>
-            <a:srgbClr val="B8D7EA"/>
-          </a:solidFill>
-          <a:ln>
-            <a:noFill/>
-          </a:ln>
-        </p:spPr>
-        <p:style>
-          <a:lnRef idx="1">
-            <a:schemeClr val="accent1"/>
-          </a:lnRef>
-          <a:fillRef idx="3">
-            <a:schemeClr val="accent1"/>
-          </a:fillRef>
-          <a:effectRef idx="2">
-            <a:schemeClr val="accent1"/>
-          </a:effectRef>
-          <a:fontRef idx="minor">
-            <a:schemeClr val="lt1"/>
-          </a:fontRef>
-        </p:style>
-        <p:txBody>
-          <a:bodyPr rtlCol="0" anchor="ctr"/>
-          <a:lstStyle/>
-          <a:p>
-            <a:pPr algn="ctr"/>
-          </a:p>
-        </p:txBody>
-      </p:sp>
-      <p:sp>
-        <p:nvSpPr>
-          <p:cNvPr id="8" name="Rectangle 7"/>
-          <p:cNvSpPr/>
-          <p:nvPr/>
-        </p:nvSpPr>
-        <p:spPr>
-          <a:xfrm>
-            <a:off x="621792" y="6373368"/>
-            <a:ext cx="292608" cy="292608"/>
-          </a:xfrm>
-          <a:prstGeom prst="rect">
-            <a:avLst/>
-          </a:prstGeom>
-          <a:solidFill>
-            <a:srgbClr val="C5C3D3"/>
-          </a:solidFill>
-          <a:ln>
-            <a:noFill/>
-          </a:ln>
-        </p:spPr>
-        <p:style>
-          <a:lnRef idx="1">
-            <a:schemeClr val="accent1"/>
-          </a:lnRef>
-          <a:fillRef idx="3">
-            <a:schemeClr val="accent1"/>
-          </a:fillRef>
-          <a:effectRef idx="2">
-            <a:schemeClr val="accent1"/>
-          </a:effectRef>
-          <a:fontRef idx="minor">
-            <a:schemeClr val="lt1"/>
-          </a:fontRef>
-        </p:style>
-        <p:txBody>
-          <a:bodyPr rtlCol="0" anchor="ctr"/>
-          <a:lstStyle/>
-          <a:p>
-            <a:pPr algn="ctr"/>
-          </a:p>
-        </p:txBody>
-      </p:sp>
-      <p:sp>
-        <p:nvSpPr>
-          <p:cNvPr id="9" name="TextBox 8"/>
+          <p:cNvPr id="7" name="TextBox 6"/>
           <p:cNvSpPr txBox="1"/>
           <p:nvPr/>
         </p:nvSpPr>
@@ -8009,7 +7407,7 @@
       </p:sp>
       <p:sp>
         <p:nvSpPr>
-          <p:cNvPr id="10" name="TextBox 9"/>
+          <p:cNvPr id="8" name="TextBox 7"/>
           <p:cNvSpPr txBox="1"/>
           <p:nvPr/>
         </p:nvSpPr>
@@ -8051,7 +7449,7 @@
       </p:sp>
       <p:sp>
         <p:nvSpPr>
-          <p:cNvPr id="11" name="TextBox 10"/>
+          <p:cNvPr id="9" name="TextBox 8"/>
           <p:cNvSpPr txBox="1"/>
           <p:nvPr/>
         </p:nvSpPr>
@@ -8093,7 +7491,7 @@
       </p:sp>
       <p:sp>
         <p:nvSpPr>
-          <p:cNvPr id="12" name="TextBox 11"/>
+          <p:cNvPr id="10" name="TextBox 9"/>
           <p:cNvSpPr txBox="1"/>
           <p:nvPr/>
         </p:nvSpPr>
@@ -8135,7 +7533,7 @@
       </p:sp>
       <p:sp>
         <p:nvSpPr>
-          <p:cNvPr id="13" name="TextBox 12"/>
+          <p:cNvPr id="11" name="TextBox 10"/>
           <p:cNvSpPr txBox="1"/>
           <p:nvPr/>
         </p:nvSpPr>
@@ -8177,7 +7575,7 @@
       </p:sp>
       <p:sp>
         <p:nvSpPr>
-          <p:cNvPr id="14" name="TextBox 13"/>
+          <p:cNvPr id="12" name="TextBox 11"/>
           <p:cNvSpPr txBox="1"/>
           <p:nvPr/>
         </p:nvSpPr>
@@ -8219,7 +7617,7 @@
       </p:sp>
       <p:sp>
         <p:nvSpPr>
-          <p:cNvPr id="15" name="TextBox 14"/>
+          <p:cNvPr id="13" name="TextBox 12"/>
           <p:cNvSpPr txBox="1"/>
           <p:nvPr/>
         </p:nvSpPr>
@@ -8424,93 +7822,7 @@
       </p:sp>
       <p:sp>
         <p:nvSpPr>
-          <p:cNvPr id="6" name="Rectangle 5"/>
-          <p:cNvSpPr/>
-          <p:nvPr/>
-        </p:nvSpPr>
-        <p:spPr>
-          <a:xfrm>
-            <a:off x="256032" y="6373368"/>
-            <a:ext cx="292608" cy="292608"/>
-          </a:xfrm>
-          <a:prstGeom prst="rect">
-            <a:avLst/>
-          </a:prstGeom>
-          <a:solidFill>
-            <a:srgbClr val="B8D7EA"/>
-          </a:solidFill>
-          <a:ln>
-            <a:noFill/>
-          </a:ln>
-        </p:spPr>
-        <p:style>
-          <a:lnRef idx="1">
-            <a:schemeClr val="accent1"/>
-          </a:lnRef>
-          <a:fillRef idx="3">
-            <a:schemeClr val="accent1"/>
-          </a:fillRef>
-          <a:effectRef idx="2">
-            <a:schemeClr val="accent1"/>
-          </a:effectRef>
-          <a:fontRef idx="minor">
-            <a:schemeClr val="lt1"/>
-          </a:fontRef>
-        </p:style>
-        <p:txBody>
-          <a:bodyPr rtlCol="0" anchor="ctr"/>
-          <a:lstStyle/>
-          <a:p>
-            <a:pPr algn="ctr"/>
-          </a:p>
-        </p:txBody>
-      </p:sp>
-      <p:sp>
-        <p:nvSpPr>
-          <p:cNvPr id="7" name="Rectangle 6"/>
-          <p:cNvSpPr/>
-          <p:nvPr/>
-        </p:nvSpPr>
-        <p:spPr>
-          <a:xfrm>
-            <a:off x="621792" y="6373368"/>
-            <a:ext cx="292608" cy="292608"/>
-          </a:xfrm>
-          <a:prstGeom prst="rect">
-            <a:avLst/>
-          </a:prstGeom>
-          <a:solidFill>
-            <a:srgbClr val="C5C3D3"/>
-          </a:solidFill>
-          <a:ln>
-            <a:noFill/>
-          </a:ln>
-        </p:spPr>
-        <p:style>
-          <a:lnRef idx="1">
-            <a:schemeClr val="accent1"/>
-          </a:lnRef>
-          <a:fillRef idx="3">
-            <a:schemeClr val="accent1"/>
-          </a:fillRef>
-          <a:effectRef idx="2">
-            <a:schemeClr val="accent1"/>
-          </a:effectRef>
-          <a:fontRef idx="minor">
-            <a:schemeClr val="lt1"/>
-          </a:fontRef>
-        </p:style>
-        <p:txBody>
-          <a:bodyPr rtlCol="0" anchor="ctr"/>
-          <a:lstStyle/>
-          <a:p>
-            <a:pPr algn="ctr"/>
-          </a:p>
-        </p:txBody>
-      </p:sp>
-      <p:sp>
-        <p:nvSpPr>
-          <p:cNvPr id="8" name="TextBox 7"/>
+          <p:cNvPr id="6" name="TextBox 5"/>
           <p:cNvSpPr txBox="1"/>
           <p:nvPr/>
         </p:nvSpPr>
@@ -8549,7 +7861,7 @@
       </p:sp>
       <p:sp>
         <p:nvSpPr>
-          <p:cNvPr id="9" name="Rectangle 8"/>
+          <p:cNvPr id="7" name="Rectangle 6"/>
           <p:cNvSpPr/>
           <p:nvPr/>
         </p:nvSpPr>
@@ -8592,7 +7904,7 @@
       </p:sp>
       <p:sp>
         <p:nvSpPr>
-          <p:cNvPr id="10" name="TextBox 9"/>
+          <p:cNvPr id="8" name="TextBox 7"/>
           <p:cNvSpPr txBox="1"/>
           <p:nvPr/>
         </p:nvSpPr>
@@ -8631,7 +7943,7 @@
       </p:sp>
       <p:sp>
         <p:nvSpPr>
-          <p:cNvPr id="11" name="TextBox 10"/>
+          <p:cNvPr id="9" name="TextBox 8"/>
           <p:cNvSpPr txBox="1"/>
           <p:nvPr/>
         </p:nvSpPr>
@@ -8670,7 +7982,7 @@
       </p:sp>
       <p:sp>
         <p:nvSpPr>
-          <p:cNvPr id="12" name="Rectangle 11"/>
+          <p:cNvPr id="10" name="Rectangle 9"/>
           <p:cNvSpPr/>
           <p:nvPr/>
         </p:nvSpPr>
@@ -8713,7 +8025,7 @@
       </p:sp>
       <p:sp>
         <p:nvSpPr>
-          <p:cNvPr id="13" name="TextBox 12"/>
+          <p:cNvPr id="11" name="TextBox 10"/>
           <p:cNvSpPr txBox="1"/>
           <p:nvPr/>
         </p:nvSpPr>
@@ -8752,7 +8064,7 @@
       </p:sp>
       <p:sp>
         <p:nvSpPr>
-          <p:cNvPr id="14" name="TextBox 13"/>
+          <p:cNvPr id="12" name="TextBox 11"/>
           <p:cNvSpPr txBox="1"/>
           <p:nvPr/>
         </p:nvSpPr>
@@ -8791,7 +8103,7 @@
       </p:sp>
       <p:sp>
         <p:nvSpPr>
-          <p:cNvPr id="15" name="Rectangle 14"/>
+          <p:cNvPr id="13" name="Rectangle 12"/>
           <p:cNvSpPr/>
           <p:nvPr/>
         </p:nvSpPr>
@@ -8834,7 +8146,7 @@
       </p:sp>
       <p:sp>
         <p:nvSpPr>
-          <p:cNvPr id="16" name="TextBox 15"/>
+          <p:cNvPr id="14" name="TextBox 13"/>
           <p:cNvSpPr txBox="1"/>
           <p:nvPr/>
         </p:nvSpPr>
@@ -8873,7 +8185,7 @@
       </p:sp>
       <p:sp>
         <p:nvSpPr>
-          <p:cNvPr id="17" name="TextBox 16"/>
+          <p:cNvPr id="15" name="TextBox 14"/>
           <p:cNvSpPr txBox="1"/>
           <p:nvPr/>
         </p:nvSpPr>
@@ -9075,93 +8387,7 @@
       </p:sp>
       <p:sp>
         <p:nvSpPr>
-          <p:cNvPr id="6" name="Rectangle 5"/>
-          <p:cNvSpPr/>
-          <p:nvPr/>
-        </p:nvSpPr>
-        <p:spPr>
-          <a:xfrm>
-            <a:off x="256032" y="6373368"/>
-            <a:ext cx="292608" cy="292608"/>
-          </a:xfrm>
-          <a:prstGeom prst="rect">
-            <a:avLst/>
-          </a:prstGeom>
-          <a:solidFill>
-            <a:srgbClr val="B8D7EA"/>
-          </a:solidFill>
-          <a:ln>
-            <a:noFill/>
-          </a:ln>
-        </p:spPr>
-        <p:style>
-          <a:lnRef idx="1">
-            <a:schemeClr val="accent1"/>
-          </a:lnRef>
-          <a:fillRef idx="3">
-            <a:schemeClr val="accent1"/>
-          </a:fillRef>
-          <a:effectRef idx="2">
-            <a:schemeClr val="accent1"/>
-          </a:effectRef>
-          <a:fontRef idx="minor">
-            <a:schemeClr val="lt1"/>
-          </a:fontRef>
-        </p:style>
-        <p:txBody>
-          <a:bodyPr rtlCol="0" anchor="ctr"/>
-          <a:lstStyle/>
-          <a:p>
-            <a:pPr algn="ctr"/>
-          </a:p>
-        </p:txBody>
-      </p:sp>
-      <p:sp>
-        <p:nvSpPr>
-          <p:cNvPr id="7" name="Rectangle 6"/>
-          <p:cNvSpPr/>
-          <p:nvPr/>
-        </p:nvSpPr>
-        <p:spPr>
-          <a:xfrm>
-            <a:off x="621792" y="6373368"/>
-            <a:ext cx="292608" cy="292608"/>
-          </a:xfrm>
-          <a:prstGeom prst="rect">
-            <a:avLst/>
-          </a:prstGeom>
-          <a:solidFill>
-            <a:srgbClr val="C5C3D3"/>
-          </a:solidFill>
-          <a:ln>
-            <a:noFill/>
-          </a:ln>
-        </p:spPr>
-        <p:style>
-          <a:lnRef idx="1">
-            <a:schemeClr val="accent1"/>
-          </a:lnRef>
-          <a:fillRef idx="3">
-            <a:schemeClr val="accent1"/>
-          </a:fillRef>
-          <a:effectRef idx="2">
-            <a:schemeClr val="accent1"/>
-          </a:effectRef>
-          <a:fontRef idx="minor">
-            <a:schemeClr val="lt1"/>
-          </a:fontRef>
-        </p:style>
-        <p:txBody>
-          <a:bodyPr rtlCol="0" anchor="ctr"/>
-          <a:lstStyle/>
-          <a:p>
-            <a:pPr algn="ctr"/>
-          </a:p>
-        </p:txBody>
-      </p:sp>
-      <p:sp>
-        <p:nvSpPr>
-          <p:cNvPr id="8" name="TextBox 7"/>
+          <p:cNvPr id="6" name="TextBox 5"/>
           <p:cNvSpPr txBox="1"/>
           <p:nvPr/>
         </p:nvSpPr>
@@ -9200,7 +8426,7 @@
       </p:sp>
       <p:sp>
         <p:nvSpPr>
-          <p:cNvPr id="9" name="Rounded Rectangle 8"/>
+          <p:cNvPr id="7" name="Rounded Rectangle 6"/>
           <p:cNvSpPr/>
           <p:nvPr/>
         </p:nvSpPr>
@@ -9243,7 +8469,7 @@
       </p:sp>
       <p:sp>
         <p:nvSpPr>
-          <p:cNvPr id="10" name="TextBox 9"/>
+          <p:cNvPr id="8" name="TextBox 7"/>
           <p:cNvSpPr txBox="1"/>
           <p:nvPr/>
         </p:nvSpPr>
@@ -9282,7 +8508,7 @@
       </p:sp>
       <p:sp>
         <p:nvSpPr>
-          <p:cNvPr id="11" name="TextBox 10"/>
+          <p:cNvPr id="9" name="TextBox 8"/>
           <p:cNvSpPr txBox="1"/>
           <p:nvPr/>
         </p:nvSpPr>
@@ -9321,7 +8547,7 @@
       </p:sp>
       <p:sp>
         <p:nvSpPr>
-          <p:cNvPr id="12" name="Rounded Rectangle 11"/>
+          <p:cNvPr id="10" name="Rounded Rectangle 9"/>
           <p:cNvSpPr/>
           <p:nvPr/>
         </p:nvSpPr>
@@ -9364,7 +8590,7 @@
       </p:sp>
       <p:sp>
         <p:nvSpPr>
-          <p:cNvPr id="13" name="TextBox 12"/>
+          <p:cNvPr id="11" name="TextBox 10"/>
           <p:cNvSpPr txBox="1"/>
           <p:nvPr/>
         </p:nvSpPr>
@@ -9403,7 +8629,7 @@
       </p:sp>
       <p:sp>
         <p:nvSpPr>
-          <p:cNvPr id="14" name="TextBox 13"/>
+          <p:cNvPr id="12" name="TextBox 11"/>
           <p:cNvSpPr txBox="1"/>
           <p:nvPr/>
         </p:nvSpPr>
@@ -9442,7 +8668,7 @@
       </p:sp>
       <p:sp>
         <p:nvSpPr>
-          <p:cNvPr id="15" name="Rounded Rectangle 14"/>
+          <p:cNvPr id="13" name="Rounded Rectangle 12"/>
           <p:cNvSpPr/>
           <p:nvPr/>
         </p:nvSpPr>
@@ -9485,7 +8711,7 @@
       </p:sp>
       <p:sp>
         <p:nvSpPr>
-          <p:cNvPr id="16" name="TextBox 15"/>
+          <p:cNvPr id="14" name="TextBox 13"/>
           <p:cNvSpPr txBox="1"/>
           <p:nvPr/>
         </p:nvSpPr>
@@ -9524,7 +8750,7 @@
       </p:sp>
       <p:sp>
         <p:nvSpPr>
-          <p:cNvPr id="17" name="TextBox 16"/>
+          <p:cNvPr id="15" name="TextBox 14"/>
           <p:cNvSpPr txBox="1"/>
           <p:nvPr/>
         </p:nvSpPr>
@@ -9563,7 +8789,7 @@
       </p:sp>
       <p:sp>
         <p:nvSpPr>
-          <p:cNvPr id="18" name="Rounded Rectangle 17"/>
+          <p:cNvPr id="16" name="Rounded Rectangle 15"/>
           <p:cNvSpPr/>
           <p:nvPr/>
         </p:nvSpPr>
@@ -9606,7 +8832,7 @@
       </p:sp>
       <p:sp>
         <p:nvSpPr>
-          <p:cNvPr id="19" name="TextBox 18"/>
+          <p:cNvPr id="17" name="TextBox 16"/>
           <p:cNvSpPr txBox="1"/>
           <p:nvPr/>
         </p:nvSpPr>
@@ -9645,7 +8871,7 @@
       </p:sp>
       <p:sp>
         <p:nvSpPr>
-          <p:cNvPr id="20" name="TextBox 19"/>
+          <p:cNvPr id="18" name="TextBox 17"/>
           <p:cNvSpPr txBox="1"/>
           <p:nvPr/>
         </p:nvSpPr>
@@ -9684,7 +8910,7 @@
       </p:sp>
       <p:sp>
         <p:nvSpPr>
-          <p:cNvPr id="21" name="Rounded Rectangle 20"/>
+          <p:cNvPr id="19" name="Rounded Rectangle 18"/>
           <p:cNvSpPr/>
           <p:nvPr/>
         </p:nvSpPr>
@@ -9727,7 +8953,7 @@
       </p:sp>
       <p:sp>
         <p:nvSpPr>
-          <p:cNvPr id="22" name="TextBox 21"/>
+          <p:cNvPr id="20" name="TextBox 19"/>
           <p:cNvSpPr txBox="1"/>
           <p:nvPr/>
         </p:nvSpPr>
@@ -9766,7 +8992,7 @@
       </p:sp>
       <p:sp>
         <p:nvSpPr>
-          <p:cNvPr id="23" name="TextBox 22"/>
+          <p:cNvPr id="21" name="TextBox 20"/>
           <p:cNvSpPr txBox="1"/>
           <p:nvPr/>
         </p:nvSpPr>
@@ -9837,7 +9063,7 @@
       </p:sp>
       <p:sp>
         <p:nvSpPr>
-          <p:cNvPr id="24" name="TextBox 23"/>
+          <p:cNvPr id="22" name="TextBox 21"/>
           <p:cNvSpPr txBox="1"/>
           <p:nvPr/>
         </p:nvSpPr>
@@ -10039,93 +9265,7 @@
       </p:sp>
       <p:sp>
         <p:nvSpPr>
-          <p:cNvPr id="6" name="Rectangle 5"/>
-          <p:cNvSpPr/>
-          <p:nvPr/>
-        </p:nvSpPr>
-        <p:spPr>
-          <a:xfrm>
-            <a:off x="256032" y="6373368"/>
-            <a:ext cx="292608" cy="292608"/>
-          </a:xfrm>
-          <a:prstGeom prst="rect">
-            <a:avLst/>
-          </a:prstGeom>
-          <a:solidFill>
-            <a:srgbClr val="B8D7EA"/>
-          </a:solidFill>
-          <a:ln>
-            <a:noFill/>
-          </a:ln>
-        </p:spPr>
-        <p:style>
-          <a:lnRef idx="1">
-            <a:schemeClr val="accent1"/>
-          </a:lnRef>
-          <a:fillRef idx="3">
-            <a:schemeClr val="accent1"/>
-          </a:fillRef>
-          <a:effectRef idx="2">
-            <a:schemeClr val="accent1"/>
-          </a:effectRef>
-          <a:fontRef idx="minor">
-            <a:schemeClr val="lt1"/>
-          </a:fontRef>
-        </p:style>
-        <p:txBody>
-          <a:bodyPr rtlCol="0" anchor="ctr"/>
-          <a:lstStyle/>
-          <a:p>
-            <a:pPr algn="ctr"/>
-          </a:p>
-        </p:txBody>
-      </p:sp>
-      <p:sp>
-        <p:nvSpPr>
-          <p:cNvPr id="7" name="Rectangle 6"/>
-          <p:cNvSpPr/>
-          <p:nvPr/>
-        </p:nvSpPr>
-        <p:spPr>
-          <a:xfrm>
-            <a:off x="621792" y="6373368"/>
-            <a:ext cx="292608" cy="292608"/>
-          </a:xfrm>
-          <a:prstGeom prst="rect">
-            <a:avLst/>
-          </a:prstGeom>
-          <a:solidFill>
-            <a:srgbClr val="C5C3D3"/>
-          </a:solidFill>
-          <a:ln>
-            <a:noFill/>
-          </a:ln>
-        </p:spPr>
-        <p:style>
-          <a:lnRef idx="1">
-            <a:schemeClr val="accent1"/>
-          </a:lnRef>
-          <a:fillRef idx="3">
-            <a:schemeClr val="accent1"/>
-          </a:fillRef>
-          <a:effectRef idx="2">
-            <a:schemeClr val="accent1"/>
-          </a:effectRef>
-          <a:fontRef idx="minor">
-            <a:schemeClr val="lt1"/>
-          </a:fontRef>
-        </p:style>
-        <p:txBody>
-          <a:bodyPr rtlCol="0" anchor="ctr"/>
-          <a:lstStyle/>
-          <a:p>
-            <a:pPr algn="ctr"/>
-          </a:p>
-        </p:txBody>
-      </p:sp>
-      <p:sp>
-        <p:nvSpPr>
-          <p:cNvPr id="8" name="TextBox 7"/>
+          <p:cNvPr id="6" name="TextBox 5"/>
           <p:cNvSpPr txBox="1"/>
           <p:nvPr/>
         </p:nvSpPr>
@@ -10164,7 +9304,7 @@
       </p:sp>
       <p:pic>
         <p:nvPicPr>
-          <p:cNvPr id="9" name="Picture 8" descr="mnist_digits.png"/>
+          <p:cNvPr id="7" name="Picture 6" descr="mnist_digits.png"/>
           <p:cNvPicPr>
             <a:picLocks noChangeAspect="1"/>
           </p:cNvPicPr>
@@ -10188,7 +9328,7 @@
       </p:pic>
       <p:sp>
         <p:nvSpPr>
-          <p:cNvPr id="10" name="TextBox 9"/>
+          <p:cNvPr id="8" name="TextBox 7"/>
           <p:cNvSpPr txBox="1"/>
           <p:nvPr/>
         </p:nvSpPr>
@@ -10243,7 +9383,7 @@
       </p:sp>
       <p:sp>
         <p:nvSpPr>
-          <p:cNvPr id="11" name="Rounded Rectangle 10"/>
+          <p:cNvPr id="9" name="Rounded Rectangle 8"/>
           <p:cNvSpPr/>
           <p:nvPr/>
         </p:nvSpPr>
@@ -10286,7 +9426,7 @@
       </p:sp>
       <p:sp>
         <p:nvSpPr>
-          <p:cNvPr id="12" name="TextBox 11"/>
+          <p:cNvPr id="10" name="TextBox 9"/>
           <p:cNvSpPr txBox="1"/>
           <p:nvPr/>
         </p:nvSpPr>
@@ -10341,7 +9481,7 @@
       </p:sp>
       <p:sp>
         <p:nvSpPr>
-          <p:cNvPr id="13" name="TextBox 12"/>
+          <p:cNvPr id="11" name="TextBox 10"/>
           <p:cNvSpPr txBox="1"/>
           <p:nvPr/>
         </p:nvSpPr>
@@ -10380,7 +9520,7 @@
       </p:sp>
       <p:sp>
         <p:nvSpPr>
-          <p:cNvPr id="14" name="Rounded Rectangle 13"/>
+          <p:cNvPr id="12" name="Rounded Rectangle 11"/>
           <p:cNvSpPr/>
           <p:nvPr/>
         </p:nvSpPr>
@@ -10423,7 +9563,7 @@
       </p:sp>
       <p:sp>
         <p:nvSpPr>
-          <p:cNvPr id="15" name="TextBox 14"/>
+          <p:cNvPr id="13" name="TextBox 12"/>
           <p:cNvSpPr txBox="1"/>
           <p:nvPr/>
         </p:nvSpPr>
@@ -10478,7 +9618,7 @@
       </p:sp>
       <p:sp>
         <p:nvSpPr>
-          <p:cNvPr id="16" name="TextBox 15"/>
+          <p:cNvPr id="14" name="TextBox 13"/>
           <p:cNvSpPr txBox="1"/>
           <p:nvPr/>
         </p:nvSpPr>
@@ -10517,7 +9657,7 @@
       </p:sp>
       <p:sp>
         <p:nvSpPr>
-          <p:cNvPr id="17" name="Rounded Rectangle 16"/>
+          <p:cNvPr id="15" name="Rounded Rectangle 14"/>
           <p:cNvSpPr/>
           <p:nvPr/>
         </p:nvSpPr>
@@ -10560,7 +9700,7 @@
       </p:sp>
       <p:sp>
         <p:nvSpPr>
-          <p:cNvPr id="18" name="TextBox 17"/>
+          <p:cNvPr id="16" name="TextBox 15"/>
           <p:cNvSpPr txBox="1"/>
           <p:nvPr/>
         </p:nvSpPr>
@@ -10615,7 +9755,7 @@
       </p:sp>
       <p:sp>
         <p:nvSpPr>
-          <p:cNvPr id="19" name="TextBox 18"/>
+          <p:cNvPr id="17" name="TextBox 16"/>
           <p:cNvSpPr txBox="1"/>
           <p:nvPr/>
         </p:nvSpPr>
@@ -10654,7 +9794,7 @@
       </p:sp>
       <p:sp>
         <p:nvSpPr>
-          <p:cNvPr id="20" name="TextBox 19"/>
+          <p:cNvPr id="18" name="TextBox 17"/>
           <p:cNvSpPr txBox="1"/>
           <p:nvPr/>
         </p:nvSpPr>
@@ -10895,93 +10035,7 @@
       </p:sp>
       <p:sp>
         <p:nvSpPr>
-          <p:cNvPr id="7" name="Rectangle 6"/>
-          <p:cNvSpPr/>
-          <p:nvPr/>
-        </p:nvSpPr>
-        <p:spPr>
-          <a:xfrm>
-            <a:off x="256032" y="6373368"/>
-            <a:ext cx="292608" cy="292608"/>
-          </a:xfrm>
-          <a:prstGeom prst="rect">
-            <a:avLst/>
-          </a:prstGeom>
-          <a:solidFill>
-            <a:srgbClr val="B8D7EA"/>
-          </a:solidFill>
-          <a:ln>
-            <a:noFill/>
-          </a:ln>
-        </p:spPr>
-        <p:style>
-          <a:lnRef idx="1">
-            <a:schemeClr val="accent1"/>
-          </a:lnRef>
-          <a:fillRef idx="3">
-            <a:schemeClr val="accent1"/>
-          </a:fillRef>
-          <a:effectRef idx="2">
-            <a:schemeClr val="accent1"/>
-          </a:effectRef>
-          <a:fontRef idx="minor">
-            <a:schemeClr val="lt1"/>
-          </a:fontRef>
-        </p:style>
-        <p:txBody>
-          <a:bodyPr rtlCol="0" anchor="ctr"/>
-          <a:lstStyle/>
-          <a:p>
-            <a:pPr algn="ctr"/>
-          </a:p>
-        </p:txBody>
-      </p:sp>
-      <p:sp>
-        <p:nvSpPr>
-          <p:cNvPr id="8" name="Rectangle 7"/>
-          <p:cNvSpPr/>
-          <p:nvPr/>
-        </p:nvSpPr>
-        <p:spPr>
-          <a:xfrm>
-            <a:off x="621792" y="6373368"/>
-            <a:ext cx="292608" cy="292608"/>
-          </a:xfrm>
-          <a:prstGeom prst="rect">
-            <a:avLst/>
-          </a:prstGeom>
-          <a:solidFill>
-            <a:srgbClr val="C5C3D3"/>
-          </a:solidFill>
-          <a:ln>
-            <a:noFill/>
-          </a:ln>
-        </p:spPr>
-        <p:style>
-          <a:lnRef idx="1">
-            <a:schemeClr val="accent1"/>
-          </a:lnRef>
-          <a:fillRef idx="3">
-            <a:schemeClr val="accent1"/>
-          </a:fillRef>
-          <a:effectRef idx="2">
-            <a:schemeClr val="accent1"/>
-          </a:effectRef>
-          <a:fontRef idx="minor">
-            <a:schemeClr val="lt1"/>
-          </a:fontRef>
-        </p:style>
-        <p:txBody>
-          <a:bodyPr rtlCol="0" anchor="ctr"/>
-          <a:lstStyle/>
-          <a:p>
-            <a:pPr algn="ctr"/>
-          </a:p>
-        </p:txBody>
-      </p:sp>
-      <p:sp>
-        <p:nvSpPr>
-          <p:cNvPr id="9" name="TextBox 8"/>
+          <p:cNvPr id="7" name="TextBox 6"/>
           <p:cNvSpPr txBox="1"/>
           <p:nvPr/>
         </p:nvSpPr>
@@ -11020,7 +10074,7 @@
       </p:sp>
       <p:graphicFrame>
         <p:nvGraphicFramePr>
-          <p:cNvPr id="10" name="Table 9"/>
+          <p:cNvPr id="8" name="Table 7"/>
           <p:cNvGraphicFramePr>
             <a:graphicFrameLocks noGrp="1"/>
           </p:cNvGraphicFramePr>
@@ -11343,7 +10397,7 @@
       </p:graphicFrame>
       <p:sp>
         <p:nvSpPr>
-          <p:cNvPr id="11" name="TextBox 10"/>
+          <p:cNvPr id="9" name="TextBox 8"/>
           <p:cNvSpPr txBox="1"/>
           <p:nvPr/>
         </p:nvSpPr>
@@ -11385,7 +10439,7 @@
       </p:sp>
       <p:sp>
         <p:nvSpPr>
-          <p:cNvPr id="12" name="TextBox 11"/>
+          <p:cNvPr id="10" name="TextBox 9"/>
           <p:cNvSpPr txBox="1"/>
           <p:nvPr/>
         </p:nvSpPr>
@@ -11427,7 +10481,7 @@
       </p:sp>
       <p:sp>
         <p:nvSpPr>
-          <p:cNvPr id="13" name="TextBox 12"/>
+          <p:cNvPr id="11" name="TextBox 10"/>
           <p:cNvSpPr txBox="1"/>
           <p:nvPr/>
         </p:nvSpPr>
@@ -11629,93 +10683,7 @@
       </p:sp>
       <p:sp>
         <p:nvSpPr>
-          <p:cNvPr id="6" name="Rectangle 5"/>
-          <p:cNvSpPr/>
-          <p:nvPr/>
-        </p:nvSpPr>
-        <p:spPr>
-          <a:xfrm>
-            <a:off x="256032" y="6373368"/>
-            <a:ext cx="292608" cy="292608"/>
-          </a:xfrm>
-          <a:prstGeom prst="rect">
-            <a:avLst/>
-          </a:prstGeom>
-          <a:solidFill>
-            <a:srgbClr val="B8D7EA"/>
-          </a:solidFill>
-          <a:ln>
-            <a:noFill/>
-          </a:ln>
-        </p:spPr>
-        <p:style>
-          <a:lnRef idx="1">
-            <a:schemeClr val="accent1"/>
-          </a:lnRef>
-          <a:fillRef idx="3">
-            <a:schemeClr val="accent1"/>
-          </a:fillRef>
-          <a:effectRef idx="2">
-            <a:schemeClr val="accent1"/>
-          </a:effectRef>
-          <a:fontRef idx="minor">
-            <a:schemeClr val="lt1"/>
-          </a:fontRef>
-        </p:style>
-        <p:txBody>
-          <a:bodyPr rtlCol="0" anchor="ctr"/>
-          <a:lstStyle/>
-          <a:p>
-            <a:pPr algn="ctr"/>
-          </a:p>
-        </p:txBody>
-      </p:sp>
-      <p:sp>
-        <p:nvSpPr>
-          <p:cNvPr id="7" name="Rectangle 6"/>
-          <p:cNvSpPr/>
-          <p:nvPr/>
-        </p:nvSpPr>
-        <p:spPr>
-          <a:xfrm>
-            <a:off x="621792" y="6373368"/>
-            <a:ext cx="292608" cy="292608"/>
-          </a:xfrm>
-          <a:prstGeom prst="rect">
-            <a:avLst/>
-          </a:prstGeom>
-          <a:solidFill>
-            <a:srgbClr val="C5C3D3"/>
-          </a:solidFill>
-          <a:ln>
-            <a:noFill/>
-          </a:ln>
-        </p:spPr>
-        <p:style>
-          <a:lnRef idx="1">
-            <a:schemeClr val="accent1"/>
-          </a:lnRef>
-          <a:fillRef idx="3">
-            <a:schemeClr val="accent1"/>
-          </a:fillRef>
-          <a:effectRef idx="2">
-            <a:schemeClr val="accent1"/>
-          </a:effectRef>
-          <a:fontRef idx="minor">
-            <a:schemeClr val="lt1"/>
-          </a:fontRef>
-        </p:style>
-        <p:txBody>
-          <a:bodyPr rtlCol="0" anchor="ctr"/>
-          <a:lstStyle/>
-          <a:p>
-            <a:pPr algn="ctr"/>
-          </a:p>
-        </p:txBody>
-      </p:sp>
-      <p:sp>
-        <p:nvSpPr>
-          <p:cNvPr id="8" name="TextBox 7"/>
+          <p:cNvPr id="6" name="TextBox 5"/>
           <p:cNvSpPr txBox="1"/>
           <p:nvPr/>
         </p:nvSpPr>
@@ -11754,7 +10722,7 @@
       </p:sp>
       <p:sp>
         <p:nvSpPr>
-          <p:cNvPr id="9" name="Rounded Rectangle 8"/>
+          <p:cNvPr id="7" name="Rounded Rectangle 6"/>
           <p:cNvSpPr/>
           <p:nvPr/>
         </p:nvSpPr>
@@ -11797,7 +10765,7 @@
       </p:sp>
       <p:sp>
         <p:nvSpPr>
-          <p:cNvPr id="10" name="TextBox 9"/>
+          <p:cNvPr id="8" name="TextBox 7"/>
           <p:cNvSpPr txBox="1"/>
           <p:nvPr/>
         </p:nvSpPr>
@@ -11839,7 +10807,7 @@
       </p:sp>
       <p:sp>
         <p:nvSpPr>
-          <p:cNvPr id="11" name="Rounded Rectangle 10"/>
+          <p:cNvPr id="9" name="Rounded Rectangle 8"/>
           <p:cNvSpPr/>
           <p:nvPr/>
         </p:nvSpPr>
@@ -11882,7 +10850,7 @@
       </p:sp>
       <p:sp>
         <p:nvSpPr>
-          <p:cNvPr id="12" name="TextBox 11"/>
+          <p:cNvPr id="10" name="TextBox 9"/>
           <p:cNvSpPr txBox="1"/>
           <p:nvPr/>
         </p:nvSpPr>
@@ -11924,7 +10892,7 @@
       </p:sp>
       <p:sp>
         <p:nvSpPr>
-          <p:cNvPr id="13" name="Rounded Rectangle 12"/>
+          <p:cNvPr id="11" name="Rounded Rectangle 10"/>
           <p:cNvSpPr/>
           <p:nvPr/>
         </p:nvSpPr>
@@ -11967,7 +10935,7 @@
       </p:sp>
       <p:sp>
         <p:nvSpPr>
-          <p:cNvPr id="14" name="TextBox 13"/>
+          <p:cNvPr id="12" name="TextBox 11"/>
           <p:cNvSpPr txBox="1"/>
           <p:nvPr/>
         </p:nvSpPr>
@@ -12009,7 +10977,7 @@
       </p:sp>
       <p:sp>
         <p:nvSpPr>
-          <p:cNvPr id="15" name="TextBox 14"/>
+          <p:cNvPr id="13" name="TextBox 12"/>
           <p:cNvSpPr txBox="1"/>
           <p:nvPr/>
         </p:nvSpPr>
@@ -12051,7 +11019,7 @@
       </p:sp>
       <p:sp>
         <p:nvSpPr>
-          <p:cNvPr id="16" name="TextBox 15"/>
+          <p:cNvPr id="14" name="TextBox 13"/>
           <p:cNvSpPr txBox="1"/>
           <p:nvPr/>
         </p:nvSpPr>
@@ -12308,93 +11276,7 @@
       </p:sp>
       <p:sp>
         <p:nvSpPr>
-          <p:cNvPr id="7" name="Rectangle 6"/>
-          <p:cNvSpPr/>
-          <p:nvPr/>
-        </p:nvSpPr>
-        <p:spPr>
-          <a:xfrm>
-            <a:off x="256032" y="6373368"/>
-            <a:ext cx="292608" cy="292608"/>
-          </a:xfrm>
-          <a:prstGeom prst="rect">
-            <a:avLst/>
-          </a:prstGeom>
-          <a:solidFill>
-            <a:srgbClr val="B8D7EA"/>
-          </a:solidFill>
-          <a:ln>
-            <a:noFill/>
-          </a:ln>
-        </p:spPr>
-        <p:style>
-          <a:lnRef idx="1">
-            <a:schemeClr val="accent1"/>
-          </a:lnRef>
-          <a:fillRef idx="3">
-            <a:schemeClr val="accent1"/>
-          </a:fillRef>
-          <a:effectRef idx="2">
-            <a:schemeClr val="accent1"/>
-          </a:effectRef>
-          <a:fontRef idx="minor">
-            <a:schemeClr val="lt1"/>
-          </a:fontRef>
-        </p:style>
-        <p:txBody>
-          <a:bodyPr rtlCol="0" anchor="ctr"/>
-          <a:lstStyle/>
-          <a:p>
-            <a:pPr algn="ctr"/>
-          </a:p>
-        </p:txBody>
-      </p:sp>
-      <p:sp>
-        <p:nvSpPr>
-          <p:cNvPr id="8" name="Rectangle 7"/>
-          <p:cNvSpPr/>
-          <p:nvPr/>
-        </p:nvSpPr>
-        <p:spPr>
-          <a:xfrm>
-            <a:off x="621792" y="6373368"/>
-            <a:ext cx="292608" cy="292608"/>
-          </a:xfrm>
-          <a:prstGeom prst="rect">
-            <a:avLst/>
-          </a:prstGeom>
-          <a:solidFill>
-            <a:srgbClr val="C5C3D3"/>
-          </a:solidFill>
-          <a:ln>
-            <a:noFill/>
-          </a:ln>
-        </p:spPr>
-        <p:style>
-          <a:lnRef idx="1">
-            <a:schemeClr val="accent1"/>
-          </a:lnRef>
-          <a:fillRef idx="3">
-            <a:schemeClr val="accent1"/>
-          </a:fillRef>
-          <a:effectRef idx="2">
-            <a:schemeClr val="accent1"/>
-          </a:effectRef>
-          <a:fontRef idx="minor">
-            <a:schemeClr val="lt1"/>
-          </a:fontRef>
-        </p:style>
-        <p:txBody>
-          <a:bodyPr rtlCol="0" anchor="ctr"/>
-          <a:lstStyle/>
-          <a:p>
-            <a:pPr algn="ctr"/>
-          </a:p>
-        </p:txBody>
-      </p:sp>
-      <p:sp>
-        <p:nvSpPr>
-          <p:cNvPr id="9" name="TextBox 8"/>
+          <p:cNvPr id="7" name="TextBox 6"/>
           <p:cNvSpPr txBox="1"/>
           <p:nvPr/>
         </p:nvSpPr>
@@ -12433,7 +11315,7 @@
       </p:sp>
       <p:sp>
         <p:nvSpPr>
-          <p:cNvPr id="10" name="Rounded Rectangle 9"/>
+          <p:cNvPr id="8" name="Rounded Rectangle 7"/>
           <p:cNvSpPr/>
           <p:nvPr/>
         </p:nvSpPr>
@@ -12476,7 +11358,7 @@
       </p:sp>
       <p:sp>
         <p:nvSpPr>
-          <p:cNvPr id="11" name="TextBox 10"/>
+          <p:cNvPr id="9" name="TextBox 8"/>
           <p:cNvSpPr txBox="1"/>
           <p:nvPr/>
         </p:nvSpPr>
@@ -12563,7 +11445,7 @@
       </p:sp>
       <p:sp>
         <p:nvSpPr>
-          <p:cNvPr id="12" name="TextBox 11"/>
+          <p:cNvPr id="10" name="TextBox 9"/>
           <p:cNvSpPr txBox="1"/>
           <p:nvPr/>
         </p:nvSpPr>
@@ -12602,7 +11484,7 @@
       </p:sp>
       <p:sp>
         <p:nvSpPr>
-          <p:cNvPr id="13" name="TextBox 12"/>
+          <p:cNvPr id="11" name="TextBox 10"/>
           <p:cNvSpPr txBox="1"/>
           <p:nvPr/>
         </p:nvSpPr>
@@ -12820,93 +11702,7 @@
       </p:sp>
       <p:sp>
         <p:nvSpPr>
-          <p:cNvPr id="6" name="Rectangle 5"/>
-          <p:cNvSpPr/>
-          <p:nvPr/>
-        </p:nvSpPr>
-        <p:spPr>
-          <a:xfrm>
-            <a:off x="256032" y="6373368"/>
-            <a:ext cx="292608" cy="292608"/>
-          </a:xfrm>
-          <a:prstGeom prst="rect">
-            <a:avLst/>
-          </a:prstGeom>
-          <a:solidFill>
-            <a:srgbClr val="B8D7EA"/>
-          </a:solidFill>
-          <a:ln>
-            <a:noFill/>
-          </a:ln>
-        </p:spPr>
-        <p:style>
-          <a:lnRef idx="1">
-            <a:schemeClr val="accent1"/>
-          </a:lnRef>
-          <a:fillRef idx="3">
-            <a:schemeClr val="accent1"/>
-          </a:fillRef>
-          <a:effectRef idx="2">
-            <a:schemeClr val="accent1"/>
-          </a:effectRef>
-          <a:fontRef idx="minor">
-            <a:schemeClr val="lt1"/>
-          </a:fontRef>
-        </p:style>
-        <p:txBody>
-          <a:bodyPr rtlCol="0" anchor="ctr"/>
-          <a:lstStyle/>
-          <a:p>
-            <a:pPr algn="ctr"/>
-          </a:p>
-        </p:txBody>
-      </p:sp>
-      <p:sp>
-        <p:nvSpPr>
-          <p:cNvPr id="7" name="Rectangle 6"/>
-          <p:cNvSpPr/>
-          <p:nvPr/>
-        </p:nvSpPr>
-        <p:spPr>
-          <a:xfrm>
-            <a:off x="621792" y="6373368"/>
-            <a:ext cx="292608" cy="292608"/>
-          </a:xfrm>
-          <a:prstGeom prst="rect">
-            <a:avLst/>
-          </a:prstGeom>
-          <a:solidFill>
-            <a:srgbClr val="C5C3D3"/>
-          </a:solidFill>
-          <a:ln>
-            <a:noFill/>
-          </a:ln>
-        </p:spPr>
-        <p:style>
-          <a:lnRef idx="1">
-            <a:schemeClr val="accent1"/>
-          </a:lnRef>
-          <a:fillRef idx="3">
-            <a:schemeClr val="accent1"/>
-          </a:fillRef>
-          <a:effectRef idx="2">
-            <a:schemeClr val="accent1"/>
-          </a:effectRef>
-          <a:fontRef idx="minor">
-            <a:schemeClr val="lt1"/>
-          </a:fontRef>
-        </p:style>
-        <p:txBody>
-          <a:bodyPr rtlCol="0" anchor="ctr"/>
-          <a:lstStyle/>
-          <a:p>
-            <a:pPr algn="ctr"/>
-          </a:p>
-        </p:txBody>
-      </p:sp>
-      <p:sp>
-        <p:nvSpPr>
-          <p:cNvPr id="8" name="TextBox 7"/>
+          <p:cNvPr id="6" name="TextBox 5"/>
           <p:cNvSpPr txBox="1"/>
           <p:nvPr/>
         </p:nvSpPr>
@@ -12945,7 +11741,7 @@
       </p:sp>
       <p:sp>
         <p:nvSpPr>
-          <p:cNvPr id="9" name="Rectangle 8"/>
+          <p:cNvPr id="7" name="Rectangle 6"/>
           <p:cNvSpPr/>
           <p:nvPr/>
         </p:nvSpPr>
@@ -12988,7 +11784,7 @@
       </p:sp>
       <p:sp>
         <p:nvSpPr>
-          <p:cNvPr id="10" name="TextBox 9"/>
+          <p:cNvPr id="8" name="TextBox 7"/>
           <p:cNvSpPr txBox="1"/>
           <p:nvPr/>
         </p:nvSpPr>
@@ -13027,7 +11823,7 @@
       </p:sp>
       <p:sp>
         <p:nvSpPr>
-          <p:cNvPr id="11" name="TextBox 10"/>
+          <p:cNvPr id="9" name="TextBox 8"/>
           <p:cNvSpPr txBox="1"/>
           <p:nvPr/>
         </p:nvSpPr>
@@ -13066,7 +11862,7 @@
       </p:sp>
       <p:sp>
         <p:nvSpPr>
-          <p:cNvPr id="12" name="Rectangle 11"/>
+          <p:cNvPr id="10" name="Rectangle 9"/>
           <p:cNvSpPr/>
           <p:nvPr/>
         </p:nvSpPr>
@@ -13109,7 +11905,7 @@
       </p:sp>
       <p:sp>
         <p:nvSpPr>
-          <p:cNvPr id="13" name="TextBox 12"/>
+          <p:cNvPr id="11" name="TextBox 10"/>
           <p:cNvSpPr txBox="1"/>
           <p:nvPr/>
         </p:nvSpPr>
@@ -13148,7 +11944,7 @@
       </p:sp>
       <p:sp>
         <p:nvSpPr>
-          <p:cNvPr id="14" name="TextBox 13"/>
+          <p:cNvPr id="12" name="TextBox 11"/>
           <p:cNvSpPr txBox="1"/>
           <p:nvPr/>
         </p:nvSpPr>
@@ -13187,7 +11983,7 @@
       </p:sp>
       <p:sp>
         <p:nvSpPr>
-          <p:cNvPr id="15" name="Rectangle 14"/>
+          <p:cNvPr id="13" name="Rectangle 12"/>
           <p:cNvSpPr/>
           <p:nvPr/>
         </p:nvSpPr>
@@ -13230,7 +12026,7 @@
       </p:sp>
       <p:sp>
         <p:nvSpPr>
-          <p:cNvPr id="16" name="TextBox 15"/>
+          <p:cNvPr id="14" name="TextBox 13"/>
           <p:cNvSpPr txBox="1"/>
           <p:nvPr/>
         </p:nvSpPr>
@@ -13269,7 +12065,7 @@
       </p:sp>
       <p:sp>
         <p:nvSpPr>
-          <p:cNvPr id="17" name="TextBox 16"/>
+          <p:cNvPr id="15" name="TextBox 14"/>
           <p:cNvSpPr txBox="1"/>
           <p:nvPr/>
         </p:nvSpPr>
@@ -13308,7 +12104,7 @@
       </p:sp>
       <p:sp>
         <p:nvSpPr>
-          <p:cNvPr id="18" name="Rectangle 17"/>
+          <p:cNvPr id="16" name="Rectangle 15"/>
           <p:cNvSpPr/>
           <p:nvPr/>
         </p:nvSpPr>
@@ -13351,7 +12147,7 @@
       </p:sp>
       <p:sp>
         <p:nvSpPr>
-          <p:cNvPr id="19" name="TextBox 18"/>
+          <p:cNvPr id="17" name="TextBox 16"/>
           <p:cNvSpPr txBox="1"/>
           <p:nvPr/>
         </p:nvSpPr>
@@ -13390,7 +12186,7 @@
       </p:sp>
       <p:sp>
         <p:nvSpPr>
-          <p:cNvPr id="20" name="TextBox 19"/>
+          <p:cNvPr id="18" name="TextBox 17"/>
           <p:cNvSpPr txBox="1"/>
           <p:nvPr/>
         </p:nvSpPr>
@@ -13429,7 +12225,7 @@
       </p:sp>
       <p:sp>
         <p:nvSpPr>
-          <p:cNvPr id="21" name="Rectangle 20"/>
+          <p:cNvPr id="19" name="Rectangle 18"/>
           <p:cNvSpPr/>
           <p:nvPr/>
         </p:nvSpPr>
@@ -13472,7 +12268,7 @@
       </p:sp>
       <p:sp>
         <p:nvSpPr>
-          <p:cNvPr id="22" name="TextBox 21"/>
+          <p:cNvPr id="20" name="TextBox 19"/>
           <p:cNvSpPr txBox="1"/>
           <p:nvPr/>
         </p:nvSpPr>
@@ -13511,7 +12307,7 @@
       </p:sp>
       <p:sp>
         <p:nvSpPr>
-          <p:cNvPr id="23" name="TextBox 22"/>
+          <p:cNvPr id="21" name="TextBox 20"/>
           <p:cNvSpPr txBox="1"/>
           <p:nvPr/>
         </p:nvSpPr>
@@ -13550,7 +12346,7 @@
       </p:sp>
       <p:sp>
         <p:nvSpPr>
-          <p:cNvPr id="24" name="Rounded Rectangle 23"/>
+          <p:cNvPr id="22" name="Rounded Rectangle 21"/>
           <p:cNvSpPr/>
           <p:nvPr/>
         </p:nvSpPr>
@@ -13593,7 +12389,7 @@
       </p:sp>
       <p:sp>
         <p:nvSpPr>
-          <p:cNvPr id="25" name="TextBox 24"/>
+          <p:cNvPr id="23" name="TextBox 22"/>
           <p:cNvSpPr txBox="1"/>
           <p:nvPr/>
         </p:nvSpPr>
@@ -13680,7 +12476,7 @@
       </p:sp>
       <p:sp>
         <p:nvSpPr>
-          <p:cNvPr id="26" name="TextBox 25"/>
+          <p:cNvPr id="24" name="TextBox 23"/>
           <p:cNvSpPr txBox="1"/>
           <p:nvPr/>
         </p:nvSpPr>
@@ -13751,7 +12547,7 @@
       </p:sp>
       <p:sp>
         <p:nvSpPr>
-          <p:cNvPr id="27" name="TextBox 26"/>
+          <p:cNvPr id="25" name="TextBox 24"/>
           <p:cNvSpPr txBox="1"/>
           <p:nvPr/>
         </p:nvSpPr>
@@ -13953,93 +12749,7 @@
       </p:sp>
       <p:sp>
         <p:nvSpPr>
-          <p:cNvPr id="6" name="Rectangle 5"/>
-          <p:cNvSpPr/>
-          <p:nvPr/>
-        </p:nvSpPr>
-        <p:spPr>
-          <a:xfrm>
-            <a:off x="256032" y="6373368"/>
-            <a:ext cx="292608" cy="292608"/>
-          </a:xfrm>
-          <a:prstGeom prst="rect">
-            <a:avLst/>
-          </a:prstGeom>
-          <a:solidFill>
-            <a:srgbClr val="B8D7EA"/>
-          </a:solidFill>
-          <a:ln>
-            <a:noFill/>
-          </a:ln>
-        </p:spPr>
-        <p:style>
-          <a:lnRef idx="1">
-            <a:schemeClr val="accent1"/>
-          </a:lnRef>
-          <a:fillRef idx="3">
-            <a:schemeClr val="accent1"/>
-          </a:fillRef>
-          <a:effectRef idx="2">
-            <a:schemeClr val="accent1"/>
-          </a:effectRef>
-          <a:fontRef idx="minor">
-            <a:schemeClr val="lt1"/>
-          </a:fontRef>
-        </p:style>
-        <p:txBody>
-          <a:bodyPr rtlCol="0" anchor="ctr"/>
-          <a:lstStyle/>
-          <a:p>
-            <a:pPr algn="ctr"/>
-          </a:p>
-        </p:txBody>
-      </p:sp>
-      <p:sp>
-        <p:nvSpPr>
-          <p:cNvPr id="7" name="Rectangle 6"/>
-          <p:cNvSpPr/>
-          <p:nvPr/>
-        </p:nvSpPr>
-        <p:spPr>
-          <a:xfrm>
-            <a:off x="621792" y="6373368"/>
-            <a:ext cx="292608" cy="292608"/>
-          </a:xfrm>
-          <a:prstGeom prst="rect">
-            <a:avLst/>
-          </a:prstGeom>
-          <a:solidFill>
-            <a:srgbClr val="C5C3D3"/>
-          </a:solidFill>
-          <a:ln>
-            <a:noFill/>
-          </a:ln>
-        </p:spPr>
-        <p:style>
-          <a:lnRef idx="1">
-            <a:schemeClr val="accent1"/>
-          </a:lnRef>
-          <a:fillRef idx="3">
-            <a:schemeClr val="accent1"/>
-          </a:fillRef>
-          <a:effectRef idx="2">
-            <a:schemeClr val="accent1"/>
-          </a:effectRef>
-          <a:fontRef idx="minor">
-            <a:schemeClr val="lt1"/>
-          </a:fontRef>
-        </p:style>
-        <p:txBody>
-          <a:bodyPr rtlCol="0" anchor="ctr"/>
-          <a:lstStyle/>
-          <a:p>
-            <a:pPr algn="ctr"/>
-          </a:p>
-        </p:txBody>
-      </p:sp>
-      <p:sp>
-        <p:nvSpPr>
-          <p:cNvPr id="8" name="TextBox 7"/>
+          <p:cNvPr id="6" name="TextBox 5"/>
           <p:cNvSpPr txBox="1"/>
           <p:nvPr/>
         </p:nvSpPr>
@@ -14078,7 +12788,7 @@
       </p:sp>
       <p:sp>
         <p:nvSpPr>
-          <p:cNvPr id="9" name="Rounded Rectangle 8"/>
+          <p:cNvPr id="7" name="Rounded Rectangle 6"/>
           <p:cNvSpPr/>
           <p:nvPr/>
         </p:nvSpPr>
@@ -14121,7 +12831,7 @@
       </p:sp>
       <p:sp>
         <p:nvSpPr>
-          <p:cNvPr id="10" name="TextBox 9"/>
+          <p:cNvPr id="8" name="TextBox 7"/>
           <p:cNvSpPr txBox="1"/>
           <p:nvPr/>
         </p:nvSpPr>
@@ -14176,7 +12886,7 @@
       </p:sp>
       <p:sp>
         <p:nvSpPr>
-          <p:cNvPr id="11" name="Rounded Rectangle 10"/>
+          <p:cNvPr id="9" name="Rounded Rectangle 8"/>
           <p:cNvSpPr/>
           <p:nvPr/>
         </p:nvSpPr>
@@ -14219,7 +12929,7 @@
       </p:sp>
       <p:sp>
         <p:nvSpPr>
-          <p:cNvPr id="12" name="TextBox 11"/>
+          <p:cNvPr id="10" name="TextBox 9"/>
           <p:cNvSpPr txBox="1"/>
           <p:nvPr/>
         </p:nvSpPr>
@@ -14258,7 +12968,7 @@
       </p:sp>
       <p:sp>
         <p:nvSpPr>
-          <p:cNvPr id="13" name="TextBox 12"/>
+          <p:cNvPr id="11" name="TextBox 10"/>
           <p:cNvSpPr txBox="1"/>
           <p:nvPr/>
         </p:nvSpPr>
@@ -14313,7 +13023,7 @@
       </p:sp>
       <p:sp>
         <p:nvSpPr>
-          <p:cNvPr id="14" name="Rounded Rectangle 13"/>
+          <p:cNvPr id="12" name="Rounded Rectangle 11"/>
           <p:cNvSpPr/>
           <p:nvPr/>
         </p:nvSpPr>
@@ -14356,7 +13066,7 @@
       </p:sp>
       <p:sp>
         <p:nvSpPr>
-          <p:cNvPr id="15" name="TextBox 14"/>
+          <p:cNvPr id="13" name="TextBox 12"/>
           <p:cNvSpPr txBox="1"/>
           <p:nvPr/>
         </p:nvSpPr>
@@ -14395,7 +13105,7 @@
       </p:sp>
       <p:sp>
         <p:nvSpPr>
-          <p:cNvPr id="16" name="TextBox 15"/>
+          <p:cNvPr id="14" name="TextBox 13"/>
           <p:cNvSpPr txBox="1"/>
           <p:nvPr/>
         </p:nvSpPr>
@@ -14450,7 +13160,7 @@
       </p:sp>
       <p:sp>
         <p:nvSpPr>
-          <p:cNvPr id="17" name="Rounded Rectangle 16"/>
+          <p:cNvPr id="15" name="Rounded Rectangle 14"/>
           <p:cNvSpPr/>
           <p:nvPr/>
         </p:nvSpPr>
@@ -14493,7 +13203,7 @@
       </p:sp>
       <p:sp>
         <p:nvSpPr>
-          <p:cNvPr id="18" name="TextBox 17"/>
+          <p:cNvPr id="16" name="TextBox 15"/>
           <p:cNvSpPr txBox="1"/>
           <p:nvPr/>
         </p:nvSpPr>
@@ -14532,7 +13242,7 @@
       </p:sp>
       <p:sp>
         <p:nvSpPr>
-          <p:cNvPr id="19" name="TextBox 18"/>
+          <p:cNvPr id="17" name="TextBox 16"/>
           <p:cNvSpPr txBox="1"/>
           <p:nvPr/>
         </p:nvSpPr>
@@ -14587,7 +13297,7 @@
       </p:sp>
       <p:sp>
         <p:nvSpPr>
-          <p:cNvPr id="20" name="TextBox 19"/>
+          <p:cNvPr id="18" name="TextBox 17"/>
           <p:cNvSpPr txBox="1"/>
           <p:nvPr/>
         </p:nvSpPr>

</xml_diff>

<commit_message>
Add simple local GPU requirements
</commit_message>
<xml_diff>
--- a/docs/ByteFormer_MNIST_零基础实验课.pptx
+++ b/docs/ByteFormer_MNIST_零基础实验课.pptx
@@ -16044,7 +16044,7 @@
                         </a:defRPr>
                       </a:pPr>
                       <a:r>
-                        <a:t>本地环境</a:t>
+                        <a:t>本地GPU</a:t>
                       </a:r>
                     </a:p>
                   </a:txBody>
@@ -16068,7 +16068,7 @@
                         </a:defRPr>
                       </a:pPr>
                       <a:r>
-                        <a:t>用于查看代码或小规模检查</a:t>
+                        <a:t>已安装Python 3.9—3.12</a:t>
                       </a:r>
                     </a:p>
                   </a:txBody>
@@ -16092,7 +16092,7 @@
                         </a:defRPr>
                       </a:pPr>
                       <a:r>
-                        <a:t>Python、PyTorch环境</a:t>
+                        <a:t>pip install -r requirements-local.txt</a:t>
                       </a:r>
                     </a:p>
                   </a:txBody>

</xml_diff>

<commit_message>
Reorder corruption impact before byte model background
</commit_message>
<xml_diff>
--- a/docs/ByteFormer_MNIST_零基础实验课.pptx
+++ b/docs/ByteFormer_MNIST_零基础实验课.pptx
@@ -13815,7 +13815,7 @@
               </a:defRPr>
             </a:pPr>
             <a:r>
-              <a:t>05 代表性字节模型</a:t>
+              <a:t>05 码流损坏的影响：为什么需要字节域理解</a:t>
             </a:r>
           </a:p>
         </p:txBody>
@@ -13897,7 +13897,7 @@
               </a:defRPr>
             </a:pPr>
             <a:r>
-              <a:t>字节模型直接读取 0—255 字节值，重点解决超长序列和多尺度结构建模。</a:t>
+              <a:t>损坏位置不同，解码器可能直接失败，也可能输出不可靠的像素或后续帧。</a:t>
             </a:r>
           </a:p>
         </p:txBody>
@@ -13943,20 +13943,59 @@
       </p:sp>
       <p:sp>
         <p:nvSpPr>
-          <p:cNvPr id="8" name="Rounded Rectangle 7"/>
+          <p:cNvPr id="8" name="TextBox 7"/>
+          <p:cNvSpPr txBox="1"/>
+          <p:nvPr/>
+        </p:nvSpPr>
+        <p:spPr>
+          <a:xfrm>
+            <a:off x="749808" y="1792224"/>
+            <a:ext cx="10332720" cy="365760"/>
+          </a:xfrm>
+          <a:prstGeom prst="rect">
+            <a:avLst/>
+          </a:prstGeom>
+          <a:noFill/>
+        </p:spPr>
+        <p:txBody>
+          <a:bodyPr wrap="square" lIns="27432" rIns="27432" tIns="18288" bIns="18288">
+            <a:spAutoFit/>
+          </a:bodyPr>
+          <a:lstStyle/>
+          <a:p>
+            <a:pPr algn="ctr">
+              <a:spcAft>
+                <a:spcPts val="600"/>
+              </a:spcAft>
+              <a:defRPr sz="2200" b="1">
+                <a:solidFill>
+                  <a:srgbClr val="176BA0"/>
+                </a:solidFill>
+                <a:latin typeface="Noto Sans CJK SC"/>
+              </a:defRPr>
+            </a:pPr>
+            <a:r>
+              <a:t>损坏位置 → 解码结果 → 对视觉模型的影响</a:t>
+            </a:r>
+          </a:p>
+        </p:txBody>
+      </p:sp>
+      <p:sp>
+        <p:nvSpPr>
+          <p:cNvPr id="9" name="Rounded Rectangle 8"/>
           <p:cNvSpPr/>
           <p:nvPr/>
         </p:nvSpPr>
         <p:spPr>
           <a:xfrm>
-            <a:off x="594360" y="2029968"/>
-            <a:ext cx="2084831" cy="2953512"/>
+            <a:off x="713232" y="2340864"/>
+            <a:ext cx="3401568" cy="1965960"/>
           </a:xfrm>
           <a:prstGeom prst="roundRect">
             <a:avLst/>
           </a:prstGeom>
           <a:solidFill>
-            <a:srgbClr val="EDF4F8"/>
+            <a:srgbClr val="F5DEDE"/>
           </a:solidFill>
           <a:ln>
             <a:noFill/>
@@ -13986,14 +14025,14 @@
       </p:sp>
       <p:sp>
         <p:nvSpPr>
-          <p:cNvPr id="9" name="TextBox 8"/>
-          <p:cNvSpPr txBox="1"/>
-          <p:nvPr/>
-        </p:nvSpPr>
-        <p:spPr>
-          <a:xfrm>
-            <a:off x="694944" y="2221992"/>
-            <a:ext cx="1883664" cy="384048"/>
+          <p:cNvPr id="10" name="TextBox 9"/>
+          <p:cNvSpPr txBox="1"/>
+          <p:nvPr/>
+        </p:nvSpPr>
+        <p:spPr>
+          <a:xfrm>
+            <a:off x="859536" y="2542032"/>
+            <a:ext cx="3108960" cy="329184"/>
           </a:xfrm>
           <a:prstGeom prst="rect">
             <a:avLst/>
@@ -14018,21 +14057,21 @@
               </a:defRPr>
             </a:pPr>
             <a:r>
-              <a:t>MEGABYTE</a:t>
-            </a:r>
-          </a:p>
-        </p:txBody>
-      </p:sp>
-      <p:sp>
-        <p:nvSpPr>
-          <p:cNvPr id="10" name="TextBox 9"/>
-          <p:cNvSpPr txBox="1"/>
-          <p:nvPr/>
-        </p:nvSpPr>
-        <p:spPr>
-          <a:xfrm>
-            <a:off x="694944" y="2633472"/>
-            <a:ext cx="1883664" cy="274320"/>
+              <a:t>文件头 / 参数表</a:t>
+            </a:r>
+          </a:p>
+        </p:txBody>
+      </p:sp>
+      <p:sp>
+        <p:nvSpPr>
+          <p:cNvPr id="11" name="TextBox 10"/>
+          <p:cNvSpPr txBox="1"/>
+          <p:nvPr/>
+        </p:nvSpPr>
+        <p:spPr>
+          <a:xfrm>
+            <a:off x="877824" y="3026664"/>
+            <a:ext cx="3072384" cy="512064"/>
           </a:xfrm>
           <a:prstGeom prst="rect">
             <a:avLst/>
@@ -14051,44 +14090,21 @@
               </a:spcAft>
               <a:defRPr sz="1500" b="0">
                 <a:solidFill>
-                  <a:srgbClr val="647483"/>
-                </a:solidFill>
-                <a:latin typeface="Noto Sans CJK SC"/>
-              </a:defRPr>
-            </a:pPr>
-            <a:r>
-              <a:t>2023</a:t>
-            </a:r>
-          </a:p>
-        </p:txBody>
-      </p:sp>
-      <p:sp>
-        <p:nvSpPr>
-          <p:cNvPr id="11" name="TextBox 10"/>
-          <p:cNvSpPr txBox="1"/>
-          <p:nvPr/>
-        </p:nvSpPr>
-        <p:spPr>
-          <a:xfrm>
-            <a:off x="722376" y="3154680"/>
-            <a:ext cx="1828800" cy="850392"/>
-          </a:xfrm>
-          <a:prstGeom prst="rect">
-            <a:avLst/>
-          </a:prstGeom>
-          <a:noFill/>
-        </p:spPr>
-        <p:txBody>
-          <a:bodyPr wrap="square" lIns="27432" rIns="27432" tIns="18288" bIns="18288">
-            <a:spAutoFit/>
-          </a:bodyPr>
-          <a:lstStyle/>
+                  <a:srgbClr val="243547"/>
+                </a:solidFill>
+                <a:latin typeface="Noto Sans CJK SC"/>
+              </a:defRPr>
+            </a:pPr>
+            <a:r>
+              <a:t>JPEG 的 SOI、DQT、DHT；</a:t>
+            </a:r>
+          </a:p>
           <a:p>
             <a:pPr algn="ctr">
               <a:spcAft>
                 <a:spcPts val="600"/>
               </a:spcAft>
-              <a:defRPr sz="1600" b="0">
+              <a:defRPr sz="1500" b="0">
                 <a:solidFill>
                   <a:srgbClr val="243547"/>
                 </a:solidFill>
@@ -14096,62 +14112,46 @@
               </a:defRPr>
             </a:pPr>
             <a:r>
-              <a:t>全局模型处理字节块</a:t>
-            </a:r>
-          </a:p>
+              <a:t>H.264 的 SPS、PPS</a:t>
+            </a:r>
+          </a:p>
+        </p:txBody>
+      </p:sp>
+      <p:sp>
+        <p:nvSpPr>
+          <p:cNvPr id="12" name="TextBox 11"/>
+          <p:cNvSpPr txBox="1"/>
+          <p:nvPr/>
+        </p:nvSpPr>
+        <p:spPr>
+          <a:xfrm>
+            <a:off x="877824" y="3785615"/>
+            <a:ext cx="3072384" cy="356616"/>
+          </a:xfrm>
+          <a:prstGeom prst="rect">
+            <a:avLst/>
+          </a:prstGeom>
+          <a:noFill/>
+        </p:spPr>
+        <p:txBody>
+          <a:bodyPr wrap="square" lIns="27432" rIns="27432" tIns="18288" bIns="18288">
+            <a:spAutoFit/>
+          </a:bodyPr>
+          <a:lstStyle/>
           <a:p>
             <a:pPr algn="ctr">
               <a:spcAft>
                 <a:spcPts val="600"/>
               </a:spcAft>
-              <a:defRPr sz="1600" b="0">
-                <a:solidFill>
-                  <a:srgbClr val="243547"/>
-                </a:solidFill>
-                <a:latin typeface="Noto Sans CJK SC"/>
-              </a:defRPr>
-            </a:pPr>
-            <a:r>
-              <a:t>局部模型预测块内字节</a:t>
-            </a:r>
-          </a:p>
-        </p:txBody>
-      </p:sp>
-      <p:sp>
-        <p:nvSpPr>
-          <p:cNvPr id="12" name="TextBox 11"/>
-          <p:cNvSpPr txBox="1"/>
-          <p:nvPr/>
-        </p:nvSpPr>
-        <p:spPr>
-          <a:xfrm>
-            <a:off x="722376" y="4325112"/>
-            <a:ext cx="1828800" cy="411480"/>
-          </a:xfrm>
-          <a:prstGeom prst="rect">
-            <a:avLst/>
-          </a:prstGeom>
-          <a:noFill/>
-        </p:spPr>
-        <p:txBody>
-          <a:bodyPr wrap="square" lIns="27432" rIns="27432" tIns="18288" bIns="18288">
-            <a:spAutoFit/>
-          </a:bodyPr>
-          <a:lstStyle/>
-          <a:p>
-            <a:pPr algn="ctr">
-              <a:spcAft>
-                <a:spcPts val="600"/>
-              </a:spcAft>
-              <a:defRPr sz="1300" b="0">
-                <a:solidFill>
-                  <a:srgbClr val="647483"/>
-                </a:solidFill>
-                <a:latin typeface="Noto Sans CJK SC"/>
-              </a:defRPr>
-            </a:pPr>
-            <a:r>
-              <a:t>层级生成</a:t>
+              <a:defRPr sz="1500" b="1">
+                <a:solidFill>
+                  <a:srgbClr val="BA3F3F"/>
+                </a:solidFill>
+                <a:latin typeface="Noto Sans CJK SC"/>
+              </a:defRPr>
+            </a:pPr>
+            <a:r>
+              <a:t>无法解析文件或后续帧</a:t>
             </a:r>
           </a:p>
         </p:txBody>
@@ -14164,14 +14164,14 @@
         </p:nvSpPr>
         <p:spPr>
           <a:xfrm>
-            <a:off x="2907791" y="2029968"/>
-            <a:ext cx="2084831" cy="2953512"/>
+            <a:off x="4389120" y="2340864"/>
+            <a:ext cx="3401568" cy="1965960"/>
           </a:xfrm>
           <a:prstGeom prst="roundRect">
             <a:avLst/>
           </a:prstGeom>
           <a:solidFill>
-            <a:srgbClr val="EDF4F8"/>
+            <a:srgbClr val="F4E5D5"/>
           </a:solidFill>
           <a:ln>
             <a:noFill/>
@@ -14207,8 +14207,8 @@
         </p:nvSpPr>
         <p:spPr>
           <a:xfrm>
-            <a:off x="3008375" y="2221992"/>
-            <a:ext cx="1883664" cy="384048"/>
+            <a:off x="4535424" y="2542032"/>
+            <a:ext cx="3108960" cy="329184"/>
           </a:xfrm>
           <a:prstGeom prst="rect">
             <a:avLst/>
@@ -14233,7 +14233,7 @@
               </a:defRPr>
             </a:pPr>
             <a:r>
-              <a:t>ByteFormer</a:t>
+              <a:t>扫描数据 / 关键帧</a:t>
             </a:r>
           </a:p>
         </p:txBody>
@@ -14246,8 +14246,8 @@
         </p:nvSpPr>
         <p:spPr>
           <a:xfrm>
-            <a:off x="3008375" y="2633472"/>
-            <a:ext cx="1883664" cy="274320"/>
+            <a:off x="4553712" y="3026664"/>
+            <a:ext cx="3072384" cy="512064"/>
           </a:xfrm>
           <a:prstGeom prst="rect">
             <a:avLst/>
@@ -14266,13 +14266,29 @@
               </a:spcAft>
               <a:defRPr sz="1500" b="0">
                 <a:solidFill>
-                  <a:srgbClr val="647483"/>
-                </a:solidFill>
-                <a:latin typeface="Noto Sans CJK SC"/>
-              </a:defRPr>
-            </a:pPr>
-            <a:r>
-              <a:t>2023</a:t>
+                  <a:srgbClr val="243547"/>
+                </a:solidFill>
+                <a:latin typeface="Noto Sans CJK SC"/>
+              </a:defRPr>
+            </a:pPr>
+            <a:r>
+              <a:t>JPEG 压缩数据；</a:t>
+            </a:r>
+          </a:p>
+          <a:p>
+            <a:pPr algn="ctr">
+              <a:spcAft>
+                <a:spcPts val="600"/>
+              </a:spcAft>
+              <a:defRPr sz="1500" b="0">
+                <a:solidFill>
+                  <a:srgbClr val="243547"/>
+                </a:solidFill>
+                <a:latin typeface="Noto Sans CJK SC"/>
+              </a:defRPr>
+            </a:pPr>
+            <a:r>
+              <a:t>H.264 的 IDR、P、B 帧</a:t>
             </a:r>
           </a:p>
         </p:txBody>
@@ -14285,8 +14301,8 @@
         </p:nvSpPr>
         <p:spPr>
           <a:xfrm>
-            <a:off x="3035808" y="3154680"/>
-            <a:ext cx="1828800" cy="850392"/>
+            <a:off x="4553712" y="3785615"/>
+            <a:ext cx="3072384" cy="356616"/>
           </a:xfrm>
           <a:prstGeom prst="rect">
             <a:avLst/>
@@ -14303,90 +14319,35 @@
               <a:spcAft>
                 <a:spcPts val="600"/>
               </a:spcAft>
-              <a:defRPr sz="1600" b="0">
-                <a:solidFill>
-                  <a:srgbClr val="243547"/>
-                </a:solidFill>
-                <a:latin typeface="Noto Sans CJK SC"/>
-              </a:defRPr>
-            </a:pPr>
-            <a:r>
-              <a:t>卷积缩短序列</a:t>
-            </a:r>
-          </a:p>
-          <a:p>
-            <a:pPr algn="ctr">
-              <a:spcAft>
-                <a:spcPts val="600"/>
-              </a:spcAft>
-              <a:defRPr sz="1600" b="0">
-                <a:solidFill>
-                  <a:srgbClr val="243547"/>
-                </a:solidFill>
-                <a:latin typeface="Noto Sans CJK SC"/>
-              </a:defRPr>
-            </a:pPr>
-            <a:r>
-              <a:t>窗口 Transformer 分类</a:t>
-            </a:r>
-          </a:p>
-        </p:txBody>
-      </p:sp>
-      <p:sp>
-        <p:nvSpPr>
-          <p:cNvPr id="17" name="TextBox 16"/>
-          <p:cNvSpPr txBox="1"/>
-          <p:nvPr/>
-        </p:nvSpPr>
-        <p:spPr>
-          <a:xfrm>
-            <a:off x="3035808" y="4325112"/>
-            <a:ext cx="1828800" cy="411480"/>
-          </a:xfrm>
-          <a:prstGeom prst="rect">
-            <a:avLst/>
-          </a:prstGeom>
-          <a:noFill/>
-        </p:spPr>
-        <p:txBody>
-          <a:bodyPr wrap="square" lIns="27432" rIns="27432" tIns="18288" bIns="18288">
-            <a:spAutoFit/>
-          </a:bodyPr>
-          <a:lstStyle/>
-          <a:p>
-            <a:pPr algn="ctr">
-              <a:spcAft>
-                <a:spcPts val="600"/>
-              </a:spcAft>
-              <a:defRPr sz="1300" b="0">
-                <a:solidFill>
-                  <a:srgbClr val="647483"/>
-                </a:solidFill>
-                <a:latin typeface="Noto Sans CJK SC"/>
-              </a:defRPr>
-            </a:pPr>
-            <a:r>
-              <a:t>文件分类</a:t>
-            </a:r>
-          </a:p>
-        </p:txBody>
-      </p:sp>
-      <p:sp>
-        <p:nvSpPr>
-          <p:cNvPr id="18" name="Rounded Rectangle 17"/>
+              <a:defRPr sz="1500" b="1">
+                <a:solidFill>
+                  <a:srgbClr val="BA3F3F"/>
+                </a:solidFill>
+                <a:latin typeface="Noto Sans CJK SC"/>
+              </a:defRPr>
+            </a:pPr>
+            <a:r>
+              <a:t>错块、花屏、错误传播</a:t>
+            </a:r>
+          </a:p>
+        </p:txBody>
+      </p:sp>
+      <p:sp>
+        <p:nvSpPr>
+          <p:cNvPr id="17" name="Rounded Rectangle 16"/>
           <p:cNvSpPr/>
           <p:nvPr/>
         </p:nvSpPr>
         <p:spPr>
           <a:xfrm>
-            <a:off x="5221224" y="2029968"/>
-            <a:ext cx="2084831" cy="2953512"/>
+            <a:off x="8065007" y="2340864"/>
+            <a:ext cx="3401568" cy="1965960"/>
           </a:xfrm>
           <a:prstGeom prst="roundRect">
             <a:avLst/>
           </a:prstGeom>
           <a:solidFill>
-            <a:srgbClr val="EDF4F8"/>
+            <a:srgbClr val="E8E2F3"/>
           </a:solidFill>
           <a:ln>
             <a:noFill/>
@@ -14416,14 +14377,53 @@
       </p:sp>
       <p:sp>
         <p:nvSpPr>
+          <p:cNvPr id="18" name="TextBox 17"/>
+          <p:cNvSpPr txBox="1"/>
+          <p:nvPr/>
+        </p:nvSpPr>
+        <p:spPr>
+          <a:xfrm>
+            <a:off x="8211311" y="2542032"/>
+            <a:ext cx="3108960" cy="329184"/>
+          </a:xfrm>
+          <a:prstGeom prst="rect">
+            <a:avLst/>
+          </a:prstGeom>
+          <a:noFill/>
+        </p:spPr>
+        <p:txBody>
+          <a:bodyPr wrap="square" lIns="27432" rIns="27432" tIns="18288" bIns="18288">
+            <a:spAutoFit/>
+          </a:bodyPr>
+          <a:lstStyle/>
+          <a:p>
+            <a:pPr algn="ctr">
+              <a:spcAft>
+                <a:spcPts val="600"/>
+              </a:spcAft>
+              <a:defRPr sz="2000" b="1">
+                <a:solidFill>
+                  <a:srgbClr val="176BA0"/>
+                </a:solidFill>
+                <a:latin typeface="Noto Sans CJK SC"/>
+              </a:defRPr>
+            </a:pPr>
+            <a:r>
+              <a:t>解码输出</a:t>
+            </a:r>
+          </a:p>
+        </p:txBody>
+      </p:sp>
+      <p:sp>
+        <p:nvSpPr>
           <p:cNvPr id="19" name="TextBox 18"/>
           <p:cNvSpPr txBox="1"/>
           <p:nvPr/>
         </p:nvSpPr>
         <p:spPr>
           <a:xfrm>
-            <a:off x="5321808" y="2221992"/>
-            <a:ext cx="1883664" cy="384048"/>
+            <a:off x="8229599" y="3026664"/>
+            <a:ext cx="3072384" cy="512064"/>
           </a:xfrm>
           <a:prstGeom prst="rect">
             <a:avLst/>
@@ -14440,7 +14440,149 @@
               <a:spcAft>
                 <a:spcPts val="600"/>
               </a:spcAft>
-              <a:defRPr sz="2000" b="1">
+              <a:defRPr sz="1500" b="0">
+                <a:solidFill>
+                  <a:srgbClr val="243547"/>
+                </a:solidFill>
+                <a:latin typeface="Noto Sans CJK SC"/>
+              </a:defRPr>
+            </a:pPr>
+            <a:r>
+              <a:t>像素缺失、尺寸异常或</a:t>
+            </a:r>
+          </a:p>
+          <a:p>
+            <a:pPr algn="ctr">
+              <a:spcAft>
+                <a:spcPts val="600"/>
+              </a:spcAft>
+              <a:defRPr sz="1500" b="0">
+                <a:solidFill>
+                  <a:srgbClr val="243547"/>
+                </a:solidFill>
+                <a:latin typeface="Noto Sans CJK SC"/>
+              </a:defRPr>
+            </a:pPr>
+            <a:r>
+              <a:t>整段视频无法恢复</a:t>
+            </a:r>
+          </a:p>
+        </p:txBody>
+      </p:sp>
+      <p:sp>
+        <p:nvSpPr>
+          <p:cNvPr id="20" name="TextBox 19"/>
+          <p:cNvSpPr txBox="1"/>
+          <p:nvPr/>
+        </p:nvSpPr>
+        <p:spPr>
+          <a:xfrm>
+            <a:off x="8229599" y="3785615"/>
+            <a:ext cx="3072384" cy="356616"/>
+          </a:xfrm>
+          <a:prstGeom prst="rect">
+            <a:avLst/>
+          </a:prstGeom>
+          <a:noFill/>
+        </p:spPr>
+        <p:txBody>
+          <a:bodyPr wrap="square" lIns="27432" rIns="27432" tIns="18288" bIns="18288">
+            <a:spAutoFit/>
+          </a:bodyPr>
+          <a:lstStyle/>
+          <a:p>
+            <a:pPr algn="ctr">
+              <a:spcAft>
+                <a:spcPts val="600"/>
+              </a:spcAft>
+              <a:defRPr sz="1500" b="1">
+                <a:solidFill>
+                  <a:srgbClr val="BA3F3F"/>
+                </a:solidFill>
+                <a:latin typeface="Noto Sans CJK SC"/>
+              </a:defRPr>
+            </a:pPr>
+            <a:r>
+              <a:t>像素域模型没有可靠输入</a:t>
+            </a:r>
+          </a:p>
+        </p:txBody>
+      </p:sp>
+      <p:pic>
+        <p:nvPicPr>
+          <p:cNvPr id="21" name="Picture 20" descr="byteaction_framework.png"/>
+          <p:cNvPicPr>
+            <a:picLocks noChangeAspect="1"/>
+          </p:cNvPicPr>
+          <p:nvPr/>
+        </p:nvPicPr>
+        <p:blipFill>
+          <a:blip r:embed="rId3"/>
+          <a:stretch>
+            <a:fillRect/>
+          </a:stretch>
+        </p:blipFill>
+        <p:spPr>
+          <a:xfrm>
+            <a:off x="2289115" y="4645152"/>
+            <a:ext cx="1721985" cy="1216152"/>
+          </a:xfrm>
+          <a:prstGeom prst="rect">
+            <a:avLst/>
+          </a:prstGeom>
+        </p:spPr>
+      </p:pic>
+      <p:pic>
+        <p:nvPicPr>
+          <p:cNvPr id="22" name="Picture 21" descr="vub_motivation.png"/>
+          <p:cNvPicPr>
+            <a:picLocks noChangeAspect="1"/>
+          </p:cNvPicPr>
+          <p:nvPr/>
+        </p:nvPicPr>
+        <p:blipFill>
+          <a:blip r:embed="rId4"/>
+          <a:stretch>
+            <a:fillRect/>
+          </a:stretch>
+        </p:blipFill>
+        <p:spPr>
+          <a:xfrm>
+            <a:off x="7849048" y="4681728"/>
+            <a:ext cx="1949823" cy="1060704"/>
+          </a:xfrm>
+          <a:prstGeom prst="rect">
+            <a:avLst/>
+          </a:prstGeom>
+        </p:spPr>
+      </p:pic>
+      <p:sp>
+        <p:nvSpPr>
+          <p:cNvPr id="23" name="TextBox 22"/>
+          <p:cNvSpPr txBox="1"/>
+          <p:nvPr/>
+        </p:nvSpPr>
+        <p:spPr>
+          <a:xfrm>
+            <a:off x="841248" y="5934456"/>
+            <a:ext cx="10405872" cy="393192"/>
+          </a:xfrm>
+          <a:prstGeom prst="rect">
+            <a:avLst/>
+          </a:prstGeom>
+          <a:noFill/>
+        </p:spPr>
+        <p:txBody>
+          <a:bodyPr wrap="square" lIns="27432" rIns="27432" tIns="18288" bIns="18288">
+            <a:spAutoFit/>
+          </a:bodyPr>
+          <a:lstStyle/>
+          <a:p>
+            <a:pPr algn="ctr">
+              <a:spcAft>
+                <a:spcPts val="600"/>
+              </a:spcAft>
+              <a:defRPr sz="1600" b="1">
                 <a:solidFill>
                   <a:srgbClr val="176BA0"/>
                 </a:solidFill>
@@ -14448,652 +14590,7 @@
               </a:defRPr>
             </a:pPr>
             <a:r>
-              <a:t>MambaByte</a:t>
-            </a:r>
-          </a:p>
-        </p:txBody>
-      </p:sp>
-      <p:sp>
-        <p:nvSpPr>
-          <p:cNvPr id="20" name="TextBox 19"/>
-          <p:cNvSpPr txBox="1"/>
-          <p:nvPr/>
-        </p:nvSpPr>
-        <p:spPr>
-          <a:xfrm>
-            <a:off x="5321808" y="2633472"/>
-            <a:ext cx="1883664" cy="274320"/>
-          </a:xfrm>
-          <a:prstGeom prst="rect">
-            <a:avLst/>
-          </a:prstGeom>
-          <a:noFill/>
-        </p:spPr>
-        <p:txBody>
-          <a:bodyPr wrap="square" lIns="27432" rIns="27432" tIns="18288" bIns="18288">
-            <a:spAutoFit/>
-          </a:bodyPr>
-          <a:lstStyle/>
-          <a:p>
-            <a:pPr algn="ctr">
-              <a:spcAft>
-                <a:spcPts val="600"/>
-              </a:spcAft>
-              <a:defRPr sz="1500" b="0">
-                <a:solidFill>
-                  <a:srgbClr val="647483"/>
-                </a:solidFill>
-                <a:latin typeface="Noto Sans CJK SC"/>
-              </a:defRPr>
-            </a:pPr>
-            <a:r>
-              <a:t>2024</a:t>
-            </a:r>
-          </a:p>
-        </p:txBody>
-      </p:sp>
-      <p:sp>
-        <p:nvSpPr>
-          <p:cNvPr id="21" name="TextBox 20"/>
-          <p:cNvSpPr txBox="1"/>
-          <p:nvPr/>
-        </p:nvSpPr>
-        <p:spPr>
-          <a:xfrm>
-            <a:off x="5349240" y="3154680"/>
-            <a:ext cx="1828800" cy="850392"/>
-          </a:xfrm>
-          <a:prstGeom prst="rect">
-            <a:avLst/>
-          </a:prstGeom>
-          <a:noFill/>
-        </p:spPr>
-        <p:txBody>
-          <a:bodyPr wrap="square" lIns="27432" rIns="27432" tIns="18288" bIns="18288">
-            <a:spAutoFit/>
-          </a:bodyPr>
-          <a:lstStyle/>
-          <a:p>
-            <a:pPr algn="ctr">
-              <a:spcAft>
-                <a:spcPts val="600"/>
-              </a:spcAft>
-              <a:defRPr sz="1600" b="0">
-                <a:solidFill>
-                  <a:srgbClr val="243547"/>
-                </a:solidFill>
-                <a:latin typeface="Noto Sans CJK SC"/>
-              </a:defRPr>
-            </a:pPr>
-            <a:r>
-              <a:t>选择性状态空间模型</a:t>
-            </a:r>
-          </a:p>
-          <a:p>
-            <a:pPr algn="ctr">
-              <a:spcAft>
-                <a:spcPts val="600"/>
-              </a:spcAft>
-              <a:defRPr sz="1600" b="0">
-                <a:solidFill>
-                  <a:srgbClr val="243547"/>
-                </a:solidFill>
-                <a:latin typeface="Noto Sans CJK SC"/>
-              </a:defRPr>
-            </a:pPr>
-            <a:r>
-              <a:t>近似线性处理长序列</a:t>
-            </a:r>
-          </a:p>
-        </p:txBody>
-      </p:sp>
-      <p:sp>
-        <p:nvSpPr>
-          <p:cNvPr id="22" name="TextBox 21"/>
-          <p:cNvSpPr txBox="1"/>
-          <p:nvPr/>
-        </p:nvSpPr>
-        <p:spPr>
-          <a:xfrm>
-            <a:off x="5349240" y="4325112"/>
-            <a:ext cx="1828800" cy="411480"/>
-          </a:xfrm>
-          <a:prstGeom prst="rect">
-            <a:avLst/>
-          </a:prstGeom>
-          <a:noFill/>
-        </p:spPr>
-        <p:txBody>
-          <a:bodyPr wrap="square" lIns="27432" rIns="27432" tIns="18288" bIns="18288">
-            <a:spAutoFit/>
-          </a:bodyPr>
-          <a:lstStyle/>
-          <a:p>
-            <a:pPr algn="ctr">
-              <a:spcAft>
-                <a:spcPts val="600"/>
-              </a:spcAft>
-              <a:defRPr sz="1300" b="0">
-                <a:solidFill>
-                  <a:srgbClr val="647483"/>
-                </a:solidFill>
-                <a:latin typeface="Noto Sans CJK SC"/>
-              </a:defRPr>
-            </a:pPr>
-            <a:r>
-              <a:t>长序列建模</a:t>
-            </a:r>
-          </a:p>
-        </p:txBody>
-      </p:sp>
-      <p:sp>
-        <p:nvSpPr>
-          <p:cNvPr id="23" name="Rounded Rectangle 22"/>
-          <p:cNvSpPr/>
-          <p:nvPr/>
-        </p:nvSpPr>
-        <p:spPr>
-          <a:xfrm>
-            <a:off x="7534656" y="2029968"/>
-            <a:ext cx="2084831" cy="2953512"/>
-          </a:xfrm>
-          <a:prstGeom prst="roundRect">
-            <a:avLst/>
-          </a:prstGeom>
-          <a:solidFill>
-            <a:srgbClr val="EDF4F8"/>
-          </a:solidFill>
-          <a:ln>
-            <a:noFill/>
-          </a:ln>
-        </p:spPr>
-        <p:style>
-          <a:lnRef idx="1">
-            <a:schemeClr val="accent1"/>
-          </a:lnRef>
-          <a:fillRef idx="3">
-            <a:schemeClr val="accent1"/>
-          </a:fillRef>
-          <a:effectRef idx="2">
-            <a:schemeClr val="accent1"/>
-          </a:effectRef>
-          <a:fontRef idx="minor">
-            <a:schemeClr val="lt1"/>
-          </a:fontRef>
-        </p:style>
-        <p:txBody>
-          <a:bodyPr rtlCol="0" anchor="ctr"/>
-          <a:lstStyle/>
-          <a:p>
-            <a:pPr algn="ctr"/>
-          </a:p>
-        </p:txBody>
-      </p:sp>
-      <p:sp>
-        <p:nvSpPr>
-          <p:cNvPr id="24" name="TextBox 23"/>
-          <p:cNvSpPr txBox="1"/>
-          <p:nvPr/>
-        </p:nvSpPr>
-        <p:spPr>
-          <a:xfrm>
-            <a:off x="7635240" y="2221992"/>
-            <a:ext cx="1883664" cy="384048"/>
-          </a:xfrm>
-          <a:prstGeom prst="rect">
-            <a:avLst/>
-          </a:prstGeom>
-          <a:noFill/>
-        </p:spPr>
-        <p:txBody>
-          <a:bodyPr wrap="square" lIns="27432" rIns="27432" tIns="18288" bIns="18288">
-            <a:spAutoFit/>
-          </a:bodyPr>
-          <a:lstStyle/>
-          <a:p>
-            <a:pPr algn="ctr">
-              <a:spcAft>
-                <a:spcPts val="600"/>
-              </a:spcAft>
-              <a:defRPr sz="2000" b="1">
-                <a:solidFill>
-                  <a:srgbClr val="176BA0"/>
-                </a:solidFill>
-                <a:latin typeface="Noto Sans CJK SC"/>
-              </a:defRPr>
-            </a:pPr>
-            <a:r>
-              <a:t>bGPT</a:t>
-            </a:r>
-          </a:p>
-        </p:txBody>
-      </p:sp>
-      <p:sp>
-        <p:nvSpPr>
-          <p:cNvPr id="25" name="TextBox 24"/>
-          <p:cNvSpPr txBox="1"/>
-          <p:nvPr/>
-        </p:nvSpPr>
-        <p:spPr>
-          <a:xfrm>
-            <a:off x="7635240" y="2633472"/>
-            <a:ext cx="1883664" cy="274320"/>
-          </a:xfrm>
-          <a:prstGeom prst="rect">
-            <a:avLst/>
-          </a:prstGeom>
-          <a:noFill/>
-        </p:spPr>
-        <p:txBody>
-          <a:bodyPr wrap="square" lIns="27432" rIns="27432" tIns="18288" bIns="18288">
-            <a:spAutoFit/>
-          </a:bodyPr>
-          <a:lstStyle/>
-          <a:p>
-            <a:pPr algn="ctr">
-              <a:spcAft>
-                <a:spcPts val="600"/>
-              </a:spcAft>
-              <a:defRPr sz="1500" b="0">
-                <a:solidFill>
-                  <a:srgbClr val="647483"/>
-                </a:solidFill>
-                <a:latin typeface="Noto Sans CJK SC"/>
-              </a:defRPr>
-            </a:pPr>
-            <a:r>
-              <a:t>2024</a:t>
-            </a:r>
-          </a:p>
-        </p:txBody>
-      </p:sp>
-      <p:sp>
-        <p:nvSpPr>
-          <p:cNvPr id="26" name="TextBox 25"/>
-          <p:cNvSpPr txBox="1"/>
-          <p:nvPr/>
-        </p:nvSpPr>
-        <p:spPr>
-          <a:xfrm>
-            <a:off x="7662672" y="3154680"/>
-            <a:ext cx="1828800" cy="850392"/>
-          </a:xfrm>
-          <a:prstGeom prst="rect">
-            <a:avLst/>
-          </a:prstGeom>
-          <a:noFill/>
-        </p:spPr>
-        <p:txBody>
-          <a:bodyPr wrap="square" lIns="27432" rIns="27432" tIns="18288" bIns="18288">
-            <a:spAutoFit/>
-          </a:bodyPr>
-          <a:lstStyle/>
-          <a:p>
-            <a:pPr algn="ctr">
-              <a:spcAft>
-                <a:spcPts val="600"/>
-              </a:spcAft>
-              <a:defRPr sz="1600" b="0">
-                <a:solidFill>
-                  <a:srgbClr val="243547"/>
-                </a:solidFill>
-                <a:latin typeface="Noto Sans CJK SC"/>
-              </a:defRPr>
-            </a:pPr>
-            <a:r>
-              <a:t>Patch-level + Byte-level</a:t>
-            </a:r>
-          </a:p>
-          <a:p>
-            <a:pPr algn="ctr">
-              <a:spcAft>
-                <a:spcPts val="600"/>
-              </a:spcAft>
-              <a:defRPr sz="1600" b="0">
-                <a:solidFill>
-                  <a:srgbClr val="243547"/>
-                </a:solidFill>
-                <a:latin typeface="Noto Sans CJK SC"/>
-              </a:defRPr>
-            </a:pPr>
-            <a:r>
-              <a:t>多模态字节生成</a:t>
-            </a:r>
-          </a:p>
-        </p:txBody>
-      </p:sp>
-      <p:sp>
-        <p:nvSpPr>
-          <p:cNvPr id="27" name="TextBox 26"/>
-          <p:cNvSpPr txBox="1"/>
-          <p:nvPr/>
-        </p:nvSpPr>
-        <p:spPr>
-          <a:xfrm>
-            <a:off x="7662672" y="4325112"/>
-            <a:ext cx="1828800" cy="411480"/>
-          </a:xfrm>
-          <a:prstGeom prst="rect">
-            <a:avLst/>
-          </a:prstGeom>
-          <a:noFill/>
-        </p:spPr>
-        <p:txBody>
-          <a:bodyPr wrap="square" lIns="27432" rIns="27432" tIns="18288" bIns="18288">
-            <a:spAutoFit/>
-          </a:bodyPr>
-          <a:lstStyle/>
-          <a:p>
-            <a:pPr algn="ctr">
-              <a:spcAft>
-                <a:spcPts val="600"/>
-              </a:spcAft>
-              <a:defRPr sz="1300" b="0">
-                <a:solidFill>
-                  <a:srgbClr val="647483"/>
-                </a:solidFill>
-                <a:latin typeface="Noto Sans CJK SC"/>
-              </a:defRPr>
-            </a:pPr>
-            <a:r>
-              <a:t>通用字节生成</a:t>
-            </a:r>
-          </a:p>
-        </p:txBody>
-      </p:sp>
-      <p:sp>
-        <p:nvSpPr>
-          <p:cNvPr id="28" name="Rounded Rectangle 27"/>
-          <p:cNvSpPr/>
-          <p:nvPr/>
-        </p:nvSpPr>
-        <p:spPr>
-          <a:xfrm>
-            <a:off x="9848088" y="2029968"/>
-            <a:ext cx="2084831" cy="2953512"/>
-          </a:xfrm>
-          <a:prstGeom prst="roundRect">
-            <a:avLst/>
-          </a:prstGeom>
-          <a:solidFill>
-            <a:srgbClr val="EDF4F8"/>
-          </a:solidFill>
-          <a:ln>
-            <a:noFill/>
-          </a:ln>
-        </p:spPr>
-        <p:style>
-          <a:lnRef idx="1">
-            <a:schemeClr val="accent1"/>
-          </a:lnRef>
-          <a:fillRef idx="3">
-            <a:schemeClr val="accent1"/>
-          </a:fillRef>
-          <a:effectRef idx="2">
-            <a:schemeClr val="accent1"/>
-          </a:effectRef>
-          <a:fontRef idx="minor">
-            <a:schemeClr val="lt1"/>
-          </a:fontRef>
-        </p:style>
-        <p:txBody>
-          <a:bodyPr rtlCol="0" anchor="ctr"/>
-          <a:lstStyle/>
-          <a:p>
-            <a:pPr algn="ctr"/>
-          </a:p>
-        </p:txBody>
-      </p:sp>
-      <p:sp>
-        <p:nvSpPr>
-          <p:cNvPr id="29" name="TextBox 28"/>
-          <p:cNvSpPr txBox="1"/>
-          <p:nvPr/>
-        </p:nvSpPr>
-        <p:spPr>
-          <a:xfrm>
-            <a:off x="9948672" y="2221992"/>
-            <a:ext cx="1883664" cy="384048"/>
-          </a:xfrm>
-          <a:prstGeom prst="rect">
-            <a:avLst/>
-          </a:prstGeom>
-          <a:noFill/>
-        </p:spPr>
-        <p:txBody>
-          <a:bodyPr wrap="square" lIns="27432" rIns="27432" tIns="18288" bIns="18288">
-            <a:spAutoFit/>
-          </a:bodyPr>
-          <a:lstStyle/>
-          <a:p>
-            <a:pPr algn="ctr">
-              <a:spcAft>
-                <a:spcPts val="600"/>
-              </a:spcAft>
-              <a:defRPr sz="2000" b="1">
-                <a:solidFill>
-                  <a:srgbClr val="176BA0"/>
-                </a:solidFill>
-                <a:latin typeface="Noto Sans CJK SC"/>
-              </a:defRPr>
-            </a:pPr>
-            <a:r>
-              <a:t>mBLM</a:t>
-            </a:r>
-          </a:p>
-        </p:txBody>
-      </p:sp>
-      <p:sp>
-        <p:nvSpPr>
-          <p:cNvPr id="30" name="TextBox 29"/>
-          <p:cNvSpPr txBox="1"/>
-          <p:nvPr/>
-        </p:nvSpPr>
-        <p:spPr>
-          <a:xfrm>
-            <a:off x="9948672" y="2633472"/>
-            <a:ext cx="1883664" cy="274320"/>
-          </a:xfrm>
-          <a:prstGeom prst="rect">
-            <a:avLst/>
-          </a:prstGeom>
-          <a:noFill/>
-        </p:spPr>
-        <p:txBody>
-          <a:bodyPr wrap="square" lIns="27432" rIns="27432" tIns="18288" bIns="18288">
-            <a:spAutoFit/>
-          </a:bodyPr>
-          <a:lstStyle/>
-          <a:p>
-            <a:pPr algn="ctr">
-              <a:spcAft>
-                <a:spcPts val="600"/>
-              </a:spcAft>
-              <a:defRPr sz="1500" b="0">
-                <a:solidFill>
-                  <a:srgbClr val="647483"/>
-                </a:solidFill>
-                <a:latin typeface="Noto Sans CJK SC"/>
-              </a:defRPr>
-            </a:pPr>
-            <a:r>
-              <a:t>2025</a:t>
-            </a:r>
-          </a:p>
-        </p:txBody>
-      </p:sp>
-      <p:sp>
-        <p:nvSpPr>
-          <p:cNvPr id="31" name="TextBox 30"/>
-          <p:cNvSpPr txBox="1"/>
-          <p:nvPr/>
-        </p:nvSpPr>
-        <p:spPr>
-          <a:xfrm>
-            <a:off x="9976104" y="3154680"/>
-            <a:ext cx="1828800" cy="850392"/>
-          </a:xfrm>
-          <a:prstGeom prst="rect">
-            <a:avLst/>
-          </a:prstGeom>
-          <a:noFill/>
-        </p:spPr>
-        <p:txBody>
-          <a:bodyPr wrap="square" lIns="27432" rIns="27432" tIns="18288" bIns="18288">
-            <a:spAutoFit/>
-          </a:bodyPr>
-          <a:lstStyle/>
-          <a:p>
-            <a:pPr algn="ctr">
-              <a:spcAft>
-                <a:spcPts val="600"/>
-              </a:spcAft>
-              <a:defRPr sz="1600" b="0">
-                <a:solidFill>
-                  <a:srgbClr val="243547"/>
-                </a:solidFill>
-                <a:latin typeface="Noto Sans CJK SC"/>
-              </a:defRPr>
-            </a:pPr>
-            <a:r>
-              <a:t>多层级 Byte Patch</a:t>
-            </a:r>
-          </a:p>
-          <a:p>
-            <a:pPr algn="ctr">
-              <a:spcAft>
-                <a:spcPts val="600"/>
-              </a:spcAft>
-              <a:defRPr sz="1600" b="0">
-                <a:solidFill>
-                  <a:srgbClr val="243547"/>
-                </a:solidFill>
-                <a:latin typeface="Noto Sans CJK SC"/>
-              </a:defRPr>
-            </a:pPr>
-            <a:r>
-              <a:t>Transformer / Mamba 可选</a:t>
-            </a:r>
-          </a:p>
-        </p:txBody>
-      </p:sp>
-      <p:sp>
-        <p:nvSpPr>
-          <p:cNvPr id="32" name="TextBox 31"/>
-          <p:cNvSpPr txBox="1"/>
-          <p:nvPr/>
-        </p:nvSpPr>
-        <p:spPr>
-          <a:xfrm>
-            <a:off x="9976104" y="4325112"/>
-            <a:ext cx="1828800" cy="411480"/>
-          </a:xfrm>
-          <a:prstGeom prst="rect">
-            <a:avLst/>
-          </a:prstGeom>
-          <a:noFill/>
-        </p:spPr>
-        <p:txBody>
-          <a:bodyPr wrap="square" lIns="27432" rIns="27432" tIns="18288" bIns="18288">
-            <a:spAutoFit/>
-          </a:bodyPr>
-          <a:lstStyle/>
-          <a:p>
-            <a:pPr algn="ctr">
-              <a:spcAft>
-                <a:spcPts val="600"/>
-              </a:spcAft>
-              <a:defRPr sz="1300" b="0">
-                <a:solidFill>
-                  <a:srgbClr val="647483"/>
-                </a:solidFill>
-                <a:latin typeface="Noto Sans CJK SC"/>
-              </a:defRPr>
-            </a:pPr>
-            <a:r>
-              <a:t>百万字节上下文</a:t>
-            </a:r>
-          </a:p>
-        </p:txBody>
-      </p:sp>
-      <p:sp>
-        <p:nvSpPr>
-          <p:cNvPr id="33" name="Rounded Rectangle 32"/>
-          <p:cNvSpPr/>
-          <p:nvPr/>
-        </p:nvSpPr>
-        <p:spPr>
-          <a:xfrm>
-            <a:off x="758952" y="5349240"/>
-            <a:ext cx="10689336" cy="576072"/>
-          </a:xfrm>
-          <a:prstGeom prst="roundRect">
-            <a:avLst/>
-          </a:prstGeom>
-          <a:solidFill>
-            <a:srgbClr val="DDEBF3"/>
-          </a:solidFill>
-          <a:ln>
-            <a:noFill/>
-          </a:ln>
-        </p:spPr>
-        <p:style>
-          <a:lnRef idx="1">
-            <a:schemeClr val="accent1"/>
-          </a:lnRef>
-          <a:fillRef idx="3">
-            <a:schemeClr val="accent1"/>
-          </a:fillRef>
-          <a:effectRef idx="2">
-            <a:schemeClr val="accent1"/>
-          </a:effectRef>
-          <a:fontRef idx="minor">
-            <a:schemeClr val="lt1"/>
-          </a:fontRef>
-        </p:style>
-        <p:txBody>
-          <a:bodyPr rtlCol="0" anchor="ctr"/>
-          <a:lstStyle/>
-          <a:p>
-            <a:pPr algn="ctr"/>
-          </a:p>
-        </p:txBody>
-      </p:sp>
-      <p:sp>
-        <p:nvSpPr>
-          <p:cNvPr id="34" name="TextBox 33"/>
-          <p:cNvSpPr txBox="1"/>
-          <p:nvPr/>
-        </p:nvSpPr>
-        <p:spPr>
-          <a:xfrm>
-            <a:off x="923544" y="5504688"/>
-            <a:ext cx="10369296" cy="310896"/>
-          </a:xfrm>
-          <a:prstGeom prst="rect">
-            <a:avLst/>
-          </a:prstGeom>
-          <a:noFill/>
-        </p:spPr>
-        <p:txBody>
-          <a:bodyPr wrap="square" lIns="27432" rIns="27432" tIns="18288" bIns="18288">
-            <a:spAutoFit/>
-          </a:bodyPr>
-          <a:lstStyle/>
-          <a:p>
-            <a:pPr algn="ctr">
-              <a:spcAft>
-                <a:spcPts val="600"/>
-              </a:spcAft>
-              <a:defRPr sz="2000" b="1">
-                <a:solidFill>
-                  <a:srgbClr val="176BA0"/>
-                </a:solidFill>
-                <a:latin typeface="Noto Sans CJK SC"/>
-              </a:defRPr>
-            </a:pPr>
-            <a:r>
-              <a:t>课程选择 ByteFormer：面向文件分类，有公开代码和预训练权重，适合完成 MNIST 微调。</a:t>
+              <a:t>传统流程：码流 → 解码 → 像素 → 视觉模型　　字节域流程：码流 → 字节模型 → 分类或语义理解</a:t>
             </a:r>
           </a:p>
         </p:txBody>
@@ -15213,7 +14710,7 @@
               </a:defRPr>
             </a:pPr>
             <a:r>
-              <a:t>06 为什么要直接从字节理解内容</a:t>
+              <a:t>06 代表性字节模型</a:t>
             </a:r>
           </a:p>
         </p:txBody>
@@ -15295,7 +14792,7 @@
               </a:defRPr>
             </a:pPr>
             <a:r>
-              <a:t>当文件损坏后无法完整解码，像素域模型就可能失去输入；字节模型保留了更多原始线索。</a:t>
+              <a:t>字节模型直接读取 0—255 字节值，重点解决超长序列和多尺度结构建模。</a:t>
             </a:r>
           </a:p>
         </p:txBody>
@@ -15339,54 +14836,88 @@
           </a:p>
         </p:txBody>
       </p:sp>
-      <p:pic>
-        <p:nvPicPr>
-          <p:cNvPr id="8" name="Picture 7" descr="byteaction_framework.png"/>
-          <p:cNvPicPr>
-            <a:picLocks noChangeAspect="1"/>
-          </p:cNvPicPr>
-          <p:nvPr/>
-        </p:nvPicPr>
-        <p:blipFill>
-          <a:blip r:embed="rId3"/>
-          <a:stretch>
-            <a:fillRect/>
-          </a:stretch>
-        </p:blipFill>
-        <p:spPr>
-          <a:xfrm>
-            <a:off x="670748" y="1773936"/>
-            <a:ext cx="5114166" cy="3611880"/>
-          </a:xfrm>
-          <a:prstGeom prst="rect">
-            <a:avLst/>
-          </a:prstGeom>
-        </p:spPr>
-      </p:pic>
-      <p:pic>
-        <p:nvPicPr>
-          <p:cNvPr id="9" name="Picture 8" descr="vub_motivation.png"/>
-          <p:cNvPicPr>
-            <a:picLocks noChangeAspect="1"/>
-          </p:cNvPicPr>
-          <p:nvPr/>
-        </p:nvPicPr>
-        <p:blipFill>
-          <a:blip r:embed="rId4"/>
-          <a:stretch>
-            <a:fillRect/>
-          </a:stretch>
-        </p:blipFill>
-        <p:spPr>
-          <a:xfrm>
-            <a:off x="6228005" y="1847087"/>
-            <a:ext cx="5009029" cy="2724912"/>
-          </a:xfrm>
-          <a:prstGeom prst="rect">
-            <a:avLst/>
-          </a:prstGeom>
-        </p:spPr>
-      </p:pic>
+      <p:sp>
+        <p:nvSpPr>
+          <p:cNvPr id="8" name="Rounded Rectangle 7"/>
+          <p:cNvSpPr/>
+          <p:nvPr/>
+        </p:nvSpPr>
+        <p:spPr>
+          <a:xfrm>
+            <a:off x="594360" y="2029968"/>
+            <a:ext cx="2084831" cy="2953512"/>
+          </a:xfrm>
+          <a:prstGeom prst="roundRect">
+            <a:avLst/>
+          </a:prstGeom>
+          <a:solidFill>
+            <a:srgbClr val="EDF4F8"/>
+          </a:solidFill>
+          <a:ln>
+            <a:noFill/>
+          </a:ln>
+        </p:spPr>
+        <p:style>
+          <a:lnRef idx="1">
+            <a:schemeClr val="accent1"/>
+          </a:lnRef>
+          <a:fillRef idx="3">
+            <a:schemeClr val="accent1"/>
+          </a:fillRef>
+          <a:effectRef idx="2">
+            <a:schemeClr val="accent1"/>
+          </a:effectRef>
+          <a:fontRef idx="minor">
+            <a:schemeClr val="lt1"/>
+          </a:fontRef>
+        </p:style>
+        <p:txBody>
+          <a:bodyPr rtlCol="0" anchor="ctr"/>
+          <a:lstStyle/>
+          <a:p>
+            <a:pPr algn="ctr"/>
+          </a:p>
+        </p:txBody>
+      </p:sp>
+      <p:sp>
+        <p:nvSpPr>
+          <p:cNvPr id="9" name="TextBox 8"/>
+          <p:cNvSpPr txBox="1"/>
+          <p:nvPr/>
+        </p:nvSpPr>
+        <p:spPr>
+          <a:xfrm>
+            <a:off x="694944" y="2221992"/>
+            <a:ext cx="1883664" cy="384048"/>
+          </a:xfrm>
+          <a:prstGeom prst="rect">
+            <a:avLst/>
+          </a:prstGeom>
+          <a:noFill/>
+        </p:spPr>
+        <p:txBody>
+          <a:bodyPr wrap="square" lIns="27432" rIns="27432" tIns="18288" bIns="18288">
+            <a:spAutoFit/>
+          </a:bodyPr>
+          <a:lstStyle/>
+          <a:p>
+            <a:pPr algn="ctr">
+              <a:spcAft>
+                <a:spcPts val="600"/>
+              </a:spcAft>
+              <a:defRPr sz="2000" b="1">
+                <a:solidFill>
+                  <a:srgbClr val="176BA0"/>
+                </a:solidFill>
+                <a:latin typeface="Noto Sans CJK SC"/>
+              </a:defRPr>
+            </a:pPr>
+            <a:r>
+              <a:t>MEGABYTE</a:t>
+            </a:r>
+          </a:p>
+        </p:txBody>
+      </p:sp>
       <p:sp>
         <p:nvSpPr>
           <p:cNvPr id="10" name="TextBox 9"/>
@@ -15395,25 +14926,64 @@
         </p:nvSpPr>
         <p:spPr>
           <a:xfrm>
-            <a:off x="6227064" y="4727448"/>
-            <a:ext cx="4983480" cy="1014984"/>
-          </a:xfrm>
-          <a:prstGeom prst="rect">
-            <a:avLst/>
-          </a:prstGeom>
-          <a:noFill/>
-        </p:spPr>
-        <p:txBody>
-          <a:bodyPr wrap="square" lIns="27432" rIns="27432" tIns="18288" bIns="18288">
-            <a:spAutoFit/>
-          </a:bodyPr>
-          <a:lstStyle/>
-          <a:p>
-            <a:pPr>
-              <a:spcAft>
-                <a:spcPts val="600"/>
-              </a:spcAft>
-              <a:defRPr sz="1800" b="0">
+            <a:off x="694944" y="2633472"/>
+            <a:ext cx="1883664" cy="274320"/>
+          </a:xfrm>
+          <a:prstGeom prst="rect">
+            <a:avLst/>
+          </a:prstGeom>
+          <a:noFill/>
+        </p:spPr>
+        <p:txBody>
+          <a:bodyPr wrap="square" lIns="27432" rIns="27432" tIns="18288" bIns="18288">
+            <a:spAutoFit/>
+          </a:bodyPr>
+          <a:lstStyle/>
+          <a:p>
+            <a:pPr algn="ctr">
+              <a:spcAft>
+                <a:spcPts val="600"/>
+              </a:spcAft>
+              <a:defRPr sz="1500" b="0">
+                <a:solidFill>
+                  <a:srgbClr val="647483"/>
+                </a:solidFill>
+                <a:latin typeface="Noto Sans CJK SC"/>
+              </a:defRPr>
+            </a:pPr>
+            <a:r>
+              <a:t>2023</a:t>
+            </a:r>
+          </a:p>
+        </p:txBody>
+      </p:sp>
+      <p:sp>
+        <p:nvSpPr>
+          <p:cNvPr id="11" name="TextBox 10"/>
+          <p:cNvSpPr txBox="1"/>
+          <p:nvPr/>
+        </p:nvSpPr>
+        <p:spPr>
+          <a:xfrm>
+            <a:off x="722376" y="3154680"/>
+            <a:ext cx="1828800" cy="850392"/>
+          </a:xfrm>
+          <a:prstGeom prst="rect">
+            <a:avLst/>
+          </a:prstGeom>
+          <a:noFill/>
+        </p:spPr>
+        <p:txBody>
+          <a:bodyPr wrap="square" lIns="27432" rIns="27432" tIns="18288" bIns="18288">
+            <a:spAutoFit/>
+          </a:bodyPr>
+          <a:lstStyle/>
+          <a:p>
+            <a:pPr algn="ctr">
+              <a:spcAft>
+                <a:spcPts val="600"/>
+              </a:spcAft>
+              <a:defRPr sz="1600" b="0">
                 <a:solidFill>
                   <a:srgbClr val="243547"/>
                 </a:solidFill>
@@ -15421,15 +14991,15 @@
               </a:defRPr>
             </a:pPr>
             <a:r>
-              <a:t>传统流程：码流 → 解码 → 像素 → 视觉模型</a:t>
-            </a:r>
-          </a:p>
-          <a:p>
-            <a:pPr>
-              <a:spcAft>
-                <a:spcPts val="600"/>
-              </a:spcAft>
-              <a:defRPr sz="1800" b="0">
+              <a:t>全局模型处理字节块</a:t>
+            </a:r>
+          </a:p>
+          <a:p>
+            <a:pPr algn="ctr">
+              <a:spcAft>
+                <a:spcPts val="600"/>
+              </a:spcAft>
+              <a:defRPr sz="1600" b="0">
                 <a:solidFill>
                   <a:srgbClr val="243547"/>
                 </a:solidFill>
@@ -15437,15 +15007,198 @@
               </a:defRPr>
             </a:pPr>
             <a:r>
-              <a:t>字节域流程：码流 → 字节模型 → 分类或语义理解</a:t>
-            </a:r>
-          </a:p>
-          <a:p>
-            <a:pPr>
-              <a:spcAft>
-                <a:spcPts val="600"/>
-              </a:spcAft>
-              <a:defRPr sz="1800" b="0">
+              <a:t>局部模型预测块内字节</a:t>
+            </a:r>
+          </a:p>
+        </p:txBody>
+      </p:sp>
+      <p:sp>
+        <p:nvSpPr>
+          <p:cNvPr id="12" name="TextBox 11"/>
+          <p:cNvSpPr txBox="1"/>
+          <p:nvPr/>
+        </p:nvSpPr>
+        <p:spPr>
+          <a:xfrm>
+            <a:off x="722376" y="4325112"/>
+            <a:ext cx="1828800" cy="411480"/>
+          </a:xfrm>
+          <a:prstGeom prst="rect">
+            <a:avLst/>
+          </a:prstGeom>
+          <a:noFill/>
+        </p:spPr>
+        <p:txBody>
+          <a:bodyPr wrap="square" lIns="27432" rIns="27432" tIns="18288" bIns="18288">
+            <a:spAutoFit/>
+          </a:bodyPr>
+          <a:lstStyle/>
+          <a:p>
+            <a:pPr algn="ctr">
+              <a:spcAft>
+                <a:spcPts val="600"/>
+              </a:spcAft>
+              <a:defRPr sz="1300" b="0">
+                <a:solidFill>
+                  <a:srgbClr val="647483"/>
+                </a:solidFill>
+                <a:latin typeface="Noto Sans CJK SC"/>
+              </a:defRPr>
+            </a:pPr>
+            <a:r>
+              <a:t>层级生成</a:t>
+            </a:r>
+          </a:p>
+        </p:txBody>
+      </p:sp>
+      <p:sp>
+        <p:nvSpPr>
+          <p:cNvPr id="13" name="Rounded Rectangle 12"/>
+          <p:cNvSpPr/>
+          <p:nvPr/>
+        </p:nvSpPr>
+        <p:spPr>
+          <a:xfrm>
+            <a:off x="2907791" y="2029968"/>
+            <a:ext cx="2084831" cy="2953512"/>
+          </a:xfrm>
+          <a:prstGeom prst="roundRect">
+            <a:avLst/>
+          </a:prstGeom>
+          <a:solidFill>
+            <a:srgbClr val="EDF4F8"/>
+          </a:solidFill>
+          <a:ln>
+            <a:noFill/>
+          </a:ln>
+        </p:spPr>
+        <p:style>
+          <a:lnRef idx="1">
+            <a:schemeClr val="accent1"/>
+          </a:lnRef>
+          <a:fillRef idx="3">
+            <a:schemeClr val="accent1"/>
+          </a:fillRef>
+          <a:effectRef idx="2">
+            <a:schemeClr val="accent1"/>
+          </a:effectRef>
+          <a:fontRef idx="minor">
+            <a:schemeClr val="lt1"/>
+          </a:fontRef>
+        </p:style>
+        <p:txBody>
+          <a:bodyPr rtlCol="0" anchor="ctr"/>
+          <a:lstStyle/>
+          <a:p>
+            <a:pPr algn="ctr"/>
+          </a:p>
+        </p:txBody>
+      </p:sp>
+      <p:sp>
+        <p:nvSpPr>
+          <p:cNvPr id="14" name="TextBox 13"/>
+          <p:cNvSpPr txBox="1"/>
+          <p:nvPr/>
+        </p:nvSpPr>
+        <p:spPr>
+          <a:xfrm>
+            <a:off x="3008375" y="2221992"/>
+            <a:ext cx="1883664" cy="384048"/>
+          </a:xfrm>
+          <a:prstGeom prst="rect">
+            <a:avLst/>
+          </a:prstGeom>
+          <a:noFill/>
+        </p:spPr>
+        <p:txBody>
+          <a:bodyPr wrap="square" lIns="27432" rIns="27432" tIns="18288" bIns="18288">
+            <a:spAutoFit/>
+          </a:bodyPr>
+          <a:lstStyle/>
+          <a:p>
+            <a:pPr algn="ctr">
+              <a:spcAft>
+                <a:spcPts val="600"/>
+              </a:spcAft>
+              <a:defRPr sz="2000" b="1">
+                <a:solidFill>
+                  <a:srgbClr val="176BA0"/>
+                </a:solidFill>
+                <a:latin typeface="Noto Sans CJK SC"/>
+              </a:defRPr>
+            </a:pPr>
+            <a:r>
+              <a:t>ByteFormer</a:t>
+            </a:r>
+          </a:p>
+        </p:txBody>
+      </p:sp>
+      <p:sp>
+        <p:nvSpPr>
+          <p:cNvPr id="15" name="TextBox 14"/>
+          <p:cNvSpPr txBox="1"/>
+          <p:nvPr/>
+        </p:nvSpPr>
+        <p:spPr>
+          <a:xfrm>
+            <a:off x="3008375" y="2633472"/>
+            <a:ext cx="1883664" cy="274320"/>
+          </a:xfrm>
+          <a:prstGeom prst="rect">
+            <a:avLst/>
+          </a:prstGeom>
+          <a:noFill/>
+        </p:spPr>
+        <p:txBody>
+          <a:bodyPr wrap="square" lIns="27432" rIns="27432" tIns="18288" bIns="18288">
+            <a:spAutoFit/>
+          </a:bodyPr>
+          <a:lstStyle/>
+          <a:p>
+            <a:pPr algn="ctr">
+              <a:spcAft>
+                <a:spcPts val="600"/>
+              </a:spcAft>
+              <a:defRPr sz="1500" b="0">
+                <a:solidFill>
+                  <a:srgbClr val="647483"/>
+                </a:solidFill>
+                <a:latin typeface="Noto Sans CJK SC"/>
+              </a:defRPr>
+            </a:pPr>
+            <a:r>
+              <a:t>2023</a:t>
+            </a:r>
+          </a:p>
+        </p:txBody>
+      </p:sp>
+      <p:sp>
+        <p:nvSpPr>
+          <p:cNvPr id="16" name="TextBox 15"/>
+          <p:cNvSpPr txBox="1"/>
+          <p:nvPr/>
+        </p:nvSpPr>
+        <p:spPr>
+          <a:xfrm>
+            <a:off x="3035808" y="3154680"/>
+            <a:ext cx="1828800" cy="850392"/>
+          </a:xfrm>
+          <a:prstGeom prst="rect">
+            <a:avLst/>
+          </a:prstGeom>
+          <a:noFill/>
+        </p:spPr>
+        <p:txBody>
+          <a:bodyPr wrap="square" lIns="27432" rIns="27432" tIns="18288" bIns="18288">
+            <a:spAutoFit/>
+          </a:bodyPr>
+          <a:lstStyle/>
+          <a:p>
+            <a:pPr algn="ctr">
+              <a:spcAft>
+                <a:spcPts val="600"/>
+              </a:spcAft>
+              <a:defRPr sz="1600" b="0">
                 <a:solidFill>
                   <a:srgbClr val="243547"/>
                 </a:solidFill>
@@ -15453,7 +15206,789 @@
               </a:defRPr>
             </a:pPr>
             <a:r>
-              <a:t>课程先完成干净码流，再观察损坏码流的差异。</a:t>
+              <a:t>卷积缩短序列</a:t>
+            </a:r>
+          </a:p>
+          <a:p>
+            <a:pPr algn="ctr">
+              <a:spcAft>
+                <a:spcPts val="600"/>
+              </a:spcAft>
+              <a:defRPr sz="1600" b="0">
+                <a:solidFill>
+                  <a:srgbClr val="243547"/>
+                </a:solidFill>
+                <a:latin typeface="Noto Sans CJK SC"/>
+              </a:defRPr>
+            </a:pPr>
+            <a:r>
+              <a:t>窗口 Transformer 分类</a:t>
+            </a:r>
+          </a:p>
+        </p:txBody>
+      </p:sp>
+      <p:sp>
+        <p:nvSpPr>
+          <p:cNvPr id="17" name="TextBox 16"/>
+          <p:cNvSpPr txBox="1"/>
+          <p:nvPr/>
+        </p:nvSpPr>
+        <p:spPr>
+          <a:xfrm>
+            <a:off x="3035808" y="4325112"/>
+            <a:ext cx="1828800" cy="411480"/>
+          </a:xfrm>
+          <a:prstGeom prst="rect">
+            <a:avLst/>
+          </a:prstGeom>
+          <a:noFill/>
+        </p:spPr>
+        <p:txBody>
+          <a:bodyPr wrap="square" lIns="27432" rIns="27432" tIns="18288" bIns="18288">
+            <a:spAutoFit/>
+          </a:bodyPr>
+          <a:lstStyle/>
+          <a:p>
+            <a:pPr algn="ctr">
+              <a:spcAft>
+                <a:spcPts val="600"/>
+              </a:spcAft>
+              <a:defRPr sz="1300" b="0">
+                <a:solidFill>
+                  <a:srgbClr val="647483"/>
+                </a:solidFill>
+                <a:latin typeface="Noto Sans CJK SC"/>
+              </a:defRPr>
+            </a:pPr>
+            <a:r>
+              <a:t>文件分类</a:t>
+            </a:r>
+          </a:p>
+        </p:txBody>
+      </p:sp>
+      <p:sp>
+        <p:nvSpPr>
+          <p:cNvPr id="18" name="Rounded Rectangle 17"/>
+          <p:cNvSpPr/>
+          <p:nvPr/>
+        </p:nvSpPr>
+        <p:spPr>
+          <a:xfrm>
+            <a:off x="5221224" y="2029968"/>
+            <a:ext cx="2084831" cy="2953512"/>
+          </a:xfrm>
+          <a:prstGeom prst="roundRect">
+            <a:avLst/>
+          </a:prstGeom>
+          <a:solidFill>
+            <a:srgbClr val="EDF4F8"/>
+          </a:solidFill>
+          <a:ln>
+            <a:noFill/>
+          </a:ln>
+        </p:spPr>
+        <p:style>
+          <a:lnRef idx="1">
+            <a:schemeClr val="accent1"/>
+          </a:lnRef>
+          <a:fillRef idx="3">
+            <a:schemeClr val="accent1"/>
+          </a:fillRef>
+          <a:effectRef idx="2">
+            <a:schemeClr val="accent1"/>
+          </a:effectRef>
+          <a:fontRef idx="minor">
+            <a:schemeClr val="lt1"/>
+          </a:fontRef>
+        </p:style>
+        <p:txBody>
+          <a:bodyPr rtlCol="0" anchor="ctr"/>
+          <a:lstStyle/>
+          <a:p>
+            <a:pPr algn="ctr"/>
+          </a:p>
+        </p:txBody>
+      </p:sp>
+      <p:sp>
+        <p:nvSpPr>
+          <p:cNvPr id="19" name="TextBox 18"/>
+          <p:cNvSpPr txBox="1"/>
+          <p:nvPr/>
+        </p:nvSpPr>
+        <p:spPr>
+          <a:xfrm>
+            <a:off x="5321808" y="2221992"/>
+            <a:ext cx="1883664" cy="384048"/>
+          </a:xfrm>
+          <a:prstGeom prst="rect">
+            <a:avLst/>
+          </a:prstGeom>
+          <a:noFill/>
+        </p:spPr>
+        <p:txBody>
+          <a:bodyPr wrap="square" lIns="27432" rIns="27432" tIns="18288" bIns="18288">
+            <a:spAutoFit/>
+          </a:bodyPr>
+          <a:lstStyle/>
+          <a:p>
+            <a:pPr algn="ctr">
+              <a:spcAft>
+                <a:spcPts val="600"/>
+              </a:spcAft>
+              <a:defRPr sz="2000" b="1">
+                <a:solidFill>
+                  <a:srgbClr val="176BA0"/>
+                </a:solidFill>
+                <a:latin typeface="Noto Sans CJK SC"/>
+              </a:defRPr>
+            </a:pPr>
+            <a:r>
+              <a:t>MambaByte</a:t>
+            </a:r>
+          </a:p>
+        </p:txBody>
+      </p:sp>
+      <p:sp>
+        <p:nvSpPr>
+          <p:cNvPr id="20" name="TextBox 19"/>
+          <p:cNvSpPr txBox="1"/>
+          <p:nvPr/>
+        </p:nvSpPr>
+        <p:spPr>
+          <a:xfrm>
+            <a:off x="5321808" y="2633472"/>
+            <a:ext cx="1883664" cy="274320"/>
+          </a:xfrm>
+          <a:prstGeom prst="rect">
+            <a:avLst/>
+          </a:prstGeom>
+          <a:noFill/>
+        </p:spPr>
+        <p:txBody>
+          <a:bodyPr wrap="square" lIns="27432" rIns="27432" tIns="18288" bIns="18288">
+            <a:spAutoFit/>
+          </a:bodyPr>
+          <a:lstStyle/>
+          <a:p>
+            <a:pPr algn="ctr">
+              <a:spcAft>
+                <a:spcPts val="600"/>
+              </a:spcAft>
+              <a:defRPr sz="1500" b="0">
+                <a:solidFill>
+                  <a:srgbClr val="647483"/>
+                </a:solidFill>
+                <a:latin typeface="Noto Sans CJK SC"/>
+              </a:defRPr>
+            </a:pPr>
+            <a:r>
+              <a:t>2024</a:t>
+            </a:r>
+          </a:p>
+        </p:txBody>
+      </p:sp>
+      <p:sp>
+        <p:nvSpPr>
+          <p:cNvPr id="21" name="TextBox 20"/>
+          <p:cNvSpPr txBox="1"/>
+          <p:nvPr/>
+        </p:nvSpPr>
+        <p:spPr>
+          <a:xfrm>
+            <a:off x="5349240" y="3154680"/>
+            <a:ext cx="1828800" cy="850392"/>
+          </a:xfrm>
+          <a:prstGeom prst="rect">
+            <a:avLst/>
+          </a:prstGeom>
+          <a:noFill/>
+        </p:spPr>
+        <p:txBody>
+          <a:bodyPr wrap="square" lIns="27432" rIns="27432" tIns="18288" bIns="18288">
+            <a:spAutoFit/>
+          </a:bodyPr>
+          <a:lstStyle/>
+          <a:p>
+            <a:pPr algn="ctr">
+              <a:spcAft>
+                <a:spcPts val="600"/>
+              </a:spcAft>
+              <a:defRPr sz="1600" b="0">
+                <a:solidFill>
+                  <a:srgbClr val="243547"/>
+                </a:solidFill>
+                <a:latin typeface="Noto Sans CJK SC"/>
+              </a:defRPr>
+            </a:pPr>
+            <a:r>
+              <a:t>选择性状态空间模型</a:t>
+            </a:r>
+          </a:p>
+          <a:p>
+            <a:pPr algn="ctr">
+              <a:spcAft>
+                <a:spcPts val="600"/>
+              </a:spcAft>
+              <a:defRPr sz="1600" b="0">
+                <a:solidFill>
+                  <a:srgbClr val="243547"/>
+                </a:solidFill>
+                <a:latin typeface="Noto Sans CJK SC"/>
+              </a:defRPr>
+            </a:pPr>
+            <a:r>
+              <a:t>近似线性处理长序列</a:t>
+            </a:r>
+          </a:p>
+        </p:txBody>
+      </p:sp>
+      <p:sp>
+        <p:nvSpPr>
+          <p:cNvPr id="22" name="TextBox 21"/>
+          <p:cNvSpPr txBox="1"/>
+          <p:nvPr/>
+        </p:nvSpPr>
+        <p:spPr>
+          <a:xfrm>
+            <a:off x="5349240" y="4325112"/>
+            <a:ext cx="1828800" cy="411480"/>
+          </a:xfrm>
+          <a:prstGeom prst="rect">
+            <a:avLst/>
+          </a:prstGeom>
+          <a:noFill/>
+        </p:spPr>
+        <p:txBody>
+          <a:bodyPr wrap="square" lIns="27432" rIns="27432" tIns="18288" bIns="18288">
+            <a:spAutoFit/>
+          </a:bodyPr>
+          <a:lstStyle/>
+          <a:p>
+            <a:pPr algn="ctr">
+              <a:spcAft>
+                <a:spcPts val="600"/>
+              </a:spcAft>
+              <a:defRPr sz="1300" b="0">
+                <a:solidFill>
+                  <a:srgbClr val="647483"/>
+                </a:solidFill>
+                <a:latin typeface="Noto Sans CJK SC"/>
+              </a:defRPr>
+            </a:pPr>
+            <a:r>
+              <a:t>长序列建模</a:t>
+            </a:r>
+          </a:p>
+        </p:txBody>
+      </p:sp>
+      <p:sp>
+        <p:nvSpPr>
+          <p:cNvPr id="23" name="Rounded Rectangle 22"/>
+          <p:cNvSpPr/>
+          <p:nvPr/>
+        </p:nvSpPr>
+        <p:spPr>
+          <a:xfrm>
+            <a:off x="7534656" y="2029968"/>
+            <a:ext cx="2084831" cy="2953512"/>
+          </a:xfrm>
+          <a:prstGeom prst="roundRect">
+            <a:avLst/>
+          </a:prstGeom>
+          <a:solidFill>
+            <a:srgbClr val="EDF4F8"/>
+          </a:solidFill>
+          <a:ln>
+            <a:noFill/>
+          </a:ln>
+        </p:spPr>
+        <p:style>
+          <a:lnRef idx="1">
+            <a:schemeClr val="accent1"/>
+          </a:lnRef>
+          <a:fillRef idx="3">
+            <a:schemeClr val="accent1"/>
+          </a:fillRef>
+          <a:effectRef idx="2">
+            <a:schemeClr val="accent1"/>
+          </a:effectRef>
+          <a:fontRef idx="minor">
+            <a:schemeClr val="lt1"/>
+          </a:fontRef>
+        </p:style>
+        <p:txBody>
+          <a:bodyPr rtlCol="0" anchor="ctr"/>
+          <a:lstStyle/>
+          <a:p>
+            <a:pPr algn="ctr"/>
+          </a:p>
+        </p:txBody>
+      </p:sp>
+      <p:sp>
+        <p:nvSpPr>
+          <p:cNvPr id="24" name="TextBox 23"/>
+          <p:cNvSpPr txBox="1"/>
+          <p:nvPr/>
+        </p:nvSpPr>
+        <p:spPr>
+          <a:xfrm>
+            <a:off x="7635240" y="2221992"/>
+            <a:ext cx="1883664" cy="384048"/>
+          </a:xfrm>
+          <a:prstGeom prst="rect">
+            <a:avLst/>
+          </a:prstGeom>
+          <a:noFill/>
+        </p:spPr>
+        <p:txBody>
+          <a:bodyPr wrap="square" lIns="27432" rIns="27432" tIns="18288" bIns="18288">
+            <a:spAutoFit/>
+          </a:bodyPr>
+          <a:lstStyle/>
+          <a:p>
+            <a:pPr algn="ctr">
+              <a:spcAft>
+                <a:spcPts val="600"/>
+              </a:spcAft>
+              <a:defRPr sz="2000" b="1">
+                <a:solidFill>
+                  <a:srgbClr val="176BA0"/>
+                </a:solidFill>
+                <a:latin typeface="Noto Sans CJK SC"/>
+              </a:defRPr>
+            </a:pPr>
+            <a:r>
+              <a:t>bGPT</a:t>
+            </a:r>
+          </a:p>
+        </p:txBody>
+      </p:sp>
+      <p:sp>
+        <p:nvSpPr>
+          <p:cNvPr id="25" name="TextBox 24"/>
+          <p:cNvSpPr txBox="1"/>
+          <p:nvPr/>
+        </p:nvSpPr>
+        <p:spPr>
+          <a:xfrm>
+            <a:off x="7635240" y="2633472"/>
+            <a:ext cx="1883664" cy="274320"/>
+          </a:xfrm>
+          <a:prstGeom prst="rect">
+            <a:avLst/>
+          </a:prstGeom>
+          <a:noFill/>
+        </p:spPr>
+        <p:txBody>
+          <a:bodyPr wrap="square" lIns="27432" rIns="27432" tIns="18288" bIns="18288">
+            <a:spAutoFit/>
+          </a:bodyPr>
+          <a:lstStyle/>
+          <a:p>
+            <a:pPr algn="ctr">
+              <a:spcAft>
+                <a:spcPts val="600"/>
+              </a:spcAft>
+              <a:defRPr sz="1500" b="0">
+                <a:solidFill>
+                  <a:srgbClr val="647483"/>
+                </a:solidFill>
+                <a:latin typeface="Noto Sans CJK SC"/>
+              </a:defRPr>
+            </a:pPr>
+            <a:r>
+              <a:t>2024</a:t>
+            </a:r>
+          </a:p>
+        </p:txBody>
+      </p:sp>
+      <p:sp>
+        <p:nvSpPr>
+          <p:cNvPr id="26" name="TextBox 25"/>
+          <p:cNvSpPr txBox="1"/>
+          <p:nvPr/>
+        </p:nvSpPr>
+        <p:spPr>
+          <a:xfrm>
+            <a:off x="7662672" y="3154680"/>
+            <a:ext cx="1828800" cy="850392"/>
+          </a:xfrm>
+          <a:prstGeom prst="rect">
+            <a:avLst/>
+          </a:prstGeom>
+          <a:noFill/>
+        </p:spPr>
+        <p:txBody>
+          <a:bodyPr wrap="square" lIns="27432" rIns="27432" tIns="18288" bIns="18288">
+            <a:spAutoFit/>
+          </a:bodyPr>
+          <a:lstStyle/>
+          <a:p>
+            <a:pPr algn="ctr">
+              <a:spcAft>
+                <a:spcPts val="600"/>
+              </a:spcAft>
+              <a:defRPr sz="1600" b="0">
+                <a:solidFill>
+                  <a:srgbClr val="243547"/>
+                </a:solidFill>
+                <a:latin typeface="Noto Sans CJK SC"/>
+              </a:defRPr>
+            </a:pPr>
+            <a:r>
+              <a:t>Patch-level + Byte-level</a:t>
+            </a:r>
+          </a:p>
+          <a:p>
+            <a:pPr algn="ctr">
+              <a:spcAft>
+                <a:spcPts val="600"/>
+              </a:spcAft>
+              <a:defRPr sz="1600" b="0">
+                <a:solidFill>
+                  <a:srgbClr val="243547"/>
+                </a:solidFill>
+                <a:latin typeface="Noto Sans CJK SC"/>
+              </a:defRPr>
+            </a:pPr>
+            <a:r>
+              <a:t>多模态字节生成</a:t>
+            </a:r>
+          </a:p>
+        </p:txBody>
+      </p:sp>
+      <p:sp>
+        <p:nvSpPr>
+          <p:cNvPr id="27" name="TextBox 26"/>
+          <p:cNvSpPr txBox="1"/>
+          <p:nvPr/>
+        </p:nvSpPr>
+        <p:spPr>
+          <a:xfrm>
+            <a:off x="7662672" y="4325112"/>
+            <a:ext cx="1828800" cy="411480"/>
+          </a:xfrm>
+          <a:prstGeom prst="rect">
+            <a:avLst/>
+          </a:prstGeom>
+          <a:noFill/>
+        </p:spPr>
+        <p:txBody>
+          <a:bodyPr wrap="square" lIns="27432" rIns="27432" tIns="18288" bIns="18288">
+            <a:spAutoFit/>
+          </a:bodyPr>
+          <a:lstStyle/>
+          <a:p>
+            <a:pPr algn="ctr">
+              <a:spcAft>
+                <a:spcPts val="600"/>
+              </a:spcAft>
+              <a:defRPr sz="1300" b="0">
+                <a:solidFill>
+                  <a:srgbClr val="647483"/>
+                </a:solidFill>
+                <a:latin typeface="Noto Sans CJK SC"/>
+              </a:defRPr>
+            </a:pPr>
+            <a:r>
+              <a:t>通用字节生成</a:t>
+            </a:r>
+          </a:p>
+        </p:txBody>
+      </p:sp>
+      <p:sp>
+        <p:nvSpPr>
+          <p:cNvPr id="28" name="Rounded Rectangle 27"/>
+          <p:cNvSpPr/>
+          <p:nvPr/>
+        </p:nvSpPr>
+        <p:spPr>
+          <a:xfrm>
+            <a:off x="9848088" y="2029968"/>
+            <a:ext cx="2084831" cy="2953512"/>
+          </a:xfrm>
+          <a:prstGeom prst="roundRect">
+            <a:avLst/>
+          </a:prstGeom>
+          <a:solidFill>
+            <a:srgbClr val="EDF4F8"/>
+          </a:solidFill>
+          <a:ln>
+            <a:noFill/>
+          </a:ln>
+        </p:spPr>
+        <p:style>
+          <a:lnRef idx="1">
+            <a:schemeClr val="accent1"/>
+          </a:lnRef>
+          <a:fillRef idx="3">
+            <a:schemeClr val="accent1"/>
+          </a:fillRef>
+          <a:effectRef idx="2">
+            <a:schemeClr val="accent1"/>
+          </a:effectRef>
+          <a:fontRef idx="minor">
+            <a:schemeClr val="lt1"/>
+          </a:fontRef>
+        </p:style>
+        <p:txBody>
+          <a:bodyPr rtlCol="0" anchor="ctr"/>
+          <a:lstStyle/>
+          <a:p>
+            <a:pPr algn="ctr"/>
+          </a:p>
+        </p:txBody>
+      </p:sp>
+      <p:sp>
+        <p:nvSpPr>
+          <p:cNvPr id="29" name="TextBox 28"/>
+          <p:cNvSpPr txBox="1"/>
+          <p:nvPr/>
+        </p:nvSpPr>
+        <p:spPr>
+          <a:xfrm>
+            <a:off x="9948672" y="2221992"/>
+            <a:ext cx="1883664" cy="384048"/>
+          </a:xfrm>
+          <a:prstGeom prst="rect">
+            <a:avLst/>
+          </a:prstGeom>
+          <a:noFill/>
+        </p:spPr>
+        <p:txBody>
+          <a:bodyPr wrap="square" lIns="27432" rIns="27432" tIns="18288" bIns="18288">
+            <a:spAutoFit/>
+          </a:bodyPr>
+          <a:lstStyle/>
+          <a:p>
+            <a:pPr algn="ctr">
+              <a:spcAft>
+                <a:spcPts val="600"/>
+              </a:spcAft>
+              <a:defRPr sz="2000" b="1">
+                <a:solidFill>
+                  <a:srgbClr val="176BA0"/>
+                </a:solidFill>
+                <a:latin typeface="Noto Sans CJK SC"/>
+              </a:defRPr>
+            </a:pPr>
+            <a:r>
+              <a:t>mBLM</a:t>
+            </a:r>
+          </a:p>
+        </p:txBody>
+      </p:sp>
+      <p:sp>
+        <p:nvSpPr>
+          <p:cNvPr id="30" name="TextBox 29"/>
+          <p:cNvSpPr txBox="1"/>
+          <p:nvPr/>
+        </p:nvSpPr>
+        <p:spPr>
+          <a:xfrm>
+            <a:off x="9948672" y="2633472"/>
+            <a:ext cx="1883664" cy="274320"/>
+          </a:xfrm>
+          <a:prstGeom prst="rect">
+            <a:avLst/>
+          </a:prstGeom>
+          <a:noFill/>
+        </p:spPr>
+        <p:txBody>
+          <a:bodyPr wrap="square" lIns="27432" rIns="27432" tIns="18288" bIns="18288">
+            <a:spAutoFit/>
+          </a:bodyPr>
+          <a:lstStyle/>
+          <a:p>
+            <a:pPr algn="ctr">
+              <a:spcAft>
+                <a:spcPts val="600"/>
+              </a:spcAft>
+              <a:defRPr sz="1500" b="0">
+                <a:solidFill>
+                  <a:srgbClr val="647483"/>
+                </a:solidFill>
+                <a:latin typeface="Noto Sans CJK SC"/>
+              </a:defRPr>
+            </a:pPr>
+            <a:r>
+              <a:t>2025</a:t>
+            </a:r>
+          </a:p>
+        </p:txBody>
+      </p:sp>
+      <p:sp>
+        <p:nvSpPr>
+          <p:cNvPr id="31" name="TextBox 30"/>
+          <p:cNvSpPr txBox="1"/>
+          <p:nvPr/>
+        </p:nvSpPr>
+        <p:spPr>
+          <a:xfrm>
+            <a:off x="9976104" y="3154680"/>
+            <a:ext cx="1828800" cy="850392"/>
+          </a:xfrm>
+          <a:prstGeom prst="rect">
+            <a:avLst/>
+          </a:prstGeom>
+          <a:noFill/>
+        </p:spPr>
+        <p:txBody>
+          <a:bodyPr wrap="square" lIns="27432" rIns="27432" tIns="18288" bIns="18288">
+            <a:spAutoFit/>
+          </a:bodyPr>
+          <a:lstStyle/>
+          <a:p>
+            <a:pPr algn="ctr">
+              <a:spcAft>
+                <a:spcPts val="600"/>
+              </a:spcAft>
+              <a:defRPr sz="1600" b="0">
+                <a:solidFill>
+                  <a:srgbClr val="243547"/>
+                </a:solidFill>
+                <a:latin typeface="Noto Sans CJK SC"/>
+              </a:defRPr>
+            </a:pPr>
+            <a:r>
+              <a:t>多层级 Byte Patch</a:t>
+            </a:r>
+          </a:p>
+          <a:p>
+            <a:pPr algn="ctr">
+              <a:spcAft>
+                <a:spcPts val="600"/>
+              </a:spcAft>
+              <a:defRPr sz="1600" b="0">
+                <a:solidFill>
+                  <a:srgbClr val="243547"/>
+                </a:solidFill>
+                <a:latin typeface="Noto Sans CJK SC"/>
+              </a:defRPr>
+            </a:pPr>
+            <a:r>
+              <a:t>Transformer / Mamba 可选</a:t>
+            </a:r>
+          </a:p>
+        </p:txBody>
+      </p:sp>
+      <p:sp>
+        <p:nvSpPr>
+          <p:cNvPr id="32" name="TextBox 31"/>
+          <p:cNvSpPr txBox="1"/>
+          <p:nvPr/>
+        </p:nvSpPr>
+        <p:spPr>
+          <a:xfrm>
+            <a:off x="9976104" y="4325112"/>
+            <a:ext cx="1828800" cy="411480"/>
+          </a:xfrm>
+          <a:prstGeom prst="rect">
+            <a:avLst/>
+          </a:prstGeom>
+          <a:noFill/>
+        </p:spPr>
+        <p:txBody>
+          <a:bodyPr wrap="square" lIns="27432" rIns="27432" tIns="18288" bIns="18288">
+            <a:spAutoFit/>
+          </a:bodyPr>
+          <a:lstStyle/>
+          <a:p>
+            <a:pPr algn="ctr">
+              <a:spcAft>
+                <a:spcPts val="600"/>
+              </a:spcAft>
+              <a:defRPr sz="1300" b="0">
+                <a:solidFill>
+                  <a:srgbClr val="647483"/>
+                </a:solidFill>
+                <a:latin typeface="Noto Sans CJK SC"/>
+              </a:defRPr>
+            </a:pPr>
+            <a:r>
+              <a:t>百万字节上下文</a:t>
+            </a:r>
+          </a:p>
+        </p:txBody>
+      </p:sp>
+      <p:sp>
+        <p:nvSpPr>
+          <p:cNvPr id="33" name="Rounded Rectangle 32"/>
+          <p:cNvSpPr/>
+          <p:nvPr/>
+        </p:nvSpPr>
+        <p:spPr>
+          <a:xfrm>
+            <a:off x="758952" y="5349240"/>
+            <a:ext cx="10689336" cy="576072"/>
+          </a:xfrm>
+          <a:prstGeom prst="roundRect">
+            <a:avLst/>
+          </a:prstGeom>
+          <a:solidFill>
+            <a:srgbClr val="DDEBF3"/>
+          </a:solidFill>
+          <a:ln>
+            <a:noFill/>
+          </a:ln>
+        </p:spPr>
+        <p:style>
+          <a:lnRef idx="1">
+            <a:schemeClr val="accent1"/>
+          </a:lnRef>
+          <a:fillRef idx="3">
+            <a:schemeClr val="accent1"/>
+          </a:fillRef>
+          <a:effectRef idx="2">
+            <a:schemeClr val="accent1"/>
+          </a:effectRef>
+          <a:fontRef idx="minor">
+            <a:schemeClr val="lt1"/>
+          </a:fontRef>
+        </p:style>
+        <p:txBody>
+          <a:bodyPr rtlCol="0" anchor="ctr"/>
+          <a:lstStyle/>
+          <a:p>
+            <a:pPr algn="ctr"/>
+          </a:p>
+        </p:txBody>
+      </p:sp>
+      <p:sp>
+        <p:nvSpPr>
+          <p:cNvPr id="34" name="TextBox 33"/>
+          <p:cNvSpPr txBox="1"/>
+          <p:nvPr/>
+        </p:nvSpPr>
+        <p:spPr>
+          <a:xfrm>
+            <a:off x="923544" y="5504688"/>
+            <a:ext cx="10369296" cy="310896"/>
+          </a:xfrm>
+          <a:prstGeom prst="rect">
+            <a:avLst/>
+          </a:prstGeom>
+          <a:noFill/>
+        </p:spPr>
+        <p:txBody>
+          <a:bodyPr wrap="square" lIns="27432" rIns="27432" tIns="18288" bIns="18288">
+            <a:spAutoFit/>
+          </a:bodyPr>
+          <a:lstStyle/>
+          <a:p>
+            <a:pPr algn="ctr">
+              <a:spcAft>
+                <a:spcPts val="600"/>
+              </a:spcAft>
+              <a:defRPr sz="2000" b="1">
+                <a:solidFill>
+                  <a:srgbClr val="176BA0"/>
+                </a:solidFill>
+                <a:latin typeface="Noto Sans CJK SC"/>
+              </a:defRPr>
+            </a:pPr>
+            <a:r>
+              <a:t>课程选择 ByteFormer：面向文件分类，有公开代码和预训练权重，适合完成 MNIST 微调。</a:t>
             </a:r>
           </a:p>
         </p:txBody>

</xml_diff>